<commit_message>
Add share-price line and comprehensive framing; fix unlimited portfolio add/remove
Track Record now plots the indexed share price on a secondary axis alongside
the two risk lines, and the ForesightAI line is labelled comprehensive (it is
the combined Altman-plus-signals score, not signals alone). The tab and its
copy lead with breadth rather than beating Altman.

Portfolio add/remove is now unlimited: explicit add and explicit remove
controls replace the default-all multiselect that silently pruned every new
addition after the first.

Deck reframed around comprehensiveness - one score from six inputs, the
Foresight Fix, a dual-line Altman-vs-ForesightAI chart and the five
non-financial cases across five sectors.
</commit_message>
<xml_diff>
--- a/deck/ForesightAI.pptx
+++ b/deck/ForesightAI.pptx
@@ -1734,7 +1734,7 @@
         <p:spPr>
           <a:xfrm>
             <a:off x="822960" y="2788920"/>
-            <a:ext cx="7040880" cy="1097280"/>
+            <a:ext cx="7223760" cy="1097280"/>
           </a:xfrm>
           <a:prstGeom prst="rect">
             <a:avLst/>
@@ -1761,7 +1761,7 @@
                 <a:ea typeface="Calibri" pitchFamily="34" charset="-122"/>
                 <a:cs typeface="Calibri" pitchFamily="34" charset="-120"/>
               </a:rPr>
-              <a:t>Point it at any listed Indian company. Get a live, explainable</a:t>
+              <a:t>Point it at any listed Indian company. Get one explainable 0-100 score</a:t>
             </a:r>
             <a:endParaRPr lang="en-US" sz="1800" dirty="0"/>
           </a:p>
@@ -1781,7 +1781,7 @@
                 <a:ea typeface="Calibri" pitchFamily="34" charset="-122"/>
                 <a:cs typeface="Calibri" pitchFamily="34" charset="-120"/>
               </a:rPr>
-              <a:t>risk read in seconds - the Altman Z-Score fused with market signals:</a:t>
+              <a:t>that fuses the Altman Z-Score with the market signals others read separately:</a:t>
             </a:r>
             <a:endParaRPr lang="en-US" sz="1800" dirty="0"/>
           </a:p>
@@ -1801,7 +1801,7 @@
                 <a:ea typeface="Calibri" pitchFamily="34" charset="-122"/>
                 <a:cs typeface="Calibri" pitchFamily="34" charset="-120"/>
               </a:rPr>
-              <a:t>credit ratings, leadership changes and live news.</a:t>
+              <a:t>credit ratings, leadership, news, hiring and employee sentiment.</a:t>
             </a:r>
             <a:endParaRPr lang="en-US" sz="1800" dirty="0"/>
           </a:p>
@@ -2777,7 +2777,7 @@
                 <a:ea typeface="Calibri" pitchFamily="34" charset="-122"/>
                 <a:cs typeface="Calibri" pitchFamily="34" charset="-120"/>
               </a:rPr>
-              <a:t>SEEN IN HINDSIGHT</a:t>
+              <a:t>THE FORESIGHT FIX</a:t>
             </a:r>
             <a:endParaRPr lang="en-US" sz="1150" dirty="0"/>
           </a:p>
@@ -2816,7 +2816,7 @@
                 <a:ea typeface="Calibri" pitchFamily="34" charset="-122"/>
                 <a:cs typeface="Calibri" pitchFamily="34" charset="-120"/>
               </a:rPr>
-              <a:t>Reliance Communications</a:t>
+              <a:t>Everything public, in one score</a:t>
             </a:r>
             <a:endParaRPr lang="en-US" sz="1900" dirty="0"/>
           </a:p>
@@ -2830,8 +2830,8 @@
         </p:nvSpPr>
         <p:spPr>
           <a:xfrm>
-            <a:off x="7360920" y="3063240"/>
-            <a:ext cx="1463040" cy="1005840"/>
+            <a:off x="7360920" y="3035808"/>
+            <a:ext cx="1280160" cy="1005840"/>
           </a:xfrm>
           <a:prstGeom prst="rect">
             <a:avLst/>
@@ -2855,7 +2855,7 @@
                 <a:ea typeface="Calibri" pitchFamily="34" charset="-122"/>
                 <a:cs typeface="Calibri" pitchFamily="34" charset="-120"/>
               </a:rPr>
-              <a:t>3</a:t>
+              <a:t>6</a:t>
             </a:r>
             <a:endParaRPr lang="en-US" sz="7400" dirty="0"/>
           </a:p>
@@ -2869,8 +2869,8 @@
         </p:nvSpPr>
         <p:spPr>
           <a:xfrm>
-            <a:off x="8778240" y="3200400"/>
-            <a:ext cx="2423160" cy="914400"/>
+            <a:off x="8641080" y="3200400"/>
+            <a:ext cx="2560320" cy="914400"/>
           </a:xfrm>
           <a:prstGeom prst="rect">
             <a:avLst/>
@@ -2897,7 +2897,7 @@
                 <a:ea typeface="Calibri" pitchFamily="34" charset="-122"/>
                 <a:cs typeface="Calibri" pitchFamily="34" charset="-120"/>
               </a:rPr>
-              <a:t>years</a:t>
+              <a:t>signals</a:t>
             </a:r>
             <a:pPr indent="0" marL="0">
               <a:lnSpc>
@@ -2923,7 +2923,7 @@
                 <a:ea typeface="Calibri" pitchFamily="34" charset="-122"/>
                 <a:cs typeface="Calibri" pitchFamily="34" charset="-120"/>
               </a:rPr>
-              <a:t>of warning before</a:t>
+              <a:t>fused into one</a:t>
             </a:r>
             <a:endParaRPr lang="en-US" sz="2000" dirty="0"/>
           </a:p>
@@ -2943,7 +2943,7 @@
                 <a:ea typeface="Calibri" pitchFamily="34" charset="-122"/>
                 <a:cs typeface="Calibri" pitchFamily="34" charset="-120"/>
               </a:rPr>
-              <a:t>insolvency</a:t>
+              <a:t>0-100 read</a:t>
             </a:r>
             <a:endParaRPr lang="en-US" sz="2000" dirty="0"/>
           </a:p>
@@ -2951,206 +2951,14 @@
       </p:sp>
       <p:sp>
         <p:nvSpPr>
-          <p:cNvPr id="24" name="Shape 19"/>
-          <p:cNvSpPr/>
-          <p:nvPr/>
-        </p:nvSpPr>
-        <p:spPr>
-          <a:xfrm>
-            <a:off x="7452360" y="4526280"/>
-            <a:ext cx="777240" cy="182880"/>
-          </a:xfrm>
-          <a:prstGeom prst="line">
-            <a:avLst/>
-          </a:prstGeom>
-          <a:noFill/>
-          <a:ln w="31750">
-            <a:solidFill>
-              <a:srgbClr val="EF4444"/>
-            </a:solidFill>
-            <a:prstDash val="solid"/>
-          </a:ln>
-        </p:spPr>
-      </p:sp>
-      <p:sp>
-        <p:nvSpPr>
-          <p:cNvPr id="25" name="Shape 20"/>
-          <p:cNvSpPr/>
-          <p:nvPr/>
-        </p:nvSpPr>
-        <p:spPr>
-          <a:xfrm>
-            <a:off x="8229600" y="4709160"/>
-            <a:ext cx="777240" cy="182880"/>
-          </a:xfrm>
-          <a:prstGeom prst="line">
-            <a:avLst/>
-          </a:prstGeom>
-          <a:noFill/>
-          <a:ln w="31750">
-            <a:solidFill>
-              <a:srgbClr val="EF4444"/>
-            </a:solidFill>
-            <a:prstDash val="solid"/>
-          </a:ln>
-        </p:spPr>
-      </p:sp>
-      <p:sp>
-        <p:nvSpPr>
-          <p:cNvPr id="26" name="Shape 21"/>
-          <p:cNvSpPr/>
-          <p:nvPr/>
-        </p:nvSpPr>
-        <p:spPr>
-          <a:xfrm>
-            <a:off x="9006840" y="4892040"/>
-            <a:ext cx="777240" cy="320040"/>
-          </a:xfrm>
-          <a:prstGeom prst="line">
-            <a:avLst/>
-          </a:prstGeom>
-          <a:noFill/>
-          <a:ln w="31750">
-            <a:solidFill>
-              <a:srgbClr val="EF4444"/>
-            </a:solidFill>
-            <a:prstDash val="solid"/>
-          </a:ln>
-        </p:spPr>
-      </p:sp>
-      <p:sp>
-        <p:nvSpPr>
-          <p:cNvPr id="27" name="Shape 22"/>
-          <p:cNvSpPr/>
-          <p:nvPr/>
-        </p:nvSpPr>
-        <p:spPr>
-          <a:xfrm>
-            <a:off x="9784080" y="5212080"/>
-            <a:ext cx="868680" cy="91440"/>
-          </a:xfrm>
-          <a:prstGeom prst="line">
-            <a:avLst/>
-          </a:prstGeom>
-          <a:noFill/>
-          <a:ln w="31750">
-            <a:solidFill>
-              <a:srgbClr val="EF4444"/>
-            </a:solidFill>
-            <a:prstDash val="solid"/>
-          </a:ln>
-        </p:spPr>
-      </p:sp>
-      <p:sp>
-        <p:nvSpPr>
-          <p:cNvPr id="28" name="Shape 23"/>
-          <p:cNvSpPr/>
-          <p:nvPr/>
-        </p:nvSpPr>
-        <p:spPr>
-          <a:xfrm>
-            <a:off x="7402068" y="4475988"/>
-            <a:ext cx="100584" cy="100584"/>
-          </a:xfrm>
-          <a:prstGeom prst="ellipse">
-            <a:avLst/>
-          </a:prstGeom>
-          <a:solidFill>
-            <a:srgbClr val="EF4444"/>
-          </a:solidFill>
-          <a:ln/>
-        </p:spPr>
-      </p:sp>
-      <p:sp>
-        <p:nvSpPr>
-          <p:cNvPr id="29" name="Shape 24"/>
-          <p:cNvSpPr/>
-          <p:nvPr/>
-        </p:nvSpPr>
-        <p:spPr>
-          <a:xfrm>
-            <a:off x="8179308" y="4658868"/>
-            <a:ext cx="100584" cy="100584"/>
-          </a:xfrm>
-          <a:prstGeom prst="ellipse">
-            <a:avLst/>
-          </a:prstGeom>
-          <a:solidFill>
-            <a:srgbClr val="F59E0B"/>
-          </a:solidFill>
-          <a:ln/>
-        </p:spPr>
-      </p:sp>
-      <p:sp>
-        <p:nvSpPr>
-          <p:cNvPr id="30" name="Shape 25"/>
-          <p:cNvSpPr/>
-          <p:nvPr/>
-        </p:nvSpPr>
-        <p:spPr>
-          <a:xfrm>
-            <a:off x="8956548" y="4841748"/>
-            <a:ext cx="100584" cy="100584"/>
-          </a:xfrm>
-          <a:prstGeom prst="ellipse">
-            <a:avLst/>
-          </a:prstGeom>
-          <a:solidFill>
-            <a:srgbClr val="EF4444"/>
-          </a:solidFill>
-          <a:ln/>
-        </p:spPr>
-      </p:sp>
-      <p:sp>
-        <p:nvSpPr>
-          <p:cNvPr id="31" name="Shape 26"/>
-          <p:cNvSpPr/>
-          <p:nvPr/>
-        </p:nvSpPr>
-        <p:spPr>
-          <a:xfrm>
-            <a:off x="9733788" y="5161788"/>
-            <a:ext cx="100584" cy="100584"/>
-          </a:xfrm>
-          <a:prstGeom prst="ellipse">
-            <a:avLst/>
-          </a:prstGeom>
-          <a:solidFill>
-            <a:srgbClr val="EF4444"/>
-          </a:solidFill>
-          <a:ln/>
-        </p:spPr>
-      </p:sp>
-      <p:sp>
-        <p:nvSpPr>
-          <p:cNvPr id="32" name="Shape 27"/>
-          <p:cNvSpPr/>
-          <p:nvPr/>
-        </p:nvSpPr>
-        <p:spPr>
-          <a:xfrm>
-            <a:off x="10602468" y="5253228"/>
-            <a:ext cx="100584" cy="100584"/>
-          </a:xfrm>
-          <a:prstGeom prst="ellipse">
-            <a:avLst/>
-          </a:prstGeom>
-          <a:solidFill>
-            <a:srgbClr val="EF4444"/>
-          </a:solidFill>
-          <a:ln/>
-        </p:spPr>
-      </p:sp>
-      <p:sp>
-        <p:nvSpPr>
-          <p:cNvPr id="33" name="Text 28"/>
-          <p:cNvSpPr/>
-          <p:nvPr/>
-        </p:nvSpPr>
-        <p:spPr>
-          <a:xfrm>
-            <a:off x="7406640" y="5504688"/>
-            <a:ext cx="3703320" cy="320040"/>
+          <p:cNvPr id="24" name="Text 19"/>
+          <p:cNvSpPr/>
+          <p:nvPr/>
+        </p:nvSpPr>
+        <p:spPr>
+          <a:xfrm>
+            <a:off x="7406640" y="4526280"/>
+            <a:ext cx="3703320" cy="640080"/>
           </a:xfrm>
           <a:prstGeom prst="rect">
             <a:avLst/>
@@ -3163,6 +2971,48 @@
           <a:lstStyle/>
           <a:p>
             <a:pPr indent="0" marL="0">
+              <a:lnSpc>
+                <a:spcPct val="110000"/>
+              </a:lnSpc>
+              <a:buNone/>
+            </a:pPr>
+            <a:r>
+              <a:rPr lang="en-US" sz="1250" dirty="0">
+                <a:solidFill>
+                  <a:srgbClr val="FFFFFF"/>
+                </a:solidFill>
+                <a:latin typeface="Calibri" pitchFamily="34" charset="0"/>
+                <a:ea typeface="Calibri" pitchFamily="34" charset="-122"/>
+                <a:cs typeface="Calibri" pitchFamily="34" charset="-120"/>
+              </a:rPr>
+              <a:t>Financials  .  credit ratings  .  leadership  .  news  .  hiring  .  employee sentiment</a:t>
+            </a:r>
+            <a:endParaRPr lang="en-US" sz="1250" dirty="0"/>
+          </a:p>
+        </p:txBody>
+      </p:sp>
+      <p:sp>
+        <p:nvSpPr>
+          <p:cNvPr id="25" name="Text 20"/>
+          <p:cNvSpPr/>
+          <p:nvPr/>
+        </p:nvSpPr>
+        <p:spPr>
+          <a:xfrm>
+            <a:off x="7406640" y="5440680"/>
+            <a:ext cx="3703320" cy="365760"/>
+          </a:xfrm>
+          <a:prstGeom prst="rect">
+            <a:avLst/>
+          </a:prstGeom>
+          <a:noFill/>
+          <a:ln/>
+        </p:spPr>
+        <p:txBody>
+          <a:bodyPr wrap="square" rtlCol="0" anchor="ctr"/>
+          <a:lstStyle/>
+          <a:p>
+            <a:pPr indent="0" marL="0">
               <a:buNone/>
             </a:pPr>
             <a:r>
@@ -3174,7 +3024,7 @@
                 <a:ea typeface="Calibri" pitchFamily="34" charset="-122"/>
                 <a:cs typeface="Calibri" pitchFamily="34" charset="-120"/>
               </a:rPr>
-              <a:t>Altman Z entered distress in FY2016. Filed for insolvency in 2019.</a:t>
+              <a:t>Read together and explained - not scattered across ten browser tabs.</a:t>
             </a:r>
             <a:endParaRPr lang="en-US" sz="1150" dirty="0"/>
           </a:p>
@@ -4500,7 +4350,7 @@
                 <a:ea typeface="Calibri" pitchFamily="34" charset="-122"/>
                 <a:cs typeface="Calibri" pitchFamily="34" charset="-120"/>
               </a:rPr>
-              <a:t>Would it have warned you? </a:t>
+              <a:t>One </a:t>
             </a:r>
             <a:pPr indent="0" marL="0">
               <a:buNone/>
@@ -4514,7 +4364,21 @@
                 <a:ea typeface="Calibri" pitchFamily="34" charset="-122"/>
                 <a:cs typeface="Calibri" pitchFamily="34" charset="-120"/>
               </a:rPr>
-              <a:t>Years early.</a:t>
+              <a:t>comprehensive</a:t>
+            </a:r>
+            <a:pPr indent="0" marL="0">
+              <a:buNone/>
+            </a:pPr>
+            <a:r>
+              <a:rPr lang="en-US" sz="3300" b="1" dirty="0">
+                <a:solidFill>
+                  <a:srgbClr val="FFFFFF"/>
+                </a:solidFill>
+                <a:latin typeface="Calibri" pitchFamily="34" charset="0"/>
+                <a:ea typeface="Calibri" pitchFamily="34" charset="-122"/>
+                <a:cs typeface="Calibri" pitchFamily="34" charset="-120"/>
+              </a:rPr>
+              <a:t> score, on real history</a:t>
             </a:r>
             <a:endParaRPr lang="en-US" sz="3300" dirty="0"/>
           </a:p>
@@ -4553,7 +4417,7 @@
                 <a:ea typeface="Calibri" pitchFamily="34" charset="-122"/>
                 <a:cs typeface="Calibri" pitchFamily="34" charset="-120"/>
               </a:rPr>
-              <a:t>Five real collapses, replayed - the Altman Z merged with the signals that led the accounts.</a:t>
+              <a:t>Altman reads the annual filings. ForesightAI reads the same financials plus the credit ratings, leadership, news and the market.</a:t>
             </a:r>
             <a:endParaRPr lang="en-US" sz="1550" dirty="0"/>
           </a:p>
@@ -4568,7 +4432,7 @@
         <p:spPr>
           <a:xfrm>
             <a:off x="777240" y="1874520"/>
-            <a:ext cx="4023360" cy="731520"/>
+            <a:ext cx="4023360" cy="685800"/>
           </a:xfrm>
           <a:prstGeom prst="rect">
             <a:avLst/>
@@ -4584,7 +4448,7 @@
               <a:buNone/>
             </a:pPr>
             <a:r>
-              <a:rPr lang="en-US" sz="4400" b="1" dirty="0">
+              <a:rPr lang="en-US" sz="4000" b="1" dirty="0">
                 <a:solidFill>
                   <a:srgbClr val="F59E0B"/>
                 </a:solidFill>
@@ -4592,9 +4456,9 @@
                 <a:ea typeface="Calibri" pitchFamily="34" charset="-122"/>
                 <a:cs typeface="Calibri" pitchFamily="34" charset="-120"/>
               </a:rPr>
-              <a:t>3 years</a:t>
-            </a:r>
-            <a:endParaRPr lang="en-US" sz="4400" dirty="0"/>
+              <a:t>6 inputs</a:t>
+            </a:r>
+            <a:endParaRPr lang="en-US" sz="4000" dirty="0"/>
           </a:p>
         </p:txBody>
       </p:sp>
@@ -4606,8 +4470,8 @@
         </p:nvSpPr>
         <p:spPr>
           <a:xfrm>
-            <a:off x="795528" y="2606040"/>
-            <a:ext cx="3931920" cy="502920"/>
+            <a:off x="795528" y="2578608"/>
+            <a:ext cx="3977640" cy="822960"/>
           </a:xfrm>
           <a:prstGeom prst="rect">
             <a:avLst/>
@@ -4620,10 +4484,13 @@
           <a:lstStyle/>
           <a:p>
             <a:pPr indent="0" marL="0">
-              <a:buNone/>
-            </a:pPr>
-            <a:r>
-              <a:rPr lang="en-US" sz="1550" b="1" dirty="0">
+              <a:lnSpc>
+                <a:spcPct val="110000"/>
+              </a:lnSpc>
+              <a:buNone/>
+            </a:pPr>
+            <a:r>
+              <a:rPr lang="en-US" sz="1300" dirty="0">
                 <a:solidFill>
                   <a:srgbClr val="FFFFFF"/>
                 </a:solidFill>
@@ -4631,9 +4498,9 @@
                 <a:ea typeface="Calibri" pitchFamily="34" charset="-122"/>
                 <a:cs typeface="Calibri" pitchFamily="34" charset="-120"/>
               </a:rPr>
-              <a:t>of early warning on Reliance Communications.</a:t>
-            </a:r>
-            <a:endParaRPr lang="en-US" sz="1550" dirty="0"/>
+              <a:t>financials, credit ratings, leadership, news, hiring and employee sentiment - fused into one 0-100 score.</a:t>
+            </a:r>
+            <a:endParaRPr lang="en-US" sz="1300" dirty="0"/>
           </a:p>
         </p:txBody>
       </p:sp>
@@ -4645,8 +4512,8 @@
         </p:nvSpPr>
         <p:spPr>
           <a:xfrm>
-            <a:off x="795528" y="3108960"/>
-            <a:ext cx="3977640" cy="1234440"/>
+            <a:off x="795528" y="3401568"/>
+            <a:ext cx="3977640" cy="1051560"/>
           </a:xfrm>
           <a:prstGeom prst="rect">
             <a:avLst/>
@@ -4665,7 +4532,7 @@
               <a:buNone/>
             </a:pPr>
             <a:r>
-              <a:rPr lang="en-US" sz="1250" dirty="0">
+              <a:rPr lang="en-US" sz="1200" dirty="0">
                 <a:solidFill>
                   <a:srgbClr val="94A3B8"/>
                 </a:solidFill>
@@ -4673,9 +4540,9 @@
                 <a:ea typeface="Calibri" pitchFamily="34" charset="-122"/>
                 <a:cs typeface="Calibri" pitchFamily="34" charset="-120"/>
               </a:rPr>
-              <a:t>Altman Z slid into distress by FY2016 - and the rating cut, the Ericsson insolvency plea and the news cascade all pointed the same way, three years before the 2019 filing.</a:t>
-            </a:r>
-            <a:endParaRPr lang="en-US" sz="1250" dirty="0"/>
+              <a:t>Altman is the financial leg. ForesightAI adds the market signals, so the score reflects the full public picture - and moves the day any of them do.</a:t>
+            </a:r>
+            <a:endParaRPr lang="en-US" sz="1200" dirty="0"/>
           </a:p>
         </p:txBody>
       </p:sp>
@@ -4687,12 +4554,12 @@
         </p:nvSpPr>
         <p:spPr>
           <a:xfrm>
-            <a:off x="777240" y="4526280"/>
-            <a:ext cx="3977640" cy="1572768"/>
+            <a:off x="777240" y="4553712"/>
+            <a:ext cx="3977640" cy="1554480"/>
           </a:xfrm>
           <a:prstGeom prst="roundRect">
             <a:avLst>
-              <a:gd name="adj" fmla="val 5233"/>
+              <a:gd name="adj" fmla="val 5294"/>
             </a:avLst>
           </a:prstGeom>
           <a:solidFill>
@@ -4714,7 +4581,7 @@
         </p:nvSpPr>
         <p:spPr>
           <a:xfrm>
-            <a:off x="987552" y="4645152"/>
+            <a:off x="987552" y="4663440"/>
             <a:ext cx="3566160" cy="256032"/>
           </a:xfrm>
           <a:prstGeom prst="rect">
@@ -4739,7 +4606,7 @@
                 <a:ea typeface="Calibri" pitchFamily="34" charset="-122"/>
                 <a:cs typeface="Calibri" pitchFamily="34" charset="-120"/>
               </a:rPr>
-              <a:t>FIVE CASES, FIVE DYNAMICS</a:t>
+              <a:t>FIVE CASES, FIVE SECTORS</a:t>
             </a:r>
             <a:endParaRPr lang="en-US" sz="1050" dirty="0"/>
           </a:p>
@@ -4753,7 +4620,7 @@
         </p:nvSpPr>
         <p:spPr>
           <a:xfrm>
-            <a:off x="987552" y="4901184"/>
+            <a:off x="987552" y="4919472"/>
             <a:ext cx="3566160" cy="1133856"/>
           </a:xfrm>
           <a:prstGeom prst="rect">
@@ -4781,7 +4648,7 @@
                 <a:ea typeface="Calibri" pitchFamily="34" charset="-122"/>
                 <a:cs typeface="Calibri" pitchFamily="34" charset="-120"/>
               </a:rPr>
-              <a:t>RCom &amp; Suzlon </a:t>
+              <a:t>Unitech </a:t>
             </a:r>
             <a:pPr indent="0" marL="0">
               <a:lnSpc>
@@ -4798,7 +4665,7 @@
                 <a:ea typeface="Calibri" pitchFamily="34" charset="-122"/>
                 <a:cs typeface="Calibri" pitchFamily="34" charset="-120"/>
               </a:rPr>
-              <a:t>- Altman leads (Suzlon even recovers).  </a:t>
+              <a:t>(real estate), </a:t>
             </a:r>
             <a:pPr indent="0" marL="0">
               <a:lnSpc>
@@ -4815,7 +4682,7 @@
                 <a:ea typeface="Calibri" pitchFamily="34" charset="-122"/>
                 <a:cs typeface="Calibri" pitchFamily="34" charset="-120"/>
               </a:rPr>
-              <a:t>DHFL &amp; IL&amp;FS </a:t>
+              <a:t>Future Retail </a:t>
             </a:r>
             <a:pPr indent="0" marL="0">
               <a:lnSpc>
@@ -4832,7 +4699,7 @@
                 <a:ea typeface="Calibri" pitchFamily="34" charset="-122"/>
                 <a:cs typeface="Calibri" pitchFamily="34" charset="-120"/>
               </a:rPr>
-              <a:t>- NBFCs where Altman is blind; IL&amp;FS was rated AAA and only the signals led.  </a:t>
+              <a:t>(retail), </a:t>
             </a:r>
             <a:pPr indent="0" marL="0">
               <a:lnSpc>
@@ -4849,7 +4716,7 @@
                 <a:ea typeface="Calibri" pitchFamily="34" charset="-122"/>
                 <a:cs typeface="Calibri" pitchFamily="34" charset="-120"/>
               </a:rPr>
-              <a:t>Manpasand </a:t>
+              <a:t>Reliance Communications </a:t>
             </a:r>
             <a:pPr indent="0" marL="0">
               <a:lnSpc>
@@ -4866,7 +4733,75 @@
                 <a:ea typeface="Calibri" pitchFamily="34" charset="-122"/>
                 <a:cs typeface="Calibri" pitchFamily="34" charset="-120"/>
               </a:rPr>
-              <a:t>- an auditor exit, 12 months early.</a:t>
+              <a:t>(telecom), </a:t>
+            </a:r>
+            <a:pPr indent="0" marL="0">
+              <a:lnSpc>
+                <a:spcPct val="103000"/>
+              </a:lnSpc>
+              <a:buNone/>
+            </a:pPr>
+            <a:r>
+              <a:rPr lang="en-US" sz="1050" b="1" dirty="0">
+                <a:solidFill>
+                  <a:srgbClr val="FFFFFF"/>
+                </a:solidFill>
+                <a:latin typeface="Calibri" pitchFamily="34" charset="0"/>
+                <a:ea typeface="Calibri" pitchFamily="34" charset="-122"/>
+                <a:cs typeface="Calibri" pitchFamily="34" charset="-120"/>
+              </a:rPr>
+              <a:t>Jaiprakash Associates </a:t>
+            </a:r>
+            <a:pPr indent="0" marL="0">
+              <a:lnSpc>
+                <a:spcPct val="103000"/>
+              </a:lnSpc>
+              <a:buNone/>
+            </a:pPr>
+            <a:r>
+              <a:rPr lang="en-US" sz="1050" dirty="0">
+                <a:solidFill>
+                  <a:srgbClr val="94A3B8"/>
+                </a:solidFill>
+                <a:latin typeface="Calibri" pitchFamily="34" charset="0"/>
+                <a:ea typeface="Calibri" pitchFamily="34" charset="-122"/>
+                <a:cs typeface="Calibri" pitchFamily="34" charset="-120"/>
+              </a:rPr>
+              <a:t>(infrastructure), </a:t>
+            </a:r>
+            <a:pPr indent="0" marL="0">
+              <a:lnSpc>
+                <a:spcPct val="103000"/>
+              </a:lnSpc>
+              <a:buNone/>
+            </a:pPr>
+            <a:r>
+              <a:rPr lang="en-US" sz="1050" b="1" dirty="0">
+                <a:solidFill>
+                  <a:srgbClr val="FFFFFF"/>
+                </a:solidFill>
+                <a:latin typeface="Calibri" pitchFamily="34" charset="0"/>
+                <a:ea typeface="Calibri" pitchFamily="34" charset="-122"/>
+                <a:cs typeface="Calibri" pitchFamily="34" charset="-120"/>
+              </a:rPr>
+              <a:t>Suzlon </a:t>
+            </a:r>
+            <a:pPr indent="0" marL="0">
+              <a:lnSpc>
+                <a:spcPct val="103000"/>
+              </a:lnSpc>
+              <a:buNone/>
+            </a:pPr>
+            <a:r>
+              <a:rPr lang="en-US" sz="1050" dirty="0">
+                <a:solidFill>
+                  <a:srgbClr val="94A3B8"/>
+                </a:solidFill>
+                <a:latin typeface="Calibri" pitchFamily="34" charset="0"/>
+                <a:ea typeface="Calibri" pitchFamily="34" charset="-122"/>
+                <a:cs typeface="Calibri" pitchFamily="34" charset="-120"/>
+              </a:rPr>
+              <a:t>(renewables - a recovery). Real financials, real events.</a:t>
             </a:r>
             <a:endParaRPr lang="en-US" sz="1050" dirty="0"/>
           </a:p>
@@ -4874,42 +4809,59 @@
       </p:sp>
       <p:sp>
         <p:nvSpPr>
-          <p:cNvPr id="10" name="Shape 8"/>
+          <p:cNvPr id="10" name="Text 8"/>
+          <p:cNvSpPr/>
+          <p:nvPr/>
+        </p:nvSpPr>
+        <p:spPr>
+          <a:xfrm>
+            <a:off x="5349240" y="1664208"/>
+            <a:ext cx="6263640" cy="228600"/>
+          </a:xfrm>
+          <a:prstGeom prst="rect">
+            <a:avLst/>
+          </a:prstGeom>
+          <a:noFill/>
+          <a:ln/>
+        </p:spPr>
+        <p:txBody>
+          <a:bodyPr wrap="square" rtlCol="0" anchor="ctr"/>
+          <a:lstStyle/>
+          <a:p>
+            <a:pPr indent="0" marL="0">
+              <a:buNone/>
+            </a:pPr>
+            <a:r>
+              <a:rPr lang="en-US" sz="1100" dirty="0">
+                <a:solidFill>
+                  <a:srgbClr val="94A3B8"/>
+                </a:solidFill>
+                <a:latin typeface="Calibri" pitchFamily="34" charset="0"/>
+                <a:ea typeface="Calibri" pitchFamily="34" charset="-122"/>
+                <a:cs typeface="Calibri" pitchFamily="34" charset="-120"/>
+              </a:rPr>
+              <a:t>Example - Reliance Communications (telecom)</a:t>
+            </a:r>
+            <a:endParaRPr lang="en-US" sz="1100" dirty="0"/>
+          </a:p>
+        </p:txBody>
+      </p:sp>
+      <p:sp>
+        <p:nvSpPr>
+          <p:cNvPr id="11" name="Shape 9"/>
           <p:cNvSpPr/>
           <p:nvPr/>
         </p:nvSpPr>
         <p:spPr>
           <a:xfrm>
             <a:off x="5349240" y="1965960"/>
-            <a:ext cx="6263640" cy="243840"/>
+            <a:ext cx="6263640" cy="1207008"/>
           </a:xfrm>
           <a:prstGeom prst="rect">
             <a:avLst/>
           </a:prstGeom>
           <a:solidFill>
-            <a:srgbClr val="22C55E">
-              <a:alpha val="12000"/>
-            </a:srgbClr>
-          </a:solidFill>
-          <a:ln/>
-        </p:spPr>
-      </p:sp>
-      <p:sp>
-        <p:nvSpPr>
-          <p:cNvPr id="11" name="Shape 9"/>
-          <p:cNvSpPr/>
-          <p:nvPr/>
-        </p:nvSpPr>
-        <p:spPr>
-          <a:xfrm>
-            <a:off x="5349240" y="2209800"/>
-            <a:ext cx="6263640" cy="914400"/>
-          </a:xfrm>
-          <a:prstGeom prst="rect">
-            <a:avLst/>
-          </a:prstGeom>
-          <a:solidFill>
-            <a:srgbClr val="94A3B8">
+            <a:srgbClr val="EF4444">
               <a:alpha val="10000"/>
             </a:srgbClr>
           </a:solidFill>
@@ -4924,15 +4876,15 @@
         </p:nvSpPr>
         <p:spPr>
           <a:xfrm>
-            <a:off x="5349240" y="3124200"/>
-            <a:ext cx="6263640" cy="2865120"/>
+            <a:off x="5349240" y="4782312"/>
+            <a:ext cx="6263640" cy="1207008"/>
           </a:xfrm>
           <a:prstGeom prst="rect">
             <a:avLst/>
           </a:prstGeom>
           <a:solidFill>
-            <a:srgbClr val="EF4444">
-              <a:alpha val="16000"/>
+            <a:srgbClr val="22C55E">
+              <a:alpha val="10000"/>
             </a:srgbClr>
           </a:solidFill>
           <a:ln/>
@@ -4940,53 +4892,7 @@
       </p:sp>
       <p:sp>
         <p:nvSpPr>
-          <p:cNvPr id="13" name="Shape 11"/>
-          <p:cNvSpPr/>
-          <p:nvPr/>
-        </p:nvSpPr>
-        <p:spPr>
-          <a:xfrm>
-            <a:off x="5349240" y="2209800"/>
-            <a:ext cx="6263640" cy="914"/>
-          </a:xfrm>
-          <a:prstGeom prst="line">
-            <a:avLst/>
-          </a:prstGeom>
-          <a:noFill/>
-          <a:ln w="12700">
-            <a:solidFill>
-              <a:srgbClr val="22C55E"/>
-            </a:solidFill>
-            <a:prstDash val="solid"/>
-          </a:ln>
-        </p:spPr>
-      </p:sp>
-      <p:sp>
-        <p:nvSpPr>
-          <p:cNvPr id="14" name="Shape 12"/>
-          <p:cNvSpPr/>
-          <p:nvPr/>
-        </p:nvSpPr>
-        <p:spPr>
-          <a:xfrm>
-            <a:off x="5349240" y="3124200"/>
-            <a:ext cx="6263640" cy="914"/>
-          </a:xfrm>
-          <a:prstGeom prst="line">
-            <a:avLst/>
-          </a:prstGeom>
-          <a:noFill/>
-          <a:ln w="12700">
-            <a:solidFill>
-              <a:srgbClr val="EF4444"/>
-            </a:solidFill>
-            <a:prstDash val="solid"/>
-          </a:ln>
-        </p:spPr>
-      </p:sp>
-      <p:sp>
-        <p:nvSpPr>
-          <p:cNvPr id="15" name="Text 13"/>
+          <p:cNvPr id="13" name="Text 11"/>
           <p:cNvSpPr/>
           <p:nvPr/>
         </p:nvSpPr>
@@ -5005,19 +4911,58 @@
           <a:bodyPr wrap="square" rtlCol="0" anchor="ctr"/>
           <a:lstStyle/>
           <a:p>
-            <a:pPr algn="l" indent="0" marL="0">
+            <a:pPr indent="0" marL="0">
               <a:buNone/>
             </a:pPr>
             <a:r>
               <a:rPr lang="en-US" sz="1000" b="1" dirty="0">
                 <a:solidFill>
+                  <a:srgbClr val="EF4444"/>
+                </a:solidFill>
+                <a:latin typeface="Calibri" pitchFamily="34" charset="0"/>
+                <a:ea typeface="Calibri" pitchFamily="34" charset="-122"/>
+                <a:cs typeface="Calibri" pitchFamily="34" charset="-120"/>
+              </a:rPr>
+              <a:t>HIGH RISK</a:t>
+            </a:r>
+            <a:endParaRPr lang="en-US" sz="1000" dirty="0"/>
+          </a:p>
+        </p:txBody>
+      </p:sp>
+      <p:sp>
+        <p:nvSpPr>
+          <p:cNvPr id="14" name="Text 12"/>
+          <p:cNvSpPr/>
+          <p:nvPr/>
+        </p:nvSpPr>
+        <p:spPr>
+          <a:xfrm>
+            <a:off x="5458968" y="5733288"/>
+            <a:ext cx="1828800" cy="228600"/>
+          </a:xfrm>
+          <a:prstGeom prst="rect">
+            <a:avLst/>
+          </a:prstGeom>
+          <a:noFill/>
+          <a:ln/>
+        </p:spPr>
+        <p:txBody>
+          <a:bodyPr wrap="square" rtlCol="0" anchor="ctr"/>
+          <a:lstStyle/>
+          <a:p>
+            <a:pPr indent="0" marL="0">
+              <a:buNone/>
+            </a:pPr>
+            <a:r>
+              <a:rPr lang="en-US" sz="1000" b="1" dirty="0">
+                <a:solidFill>
                   <a:srgbClr val="22C55E"/>
                 </a:solidFill>
                 <a:latin typeface="Calibri" pitchFamily="34" charset="0"/>
                 <a:ea typeface="Calibri" pitchFamily="34" charset="-122"/>
                 <a:cs typeface="Calibri" pitchFamily="34" charset="-120"/>
               </a:rPr>
-              <a:t>SAFE  Z'' &gt; 2.6</a:t>
+              <a:t>HEALTHY</a:t>
             </a:r>
             <a:endParaRPr lang="en-US" sz="1000" dirty="0"/>
           </a:p>
@@ -5025,46 +4970,7 @@
       </p:sp>
       <p:sp>
         <p:nvSpPr>
-          <p:cNvPr id="16" name="Text 14"/>
-          <p:cNvSpPr/>
-          <p:nvPr/>
-        </p:nvSpPr>
-        <p:spPr>
-          <a:xfrm>
-            <a:off x="5458968" y="3179064"/>
-            <a:ext cx="1828800" cy="228600"/>
-          </a:xfrm>
-          <a:prstGeom prst="rect">
-            <a:avLst/>
-          </a:prstGeom>
-          <a:noFill/>
-          <a:ln/>
-        </p:spPr>
-        <p:txBody>
-          <a:bodyPr wrap="square" rtlCol="0" anchor="ctr"/>
-          <a:lstStyle/>
-          <a:p>
-            <a:pPr algn="l" indent="0" marL="0">
-              <a:buNone/>
-            </a:pPr>
-            <a:r>
-              <a:rPr lang="en-US" sz="1000" b="1" dirty="0">
-                <a:solidFill>
-                  <a:srgbClr val="EF4444"/>
-                </a:solidFill>
-                <a:latin typeface="Calibri" pitchFamily="34" charset="0"/>
-                <a:ea typeface="Calibri" pitchFamily="34" charset="-122"/>
-                <a:cs typeface="Calibri" pitchFamily="34" charset="-120"/>
-              </a:rPr>
-              <a:t>DISTRESS  Z'' &lt; 1.1</a:t>
-            </a:r>
-            <a:endParaRPr lang="en-US" sz="1000" dirty="0"/>
-          </a:p>
-        </p:txBody>
-      </p:sp>
-      <p:sp>
-        <p:nvSpPr>
-          <p:cNvPr id="17" name="Shape 15"/>
+          <p:cNvPr id="15" name="Shape 13"/>
           <p:cNvSpPr/>
           <p:nvPr/>
         </p:nvSpPr>
@@ -5087,7 +4993,7 @@
       </p:sp>
       <p:sp>
         <p:nvSpPr>
-          <p:cNvPr id="18" name="Shape 16"/>
+          <p:cNvPr id="16" name="Shape 14"/>
           <p:cNvSpPr/>
           <p:nvPr/>
         </p:nvSpPr>
@@ -5100,7 +5006,631 @@
             <a:avLst/>
           </a:prstGeom>
           <a:noFill/>
+          <a:ln w="15240">
+            <a:solidFill>
+              <a:srgbClr val="94A3B8"/>
+            </a:solidFill>
+            <a:prstDash val="solid"/>
+          </a:ln>
+        </p:spPr>
+      </p:sp>
+      <p:sp>
+        <p:nvSpPr>
+          <p:cNvPr id="17" name="Shape 15"/>
+          <p:cNvSpPr/>
+          <p:nvPr/>
+        </p:nvSpPr>
+        <p:spPr>
+          <a:xfrm>
+            <a:off x="11612880" y="2221992"/>
+            <a:ext cx="914" cy="128016"/>
+          </a:xfrm>
+          <a:prstGeom prst="line">
+            <a:avLst/>
+          </a:prstGeom>
+          <a:noFill/>
+          <a:ln w="15240">
+            <a:solidFill>
+              <a:srgbClr val="94A3B8"/>
+            </a:solidFill>
+            <a:prstDash val="solid"/>
+          </a:ln>
+        </p:spPr>
+      </p:sp>
+      <p:sp>
+        <p:nvSpPr>
+          <p:cNvPr id="18" name="Shape 16"/>
+          <p:cNvSpPr/>
+          <p:nvPr/>
+        </p:nvSpPr>
+        <p:spPr>
+          <a:xfrm>
+            <a:off x="11612880" y="2478024"/>
+            <a:ext cx="914" cy="128016"/>
+          </a:xfrm>
+          <a:prstGeom prst="line">
+            <a:avLst/>
+          </a:prstGeom>
+          <a:noFill/>
+          <a:ln w="15240">
+            <a:solidFill>
+              <a:srgbClr val="94A3B8"/>
+            </a:solidFill>
+            <a:prstDash val="solid"/>
+          </a:ln>
+        </p:spPr>
+      </p:sp>
+      <p:sp>
+        <p:nvSpPr>
+          <p:cNvPr id="19" name="Shape 17"/>
+          <p:cNvSpPr/>
+          <p:nvPr/>
+        </p:nvSpPr>
+        <p:spPr>
+          <a:xfrm>
+            <a:off x="11612880" y="2734056"/>
+            <a:ext cx="914" cy="128016"/>
+          </a:xfrm>
+          <a:prstGeom prst="line">
+            <a:avLst/>
+          </a:prstGeom>
+          <a:noFill/>
+          <a:ln w="15240">
+            <a:solidFill>
+              <a:srgbClr val="94A3B8"/>
+            </a:solidFill>
+            <a:prstDash val="solid"/>
+          </a:ln>
+        </p:spPr>
+      </p:sp>
+      <p:sp>
+        <p:nvSpPr>
+          <p:cNvPr id="20" name="Shape 18"/>
+          <p:cNvSpPr/>
+          <p:nvPr/>
+        </p:nvSpPr>
+        <p:spPr>
+          <a:xfrm>
+            <a:off x="11612880" y="2990088"/>
+            <a:ext cx="914" cy="128016"/>
+          </a:xfrm>
+          <a:prstGeom prst="line">
+            <a:avLst/>
+          </a:prstGeom>
+          <a:noFill/>
+          <a:ln w="15240">
+            <a:solidFill>
+              <a:srgbClr val="94A3B8"/>
+            </a:solidFill>
+            <a:prstDash val="solid"/>
+          </a:ln>
+        </p:spPr>
+      </p:sp>
+      <p:sp>
+        <p:nvSpPr>
+          <p:cNvPr id="21" name="Shape 19"/>
+          <p:cNvSpPr/>
+          <p:nvPr/>
+        </p:nvSpPr>
+        <p:spPr>
+          <a:xfrm>
+            <a:off x="11612880" y="3246120"/>
+            <a:ext cx="914" cy="128016"/>
+          </a:xfrm>
+          <a:prstGeom prst="line">
+            <a:avLst/>
+          </a:prstGeom>
+          <a:noFill/>
+          <a:ln w="15240">
+            <a:solidFill>
+              <a:srgbClr val="94A3B8"/>
+            </a:solidFill>
+            <a:prstDash val="solid"/>
+          </a:ln>
+        </p:spPr>
+      </p:sp>
+      <p:sp>
+        <p:nvSpPr>
+          <p:cNvPr id="22" name="Shape 20"/>
+          <p:cNvSpPr/>
+          <p:nvPr/>
+        </p:nvSpPr>
+        <p:spPr>
+          <a:xfrm>
+            <a:off x="11612880" y="3502152"/>
+            <a:ext cx="914" cy="128016"/>
+          </a:xfrm>
+          <a:prstGeom prst="line">
+            <a:avLst/>
+          </a:prstGeom>
+          <a:noFill/>
+          <a:ln w="15240">
+            <a:solidFill>
+              <a:srgbClr val="94A3B8"/>
+            </a:solidFill>
+            <a:prstDash val="solid"/>
+          </a:ln>
+        </p:spPr>
+      </p:sp>
+      <p:sp>
+        <p:nvSpPr>
+          <p:cNvPr id="23" name="Shape 21"/>
+          <p:cNvSpPr/>
+          <p:nvPr/>
+        </p:nvSpPr>
+        <p:spPr>
+          <a:xfrm>
+            <a:off x="11612880" y="3758184"/>
+            <a:ext cx="914" cy="128016"/>
+          </a:xfrm>
+          <a:prstGeom prst="line">
+            <a:avLst/>
+          </a:prstGeom>
+          <a:noFill/>
+          <a:ln w="15240">
+            <a:solidFill>
+              <a:srgbClr val="94A3B8"/>
+            </a:solidFill>
+            <a:prstDash val="solid"/>
+          </a:ln>
+        </p:spPr>
+      </p:sp>
+      <p:sp>
+        <p:nvSpPr>
+          <p:cNvPr id="24" name="Shape 22"/>
+          <p:cNvSpPr/>
+          <p:nvPr/>
+        </p:nvSpPr>
+        <p:spPr>
+          <a:xfrm>
+            <a:off x="11612880" y="4014216"/>
+            <a:ext cx="914" cy="128016"/>
+          </a:xfrm>
+          <a:prstGeom prst="line">
+            <a:avLst/>
+          </a:prstGeom>
+          <a:noFill/>
+          <a:ln w="15240">
+            <a:solidFill>
+              <a:srgbClr val="94A3B8"/>
+            </a:solidFill>
+            <a:prstDash val="solid"/>
+          </a:ln>
+        </p:spPr>
+      </p:sp>
+      <p:sp>
+        <p:nvSpPr>
+          <p:cNvPr id="25" name="Shape 23"/>
+          <p:cNvSpPr/>
+          <p:nvPr/>
+        </p:nvSpPr>
+        <p:spPr>
+          <a:xfrm>
+            <a:off x="11612880" y="4270248"/>
+            <a:ext cx="914" cy="128016"/>
+          </a:xfrm>
+          <a:prstGeom prst="line">
+            <a:avLst/>
+          </a:prstGeom>
+          <a:noFill/>
+          <a:ln w="15240">
+            <a:solidFill>
+              <a:srgbClr val="94A3B8"/>
+            </a:solidFill>
+            <a:prstDash val="solid"/>
+          </a:ln>
+        </p:spPr>
+      </p:sp>
+      <p:sp>
+        <p:nvSpPr>
+          <p:cNvPr id="26" name="Shape 24"/>
+          <p:cNvSpPr/>
+          <p:nvPr/>
+        </p:nvSpPr>
+        <p:spPr>
+          <a:xfrm>
+            <a:off x="11612880" y="4526280"/>
+            <a:ext cx="914" cy="128016"/>
+          </a:xfrm>
+          <a:prstGeom prst="line">
+            <a:avLst/>
+          </a:prstGeom>
+          <a:noFill/>
+          <a:ln w="15240">
+            <a:solidFill>
+              <a:srgbClr val="94A3B8"/>
+            </a:solidFill>
+            <a:prstDash val="solid"/>
+          </a:ln>
+        </p:spPr>
+      </p:sp>
+      <p:sp>
+        <p:nvSpPr>
+          <p:cNvPr id="27" name="Shape 25"/>
+          <p:cNvSpPr/>
+          <p:nvPr/>
+        </p:nvSpPr>
+        <p:spPr>
+          <a:xfrm>
+            <a:off x="11612880" y="4782312"/>
+            <a:ext cx="914" cy="128016"/>
+          </a:xfrm>
+          <a:prstGeom prst="line">
+            <a:avLst/>
+          </a:prstGeom>
+          <a:noFill/>
+          <a:ln w="15240">
+            <a:solidFill>
+              <a:srgbClr val="94A3B8"/>
+            </a:solidFill>
+            <a:prstDash val="solid"/>
+          </a:ln>
+        </p:spPr>
+      </p:sp>
+      <p:sp>
+        <p:nvSpPr>
+          <p:cNvPr id="28" name="Shape 26"/>
+          <p:cNvSpPr/>
+          <p:nvPr/>
+        </p:nvSpPr>
+        <p:spPr>
+          <a:xfrm>
+            <a:off x="11612880" y="5038344"/>
+            <a:ext cx="914" cy="128016"/>
+          </a:xfrm>
+          <a:prstGeom prst="line">
+            <a:avLst/>
+          </a:prstGeom>
+          <a:noFill/>
+          <a:ln w="15240">
+            <a:solidFill>
+              <a:srgbClr val="94A3B8"/>
+            </a:solidFill>
+            <a:prstDash val="solid"/>
+          </a:ln>
+        </p:spPr>
+      </p:sp>
+      <p:sp>
+        <p:nvSpPr>
+          <p:cNvPr id="29" name="Shape 27"/>
+          <p:cNvSpPr/>
+          <p:nvPr/>
+        </p:nvSpPr>
+        <p:spPr>
+          <a:xfrm>
+            <a:off x="11612880" y="5294376"/>
+            <a:ext cx="914" cy="128016"/>
+          </a:xfrm>
+          <a:prstGeom prst="line">
+            <a:avLst/>
+          </a:prstGeom>
+          <a:noFill/>
+          <a:ln w="15240">
+            <a:solidFill>
+              <a:srgbClr val="94A3B8"/>
+            </a:solidFill>
+            <a:prstDash val="solid"/>
+          </a:ln>
+        </p:spPr>
+      </p:sp>
+      <p:sp>
+        <p:nvSpPr>
+          <p:cNvPr id="30" name="Shape 28"/>
+          <p:cNvSpPr/>
+          <p:nvPr/>
+        </p:nvSpPr>
+        <p:spPr>
+          <a:xfrm>
+            <a:off x="11612880" y="5550408"/>
+            <a:ext cx="914" cy="128016"/>
+          </a:xfrm>
+          <a:prstGeom prst="line">
+            <a:avLst/>
+          </a:prstGeom>
+          <a:noFill/>
+          <a:ln w="15240">
+            <a:solidFill>
+              <a:srgbClr val="94A3B8"/>
+            </a:solidFill>
+            <a:prstDash val="solid"/>
+          </a:ln>
+        </p:spPr>
+      </p:sp>
+      <p:sp>
+        <p:nvSpPr>
+          <p:cNvPr id="31" name="Shape 29"/>
+          <p:cNvSpPr/>
+          <p:nvPr/>
+        </p:nvSpPr>
+        <p:spPr>
+          <a:xfrm>
+            <a:off x="11612880" y="5806440"/>
+            <a:ext cx="914" cy="128016"/>
+          </a:xfrm>
+          <a:prstGeom prst="line">
+            <a:avLst/>
+          </a:prstGeom>
+          <a:noFill/>
+          <a:ln w="15240">
+            <a:solidFill>
+              <a:srgbClr val="94A3B8"/>
+            </a:solidFill>
+            <a:prstDash val="solid"/>
+          </a:ln>
+        </p:spPr>
+      </p:sp>
+      <p:sp>
+        <p:nvSpPr>
+          <p:cNvPr id="32" name="Text 30"/>
+          <p:cNvSpPr/>
+          <p:nvPr/>
+        </p:nvSpPr>
+        <p:spPr>
+          <a:xfrm>
+            <a:off x="9875520" y="1920240"/>
+            <a:ext cx="1691640" cy="228600"/>
+          </a:xfrm>
+          <a:prstGeom prst="rect">
+            <a:avLst/>
+          </a:prstGeom>
+          <a:noFill/>
+          <a:ln/>
+        </p:spPr>
+        <p:txBody>
+          <a:bodyPr wrap="square" rtlCol="0" anchor="ctr"/>
+          <a:lstStyle/>
+          <a:p>
+            <a:pPr algn="r" indent="0" marL="0">
+              <a:buNone/>
+            </a:pPr>
+            <a:r>
+              <a:rPr lang="en-US" sz="1000" b="1" dirty="0">
+                <a:solidFill>
+                  <a:srgbClr val="94A3B8"/>
+                </a:solidFill>
+                <a:latin typeface="Calibri" pitchFamily="34" charset="0"/>
+                <a:ea typeface="Calibri" pitchFamily="34" charset="-122"/>
+                <a:cs typeface="Calibri" pitchFamily="34" charset="-120"/>
+              </a:rPr>
+              <a:t>INSOLVENCY 2019</a:t>
+            </a:r>
+            <a:endParaRPr lang="en-US" sz="1000" dirty="0"/>
+          </a:p>
+        </p:txBody>
+      </p:sp>
+      <p:sp>
+        <p:nvSpPr>
+          <p:cNvPr id="33" name="Shape 31"/>
+          <p:cNvSpPr/>
+          <p:nvPr/>
+        </p:nvSpPr>
+        <p:spPr>
+          <a:xfrm flipV="1">
+            <a:off x="5349240" y="3575304"/>
+            <a:ext cx="1565910" cy="1046074"/>
+          </a:xfrm>
+          <a:prstGeom prst="line">
+            <a:avLst/>
+          </a:prstGeom>
+          <a:noFill/>
+          <a:ln w="31750">
+            <a:solidFill>
+              <a:srgbClr val="5B9BD5"/>
+            </a:solidFill>
+            <a:prstDash val="solid"/>
+          </a:ln>
+        </p:spPr>
+      </p:sp>
+      <p:sp>
+        <p:nvSpPr>
+          <p:cNvPr id="34" name="Shape 32"/>
+          <p:cNvSpPr/>
+          <p:nvPr/>
+        </p:nvSpPr>
+        <p:spPr>
+          <a:xfrm flipV="1">
+            <a:off x="6915150" y="2971800"/>
+            <a:ext cx="1565910" cy="603504"/>
+          </a:xfrm>
+          <a:prstGeom prst="line">
+            <a:avLst/>
+          </a:prstGeom>
+          <a:noFill/>
+          <a:ln w="31750">
+            <a:solidFill>
+              <a:srgbClr val="5B9BD5"/>
+            </a:solidFill>
+            <a:prstDash val="solid"/>
+          </a:ln>
+        </p:spPr>
+      </p:sp>
+      <p:sp>
+        <p:nvSpPr>
+          <p:cNvPr id="35" name="Shape 33"/>
+          <p:cNvSpPr/>
+          <p:nvPr/>
+        </p:nvSpPr>
+        <p:spPr>
+          <a:xfrm flipV="1">
+            <a:off x="8481060" y="2167128"/>
+            <a:ext cx="1565910" cy="804672"/>
+          </a:xfrm>
+          <a:prstGeom prst="line">
+            <a:avLst/>
+          </a:prstGeom>
+          <a:noFill/>
+          <a:ln w="31750">
+            <a:solidFill>
+              <a:srgbClr val="5B9BD5"/>
+            </a:solidFill>
+            <a:prstDash val="solid"/>
+          </a:ln>
+        </p:spPr>
+      </p:sp>
+      <p:sp>
+        <p:nvSpPr>
+          <p:cNvPr id="36" name="Shape 34"/>
+          <p:cNvSpPr/>
+          <p:nvPr/>
+        </p:nvSpPr>
+        <p:spPr>
+          <a:xfrm flipV="1">
+            <a:off x="10046970" y="2126894"/>
+            <a:ext cx="1565910" cy="40234"/>
+          </a:xfrm>
+          <a:prstGeom prst="line">
+            <a:avLst/>
+          </a:prstGeom>
+          <a:noFill/>
+          <a:ln w="31750">
+            <a:solidFill>
+              <a:srgbClr val="5B9BD5"/>
+            </a:solidFill>
+            <a:prstDash val="solid"/>
+          </a:ln>
+        </p:spPr>
+      </p:sp>
+      <p:sp>
+        <p:nvSpPr>
+          <p:cNvPr id="37" name="Shape 35"/>
+          <p:cNvSpPr/>
+          <p:nvPr/>
+        </p:nvSpPr>
+        <p:spPr>
+          <a:xfrm>
+            <a:off x="5294376" y="4566514"/>
+            <a:ext cx="109728" cy="109728"/>
+          </a:xfrm>
+          <a:prstGeom prst="ellipse">
+            <a:avLst/>
+          </a:prstGeom>
+          <a:solidFill>
+            <a:srgbClr val="5B9BD5"/>
+          </a:solidFill>
           <a:ln w="19050">
+            <a:solidFill>
+              <a:srgbClr val="0A1628"/>
+            </a:solidFill>
+            <a:prstDash val="solid"/>
+          </a:ln>
+        </p:spPr>
+      </p:sp>
+      <p:sp>
+        <p:nvSpPr>
+          <p:cNvPr id="38" name="Shape 36"/>
+          <p:cNvSpPr/>
+          <p:nvPr/>
+        </p:nvSpPr>
+        <p:spPr>
+          <a:xfrm>
+            <a:off x="6860286" y="3520440"/>
+            <a:ext cx="109728" cy="109728"/>
+          </a:xfrm>
+          <a:prstGeom prst="ellipse">
+            <a:avLst/>
+          </a:prstGeom>
+          <a:solidFill>
+            <a:srgbClr val="5B9BD5"/>
+          </a:solidFill>
+          <a:ln w="19050">
+            <a:solidFill>
+              <a:srgbClr val="0A1628"/>
+            </a:solidFill>
+            <a:prstDash val="solid"/>
+          </a:ln>
+        </p:spPr>
+      </p:sp>
+      <p:sp>
+        <p:nvSpPr>
+          <p:cNvPr id="39" name="Shape 37"/>
+          <p:cNvSpPr/>
+          <p:nvPr/>
+        </p:nvSpPr>
+        <p:spPr>
+          <a:xfrm>
+            <a:off x="8426196" y="2916936"/>
+            <a:ext cx="109728" cy="109728"/>
+          </a:xfrm>
+          <a:prstGeom prst="ellipse">
+            <a:avLst/>
+          </a:prstGeom>
+          <a:solidFill>
+            <a:srgbClr val="5B9BD5"/>
+          </a:solidFill>
+          <a:ln w="19050">
+            <a:solidFill>
+              <a:srgbClr val="0A1628"/>
+            </a:solidFill>
+            <a:prstDash val="solid"/>
+          </a:ln>
+        </p:spPr>
+      </p:sp>
+      <p:sp>
+        <p:nvSpPr>
+          <p:cNvPr id="40" name="Shape 38"/>
+          <p:cNvSpPr/>
+          <p:nvPr/>
+        </p:nvSpPr>
+        <p:spPr>
+          <a:xfrm>
+            <a:off x="9992106" y="2112264"/>
+            <a:ext cx="109728" cy="109728"/>
+          </a:xfrm>
+          <a:prstGeom prst="ellipse">
+            <a:avLst/>
+          </a:prstGeom>
+          <a:solidFill>
+            <a:srgbClr val="5B9BD5"/>
+          </a:solidFill>
+          <a:ln w="19050">
+            <a:solidFill>
+              <a:srgbClr val="0A1628"/>
+            </a:solidFill>
+            <a:prstDash val="solid"/>
+          </a:ln>
+        </p:spPr>
+      </p:sp>
+      <p:sp>
+        <p:nvSpPr>
+          <p:cNvPr id="41" name="Shape 39"/>
+          <p:cNvSpPr/>
+          <p:nvPr/>
+        </p:nvSpPr>
+        <p:spPr>
+          <a:xfrm>
+            <a:off x="11558016" y="2072030"/>
+            <a:ext cx="109728" cy="109728"/>
+          </a:xfrm>
+          <a:prstGeom prst="ellipse">
+            <a:avLst/>
+          </a:prstGeom>
+          <a:solidFill>
+            <a:srgbClr val="5B9BD5"/>
+          </a:solidFill>
+          <a:ln w="19050">
+            <a:solidFill>
+              <a:srgbClr val="0A1628"/>
+            </a:solidFill>
+            <a:prstDash val="solid"/>
+          </a:ln>
+        </p:spPr>
+      </p:sp>
+      <p:sp>
+        <p:nvSpPr>
+          <p:cNvPr id="42" name="Shape 40"/>
+          <p:cNvSpPr/>
+          <p:nvPr/>
+        </p:nvSpPr>
+        <p:spPr>
+          <a:xfrm flipV="1">
+            <a:off x="5349240" y="3454603"/>
+            <a:ext cx="1565910" cy="925373"/>
+          </a:xfrm>
+          <a:prstGeom prst="line">
+            <a:avLst/>
+          </a:prstGeom>
+          <a:noFill/>
+          <a:ln w="44450">
             <a:solidFill>
               <a:srgbClr val="F59E0B"/>
             </a:solidFill>
@@ -5110,20 +5640,20 @@
       </p:sp>
       <p:sp>
         <p:nvSpPr>
-          <p:cNvPr id="19" name="Shape 17"/>
-          <p:cNvSpPr/>
-          <p:nvPr/>
-        </p:nvSpPr>
-        <p:spPr>
-          <a:xfrm>
-            <a:off x="11612880" y="2221992"/>
-            <a:ext cx="914" cy="128016"/>
+          <p:cNvPr id="43" name="Shape 41"/>
+          <p:cNvSpPr/>
+          <p:nvPr/>
+        </p:nvSpPr>
+        <p:spPr>
+          <a:xfrm flipV="1">
+            <a:off x="6915150" y="2609698"/>
+            <a:ext cx="1565910" cy="844906"/>
           </a:xfrm>
           <a:prstGeom prst="line">
             <a:avLst/>
           </a:prstGeom>
           <a:noFill/>
-          <a:ln w="19050">
+          <a:ln w="44450">
             <a:solidFill>
               <a:srgbClr val="F59E0B"/>
             </a:solidFill>
@@ -5133,20 +5663,20 @@
       </p:sp>
       <p:sp>
         <p:nvSpPr>
-          <p:cNvPr id="20" name="Shape 18"/>
-          <p:cNvSpPr/>
-          <p:nvPr/>
-        </p:nvSpPr>
-        <p:spPr>
-          <a:xfrm>
-            <a:off x="11612880" y="2478024"/>
-            <a:ext cx="914" cy="128016"/>
+          <p:cNvPr id="44" name="Shape 42"/>
+          <p:cNvSpPr/>
+          <p:nvPr/>
+        </p:nvSpPr>
+        <p:spPr>
+          <a:xfrm flipV="1">
+            <a:off x="8481060" y="2287829"/>
+            <a:ext cx="1565910" cy="321869"/>
           </a:xfrm>
           <a:prstGeom prst="line">
             <a:avLst/>
           </a:prstGeom>
           <a:noFill/>
-          <a:ln w="19050">
+          <a:ln w="44450">
             <a:solidFill>
               <a:srgbClr val="F59E0B"/>
             </a:solidFill>
@@ -5156,20 +5686,20 @@
       </p:sp>
       <p:sp>
         <p:nvSpPr>
-          <p:cNvPr id="21" name="Shape 19"/>
-          <p:cNvSpPr/>
-          <p:nvPr/>
-        </p:nvSpPr>
-        <p:spPr>
-          <a:xfrm>
-            <a:off x="11612880" y="2734056"/>
-            <a:ext cx="914" cy="128016"/>
+          <p:cNvPr id="45" name="Shape 43"/>
+          <p:cNvSpPr/>
+          <p:nvPr/>
+        </p:nvSpPr>
+        <p:spPr>
+          <a:xfrm flipV="1">
+            <a:off x="10046970" y="2126894"/>
+            <a:ext cx="1565910" cy="160934"/>
           </a:xfrm>
           <a:prstGeom prst="line">
             <a:avLst/>
           </a:prstGeom>
           <a:noFill/>
-          <a:ln w="19050">
+          <a:ln w="44450">
             <a:solidFill>
               <a:srgbClr val="F59E0B"/>
             </a:solidFill>
@@ -5179,421 +5709,14 @@
       </p:sp>
       <p:sp>
         <p:nvSpPr>
-          <p:cNvPr id="22" name="Shape 20"/>
-          <p:cNvSpPr/>
-          <p:nvPr/>
-        </p:nvSpPr>
-        <p:spPr>
-          <a:xfrm>
-            <a:off x="11612880" y="2990088"/>
-            <a:ext cx="914" cy="128016"/>
-          </a:xfrm>
-          <a:prstGeom prst="line">
-            <a:avLst/>
-          </a:prstGeom>
-          <a:noFill/>
-          <a:ln w="19050">
-            <a:solidFill>
-              <a:srgbClr val="F59E0B"/>
-            </a:solidFill>
-            <a:prstDash val="solid"/>
-          </a:ln>
-        </p:spPr>
-      </p:sp>
-      <p:sp>
-        <p:nvSpPr>
-          <p:cNvPr id="23" name="Shape 21"/>
-          <p:cNvSpPr/>
-          <p:nvPr/>
-        </p:nvSpPr>
-        <p:spPr>
-          <a:xfrm>
-            <a:off x="11612880" y="3246120"/>
-            <a:ext cx="914" cy="128016"/>
-          </a:xfrm>
-          <a:prstGeom prst="line">
-            <a:avLst/>
-          </a:prstGeom>
-          <a:noFill/>
-          <a:ln w="19050">
-            <a:solidFill>
-              <a:srgbClr val="F59E0B"/>
-            </a:solidFill>
-            <a:prstDash val="solid"/>
-          </a:ln>
-        </p:spPr>
-      </p:sp>
-      <p:sp>
-        <p:nvSpPr>
-          <p:cNvPr id="24" name="Shape 22"/>
-          <p:cNvSpPr/>
-          <p:nvPr/>
-        </p:nvSpPr>
-        <p:spPr>
-          <a:xfrm>
-            <a:off x="11612880" y="3502152"/>
-            <a:ext cx="914" cy="128016"/>
-          </a:xfrm>
-          <a:prstGeom prst="line">
-            <a:avLst/>
-          </a:prstGeom>
-          <a:noFill/>
-          <a:ln w="19050">
-            <a:solidFill>
-              <a:srgbClr val="F59E0B"/>
-            </a:solidFill>
-            <a:prstDash val="solid"/>
-          </a:ln>
-        </p:spPr>
-      </p:sp>
-      <p:sp>
-        <p:nvSpPr>
-          <p:cNvPr id="25" name="Shape 23"/>
-          <p:cNvSpPr/>
-          <p:nvPr/>
-        </p:nvSpPr>
-        <p:spPr>
-          <a:xfrm>
-            <a:off x="11612880" y="3758184"/>
-            <a:ext cx="914" cy="128016"/>
-          </a:xfrm>
-          <a:prstGeom prst="line">
-            <a:avLst/>
-          </a:prstGeom>
-          <a:noFill/>
-          <a:ln w="19050">
-            <a:solidFill>
-              <a:srgbClr val="F59E0B"/>
-            </a:solidFill>
-            <a:prstDash val="solid"/>
-          </a:ln>
-        </p:spPr>
-      </p:sp>
-      <p:sp>
-        <p:nvSpPr>
-          <p:cNvPr id="26" name="Shape 24"/>
-          <p:cNvSpPr/>
-          <p:nvPr/>
-        </p:nvSpPr>
-        <p:spPr>
-          <a:xfrm>
-            <a:off x="11612880" y="4014216"/>
-            <a:ext cx="914" cy="128016"/>
-          </a:xfrm>
-          <a:prstGeom prst="line">
-            <a:avLst/>
-          </a:prstGeom>
-          <a:noFill/>
-          <a:ln w="19050">
-            <a:solidFill>
-              <a:srgbClr val="F59E0B"/>
-            </a:solidFill>
-            <a:prstDash val="solid"/>
-          </a:ln>
-        </p:spPr>
-      </p:sp>
-      <p:sp>
-        <p:nvSpPr>
-          <p:cNvPr id="27" name="Shape 25"/>
-          <p:cNvSpPr/>
-          <p:nvPr/>
-        </p:nvSpPr>
-        <p:spPr>
-          <a:xfrm>
-            <a:off x="11612880" y="4270248"/>
-            <a:ext cx="914" cy="128016"/>
-          </a:xfrm>
-          <a:prstGeom prst="line">
-            <a:avLst/>
-          </a:prstGeom>
-          <a:noFill/>
-          <a:ln w="19050">
-            <a:solidFill>
-              <a:srgbClr val="F59E0B"/>
-            </a:solidFill>
-            <a:prstDash val="solid"/>
-          </a:ln>
-        </p:spPr>
-      </p:sp>
-      <p:sp>
-        <p:nvSpPr>
-          <p:cNvPr id="28" name="Shape 26"/>
-          <p:cNvSpPr/>
-          <p:nvPr/>
-        </p:nvSpPr>
-        <p:spPr>
-          <a:xfrm>
-            <a:off x="11612880" y="4526280"/>
-            <a:ext cx="914" cy="128016"/>
-          </a:xfrm>
-          <a:prstGeom prst="line">
-            <a:avLst/>
-          </a:prstGeom>
-          <a:noFill/>
-          <a:ln w="19050">
-            <a:solidFill>
-              <a:srgbClr val="F59E0B"/>
-            </a:solidFill>
-            <a:prstDash val="solid"/>
-          </a:ln>
-        </p:spPr>
-      </p:sp>
-      <p:sp>
-        <p:nvSpPr>
-          <p:cNvPr id="29" name="Shape 27"/>
-          <p:cNvSpPr/>
-          <p:nvPr/>
-        </p:nvSpPr>
-        <p:spPr>
-          <a:xfrm>
-            <a:off x="11612880" y="4782312"/>
-            <a:ext cx="914" cy="128016"/>
-          </a:xfrm>
-          <a:prstGeom prst="line">
-            <a:avLst/>
-          </a:prstGeom>
-          <a:noFill/>
-          <a:ln w="19050">
-            <a:solidFill>
-              <a:srgbClr val="F59E0B"/>
-            </a:solidFill>
-            <a:prstDash val="solid"/>
-          </a:ln>
-        </p:spPr>
-      </p:sp>
-      <p:sp>
-        <p:nvSpPr>
-          <p:cNvPr id="30" name="Shape 28"/>
-          <p:cNvSpPr/>
-          <p:nvPr/>
-        </p:nvSpPr>
-        <p:spPr>
-          <a:xfrm>
-            <a:off x="11612880" y="5038344"/>
-            <a:ext cx="914" cy="128016"/>
-          </a:xfrm>
-          <a:prstGeom prst="line">
-            <a:avLst/>
-          </a:prstGeom>
-          <a:noFill/>
-          <a:ln w="19050">
-            <a:solidFill>
-              <a:srgbClr val="F59E0B"/>
-            </a:solidFill>
-            <a:prstDash val="solid"/>
-          </a:ln>
-        </p:spPr>
-      </p:sp>
-      <p:sp>
-        <p:nvSpPr>
-          <p:cNvPr id="31" name="Shape 29"/>
-          <p:cNvSpPr/>
-          <p:nvPr/>
-        </p:nvSpPr>
-        <p:spPr>
-          <a:xfrm>
-            <a:off x="11612880" y="5294376"/>
-            <a:ext cx="914" cy="128016"/>
-          </a:xfrm>
-          <a:prstGeom prst="line">
-            <a:avLst/>
-          </a:prstGeom>
-          <a:noFill/>
-          <a:ln w="19050">
-            <a:solidFill>
-              <a:srgbClr val="F59E0B"/>
-            </a:solidFill>
-            <a:prstDash val="solid"/>
-          </a:ln>
-        </p:spPr>
-      </p:sp>
-      <p:sp>
-        <p:nvSpPr>
-          <p:cNvPr id="32" name="Shape 30"/>
-          <p:cNvSpPr/>
-          <p:nvPr/>
-        </p:nvSpPr>
-        <p:spPr>
-          <a:xfrm>
-            <a:off x="11612880" y="5550408"/>
-            <a:ext cx="914" cy="128016"/>
-          </a:xfrm>
-          <a:prstGeom prst="line">
-            <a:avLst/>
-          </a:prstGeom>
-          <a:noFill/>
-          <a:ln w="19050">
-            <a:solidFill>
-              <a:srgbClr val="F59E0B"/>
-            </a:solidFill>
-            <a:prstDash val="solid"/>
-          </a:ln>
-        </p:spPr>
-      </p:sp>
-      <p:sp>
-        <p:nvSpPr>
-          <p:cNvPr id="33" name="Shape 31"/>
-          <p:cNvSpPr/>
-          <p:nvPr/>
-        </p:nvSpPr>
-        <p:spPr>
-          <a:xfrm>
-            <a:off x="11612880" y="5806440"/>
-            <a:ext cx="914" cy="128016"/>
-          </a:xfrm>
-          <a:prstGeom prst="line">
-            <a:avLst/>
-          </a:prstGeom>
-          <a:noFill/>
-          <a:ln w="19050">
-            <a:solidFill>
-              <a:srgbClr val="F59E0B"/>
-            </a:solidFill>
-            <a:prstDash val="solid"/>
-          </a:ln>
-        </p:spPr>
-      </p:sp>
-      <p:sp>
-        <p:nvSpPr>
-          <p:cNvPr id="34" name="Text 32"/>
-          <p:cNvSpPr/>
-          <p:nvPr/>
-        </p:nvSpPr>
-        <p:spPr>
-          <a:xfrm>
-            <a:off x="9875520" y="1920240"/>
-            <a:ext cx="1691640" cy="228600"/>
-          </a:xfrm>
-          <a:prstGeom prst="rect">
-            <a:avLst/>
-          </a:prstGeom>
-          <a:noFill/>
-          <a:ln/>
-        </p:spPr>
-        <p:txBody>
-          <a:bodyPr wrap="square" rtlCol="0" anchor="ctr"/>
-          <a:lstStyle/>
-          <a:p>
-            <a:pPr algn="r" indent="0" marL="0">
-              <a:buNone/>
-            </a:pPr>
-            <a:r>
-              <a:rPr lang="en-US" sz="1000" b="1" dirty="0">
-                <a:solidFill>
-                  <a:srgbClr val="F59E0B"/>
-                </a:solidFill>
-                <a:latin typeface="Calibri" pitchFamily="34" charset="0"/>
-                <a:ea typeface="Calibri" pitchFamily="34" charset="-122"/>
-                <a:cs typeface="Calibri" pitchFamily="34" charset="-120"/>
-              </a:rPr>
-              <a:t>INSOLVENCY 2019</a:t>
-            </a:r>
-            <a:endParaRPr lang="en-US" sz="1000" dirty="0"/>
-          </a:p>
-        </p:txBody>
-      </p:sp>
-      <p:sp>
-        <p:nvSpPr>
-          <p:cNvPr id="35" name="Shape 33"/>
-          <p:cNvSpPr/>
-          <p:nvPr/>
-        </p:nvSpPr>
-        <p:spPr>
-          <a:xfrm>
-            <a:off x="5349240" y="2587752"/>
-            <a:ext cx="1565910" cy="883920"/>
-          </a:xfrm>
-          <a:prstGeom prst="line">
-            <a:avLst/>
-          </a:prstGeom>
-          <a:noFill/>
-          <a:ln w="38100">
-            <a:solidFill>
-              <a:srgbClr val="F59E0B"/>
-            </a:solidFill>
-            <a:prstDash val="solid"/>
-          </a:ln>
-        </p:spPr>
-      </p:sp>
-      <p:sp>
-        <p:nvSpPr>
-          <p:cNvPr id="36" name="Shape 34"/>
-          <p:cNvSpPr/>
-          <p:nvPr/>
-        </p:nvSpPr>
-        <p:spPr>
-          <a:xfrm>
-            <a:off x="6915150" y="3471672"/>
-            <a:ext cx="1565910" cy="548640"/>
-          </a:xfrm>
-          <a:prstGeom prst="line">
-            <a:avLst/>
-          </a:prstGeom>
-          <a:noFill/>
-          <a:ln w="38100">
-            <a:solidFill>
-              <a:srgbClr val="F59E0B"/>
-            </a:solidFill>
-            <a:prstDash val="solid"/>
-          </a:ln>
-        </p:spPr>
-      </p:sp>
-      <p:sp>
-        <p:nvSpPr>
-          <p:cNvPr id="37" name="Shape 35"/>
-          <p:cNvSpPr/>
-          <p:nvPr/>
-        </p:nvSpPr>
-        <p:spPr>
-          <a:xfrm>
-            <a:off x="8481060" y="4020312"/>
-            <a:ext cx="1565910" cy="1487424"/>
-          </a:xfrm>
-          <a:prstGeom prst="line">
-            <a:avLst/>
-          </a:prstGeom>
-          <a:noFill/>
-          <a:ln w="38100">
-            <a:solidFill>
-              <a:srgbClr val="F59E0B"/>
-            </a:solidFill>
-            <a:prstDash val="solid"/>
-          </a:ln>
-        </p:spPr>
-      </p:sp>
-      <p:sp>
-        <p:nvSpPr>
-          <p:cNvPr id="38" name="Shape 36"/>
-          <p:cNvSpPr/>
-          <p:nvPr/>
-        </p:nvSpPr>
-        <p:spPr>
-          <a:xfrm>
-            <a:off x="10046970" y="5507736"/>
-            <a:ext cx="1565910" cy="182880"/>
-          </a:xfrm>
-          <a:prstGeom prst="line">
-            <a:avLst/>
-          </a:prstGeom>
-          <a:noFill/>
-          <a:ln w="38100">
-            <a:solidFill>
-              <a:srgbClr val="F59E0B"/>
-            </a:solidFill>
-            <a:prstDash val="solid"/>
-          </a:ln>
-        </p:spPr>
-      </p:sp>
-      <p:sp>
-        <p:nvSpPr>
-          <p:cNvPr id="39" name="Shape 37"/>
-          <p:cNvSpPr/>
-          <p:nvPr/>
-        </p:nvSpPr>
-        <p:spPr>
-          <a:xfrm>
-            <a:off x="5280660" y="2519172"/>
-            <a:ext cx="137160" cy="137160"/>
+          <p:cNvPr id="46" name="Shape 44"/>
+          <p:cNvSpPr/>
+          <p:nvPr/>
+        </p:nvSpPr>
+        <p:spPr>
+          <a:xfrm>
+            <a:off x="5276088" y="4306824"/>
+            <a:ext cx="146304" cy="146304"/>
           </a:xfrm>
           <a:prstGeom prst="ellipse">
             <a:avLst/>
@@ -5611,39 +5734,14 @@
       </p:sp>
       <p:sp>
         <p:nvSpPr>
-          <p:cNvPr id="40" name="Shape 38"/>
-          <p:cNvSpPr/>
-          <p:nvPr/>
-        </p:nvSpPr>
-        <p:spPr>
-          <a:xfrm>
-            <a:off x="6814566" y="3371088"/>
-            <a:ext cx="201168" cy="201168"/>
-          </a:xfrm>
-          <a:prstGeom prst="ellipse">
-            <a:avLst/>
-          </a:prstGeom>
-          <a:solidFill>
-            <a:srgbClr val="FFFFFF"/>
-          </a:solidFill>
-          <a:ln w="19050">
-            <a:solidFill>
-              <a:srgbClr val="F59E0B"/>
-            </a:solidFill>
-            <a:prstDash val="solid"/>
-          </a:ln>
-        </p:spPr>
-      </p:sp>
-      <p:sp>
-        <p:nvSpPr>
-          <p:cNvPr id="41" name="Shape 39"/>
-          <p:cNvSpPr/>
-          <p:nvPr/>
-        </p:nvSpPr>
-        <p:spPr>
-          <a:xfrm>
-            <a:off x="8412480" y="3951732"/>
-            <a:ext cx="137160" cy="137160"/>
+          <p:cNvPr id="47" name="Shape 45"/>
+          <p:cNvSpPr/>
+          <p:nvPr/>
+        </p:nvSpPr>
+        <p:spPr>
+          <a:xfrm>
+            <a:off x="6841998" y="3381451"/>
+            <a:ext cx="146304" cy="146304"/>
           </a:xfrm>
           <a:prstGeom prst="ellipse">
             <a:avLst/>
@@ -5661,14 +5759,14 @@
       </p:sp>
       <p:sp>
         <p:nvSpPr>
-          <p:cNvPr id="42" name="Shape 40"/>
-          <p:cNvSpPr/>
-          <p:nvPr/>
-        </p:nvSpPr>
-        <p:spPr>
-          <a:xfrm>
-            <a:off x="9978390" y="5439156"/>
-            <a:ext cx="137160" cy="137160"/>
+          <p:cNvPr id="48" name="Shape 46"/>
+          <p:cNvSpPr/>
+          <p:nvPr/>
+        </p:nvSpPr>
+        <p:spPr>
+          <a:xfrm>
+            <a:off x="8407908" y="2536546"/>
+            <a:ext cx="146304" cy="146304"/>
           </a:xfrm>
           <a:prstGeom prst="ellipse">
             <a:avLst/>
@@ -5686,14 +5784,14 @@
       </p:sp>
       <p:sp>
         <p:nvSpPr>
-          <p:cNvPr id="43" name="Shape 41"/>
-          <p:cNvSpPr/>
-          <p:nvPr/>
-        </p:nvSpPr>
-        <p:spPr>
-          <a:xfrm>
-            <a:off x="11544300" y="5622036"/>
-            <a:ext cx="137160" cy="137160"/>
+          <p:cNvPr id="49" name="Shape 47"/>
+          <p:cNvSpPr/>
+          <p:nvPr/>
+        </p:nvSpPr>
+        <p:spPr>
+          <a:xfrm>
+            <a:off x="9973818" y="2214677"/>
+            <a:ext cx="146304" cy="146304"/>
           </a:xfrm>
           <a:prstGeom prst="ellipse">
             <a:avLst/>
@@ -5711,258 +5809,24 @@
       </p:sp>
       <p:sp>
         <p:nvSpPr>
-          <p:cNvPr id="44" name="Text 42"/>
-          <p:cNvSpPr/>
-          <p:nvPr/>
-        </p:nvSpPr>
-        <p:spPr>
-          <a:xfrm>
-            <a:off x="4983480" y="6044184"/>
-            <a:ext cx="731520" cy="256032"/>
-          </a:xfrm>
-          <a:prstGeom prst="rect">
-            <a:avLst/>
-          </a:prstGeom>
-          <a:noFill/>
-          <a:ln/>
-        </p:spPr>
-        <p:txBody>
-          <a:bodyPr wrap="square" rtlCol="0" anchor="ctr"/>
-          <a:lstStyle/>
-          <a:p>
-            <a:pPr algn="ctr" indent="0" marL="0">
-              <a:buNone/>
-            </a:pPr>
-            <a:r>
-              <a:rPr lang="en-US" sz="1100" dirty="0">
-                <a:solidFill>
-                  <a:srgbClr val="94A3B8"/>
-                </a:solidFill>
-                <a:latin typeface="Calibri" pitchFamily="34" charset="0"/>
-                <a:ea typeface="Calibri" pitchFamily="34" charset="-122"/>
-                <a:cs typeface="Calibri" pitchFamily="34" charset="-120"/>
-              </a:rPr>
-              <a:t>FY15</a:t>
-            </a:r>
-            <a:endParaRPr lang="en-US" sz="1100" dirty="0"/>
-          </a:p>
-        </p:txBody>
-      </p:sp>
-      <p:sp>
-        <p:nvSpPr>
-          <p:cNvPr id="45" name="Text 43"/>
-          <p:cNvSpPr/>
-          <p:nvPr/>
-        </p:nvSpPr>
-        <p:spPr>
-          <a:xfrm>
-            <a:off x="6549390" y="6044184"/>
-            <a:ext cx="731520" cy="256032"/>
-          </a:xfrm>
-          <a:prstGeom prst="rect">
-            <a:avLst/>
-          </a:prstGeom>
-          <a:noFill/>
-          <a:ln/>
-        </p:spPr>
-        <p:txBody>
-          <a:bodyPr wrap="square" rtlCol="0" anchor="ctr"/>
-          <a:lstStyle/>
-          <a:p>
-            <a:pPr algn="ctr" indent="0" marL="0">
-              <a:buNone/>
-            </a:pPr>
-            <a:r>
-              <a:rPr lang="en-US" sz="1100" dirty="0">
-                <a:solidFill>
-                  <a:srgbClr val="94A3B8"/>
-                </a:solidFill>
-                <a:latin typeface="Calibri" pitchFamily="34" charset="0"/>
-                <a:ea typeface="Calibri" pitchFamily="34" charset="-122"/>
-                <a:cs typeface="Calibri" pitchFamily="34" charset="-120"/>
-              </a:rPr>
-              <a:t>FY16</a:t>
-            </a:r>
-            <a:endParaRPr lang="en-US" sz="1100" dirty="0"/>
-          </a:p>
-        </p:txBody>
-      </p:sp>
-      <p:sp>
-        <p:nvSpPr>
-          <p:cNvPr id="46" name="Text 44"/>
-          <p:cNvSpPr/>
-          <p:nvPr/>
-        </p:nvSpPr>
-        <p:spPr>
-          <a:xfrm>
-            <a:off x="8115300" y="6044184"/>
-            <a:ext cx="731520" cy="256032"/>
-          </a:xfrm>
-          <a:prstGeom prst="rect">
-            <a:avLst/>
-          </a:prstGeom>
-          <a:noFill/>
-          <a:ln/>
-        </p:spPr>
-        <p:txBody>
-          <a:bodyPr wrap="square" rtlCol="0" anchor="ctr"/>
-          <a:lstStyle/>
-          <a:p>
-            <a:pPr algn="ctr" indent="0" marL="0">
-              <a:buNone/>
-            </a:pPr>
-            <a:r>
-              <a:rPr lang="en-US" sz="1100" dirty="0">
-                <a:solidFill>
-                  <a:srgbClr val="94A3B8"/>
-                </a:solidFill>
-                <a:latin typeface="Calibri" pitchFamily="34" charset="0"/>
-                <a:ea typeface="Calibri" pitchFamily="34" charset="-122"/>
-                <a:cs typeface="Calibri" pitchFamily="34" charset="-120"/>
-              </a:rPr>
-              <a:t>FY17</a:t>
-            </a:r>
-            <a:endParaRPr lang="en-US" sz="1100" dirty="0"/>
-          </a:p>
-        </p:txBody>
-      </p:sp>
-      <p:sp>
-        <p:nvSpPr>
-          <p:cNvPr id="47" name="Text 45"/>
-          <p:cNvSpPr/>
-          <p:nvPr/>
-        </p:nvSpPr>
-        <p:spPr>
-          <a:xfrm>
-            <a:off x="9681210" y="6044184"/>
-            <a:ext cx="731520" cy="256032"/>
-          </a:xfrm>
-          <a:prstGeom prst="rect">
-            <a:avLst/>
-          </a:prstGeom>
-          <a:noFill/>
-          <a:ln/>
-        </p:spPr>
-        <p:txBody>
-          <a:bodyPr wrap="square" rtlCol="0" anchor="ctr"/>
-          <a:lstStyle/>
-          <a:p>
-            <a:pPr algn="ctr" indent="0" marL="0">
-              <a:buNone/>
-            </a:pPr>
-            <a:r>
-              <a:rPr lang="en-US" sz="1100" dirty="0">
-                <a:solidFill>
-                  <a:srgbClr val="94A3B8"/>
-                </a:solidFill>
-                <a:latin typeface="Calibri" pitchFamily="34" charset="0"/>
-                <a:ea typeface="Calibri" pitchFamily="34" charset="-122"/>
-                <a:cs typeface="Calibri" pitchFamily="34" charset="-120"/>
-              </a:rPr>
-              <a:t>FY18</a:t>
-            </a:r>
-            <a:endParaRPr lang="en-US" sz="1100" dirty="0"/>
-          </a:p>
-        </p:txBody>
-      </p:sp>
-      <p:sp>
-        <p:nvSpPr>
-          <p:cNvPr id="48" name="Text 46"/>
-          <p:cNvSpPr/>
-          <p:nvPr/>
-        </p:nvSpPr>
-        <p:spPr>
-          <a:xfrm>
-            <a:off x="11247120" y="6044184"/>
-            <a:ext cx="731520" cy="256032"/>
-          </a:xfrm>
-          <a:prstGeom prst="rect">
-            <a:avLst/>
-          </a:prstGeom>
-          <a:noFill/>
-          <a:ln/>
-        </p:spPr>
-        <p:txBody>
-          <a:bodyPr wrap="square" rtlCol="0" anchor="ctr"/>
-          <a:lstStyle/>
-          <a:p>
-            <a:pPr algn="ctr" indent="0" marL="0">
-              <a:buNone/>
-            </a:pPr>
-            <a:r>
-              <a:rPr lang="en-US" sz="1100" dirty="0">
-                <a:solidFill>
-                  <a:srgbClr val="94A3B8"/>
-                </a:solidFill>
-                <a:latin typeface="Calibri" pitchFamily="34" charset="0"/>
-                <a:ea typeface="Calibri" pitchFamily="34" charset="-122"/>
-                <a:cs typeface="Calibri" pitchFamily="34" charset="-120"/>
-              </a:rPr>
-              <a:t>FY19</a:t>
-            </a:r>
-            <a:endParaRPr lang="en-US" sz="1100" dirty="0"/>
-          </a:p>
-        </p:txBody>
-      </p:sp>
-      <p:sp>
-        <p:nvSpPr>
-          <p:cNvPr id="49" name="Text 47"/>
-          <p:cNvSpPr/>
-          <p:nvPr/>
-        </p:nvSpPr>
-        <p:spPr>
-          <a:xfrm>
-            <a:off x="6595110" y="3636264"/>
-            <a:ext cx="2011680" cy="274320"/>
-          </a:xfrm>
-          <a:prstGeom prst="rect">
-            <a:avLst/>
-          </a:prstGeom>
-          <a:noFill/>
-          <a:ln/>
-        </p:spPr>
-        <p:txBody>
-          <a:bodyPr wrap="square" rtlCol="0" anchor="ctr"/>
-          <a:lstStyle/>
-          <a:p>
-            <a:pPr indent="0" marL="0">
-              <a:buNone/>
-            </a:pPr>
-            <a:r>
-              <a:rPr lang="en-US" sz="1050" b="1" dirty="0">
-                <a:solidFill>
-                  <a:srgbClr val="FFFFFF"/>
-                </a:solidFill>
-                <a:latin typeface="Calibri" pitchFamily="34" charset="0"/>
-                <a:ea typeface="Calibri" pitchFamily="34" charset="-122"/>
-                <a:cs typeface="Calibri" pitchFamily="34" charset="-120"/>
-              </a:rPr>
-              <a:t>distress flagged FY16</a:t>
-            </a:r>
-            <a:endParaRPr lang="en-US" sz="1050" dirty="0"/>
-          </a:p>
-        </p:txBody>
-      </p:sp>
-      <p:sp>
-        <p:nvSpPr>
           <p:cNvPr id="50" name="Shape 48"/>
           <p:cNvSpPr/>
           <p:nvPr/>
         </p:nvSpPr>
         <p:spPr>
           <a:xfrm>
-            <a:off x="8412480" y="3951732"/>
-            <a:ext cx="137160" cy="137160"/>
+            <a:off x="11539728" y="2053742"/>
+            <a:ext cx="146304" cy="146304"/>
           </a:xfrm>
           <a:prstGeom prst="ellipse">
             <a:avLst/>
           </a:prstGeom>
           <a:solidFill>
-            <a:srgbClr val="F97316"/>
+            <a:srgbClr val="F59E0B"/>
           </a:solidFill>
           <a:ln w="19050">
             <a:solidFill>
-              <a:srgbClr val="FFFFFF"/>
+              <a:srgbClr val="0A1628"/>
             </a:solidFill>
             <a:prstDash val="solid"/>
           </a:ln>
@@ -5970,24 +5834,221 @@
       </p:sp>
       <p:sp>
         <p:nvSpPr>
-          <p:cNvPr id="51" name="Shape 49"/>
-          <p:cNvSpPr/>
-          <p:nvPr/>
-        </p:nvSpPr>
-        <p:spPr>
-          <a:xfrm>
-            <a:off x="9978390" y="5439156"/>
-            <a:ext cx="137160" cy="137160"/>
-          </a:xfrm>
-          <a:prstGeom prst="ellipse">
-            <a:avLst/>
+          <p:cNvPr id="51" name="Text 49"/>
+          <p:cNvSpPr/>
+          <p:nvPr/>
+        </p:nvSpPr>
+        <p:spPr>
+          <a:xfrm>
+            <a:off x="4983480" y="6044184"/>
+            <a:ext cx="731520" cy="256032"/>
+          </a:xfrm>
+          <a:prstGeom prst="rect">
+            <a:avLst/>
+          </a:prstGeom>
+          <a:noFill/>
+          <a:ln/>
+        </p:spPr>
+        <p:txBody>
+          <a:bodyPr wrap="square" rtlCol="0" anchor="ctr"/>
+          <a:lstStyle/>
+          <a:p>
+            <a:pPr algn="ctr" indent="0" marL="0">
+              <a:buNone/>
+            </a:pPr>
+            <a:r>
+              <a:rPr lang="en-US" sz="1100" dirty="0">
+                <a:solidFill>
+                  <a:srgbClr val="94A3B8"/>
+                </a:solidFill>
+                <a:latin typeface="Calibri" pitchFamily="34" charset="0"/>
+                <a:ea typeface="Calibri" pitchFamily="34" charset="-122"/>
+                <a:cs typeface="Calibri" pitchFamily="34" charset="-120"/>
+              </a:rPr>
+              <a:t>FY15</a:t>
+            </a:r>
+            <a:endParaRPr lang="en-US" sz="1100" dirty="0"/>
+          </a:p>
+        </p:txBody>
+      </p:sp>
+      <p:sp>
+        <p:nvSpPr>
+          <p:cNvPr id="52" name="Text 50"/>
+          <p:cNvSpPr/>
+          <p:nvPr/>
+        </p:nvSpPr>
+        <p:spPr>
+          <a:xfrm>
+            <a:off x="6549390" y="6044184"/>
+            <a:ext cx="731520" cy="256032"/>
+          </a:xfrm>
+          <a:prstGeom prst="rect">
+            <a:avLst/>
+          </a:prstGeom>
+          <a:noFill/>
+          <a:ln/>
+        </p:spPr>
+        <p:txBody>
+          <a:bodyPr wrap="square" rtlCol="0" anchor="ctr"/>
+          <a:lstStyle/>
+          <a:p>
+            <a:pPr algn="ctr" indent="0" marL="0">
+              <a:buNone/>
+            </a:pPr>
+            <a:r>
+              <a:rPr lang="en-US" sz="1100" dirty="0">
+                <a:solidFill>
+                  <a:srgbClr val="94A3B8"/>
+                </a:solidFill>
+                <a:latin typeface="Calibri" pitchFamily="34" charset="0"/>
+                <a:ea typeface="Calibri" pitchFamily="34" charset="-122"/>
+                <a:cs typeface="Calibri" pitchFamily="34" charset="-120"/>
+              </a:rPr>
+              <a:t>FY16</a:t>
+            </a:r>
+            <a:endParaRPr lang="en-US" sz="1100" dirty="0"/>
+          </a:p>
+        </p:txBody>
+      </p:sp>
+      <p:sp>
+        <p:nvSpPr>
+          <p:cNvPr id="53" name="Text 51"/>
+          <p:cNvSpPr/>
+          <p:nvPr/>
+        </p:nvSpPr>
+        <p:spPr>
+          <a:xfrm>
+            <a:off x="8115300" y="6044184"/>
+            <a:ext cx="731520" cy="256032"/>
+          </a:xfrm>
+          <a:prstGeom prst="rect">
+            <a:avLst/>
+          </a:prstGeom>
+          <a:noFill/>
+          <a:ln/>
+        </p:spPr>
+        <p:txBody>
+          <a:bodyPr wrap="square" rtlCol="0" anchor="ctr"/>
+          <a:lstStyle/>
+          <a:p>
+            <a:pPr algn="ctr" indent="0" marL="0">
+              <a:buNone/>
+            </a:pPr>
+            <a:r>
+              <a:rPr lang="en-US" sz="1100" dirty="0">
+                <a:solidFill>
+                  <a:srgbClr val="94A3B8"/>
+                </a:solidFill>
+                <a:latin typeface="Calibri" pitchFamily="34" charset="0"/>
+                <a:ea typeface="Calibri" pitchFamily="34" charset="-122"/>
+                <a:cs typeface="Calibri" pitchFamily="34" charset="-120"/>
+              </a:rPr>
+              <a:t>FY17</a:t>
+            </a:r>
+            <a:endParaRPr lang="en-US" sz="1100" dirty="0"/>
+          </a:p>
+        </p:txBody>
+      </p:sp>
+      <p:sp>
+        <p:nvSpPr>
+          <p:cNvPr id="54" name="Text 52"/>
+          <p:cNvSpPr/>
+          <p:nvPr/>
+        </p:nvSpPr>
+        <p:spPr>
+          <a:xfrm>
+            <a:off x="9681210" y="6044184"/>
+            <a:ext cx="731520" cy="256032"/>
+          </a:xfrm>
+          <a:prstGeom prst="rect">
+            <a:avLst/>
+          </a:prstGeom>
+          <a:noFill/>
+          <a:ln/>
+        </p:spPr>
+        <p:txBody>
+          <a:bodyPr wrap="square" rtlCol="0" anchor="ctr"/>
+          <a:lstStyle/>
+          <a:p>
+            <a:pPr algn="ctr" indent="0" marL="0">
+              <a:buNone/>
+            </a:pPr>
+            <a:r>
+              <a:rPr lang="en-US" sz="1100" dirty="0">
+                <a:solidFill>
+                  <a:srgbClr val="94A3B8"/>
+                </a:solidFill>
+                <a:latin typeface="Calibri" pitchFamily="34" charset="0"/>
+                <a:ea typeface="Calibri" pitchFamily="34" charset="-122"/>
+                <a:cs typeface="Calibri" pitchFamily="34" charset="-120"/>
+              </a:rPr>
+              <a:t>FY18</a:t>
+            </a:r>
+            <a:endParaRPr lang="en-US" sz="1100" dirty="0"/>
+          </a:p>
+        </p:txBody>
+      </p:sp>
+      <p:sp>
+        <p:nvSpPr>
+          <p:cNvPr id="55" name="Text 53"/>
+          <p:cNvSpPr/>
+          <p:nvPr/>
+        </p:nvSpPr>
+        <p:spPr>
+          <a:xfrm>
+            <a:off x="11247120" y="6044184"/>
+            <a:ext cx="731520" cy="256032"/>
+          </a:xfrm>
+          <a:prstGeom prst="rect">
+            <a:avLst/>
+          </a:prstGeom>
+          <a:noFill/>
+          <a:ln/>
+        </p:spPr>
+        <p:txBody>
+          <a:bodyPr wrap="square" rtlCol="0" anchor="ctr"/>
+          <a:lstStyle/>
+          <a:p>
+            <a:pPr algn="ctr" indent="0" marL="0">
+              <a:buNone/>
+            </a:pPr>
+            <a:r>
+              <a:rPr lang="en-US" sz="1100" dirty="0">
+                <a:solidFill>
+                  <a:srgbClr val="94A3B8"/>
+                </a:solidFill>
+                <a:latin typeface="Calibri" pitchFamily="34" charset="0"/>
+                <a:ea typeface="Calibri" pitchFamily="34" charset="-122"/>
+                <a:cs typeface="Calibri" pitchFamily="34" charset="-120"/>
+              </a:rPr>
+              <a:t>FY19</a:t>
+            </a:r>
+            <a:endParaRPr lang="en-US" sz="1100" dirty="0"/>
+          </a:p>
+        </p:txBody>
+      </p:sp>
+      <p:sp>
+        <p:nvSpPr>
+          <p:cNvPr id="56" name="Shape 54"/>
+          <p:cNvSpPr/>
+          <p:nvPr/>
+        </p:nvSpPr>
+        <p:spPr>
+          <a:xfrm>
+            <a:off x="9116568" y="1984248"/>
+            <a:ext cx="2468880" cy="804672"/>
+          </a:xfrm>
+          <a:prstGeom prst="roundRect">
+            <a:avLst>
+              <a:gd name="adj" fmla="val 6818"/>
+            </a:avLst>
           </a:prstGeom>
           <a:solidFill>
-            <a:srgbClr val="3B82F6"/>
+            <a:srgbClr val="0A1628"/>
           </a:solidFill>
-          <a:ln w="19050">
+          <a:ln w="12700">
             <a:solidFill>
-              <a:srgbClr val="FFFFFF"/>
+              <a:srgbClr val="1E3350"/>
             </a:solidFill>
             <a:prstDash val="solid"/>
           </a:ln>
@@ -5995,14 +6056,37 @@
       </p:sp>
       <p:sp>
         <p:nvSpPr>
-          <p:cNvPr id="52" name="Text 50"/>
-          <p:cNvSpPr/>
-          <p:nvPr/>
-        </p:nvSpPr>
-        <p:spPr>
-          <a:xfrm>
-            <a:off x="9738360" y="2057400"/>
-            <a:ext cx="1828800" cy="219456"/>
+          <p:cNvPr id="57" name="Shape 55"/>
+          <p:cNvSpPr/>
+          <p:nvPr/>
+        </p:nvSpPr>
+        <p:spPr>
+          <a:xfrm>
+            <a:off x="9281160" y="2240280"/>
+            <a:ext cx="365760" cy="914"/>
+          </a:xfrm>
+          <a:prstGeom prst="line">
+            <a:avLst/>
+          </a:prstGeom>
+          <a:noFill/>
+          <a:ln w="44450">
+            <a:solidFill>
+              <a:srgbClr val="F59E0B"/>
+            </a:solidFill>
+            <a:prstDash val="solid"/>
+          </a:ln>
+        </p:spPr>
+      </p:sp>
+      <p:sp>
+        <p:nvSpPr>
+          <p:cNvPr id="58" name="Text 56"/>
+          <p:cNvSpPr/>
+          <p:nvPr/>
+        </p:nvSpPr>
+        <p:spPr>
+          <a:xfrm>
+            <a:off x="9738360" y="2112264"/>
+            <a:ext cx="1828800" cy="237744"/>
           </a:xfrm>
           <a:prstGeom prst="rect">
             <a:avLst/>
@@ -6018,7 +6102,69 @@
               <a:buNone/>
             </a:pPr>
             <a:r>
-              <a:rPr lang="en-US" sz="900" b="1" spc="150" kern="0" dirty="0">
+              <a:rPr lang="en-US" sz="1000" dirty="0">
+                <a:solidFill>
+                  <a:srgbClr val="FFFFFF"/>
+                </a:solidFill>
+                <a:latin typeface="Calibri" pitchFamily="34" charset="0"/>
+                <a:ea typeface="Calibri" pitchFamily="34" charset="-122"/>
+                <a:cs typeface="Calibri" pitchFamily="34" charset="-120"/>
+              </a:rPr>
+              <a:t>ForesightAI (comprehensive)</a:t>
+            </a:r>
+            <a:endParaRPr lang="en-US" sz="1000" dirty="0"/>
+          </a:p>
+        </p:txBody>
+      </p:sp>
+      <p:sp>
+        <p:nvSpPr>
+          <p:cNvPr id="59" name="Shape 57"/>
+          <p:cNvSpPr/>
+          <p:nvPr/>
+        </p:nvSpPr>
+        <p:spPr>
+          <a:xfrm>
+            <a:off x="9281160" y="2569464"/>
+            <a:ext cx="365760" cy="914"/>
+          </a:xfrm>
+          <a:prstGeom prst="line">
+            <a:avLst/>
+          </a:prstGeom>
+          <a:noFill/>
+          <a:ln w="31750">
+            <a:solidFill>
+              <a:srgbClr val="5B9BD5"/>
+            </a:solidFill>
+            <a:prstDash val="solid"/>
+          </a:ln>
+        </p:spPr>
+      </p:sp>
+      <p:sp>
+        <p:nvSpPr>
+          <p:cNvPr id="60" name="Text 58"/>
+          <p:cNvSpPr/>
+          <p:nvPr/>
+        </p:nvSpPr>
+        <p:spPr>
+          <a:xfrm>
+            <a:off x="9738360" y="2441448"/>
+            <a:ext cx="1828800" cy="237744"/>
+          </a:xfrm>
+          <a:prstGeom prst="rect">
+            <a:avLst/>
+          </a:prstGeom>
+          <a:noFill/>
+          <a:ln/>
+        </p:spPr>
+        <p:txBody>
+          <a:bodyPr wrap="square" rtlCol="0" anchor="ctr"/>
+          <a:lstStyle/>
+          <a:p>
+            <a:pPr indent="0" marL="0">
+              <a:buNone/>
+            </a:pPr>
+            <a:r>
+              <a:rPr lang="en-US" sz="1000" dirty="0">
                 <a:solidFill>
                   <a:srgbClr val="94A3B8"/>
                 </a:solidFill>
@@ -6026,243 +6172,7 @@
                 <a:ea typeface="Calibri" pitchFamily="34" charset="-122"/>
                 <a:cs typeface="Calibri" pitchFamily="34" charset="-120"/>
               </a:rPr>
-              <a:t>SIGNALS MERGED</a:t>
-            </a:r>
-            <a:endParaRPr lang="en-US" sz="900" dirty="0"/>
-          </a:p>
-        </p:txBody>
-      </p:sp>
-      <p:sp>
-        <p:nvSpPr>
-          <p:cNvPr id="53" name="Shape 51"/>
-          <p:cNvSpPr/>
-          <p:nvPr/>
-        </p:nvSpPr>
-        <p:spPr>
-          <a:xfrm>
-            <a:off x="9761220" y="2354580"/>
-            <a:ext cx="100584" cy="100584"/>
-          </a:xfrm>
-          <a:prstGeom prst="ellipse">
-            <a:avLst/>
-          </a:prstGeom>
-          <a:solidFill>
-            <a:srgbClr val="F97316"/>
-          </a:solidFill>
-          <a:ln/>
-        </p:spPr>
-      </p:sp>
-      <p:sp>
-        <p:nvSpPr>
-          <p:cNvPr id="54" name="Text 52"/>
-          <p:cNvSpPr/>
-          <p:nvPr/>
-        </p:nvSpPr>
-        <p:spPr>
-          <a:xfrm>
-            <a:off x="9957816" y="2276856"/>
-            <a:ext cx="1645920" cy="237744"/>
-          </a:xfrm>
-          <a:prstGeom prst="rect">
-            <a:avLst/>
-          </a:prstGeom>
-          <a:noFill/>
-          <a:ln/>
-        </p:spPr>
-        <p:txBody>
-          <a:bodyPr wrap="square" rtlCol="0" anchor="ctr"/>
-          <a:lstStyle/>
-          <a:p>
-            <a:pPr indent="0" marL="0">
-              <a:buNone/>
-            </a:pPr>
-            <a:r>
-              <a:rPr lang="en-US" sz="1000" dirty="0">
-                <a:solidFill>
-                  <a:srgbClr val="FFFFFF"/>
-                </a:solidFill>
-                <a:latin typeface="Calibri" pitchFamily="34" charset="0"/>
-                <a:ea typeface="Calibri" pitchFamily="34" charset="-122"/>
-                <a:cs typeface="Calibri" pitchFamily="34" charset="-120"/>
-              </a:rPr>
-              <a:t>Credit rating</a:t>
-            </a:r>
-            <a:endParaRPr lang="en-US" sz="1000" dirty="0"/>
-          </a:p>
-        </p:txBody>
-      </p:sp>
-      <p:sp>
-        <p:nvSpPr>
-          <p:cNvPr id="55" name="Shape 53"/>
-          <p:cNvSpPr/>
-          <p:nvPr/>
-        </p:nvSpPr>
-        <p:spPr>
-          <a:xfrm>
-            <a:off x="9761220" y="2592324"/>
-            <a:ext cx="100584" cy="100584"/>
-          </a:xfrm>
-          <a:prstGeom prst="ellipse">
-            <a:avLst/>
-          </a:prstGeom>
-          <a:solidFill>
-            <a:srgbClr val="3B82F6"/>
-          </a:solidFill>
-          <a:ln/>
-        </p:spPr>
-      </p:sp>
-      <p:sp>
-        <p:nvSpPr>
-          <p:cNvPr id="56" name="Text 54"/>
-          <p:cNvSpPr/>
-          <p:nvPr/>
-        </p:nvSpPr>
-        <p:spPr>
-          <a:xfrm>
-            <a:off x="9957816" y="2514600"/>
-            <a:ext cx="1645920" cy="237744"/>
-          </a:xfrm>
-          <a:prstGeom prst="rect">
-            <a:avLst/>
-          </a:prstGeom>
-          <a:noFill/>
-          <a:ln/>
-        </p:spPr>
-        <p:txBody>
-          <a:bodyPr wrap="square" rtlCol="0" anchor="ctr"/>
-          <a:lstStyle/>
-          <a:p>
-            <a:pPr indent="0" marL="0">
-              <a:buNone/>
-            </a:pPr>
-            <a:r>
-              <a:rPr lang="en-US" sz="1000" dirty="0">
-                <a:solidFill>
-                  <a:srgbClr val="FFFFFF"/>
-                </a:solidFill>
-                <a:latin typeface="Calibri" pitchFamily="34" charset="0"/>
-                <a:ea typeface="Calibri" pitchFamily="34" charset="-122"/>
-                <a:cs typeface="Calibri" pitchFamily="34" charset="-120"/>
-              </a:rPr>
-              <a:t>Leadership</a:t>
-            </a:r>
-            <a:endParaRPr lang="en-US" sz="1000" dirty="0"/>
-          </a:p>
-        </p:txBody>
-      </p:sp>
-      <p:sp>
-        <p:nvSpPr>
-          <p:cNvPr id="57" name="Shape 55"/>
-          <p:cNvSpPr/>
-          <p:nvPr/>
-        </p:nvSpPr>
-        <p:spPr>
-          <a:xfrm>
-            <a:off x="9761220" y="2830068"/>
-            <a:ext cx="100584" cy="100584"/>
-          </a:xfrm>
-          <a:prstGeom prst="ellipse">
-            <a:avLst/>
-          </a:prstGeom>
-          <a:solidFill>
-            <a:srgbClr val="94A3B8"/>
-          </a:solidFill>
-          <a:ln/>
-        </p:spPr>
-      </p:sp>
-      <p:sp>
-        <p:nvSpPr>
-          <p:cNvPr id="58" name="Text 56"/>
-          <p:cNvSpPr/>
-          <p:nvPr/>
-        </p:nvSpPr>
-        <p:spPr>
-          <a:xfrm>
-            <a:off x="9957816" y="2752344"/>
-            <a:ext cx="1645920" cy="237744"/>
-          </a:xfrm>
-          <a:prstGeom prst="rect">
-            <a:avLst/>
-          </a:prstGeom>
-          <a:noFill/>
-          <a:ln/>
-        </p:spPr>
-        <p:txBody>
-          <a:bodyPr wrap="square" rtlCol="0" anchor="ctr"/>
-          <a:lstStyle/>
-          <a:p>
-            <a:pPr indent="0" marL="0">
-              <a:buNone/>
-            </a:pPr>
-            <a:r>
-              <a:rPr lang="en-US" sz="1000" dirty="0">
-                <a:solidFill>
-                  <a:srgbClr val="FFFFFF"/>
-                </a:solidFill>
-                <a:latin typeface="Calibri" pitchFamily="34" charset="0"/>
-                <a:ea typeface="Calibri" pitchFamily="34" charset="-122"/>
-                <a:cs typeface="Calibri" pitchFamily="34" charset="-120"/>
-              </a:rPr>
-              <a:t>News</a:t>
-            </a:r>
-            <a:endParaRPr lang="en-US" sz="1000" dirty="0"/>
-          </a:p>
-        </p:txBody>
-      </p:sp>
-      <p:sp>
-        <p:nvSpPr>
-          <p:cNvPr id="59" name="Shape 57"/>
-          <p:cNvSpPr/>
-          <p:nvPr/>
-        </p:nvSpPr>
-        <p:spPr>
-          <a:xfrm>
-            <a:off x="9761220" y="3067812"/>
-            <a:ext cx="100584" cy="100584"/>
-          </a:xfrm>
-          <a:prstGeom prst="ellipse">
-            <a:avLst/>
-          </a:prstGeom>
-          <a:solidFill>
-            <a:srgbClr val="A855F7"/>
-          </a:solidFill>
-          <a:ln/>
-        </p:spPr>
-      </p:sp>
-      <p:sp>
-        <p:nvSpPr>
-          <p:cNvPr id="60" name="Text 58"/>
-          <p:cNvSpPr/>
-          <p:nvPr/>
-        </p:nvSpPr>
-        <p:spPr>
-          <a:xfrm>
-            <a:off x="9957816" y="2990088"/>
-            <a:ext cx="1645920" cy="237744"/>
-          </a:xfrm>
-          <a:prstGeom prst="rect">
-            <a:avLst/>
-          </a:prstGeom>
-          <a:noFill/>
-          <a:ln/>
-        </p:spPr>
-        <p:txBody>
-          <a:bodyPr wrap="square" rtlCol="0" anchor="ctr"/>
-          <a:lstStyle/>
-          <a:p>
-            <a:pPr indent="0" marL="0">
-              <a:buNone/>
-            </a:pPr>
-            <a:r>
-              <a:rPr lang="en-US" sz="1000" dirty="0">
-                <a:solidFill>
-                  <a:srgbClr val="FFFFFF"/>
-                </a:solidFill>
-                <a:latin typeface="Calibri" pitchFamily="34" charset="0"/>
-                <a:ea typeface="Calibri" pitchFamily="34" charset="-122"/>
-                <a:cs typeface="Calibri" pitchFamily="34" charset="-120"/>
-              </a:rPr>
-              <a:t>Auditor</a:t>
+              <a:t>Altman (financial only)</a:t>
             </a:r>
             <a:endParaRPr lang="en-US" sz="1000" dirty="0"/>
           </a:p>
@@ -6496,7 +6406,7 @@
                 <a:ea typeface="Calibri" pitchFamily="34" charset="-122"/>
                 <a:cs typeface="Calibri" pitchFamily="34" charset="-120"/>
               </a:rPr>
-              <a:t>Live &amp; automated</a:t>
+              <a:t>Comprehensive</a:t>
             </a:r>
             <a:endParaRPr lang="en-US" sz="1550" dirty="0"/>
           </a:p>
@@ -6538,7 +6448,7 @@
                 <a:ea typeface="Calibri" pitchFamily="34" charset="-122"/>
                 <a:cs typeface="Calibri" pitchFamily="34" charset="-120"/>
               </a:rPr>
-              <a:t>Any company, on demand. No manual pull, no waiting on filings.</a:t>
+              <a:t>Six inputs - financials, ratings, leadership, news, hiring, sentiment - in one score.</a:t>
             </a:r>
             <a:endParaRPr lang="en-US" sz="1250" dirty="0"/>
           </a:p>
@@ -6648,7 +6558,7 @@
                 <a:ea typeface="Calibri" pitchFamily="34" charset="-122"/>
                 <a:cs typeface="Calibri" pitchFamily="34" charset="-120"/>
               </a:rPr>
-              <a:t>Comprehensive</a:t>
+              <a:t>Live &amp; automated</a:t>
             </a:r>
             <a:endParaRPr lang="en-US" sz="1550" dirty="0"/>
           </a:p>
@@ -6690,7 +6600,7 @@
                 <a:ea typeface="Calibri" pitchFamily="34" charset="-122"/>
                 <a:cs typeface="Calibri" pitchFamily="34" charset="-120"/>
               </a:rPr>
-              <a:t>Altman Z fused with credit ratings, leadership, news and hiring.</a:t>
+              <a:t>Any listed company, on demand. No manual pull, no waiting on filings.</a:t>
             </a:r>
             <a:endParaRPr lang="en-US" sz="1250" dirty="0"/>
           </a:p>
@@ -6842,7 +6752,7 @@
                 <a:ea typeface="Calibri" pitchFamily="34" charset="-122"/>
                 <a:cs typeface="Calibri" pitchFamily="34" charset="-120"/>
               </a:rPr>
-              <a:t>Every point traces to a real ratio or a real headline.</a:t>
+              <a:t>Every point traces to a real ratio, rating or headline.</a:t>
             </a:r>
             <a:endParaRPr lang="en-US" sz="1250" dirty="0"/>
           </a:p>
@@ -6952,7 +6862,7 @@
                 <a:ea typeface="Calibri" pitchFamily="34" charset="-122"/>
                 <a:cs typeface="Calibri" pitchFamily="34" charset="-120"/>
               </a:rPr>
-              <a:t>Validated on history</a:t>
+              <a:t>Proven on real cases</a:t>
             </a:r>
             <a:endParaRPr lang="en-US" sz="1550" dirty="0"/>
           </a:p>
@@ -6994,7 +6904,7 @@
                 <a:ea typeface="Calibri" pitchFamily="34" charset="-122"/>
                 <a:cs typeface="Calibri" pitchFamily="34" charset="-120"/>
               </a:rPr>
-              <a:t>Flags real bankruptcies years before the event.</a:t>
+              <a:t>Replayed across five real collapses, in five sectors.</a:t>
             </a:r>
             <a:endParaRPr lang="en-US" sz="1250" dirty="0"/>
           </a:p>

</xml_diff>

<commit_message>
Unify portfolio removal; deck stacked-bar slide and clickable live link
Portfolio now has one control for every company: a single multiselect of
chips with crosses over a shared pool. Adding a live NSE company drops it
into the same pool, so it is removed the same way as the tracked names -
the separate remove dropdown is gone.

Deck: slide 4 is now a native stacked bar (Altman financial base + added
signal risk = the comprehensive score, on Unitech), matching the app. The
title slide and the closing slide carry real clickable hyperlinks to the
live Streamlit dashboard so it opens straight from the presentation.
</commit_message>
<xml_diff>
--- a/deck/ForesightAI.pptx
+++ b/deck/ForesightAI.pptx
@@ -313,6 +313,418 @@
 </file>
 
 <file path=ppt/charts/chart2.xml><?xml version="1.0" encoding="utf-8"?>
+<c:chartSpace xmlns:c="http://schemas.openxmlformats.org/drawingml/2006/chart" xmlns:a="http://schemas.openxmlformats.org/drawingml/2006/main" xmlns:r="http://schemas.openxmlformats.org/officeDocument/2006/relationships">
+  <c:date1904 val="0"/>
+  <c:roundedCorners val="1"/>
+  <c:chart>
+    <c:autoTitleDeleted val="1"/>
+    <c:plotArea>
+      <c:layout/>
+      <c:barChart>
+        <c:barDir val="col"/>
+        <c:grouping val="stacked"/>
+        <c:varyColors val="0"/>
+        <c:ser>
+          <c:idx val="0"/>
+          <c:order val="0"/>
+          <c:tx>
+            <c:strRef>
+              <c:f>Sheet1!$B$1</c:f>
+              <c:strCache>
+                <c:ptCount val="1"/>
+                <c:pt idx="0">
+                  <c:v>Altman (financial-only)</c:v>
+                </c:pt>
+              </c:strCache>
+            </c:strRef>
+          </c:tx>
+          <c:spPr>
+            <a:solidFill>
+              <a:srgbClr val="5B9BD5"/>
+            </a:solidFill>
+            <a:effectLst/>
+          </c:spPr>
+          <c:invertIfNegative val="0"/>
+          <c:dLbls>
+            <c:numFmt formatCode="#,##0" sourceLinked="0"/>
+            <c:txPr>
+              <a:bodyPr/>
+              <a:lstStyle/>
+              <a:p>
+                <a:pPr>
+                  <a:defRPr b="0" i="0" strike="noStrike" sz="1200" u="none">
+                    <a:solidFill>
+                      <a:srgbClr val="000000"/>
+                    </a:solidFill>
+                    <a:latin typeface="Arial"/>
+                  </a:defRPr>
+                </a:pPr>
+              </a:p>
+            </c:txPr>
+            <c:showLegendKey val="0"/>
+            <c:showVal val="0"/>
+            <c:showCatName val="0"/>
+            <c:showSerName val="0"/>
+            <c:showPercent val="0"/>
+            <c:showBubbleSize val="0"/>
+            <c:showLeaderLines val="0"/>
+          </c:dLbls>
+          <c:cat>
+            <c:multiLvlStrRef>
+              <c:f>Sheet1!$A$2:$A$10</c:f>
+              <c:multiLvlStrCache>
+                <c:ptCount val="9"/>
+                <c:lvl>
+                  <c:pt idx="0">
+                    <c:v>FY15</c:v>
+                  </c:pt>
+                  <c:pt idx="1">
+                    <c:v>FY16</c:v>
+                  </c:pt>
+                  <c:pt idx="2">
+                    <c:v>FY17</c:v>
+                  </c:pt>
+                  <c:pt idx="3">
+                    <c:v>FY18</c:v>
+                  </c:pt>
+                  <c:pt idx="4">
+                    <c:v>FY19</c:v>
+                  </c:pt>
+                  <c:pt idx="5">
+                    <c:v>FY20</c:v>
+                  </c:pt>
+                  <c:pt idx="6">
+                    <c:v>FY21</c:v>
+                  </c:pt>
+                  <c:pt idx="7">
+                    <c:v>FY22</c:v>
+                  </c:pt>
+                  <c:pt idx="8">
+                    <c:v>FY23</c:v>
+                  </c:pt>
+                </c:lvl>
+              </c:multiLvlStrCache>
+            </c:multiLvlStrRef>
+          </c:cat>
+          <c:val>
+            <c:numRef>
+              <c:f>Sheet1!$B$2:$B$10</c:f>
+              <c:numCache>
+                <c:formatCode>General</c:formatCode>
+                <c:ptCount val="9"/>
+                <c:pt idx="0">
+                  <c:v>13</c:v>
+                </c:pt>
+                <c:pt idx="1">
+                  <c:v>20</c:v>
+                </c:pt>
+                <c:pt idx="2">
+                  <c:v>21</c:v>
+                </c:pt>
+                <c:pt idx="3">
+                  <c:v>29</c:v>
+                </c:pt>
+                <c:pt idx="4">
+                  <c:v>34</c:v>
+                </c:pt>
+                <c:pt idx="5">
+                  <c:v>49</c:v>
+                </c:pt>
+                <c:pt idx="6">
+                  <c:v>63</c:v>
+                </c:pt>
+                <c:pt idx="7">
+                  <c:v>69</c:v>
+                </c:pt>
+                <c:pt idx="8">
+                  <c:v>85</c:v>
+                </c:pt>
+              </c:numCache>
+            </c:numRef>
+          </c:val>
+        </c:ser>
+        <c:ser>
+          <c:idx val="1"/>
+          <c:order val="1"/>
+          <c:tx>
+            <c:strRef>
+              <c:f>Sheet1!$C$1</c:f>
+              <c:strCache>
+                <c:ptCount val="1"/>
+                <c:pt idx="0">
+                  <c:v>Added risk: market signals</c:v>
+                </c:pt>
+              </c:strCache>
+            </c:strRef>
+          </c:tx>
+          <c:spPr>
+            <a:solidFill>
+              <a:srgbClr val="F59E0B"/>
+            </a:solidFill>
+            <a:effectLst/>
+          </c:spPr>
+          <c:invertIfNegative val="0"/>
+          <c:dLbls>
+            <c:numFmt formatCode="#,##0" sourceLinked="0"/>
+            <c:txPr>
+              <a:bodyPr/>
+              <a:lstStyle/>
+              <a:p>
+                <a:pPr>
+                  <a:defRPr b="0" i="0" strike="noStrike" sz="1200" u="none">
+                    <a:solidFill>
+                      <a:srgbClr val="000000"/>
+                    </a:solidFill>
+                    <a:latin typeface="Arial"/>
+                  </a:defRPr>
+                </a:pPr>
+              </a:p>
+            </c:txPr>
+            <c:showLegendKey val="0"/>
+            <c:showVal val="0"/>
+            <c:showCatName val="0"/>
+            <c:showSerName val="0"/>
+            <c:showPercent val="0"/>
+            <c:showBubbleSize val="0"/>
+            <c:showLeaderLines val="0"/>
+          </c:dLbls>
+          <c:cat>
+            <c:multiLvlStrRef>
+              <c:f>Sheet1!$A$2:$A$10</c:f>
+              <c:multiLvlStrCache>
+                <c:ptCount val="9"/>
+                <c:lvl>
+                  <c:pt idx="0">
+                    <c:v>FY15</c:v>
+                  </c:pt>
+                  <c:pt idx="1">
+                    <c:v>FY16</c:v>
+                  </c:pt>
+                  <c:pt idx="2">
+                    <c:v>FY17</c:v>
+                  </c:pt>
+                  <c:pt idx="3">
+                    <c:v>FY18</c:v>
+                  </c:pt>
+                  <c:pt idx="4">
+                    <c:v>FY19</c:v>
+                  </c:pt>
+                  <c:pt idx="5">
+                    <c:v>FY20</c:v>
+                  </c:pt>
+                  <c:pt idx="6">
+                    <c:v>FY21</c:v>
+                  </c:pt>
+                  <c:pt idx="7">
+                    <c:v>FY22</c:v>
+                  </c:pt>
+                  <c:pt idx="8">
+                    <c:v>FY23</c:v>
+                  </c:pt>
+                </c:lvl>
+              </c:multiLvlStrCache>
+            </c:multiLvlStrRef>
+          </c:cat>
+          <c:val>
+            <c:numRef>
+              <c:f>Sheet1!$C$2:$C$10</c:f>
+              <c:numCache>
+                <c:formatCode>General</c:formatCode>
+                <c:ptCount val="9"/>
+                <c:pt idx="0">
+                  <c:v>15</c:v>
+                </c:pt>
+                <c:pt idx="1">
+                  <c:v>28</c:v>
+                </c:pt>
+                <c:pt idx="2">
+                  <c:v>37</c:v>
+                </c:pt>
+                <c:pt idx="3">
+                  <c:v>45</c:v>
+                </c:pt>
+                <c:pt idx="4">
+                  <c:v>43</c:v>
+                </c:pt>
+                <c:pt idx="5">
+                  <c:v>34</c:v>
+                </c:pt>
+                <c:pt idx="6">
+                  <c:v>23</c:v>
+                </c:pt>
+                <c:pt idx="7">
+                  <c:v>19</c:v>
+                </c:pt>
+                <c:pt idx="8">
+                  <c:v>5</c:v>
+                </c:pt>
+              </c:numCache>
+            </c:numRef>
+          </c:val>
+        </c:ser>
+        <c:dLbls>
+          <c:numFmt formatCode="#,##0" sourceLinked="0"/>
+          <c:txPr>
+            <a:bodyPr/>
+            <a:lstStyle/>
+            <a:p>
+              <a:pPr>
+                <a:defRPr b="0" i="0" strike="noStrike" sz="1200" u="none">
+                  <a:solidFill>
+                    <a:srgbClr val="000000"/>
+                  </a:solidFill>
+                  <a:latin typeface="Arial"/>
+                </a:defRPr>
+              </a:pPr>
+            </a:p>
+          </c:txPr>
+          <c:showLegendKey val="0"/>
+          <c:showVal val="0"/>
+          <c:showCatName val="0"/>
+          <c:showSerName val="0"/>
+          <c:showPercent val="0"/>
+          <c:showBubbleSize val="0"/>
+          <c:showLeaderLines val="0"/>
+        </c:dLbls>
+        <c:gapWidth val="45"/>
+        <c:overlap val="100"/>
+        <c:axId val="2094734554"/>
+        <c:axId val="2094734552"/>
+        <c:axId val="2094734556"/>
+      </c:barChart>
+      <c:catAx>
+        <c:axId val="2094734554"/>
+        <c:scaling>
+          <c:orientation val="minMax"/>
+        </c:scaling>
+        <c:delete val="0"/>
+        <c:axPos val="b"/>
+        <c:numFmt formatCode="General" sourceLinked="1"/>
+        <c:majorTickMark val="out"/>
+        <c:minorTickMark val="none"/>
+        <c:tickLblPos val="low"/>
+        <c:spPr>
+          <a:ln w="12700" cap="flat">
+            <a:noFill/>
+            <a:prstDash val="solid"/>
+            <a:round/>
+          </a:ln>
+        </c:spPr>
+        <c:txPr>
+          <a:bodyPr/>
+          <a:lstStyle/>
+          <a:p>
+            <a:pPr>
+              <a:defRPr sz="1000" b="0" i="0" u="none" strike="noStrike">
+                <a:solidFill>
+                  <a:srgbClr val="94A3B8"/>
+                </a:solidFill>
+                <a:latin typeface="Arial"/>
+              </a:defRPr>
+            </a:pPr>
+            <a:endParaRPr lang="en-US"/>
+          </a:p>
+        </c:txPr>
+        <c:crossAx val="2094734552"/>
+        <c:crosses val="autoZero"/>
+        <c:auto val="1"/>
+        <c:lblAlgn val="ctr"/>
+        <c:noMultiLvlLbl val="1"/>
+      </c:catAx>
+      <c:valAx>
+        <c:axId val="2094734552"/>
+        <c:scaling>
+          <c:orientation val="minMax"/>
+          <c:max val="100"/>
+          <c:min val="0"/>
+        </c:scaling>
+        <c:delete val="0"/>
+        <c:axPos val="l"/>
+        <c:majorGridlines>
+          <c:spPr>
+            <a:ln w="6350" cap="flat">
+              <a:solidFill>
+                <a:srgbClr val="1E3350"/>
+              </a:solidFill>
+              <a:prstDash val="solid"/>
+              <a:round/>
+            </a:ln>
+          </c:spPr>
+        </c:majorGridlines>
+        <c:numFmt formatCode="General" sourceLinked="0"/>
+        <c:majorTickMark val="out"/>
+        <c:minorTickMark val="none"/>
+        <c:tickLblPos val="nextTo"/>
+        <c:spPr>
+          <a:ln w="12700" cap="flat">
+            <a:noFill/>
+            <a:prstDash val="solid"/>
+            <a:round/>
+          </a:ln>
+        </c:spPr>
+        <c:txPr>
+          <a:bodyPr/>
+          <a:lstStyle/>
+          <a:p>
+            <a:pPr>
+              <a:defRPr sz="900" b="0" i="0" u="none" strike="noStrike">
+                <a:solidFill>
+                  <a:srgbClr val="94A3B8"/>
+                </a:solidFill>
+                <a:latin typeface="Arial"/>
+              </a:defRPr>
+            </a:pPr>
+            <a:endParaRPr lang="en-US"/>
+          </a:p>
+        </c:txPr>
+        <c:crossAx val="2094734554"/>
+        <c:crosses val="autoZero"/>
+        <c:crossBetween val="between"/>
+        <c:majorUnit val="25"/>
+      </c:valAx>
+      <c:spPr>
+        <a:noFill/>
+        <a:ln>
+          <a:noFill/>
+        </a:ln>
+        <a:effectLst/>
+      </c:spPr>
+    </c:plotArea>
+    <c:legend>
+      <c:legendPos val="t"/>
+      <c:overlay val="0"/>
+      <c:txPr>
+        <a:bodyPr/>
+        <a:lstStyle/>
+        <a:p>
+          <a:pPr>
+            <a:defRPr sz="1100">
+              <a:solidFill>
+                <a:srgbClr val="FFFFFF"/>
+              </a:solidFill>
+            </a:defRPr>
+          </a:pPr>
+          <a:endParaRPr lang="en-US"/>
+        </a:p>
+      </c:txPr>
+    </c:legend>
+    <c:plotVisOnly val="1"/>
+    <c:dispBlanksAs val="span"/>
+  </c:chart>
+  <c:spPr>
+    <a:noFill/>
+    <a:ln>
+      <a:noFill/>
+    </a:ln>
+    <a:effectLst/>
+  </c:spPr>
+  <c:externalData r:id="rId1">
+    <c:autoUpdate val="0"/>
+  </c:externalData>
+</c:chartSpace>
+</file>
+
+<file path=ppt/charts/chart3.xml><?xml version="1.0" encoding="utf-8"?>
 <c:chartSpace xmlns:c="http://schemas.openxmlformats.org/drawingml/2006/chart" xmlns:a="http://schemas.openxmlformats.org/drawingml/2006/main" xmlns:r="http://schemas.openxmlformats.org/officeDocument/2006/relationships">
   <c:date1904 val="0"/>
   <c:roundedCorners val="1"/>
@@ -1809,7 +2221,9 @@
       </p:sp>
       <p:sp>
         <p:nvSpPr>
-          <p:cNvPr id="5" name="Shape 3"/>
+          <p:cNvPr id="5" name="Shape 3">
+            <a:hlinkClick r:id="rId1" tooltip="Open the live Foresight AI dashboard"/>
+          </p:cNvPr>
           <p:cNvSpPr/>
           <p:nvPr/>
         </p:nvSpPr>
@@ -1836,7 +2250,9 @@
       </p:sp>
       <p:sp>
         <p:nvSpPr>
-          <p:cNvPr id="6" name="Text 4"/>
+          <p:cNvPr id="6" name="Text 4">
+            <a:hlinkClick r:id="rId1" tooltip="Open the live Foresight AI dashboard"/>
+          </p:cNvPr>
           <p:cNvSpPr/>
           <p:nvPr/>
         </p:nvSpPr>
@@ -1859,13 +2275,20 @@
               <a:buNone/>
             </a:pPr>
             <a:r>
-              <a:rPr lang="en-US" sz="1300" dirty="0">
+              <a:rPr lang="en-US" sz="1300" u="sng" dirty="0">
                 <a:solidFill>
                   <a:srgbClr val="94A3B8"/>
                 </a:solidFill>
                 <a:latin typeface="Calibri" pitchFamily="34" charset="0"/>
                 <a:ea typeface="Calibri" pitchFamily="34" charset="-122"/>
                 <a:cs typeface="Calibri" pitchFamily="34" charset="-120"/>
+                <a:hlinkClick r:id="rId1" invalidUrl="" action="" tgtFrame="" tooltip="Open the live Foresight AI dashboard" history="1" highlightClick="0" endSnd="0">
+                  <a:extLst>
+                    <a:ext uri="{A12FA001-AC4F-418D-AE19-62706E023703}">
+                      <ahyp:hlinkClr xmlns:ahyp="http://schemas.microsoft.com/office/drawing/2018/hyperlinkcolor" val="tx"/>
+                    </a:ext>
+                  </a:extLst>
+                </a:hlinkClick>
               </a:rPr>
               <a:t>Live demo   </a:t>
             </a:r>
@@ -1873,13 +2296,20 @@
               <a:buNone/>
             </a:pPr>
             <a:r>
-              <a:rPr lang="en-US" sz="1500" b="1" dirty="0">
+              <a:rPr lang="en-US" sz="1500" b="1" u="sng" dirty="0">
                 <a:solidFill>
                   <a:srgbClr val="F59E0B"/>
                 </a:solidFill>
                 <a:latin typeface="Calibri" pitchFamily="34" charset="0"/>
                 <a:ea typeface="Calibri" pitchFamily="34" charset="-122"/>
                 <a:cs typeface="Calibri" pitchFamily="34" charset="-120"/>
+                <a:hlinkClick r:id="rId1" invalidUrl="" action="" tgtFrame="" tooltip="Open the live Foresight AI dashboard" history="1" highlightClick="0" endSnd="0">
+                  <a:extLst>
+                    <a:ext uri="{A12FA001-AC4F-418D-AE19-62706E023703}">
+                      <ahyp:hlinkClr xmlns:ahyp="http://schemas.microsoft.com/office/drawing/2018/hyperlinkcolor" val="tx"/>
+                    </a:ext>
+                  </a:extLst>
+                </a:hlinkClick>
               </a:rPr>
               <a:t>foresightai.streamlit.app</a:t>
             </a:r>
@@ -1963,7 +2393,7 @@
         </p:xfrm>
         <a:graphic xmlns:a="http://schemas.openxmlformats.org/drawingml/2006/main">
           <a:graphicData uri="http://schemas.openxmlformats.org/drawingml/2006/chart">
-            <c:chart xmlns:c="http://schemas.openxmlformats.org/drawingml/2006/chart" r:id="rId1"/>
+            <c:chart xmlns:c="http://schemas.openxmlformats.org/drawingml/2006/chart" r:id="rId2"/>
           </a:graphicData>
         </a:graphic>
       </p:graphicFrame>
@@ -4815,7 +5245,7 @@
         </p:nvSpPr>
         <p:spPr>
           <a:xfrm>
-            <a:off x="5349240" y="1664208"/>
+            <a:off x="5349240" y="1755648"/>
             <a:ext cx="6263640" cy="228600"/>
           </a:xfrm>
           <a:prstGeom prst="rect">
@@ -4840,66 +5270,38 @@
                 <a:ea typeface="Calibri" pitchFamily="34" charset="-122"/>
                 <a:cs typeface="Calibri" pitchFamily="34" charset="-120"/>
               </a:rPr>
-              <a:t>Example - Reliance Communications (telecom)</a:t>
+              <a:t>Example - Unitech (real estate): Altman read Safe for years</a:t>
             </a:r>
             <a:endParaRPr lang="en-US" sz="1100" dirty="0"/>
           </a:p>
         </p:txBody>
       </p:sp>
-      <p:sp>
-        <p:nvSpPr>
-          <p:cNvPr id="11" name="Shape 9"/>
-          <p:cNvSpPr/>
-          <p:nvPr/>
-        </p:nvSpPr>
-        <p:spPr>
-          <a:xfrm>
-            <a:off x="5349240" y="1965960"/>
-            <a:ext cx="6263640" cy="1207008"/>
-          </a:xfrm>
-          <a:prstGeom prst="rect">
-            <a:avLst/>
-          </a:prstGeom>
-          <a:solidFill>
-            <a:srgbClr val="EF4444">
-              <a:alpha val="10000"/>
-            </a:srgbClr>
-          </a:solidFill>
-          <a:ln/>
-        </p:spPr>
-      </p:sp>
-      <p:sp>
-        <p:nvSpPr>
-          <p:cNvPr id="12" name="Shape 10"/>
-          <p:cNvSpPr/>
-          <p:nvPr/>
-        </p:nvSpPr>
-        <p:spPr>
-          <a:xfrm>
-            <a:off x="5349240" y="4782312"/>
-            <a:ext cx="6263640" cy="1207008"/>
-          </a:xfrm>
-          <a:prstGeom prst="rect">
-            <a:avLst/>
-          </a:prstGeom>
-          <a:solidFill>
-            <a:srgbClr val="22C55E">
-              <a:alpha val="10000"/>
-            </a:srgbClr>
-          </a:solidFill>
-          <a:ln/>
-        </p:spPr>
-      </p:sp>
-      <p:sp>
-        <p:nvSpPr>
-          <p:cNvPr id="13" name="Text 11"/>
-          <p:cNvSpPr/>
-          <p:nvPr/>
-        </p:nvSpPr>
-        <p:spPr>
-          <a:xfrm>
-            <a:off x="5458968" y="1984248"/>
-            <a:ext cx="1828800" cy="228600"/>
+      <p:graphicFrame>
+        <p:nvGraphicFramePr>
+          <p:cNvPr id="11" name="Chart 0" descr=""/>
+          <p:cNvGraphicFramePr/>
+          <p:nvPr/>
+        </p:nvGraphicFramePr>
+        <p:xfrm>
+          <a:off x="5349240" y="2194560"/>
+          <a:ext cx="6263640" cy="3611880"/>
+        </p:xfrm>
+        <a:graphic xmlns:a="http://schemas.openxmlformats.org/drawingml/2006/main">
+          <a:graphicData uri="http://schemas.openxmlformats.org/drawingml/2006/chart">
+            <c:chart xmlns:c="http://schemas.openxmlformats.org/drawingml/2006/chart" r:id="rId1"/>
+          </a:graphicData>
+        </a:graphic>
+      </p:graphicFrame>
+      <p:sp>
+        <p:nvSpPr>
+          <p:cNvPr id="12" name="Text 9"/>
+          <p:cNvSpPr/>
+          <p:nvPr/>
+        </p:nvSpPr>
+        <p:spPr>
+          <a:xfrm>
+            <a:off x="5349240" y="5861304"/>
+            <a:ext cx="6263640" cy="274320"/>
           </a:xfrm>
           <a:prstGeom prst="rect">
             <a:avLst/>
@@ -4915,476 +5317,7 @@
               <a:buNone/>
             </a:pPr>
             <a:r>
-              <a:rPr lang="en-US" sz="1000" b="1" dirty="0">
-                <a:solidFill>
-                  <a:srgbClr val="EF4444"/>
-                </a:solidFill>
-                <a:latin typeface="Calibri" pitchFamily="34" charset="0"/>
-                <a:ea typeface="Calibri" pitchFamily="34" charset="-122"/>
-                <a:cs typeface="Calibri" pitchFamily="34" charset="-120"/>
-              </a:rPr>
-              <a:t>HIGH RISK</a:t>
-            </a:r>
-            <a:endParaRPr lang="en-US" sz="1000" dirty="0"/>
-          </a:p>
-        </p:txBody>
-      </p:sp>
-      <p:sp>
-        <p:nvSpPr>
-          <p:cNvPr id="14" name="Text 12"/>
-          <p:cNvSpPr/>
-          <p:nvPr/>
-        </p:nvSpPr>
-        <p:spPr>
-          <a:xfrm>
-            <a:off x="5458968" y="5733288"/>
-            <a:ext cx="1828800" cy="228600"/>
-          </a:xfrm>
-          <a:prstGeom prst="rect">
-            <a:avLst/>
-          </a:prstGeom>
-          <a:noFill/>
-          <a:ln/>
-        </p:spPr>
-        <p:txBody>
-          <a:bodyPr wrap="square" rtlCol="0" anchor="ctr"/>
-          <a:lstStyle/>
-          <a:p>
-            <a:pPr indent="0" marL="0">
-              <a:buNone/>
-            </a:pPr>
-            <a:r>
-              <a:rPr lang="en-US" sz="1000" b="1" dirty="0">
-                <a:solidFill>
-                  <a:srgbClr val="22C55E"/>
-                </a:solidFill>
-                <a:latin typeface="Calibri" pitchFamily="34" charset="0"/>
-                <a:ea typeface="Calibri" pitchFamily="34" charset="-122"/>
-                <a:cs typeface="Calibri" pitchFamily="34" charset="-120"/>
-              </a:rPr>
-              <a:t>HEALTHY</a:t>
-            </a:r>
-            <a:endParaRPr lang="en-US" sz="1000" dirty="0"/>
-          </a:p>
-        </p:txBody>
-      </p:sp>
-      <p:sp>
-        <p:nvSpPr>
-          <p:cNvPr id="15" name="Shape 13"/>
-          <p:cNvSpPr/>
-          <p:nvPr/>
-        </p:nvSpPr>
-        <p:spPr>
-          <a:xfrm>
-            <a:off x="5349240" y="5989320"/>
-            <a:ext cx="6263640" cy="914"/>
-          </a:xfrm>
-          <a:prstGeom prst="line">
-            <a:avLst/>
-          </a:prstGeom>
-          <a:noFill/>
-          <a:ln w="12700">
-            <a:solidFill>
-              <a:srgbClr val="1E3350"/>
-            </a:solidFill>
-            <a:prstDash val="solid"/>
-          </a:ln>
-        </p:spPr>
-      </p:sp>
-      <p:sp>
-        <p:nvSpPr>
-          <p:cNvPr id="16" name="Shape 14"/>
-          <p:cNvSpPr/>
-          <p:nvPr/>
-        </p:nvSpPr>
-        <p:spPr>
-          <a:xfrm>
-            <a:off x="11612880" y="1965960"/>
-            <a:ext cx="914" cy="128016"/>
-          </a:xfrm>
-          <a:prstGeom prst="line">
-            <a:avLst/>
-          </a:prstGeom>
-          <a:noFill/>
-          <a:ln w="15240">
-            <a:solidFill>
-              <a:srgbClr val="94A3B8"/>
-            </a:solidFill>
-            <a:prstDash val="solid"/>
-          </a:ln>
-        </p:spPr>
-      </p:sp>
-      <p:sp>
-        <p:nvSpPr>
-          <p:cNvPr id="17" name="Shape 15"/>
-          <p:cNvSpPr/>
-          <p:nvPr/>
-        </p:nvSpPr>
-        <p:spPr>
-          <a:xfrm>
-            <a:off x="11612880" y="2221992"/>
-            <a:ext cx="914" cy="128016"/>
-          </a:xfrm>
-          <a:prstGeom prst="line">
-            <a:avLst/>
-          </a:prstGeom>
-          <a:noFill/>
-          <a:ln w="15240">
-            <a:solidFill>
-              <a:srgbClr val="94A3B8"/>
-            </a:solidFill>
-            <a:prstDash val="solid"/>
-          </a:ln>
-        </p:spPr>
-      </p:sp>
-      <p:sp>
-        <p:nvSpPr>
-          <p:cNvPr id="18" name="Shape 16"/>
-          <p:cNvSpPr/>
-          <p:nvPr/>
-        </p:nvSpPr>
-        <p:spPr>
-          <a:xfrm>
-            <a:off x="11612880" y="2478024"/>
-            <a:ext cx="914" cy="128016"/>
-          </a:xfrm>
-          <a:prstGeom prst="line">
-            <a:avLst/>
-          </a:prstGeom>
-          <a:noFill/>
-          <a:ln w="15240">
-            <a:solidFill>
-              <a:srgbClr val="94A3B8"/>
-            </a:solidFill>
-            <a:prstDash val="solid"/>
-          </a:ln>
-        </p:spPr>
-      </p:sp>
-      <p:sp>
-        <p:nvSpPr>
-          <p:cNvPr id="19" name="Shape 17"/>
-          <p:cNvSpPr/>
-          <p:nvPr/>
-        </p:nvSpPr>
-        <p:spPr>
-          <a:xfrm>
-            <a:off x="11612880" y="2734056"/>
-            <a:ext cx="914" cy="128016"/>
-          </a:xfrm>
-          <a:prstGeom prst="line">
-            <a:avLst/>
-          </a:prstGeom>
-          <a:noFill/>
-          <a:ln w="15240">
-            <a:solidFill>
-              <a:srgbClr val="94A3B8"/>
-            </a:solidFill>
-            <a:prstDash val="solid"/>
-          </a:ln>
-        </p:spPr>
-      </p:sp>
-      <p:sp>
-        <p:nvSpPr>
-          <p:cNvPr id="20" name="Shape 18"/>
-          <p:cNvSpPr/>
-          <p:nvPr/>
-        </p:nvSpPr>
-        <p:spPr>
-          <a:xfrm>
-            <a:off x="11612880" y="2990088"/>
-            <a:ext cx="914" cy="128016"/>
-          </a:xfrm>
-          <a:prstGeom prst="line">
-            <a:avLst/>
-          </a:prstGeom>
-          <a:noFill/>
-          <a:ln w="15240">
-            <a:solidFill>
-              <a:srgbClr val="94A3B8"/>
-            </a:solidFill>
-            <a:prstDash val="solid"/>
-          </a:ln>
-        </p:spPr>
-      </p:sp>
-      <p:sp>
-        <p:nvSpPr>
-          <p:cNvPr id="21" name="Shape 19"/>
-          <p:cNvSpPr/>
-          <p:nvPr/>
-        </p:nvSpPr>
-        <p:spPr>
-          <a:xfrm>
-            <a:off x="11612880" y="3246120"/>
-            <a:ext cx="914" cy="128016"/>
-          </a:xfrm>
-          <a:prstGeom prst="line">
-            <a:avLst/>
-          </a:prstGeom>
-          <a:noFill/>
-          <a:ln w="15240">
-            <a:solidFill>
-              <a:srgbClr val="94A3B8"/>
-            </a:solidFill>
-            <a:prstDash val="solid"/>
-          </a:ln>
-        </p:spPr>
-      </p:sp>
-      <p:sp>
-        <p:nvSpPr>
-          <p:cNvPr id="22" name="Shape 20"/>
-          <p:cNvSpPr/>
-          <p:nvPr/>
-        </p:nvSpPr>
-        <p:spPr>
-          <a:xfrm>
-            <a:off x="11612880" y="3502152"/>
-            <a:ext cx="914" cy="128016"/>
-          </a:xfrm>
-          <a:prstGeom prst="line">
-            <a:avLst/>
-          </a:prstGeom>
-          <a:noFill/>
-          <a:ln w="15240">
-            <a:solidFill>
-              <a:srgbClr val="94A3B8"/>
-            </a:solidFill>
-            <a:prstDash val="solid"/>
-          </a:ln>
-        </p:spPr>
-      </p:sp>
-      <p:sp>
-        <p:nvSpPr>
-          <p:cNvPr id="23" name="Shape 21"/>
-          <p:cNvSpPr/>
-          <p:nvPr/>
-        </p:nvSpPr>
-        <p:spPr>
-          <a:xfrm>
-            <a:off x="11612880" y="3758184"/>
-            <a:ext cx="914" cy="128016"/>
-          </a:xfrm>
-          <a:prstGeom prst="line">
-            <a:avLst/>
-          </a:prstGeom>
-          <a:noFill/>
-          <a:ln w="15240">
-            <a:solidFill>
-              <a:srgbClr val="94A3B8"/>
-            </a:solidFill>
-            <a:prstDash val="solid"/>
-          </a:ln>
-        </p:spPr>
-      </p:sp>
-      <p:sp>
-        <p:nvSpPr>
-          <p:cNvPr id="24" name="Shape 22"/>
-          <p:cNvSpPr/>
-          <p:nvPr/>
-        </p:nvSpPr>
-        <p:spPr>
-          <a:xfrm>
-            <a:off x="11612880" y="4014216"/>
-            <a:ext cx="914" cy="128016"/>
-          </a:xfrm>
-          <a:prstGeom prst="line">
-            <a:avLst/>
-          </a:prstGeom>
-          <a:noFill/>
-          <a:ln w="15240">
-            <a:solidFill>
-              <a:srgbClr val="94A3B8"/>
-            </a:solidFill>
-            <a:prstDash val="solid"/>
-          </a:ln>
-        </p:spPr>
-      </p:sp>
-      <p:sp>
-        <p:nvSpPr>
-          <p:cNvPr id="25" name="Shape 23"/>
-          <p:cNvSpPr/>
-          <p:nvPr/>
-        </p:nvSpPr>
-        <p:spPr>
-          <a:xfrm>
-            <a:off x="11612880" y="4270248"/>
-            <a:ext cx="914" cy="128016"/>
-          </a:xfrm>
-          <a:prstGeom prst="line">
-            <a:avLst/>
-          </a:prstGeom>
-          <a:noFill/>
-          <a:ln w="15240">
-            <a:solidFill>
-              <a:srgbClr val="94A3B8"/>
-            </a:solidFill>
-            <a:prstDash val="solid"/>
-          </a:ln>
-        </p:spPr>
-      </p:sp>
-      <p:sp>
-        <p:nvSpPr>
-          <p:cNvPr id="26" name="Shape 24"/>
-          <p:cNvSpPr/>
-          <p:nvPr/>
-        </p:nvSpPr>
-        <p:spPr>
-          <a:xfrm>
-            <a:off x="11612880" y="4526280"/>
-            <a:ext cx="914" cy="128016"/>
-          </a:xfrm>
-          <a:prstGeom prst="line">
-            <a:avLst/>
-          </a:prstGeom>
-          <a:noFill/>
-          <a:ln w="15240">
-            <a:solidFill>
-              <a:srgbClr val="94A3B8"/>
-            </a:solidFill>
-            <a:prstDash val="solid"/>
-          </a:ln>
-        </p:spPr>
-      </p:sp>
-      <p:sp>
-        <p:nvSpPr>
-          <p:cNvPr id="27" name="Shape 25"/>
-          <p:cNvSpPr/>
-          <p:nvPr/>
-        </p:nvSpPr>
-        <p:spPr>
-          <a:xfrm>
-            <a:off x="11612880" y="4782312"/>
-            <a:ext cx="914" cy="128016"/>
-          </a:xfrm>
-          <a:prstGeom prst="line">
-            <a:avLst/>
-          </a:prstGeom>
-          <a:noFill/>
-          <a:ln w="15240">
-            <a:solidFill>
-              <a:srgbClr val="94A3B8"/>
-            </a:solidFill>
-            <a:prstDash val="solid"/>
-          </a:ln>
-        </p:spPr>
-      </p:sp>
-      <p:sp>
-        <p:nvSpPr>
-          <p:cNvPr id="28" name="Shape 26"/>
-          <p:cNvSpPr/>
-          <p:nvPr/>
-        </p:nvSpPr>
-        <p:spPr>
-          <a:xfrm>
-            <a:off x="11612880" y="5038344"/>
-            <a:ext cx="914" cy="128016"/>
-          </a:xfrm>
-          <a:prstGeom prst="line">
-            <a:avLst/>
-          </a:prstGeom>
-          <a:noFill/>
-          <a:ln w="15240">
-            <a:solidFill>
-              <a:srgbClr val="94A3B8"/>
-            </a:solidFill>
-            <a:prstDash val="solid"/>
-          </a:ln>
-        </p:spPr>
-      </p:sp>
-      <p:sp>
-        <p:nvSpPr>
-          <p:cNvPr id="29" name="Shape 27"/>
-          <p:cNvSpPr/>
-          <p:nvPr/>
-        </p:nvSpPr>
-        <p:spPr>
-          <a:xfrm>
-            <a:off x="11612880" y="5294376"/>
-            <a:ext cx="914" cy="128016"/>
-          </a:xfrm>
-          <a:prstGeom prst="line">
-            <a:avLst/>
-          </a:prstGeom>
-          <a:noFill/>
-          <a:ln w="15240">
-            <a:solidFill>
-              <a:srgbClr val="94A3B8"/>
-            </a:solidFill>
-            <a:prstDash val="solid"/>
-          </a:ln>
-        </p:spPr>
-      </p:sp>
-      <p:sp>
-        <p:nvSpPr>
-          <p:cNvPr id="30" name="Shape 28"/>
-          <p:cNvSpPr/>
-          <p:nvPr/>
-        </p:nvSpPr>
-        <p:spPr>
-          <a:xfrm>
-            <a:off x="11612880" y="5550408"/>
-            <a:ext cx="914" cy="128016"/>
-          </a:xfrm>
-          <a:prstGeom prst="line">
-            <a:avLst/>
-          </a:prstGeom>
-          <a:noFill/>
-          <a:ln w="15240">
-            <a:solidFill>
-              <a:srgbClr val="94A3B8"/>
-            </a:solidFill>
-            <a:prstDash val="solid"/>
-          </a:ln>
-        </p:spPr>
-      </p:sp>
-      <p:sp>
-        <p:nvSpPr>
-          <p:cNvPr id="31" name="Shape 29"/>
-          <p:cNvSpPr/>
-          <p:nvPr/>
-        </p:nvSpPr>
-        <p:spPr>
-          <a:xfrm>
-            <a:off x="11612880" y="5806440"/>
-            <a:ext cx="914" cy="128016"/>
-          </a:xfrm>
-          <a:prstGeom prst="line">
-            <a:avLst/>
-          </a:prstGeom>
-          <a:noFill/>
-          <a:ln w="15240">
-            <a:solidFill>
-              <a:srgbClr val="94A3B8"/>
-            </a:solidFill>
-            <a:prstDash val="solid"/>
-          </a:ln>
-        </p:spPr>
-      </p:sp>
-      <p:sp>
-        <p:nvSpPr>
-          <p:cNvPr id="32" name="Text 30"/>
-          <p:cNvSpPr/>
-          <p:nvPr/>
-        </p:nvSpPr>
-        <p:spPr>
-          <a:xfrm>
-            <a:off x="9875520" y="1920240"/>
-            <a:ext cx="1691640" cy="228600"/>
-          </a:xfrm>
-          <a:prstGeom prst="rect">
-            <a:avLst/>
-          </a:prstGeom>
-          <a:noFill/>
-          <a:ln/>
-        </p:spPr>
-        <p:txBody>
-          <a:bodyPr wrap="square" rtlCol="0" anchor="ctr"/>
-          <a:lstStyle/>
-          <a:p>
-            <a:pPr algn="r" indent="0" marL="0">
-              <a:buNone/>
-            </a:pPr>
-            <a:r>
-              <a:rPr lang="en-US" sz="1000" b="1" dirty="0">
+              <a:rPr lang="en-US" sz="1050" i="1" dirty="0">
                 <a:solidFill>
                   <a:srgbClr val="94A3B8"/>
                 </a:solidFill>
@@ -5392,789 +5325,9 @@
                 <a:ea typeface="Calibri" pitchFamily="34" charset="-122"/>
                 <a:cs typeface="Calibri" pitchFamily="34" charset="-120"/>
               </a:rPr>
-              <a:t>INSOLVENCY 2019</a:t>
-            </a:r>
-            <a:endParaRPr lang="en-US" sz="1000" dirty="0"/>
-          </a:p>
-        </p:txBody>
-      </p:sp>
-      <p:sp>
-        <p:nvSpPr>
-          <p:cNvPr id="33" name="Shape 31"/>
-          <p:cNvSpPr/>
-          <p:nvPr/>
-        </p:nvSpPr>
-        <p:spPr>
-          <a:xfrm flipV="1">
-            <a:off x="5349240" y="3575304"/>
-            <a:ext cx="1565910" cy="1046074"/>
-          </a:xfrm>
-          <a:prstGeom prst="line">
-            <a:avLst/>
-          </a:prstGeom>
-          <a:noFill/>
-          <a:ln w="31750">
-            <a:solidFill>
-              <a:srgbClr val="5B9BD5"/>
-            </a:solidFill>
-            <a:prstDash val="solid"/>
-          </a:ln>
-        </p:spPr>
-      </p:sp>
-      <p:sp>
-        <p:nvSpPr>
-          <p:cNvPr id="34" name="Shape 32"/>
-          <p:cNvSpPr/>
-          <p:nvPr/>
-        </p:nvSpPr>
-        <p:spPr>
-          <a:xfrm flipV="1">
-            <a:off x="6915150" y="2971800"/>
-            <a:ext cx="1565910" cy="603504"/>
-          </a:xfrm>
-          <a:prstGeom prst="line">
-            <a:avLst/>
-          </a:prstGeom>
-          <a:noFill/>
-          <a:ln w="31750">
-            <a:solidFill>
-              <a:srgbClr val="5B9BD5"/>
-            </a:solidFill>
-            <a:prstDash val="solid"/>
-          </a:ln>
-        </p:spPr>
-      </p:sp>
-      <p:sp>
-        <p:nvSpPr>
-          <p:cNvPr id="35" name="Shape 33"/>
-          <p:cNvSpPr/>
-          <p:nvPr/>
-        </p:nvSpPr>
-        <p:spPr>
-          <a:xfrm flipV="1">
-            <a:off x="8481060" y="2167128"/>
-            <a:ext cx="1565910" cy="804672"/>
-          </a:xfrm>
-          <a:prstGeom prst="line">
-            <a:avLst/>
-          </a:prstGeom>
-          <a:noFill/>
-          <a:ln w="31750">
-            <a:solidFill>
-              <a:srgbClr val="5B9BD5"/>
-            </a:solidFill>
-            <a:prstDash val="solid"/>
-          </a:ln>
-        </p:spPr>
-      </p:sp>
-      <p:sp>
-        <p:nvSpPr>
-          <p:cNvPr id="36" name="Shape 34"/>
-          <p:cNvSpPr/>
-          <p:nvPr/>
-        </p:nvSpPr>
-        <p:spPr>
-          <a:xfrm flipV="1">
-            <a:off x="10046970" y="2126894"/>
-            <a:ext cx="1565910" cy="40234"/>
-          </a:xfrm>
-          <a:prstGeom prst="line">
-            <a:avLst/>
-          </a:prstGeom>
-          <a:noFill/>
-          <a:ln w="31750">
-            <a:solidFill>
-              <a:srgbClr val="5B9BD5"/>
-            </a:solidFill>
-            <a:prstDash val="solid"/>
-          </a:ln>
-        </p:spPr>
-      </p:sp>
-      <p:sp>
-        <p:nvSpPr>
-          <p:cNvPr id="37" name="Shape 35"/>
-          <p:cNvSpPr/>
-          <p:nvPr/>
-        </p:nvSpPr>
-        <p:spPr>
-          <a:xfrm>
-            <a:off x="5294376" y="4566514"/>
-            <a:ext cx="109728" cy="109728"/>
-          </a:xfrm>
-          <a:prstGeom prst="ellipse">
-            <a:avLst/>
-          </a:prstGeom>
-          <a:solidFill>
-            <a:srgbClr val="5B9BD5"/>
-          </a:solidFill>
-          <a:ln w="19050">
-            <a:solidFill>
-              <a:srgbClr val="0A1628"/>
-            </a:solidFill>
-            <a:prstDash val="solid"/>
-          </a:ln>
-        </p:spPr>
-      </p:sp>
-      <p:sp>
-        <p:nvSpPr>
-          <p:cNvPr id="38" name="Shape 36"/>
-          <p:cNvSpPr/>
-          <p:nvPr/>
-        </p:nvSpPr>
-        <p:spPr>
-          <a:xfrm>
-            <a:off x="6860286" y="3520440"/>
-            <a:ext cx="109728" cy="109728"/>
-          </a:xfrm>
-          <a:prstGeom prst="ellipse">
-            <a:avLst/>
-          </a:prstGeom>
-          <a:solidFill>
-            <a:srgbClr val="5B9BD5"/>
-          </a:solidFill>
-          <a:ln w="19050">
-            <a:solidFill>
-              <a:srgbClr val="0A1628"/>
-            </a:solidFill>
-            <a:prstDash val="solid"/>
-          </a:ln>
-        </p:spPr>
-      </p:sp>
-      <p:sp>
-        <p:nvSpPr>
-          <p:cNvPr id="39" name="Shape 37"/>
-          <p:cNvSpPr/>
-          <p:nvPr/>
-        </p:nvSpPr>
-        <p:spPr>
-          <a:xfrm>
-            <a:off x="8426196" y="2916936"/>
-            <a:ext cx="109728" cy="109728"/>
-          </a:xfrm>
-          <a:prstGeom prst="ellipse">
-            <a:avLst/>
-          </a:prstGeom>
-          <a:solidFill>
-            <a:srgbClr val="5B9BD5"/>
-          </a:solidFill>
-          <a:ln w="19050">
-            <a:solidFill>
-              <a:srgbClr val="0A1628"/>
-            </a:solidFill>
-            <a:prstDash val="solid"/>
-          </a:ln>
-        </p:spPr>
-      </p:sp>
-      <p:sp>
-        <p:nvSpPr>
-          <p:cNvPr id="40" name="Shape 38"/>
-          <p:cNvSpPr/>
-          <p:nvPr/>
-        </p:nvSpPr>
-        <p:spPr>
-          <a:xfrm>
-            <a:off x="9992106" y="2112264"/>
-            <a:ext cx="109728" cy="109728"/>
-          </a:xfrm>
-          <a:prstGeom prst="ellipse">
-            <a:avLst/>
-          </a:prstGeom>
-          <a:solidFill>
-            <a:srgbClr val="5B9BD5"/>
-          </a:solidFill>
-          <a:ln w="19050">
-            <a:solidFill>
-              <a:srgbClr val="0A1628"/>
-            </a:solidFill>
-            <a:prstDash val="solid"/>
-          </a:ln>
-        </p:spPr>
-      </p:sp>
-      <p:sp>
-        <p:nvSpPr>
-          <p:cNvPr id="41" name="Shape 39"/>
-          <p:cNvSpPr/>
-          <p:nvPr/>
-        </p:nvSpPr>
-        <p:spPr>
-          <a:xfrm>
-            <a:off x="11558016" y="2072030"/>
-            <a:ext cx="109728" cy="109728"/>
-          </a:xfrm>
-          <a:prstGeom prst="ellipse">
-            <a:avLst/>
-          </a:prstGeom>
-          <a:solidFill>
-            <a:srgbClr val="5B9BD5"/>
-          </a:solidFill>
-          <a:ln w="19050">
-            <a:solidFill>
-              <a:srgbClr val="0A1628"/>
-            </a:solidFill>
-            <a:prstDash val="solid"/>
-          </a:ln>
-        </p:spPr>
-      </p:sp>
-      <p:sp>
-        <p:nvSpPr>
-          <p:cNvPr id="42" name="Shape 40"/>
-          <p:cNvSpPr/>
-          <p:nvPr/>
-        </p:nvSpPr>
-        <p:spPr>
-          <a:xfrm flipV="1">
-            <a:off x="5349240" y="3454603"/>
-            <a:ext cx="1565910" cy="925373"/>
-          </a:xfrm>
-          <a:prstGeom prst="line">
-            <a:avLst/>
-          </a:prstGeom>
-          <a:noFill/>
-          <a:ln w="44450">
-            <a:solidFill>
-              <a:srgbClr val="F59E0B"/>
-            </a:solidFill>
-            <a:prstDash val="solid"/>
-          </a:ln>
-        </p:spPr>
-      </p:sp>
-      <p:sp>
-        <p:nvSpPr>
-          <p:cNvPr id="43" name="Shape 41"/>
-          <p:cNvSpPr/>
-          <p:nvPr/>
-        </p:nvSpPr>
-        <p:spPr>
-          <a:xfrm flipV="1">
-            <a:off x="6915150" y="2609698"/>
-            <a:ext cx="1565910" cy="844906"/>
-          </a:xfrm>
-          <a:prstGeom prst="line">
-            <a:avLst/>
-          </a:prstGeom>
-          <a:noFill/>
-          <a:ln w="44450">
-            <a:solidFill>
-              <a:srgbClr val="F59E0B"/>
-            </a:solidFill>
-            <a:prstDash val="solid"/>
-          </a:ln>
-        </p:spPr>
-      </p:sp>
-      <p:sp>
-        <p:nvSpPr>
-          <p:cNvPr id="44" name="Shape 42"/>
-          <p:cNvSpPr/>
-          <p:nvPr/>
-        </p:nvSpPr>
-        <p:spPr>
-          <a:xfrm flipV="1">
-            <a:off x="8481060" y="2287829"/>
-            <a:ext cx="1565910" cy="321869"/>
-          </a:xfrm>
-          <a:prstGeom prst="line">
-            <a:avLst/>
-          </a:prstGeom>
-          <a:noFill/>
-          <a:ln w="44450">
-            <a:solidFill>
-              <a:srgbClr val="F59E0B"/>
-            </a:solidFill>
-            <a:prstDash val="solid"/>
-          </a:ln>
-        </p:spPr>
-      </p:sp>
-      <p:sp>
-        <p:nvSpPr>
-          <p:cNvPr id="45" name="Shape 43"/>
-          <p:cNvSpPr/>
-          <p:nvPr/>
-        </p:nvSpPr>
-        <p:spPr>
-          <a:xfrm flipV="1">
-            <a:off x="10046970" y="2126894"/>
-            <a:ext cx="1565910" cy="160934"/>
-          </a:xfrm>
-          <a:prstGeom prst="line">
-            <a:avLst/>
-          </a:prstGeom>
-          <a:noFill/>
-          <a:ln w="44450">
-            <a:solidFill>
-              <a:srgbClr val="F59E0B"/>
-            </a:solidFill>
-            <a:prstDash val="solid"/>
-          </a:ln>
-        </p:spPr>
-      </p:sp>
-      <p:sp>
-        <p:nvSpPr>
-          <p:cNvPr id="46" name="Shape 44"/>
-          <p:cNvSpPr/>
-          <p:nvPr/>
-        </p:nvSpPr>
-        <p:spPr>
-          <a:xfrm>
-            <a:off x="5276088" y="4306824"/>
-            <a:ext cx="146304" cy="146304"/>
-          </a:xfrm>
-          <a:prstGeom prst="ellipse">
-            <a:avLst/>
-          </a:prstGeom>
-          <a:solidFill>
-            <a:srgbClr val="F59E0B"/>
-          </a:solidFill>
-          <a:ln w="19050">
-            <a:solidFill>
-              <a:srgbClr val="0A1628"/>
-            </a:solidFill>
-            <a:prstDash val="solid"/>
-          </a:ln>
-        </p:spPr>
-      </p:sp>
-      <p:sp>
-        <p:nvSpPr>
-          <p:cNvPr id="47" name="Shape 45"/>
-          <p:cNvSpPr/>
-          <p:nvPr/>
-        </p:nvSpPr>
-        <p:spPr>
-          <a:xfrm>
-            <a:off x="6841998" y="3381451"/>
-            <a:ext cx="146304" cy="146304"/>
-          </a:xfrm>
-          <a:prstGeom prst="ellipse">
-            <a:avLst/>
-          </a:prstGeom>
-          <a:solidFill>
-            <a:srgbClr val="F59E0B"/>
-          </a:solidFill>
-          <a:ln w="19050">
-            <a:solidFill>
-              <a:srgbClr val="0A1628"/>
-            </a:solidFill>
-            <a:prstDash val="solid"/>
-          </a:ln>
-        </p:spPr>
-      </p:sp>
-      <p:sp>
-        <p:nvSpPr>
-          <p:cNvPr id="48" name="Shape 46"/>
-          <p:cNvSpPr/>
-          <p:nvPr/>
-        </p:nvSpPr>
-        <p:spPr>
-          <a:xfrm>
-            <a:off x="8407908" y="2536546"/>
-            <a:ext cx="146304" cy="146304"/>
-          </a:xfrm>
-          <a:prstGeom prst="ellipse">
-            <a:avLst/>
-          </a:prstGeom>
-          <a:solidFill>
-            <a:srgbClr val="F59E0B"/>
-          </a:solidFill>
-          <a:ln w="19050">
-            <a:solidFill>
-              <a:srgbClr val="0A1628"/>
-            </a:solidFill>
-            <a:prstDash val="solid"/>
-          </a:ln>
-        </p:spPr>
-      </p:sp>
-      <p:sp>
-        <p:nvSpPr>
-          <p:cNvPr id="49" name="Shape 47"/>
-          <p:cNvSpPr/>
-          <p:nvPr/>
-        </p:nvSpPr>
-        <p:spPr>
-          <a:xfrm>
-            <a:off x="9973818" y="2214677"/>
-            <a:ext cx="146304" cy="146304"/>
-          </a:xfrm>
-          <a:prstGeom prst="ellipse">
-            <a:avLst/>
-          </a:prstGeom>
-          <a:solidFill>
-            <a:srgbClr val="F59E0B"/>
-          </a:solidFill>
-          <a:ln w="19050">
-            <a:solidFill>
-              <a:srgbClr val="0A1628"/>
-            </a:solidFill>
-            <a:prstDash val="solid"/>
-          </a:ln>
-        </p:spPr>
-      </p:sp>
-      <p:sp>
-        <p:nvSpPr>
-          <p:cNvPr id="50" name="Shape 48"/>
-          <p:cNvSpPr/>
-          <p:nvPr/>
-        </p:nvSpPr>
-        <p:spPr>
-          <a:xfrm>
-            <a:off x="11539728" y="2053742"/>
-            <a:ext cx="146304" cy="146304"/>
-          </a:xfrm>
-          <a:prstGeom prst="ellipse">
-            <a:avLst/>
-          </a:prstGeom>
-          <a:solidFill>
-            <a:srgbClr val="F59E0B"/>
-          </a:solidFill>
-          <a:ln w="19050">
-            <a:solidFill>
-              <a:srgbClr val="0A1628"/>
-            </a:solidFill>
-            <a:prstDash val="solid"/>
-          </a:ln>
-        </p:spPr>
-      </p:sp>
-      <p:sp>
-        <p:nvSpPr>
-          <p:cNvPr id="51" name="Text 49"/>
-          <p:cNvSpPr/>
-          <p:nvPr/>
-        </p:nvSpPr>
-        <p:spPr>
-          <a:xfrm>
-            <a:off x="4983480" y="6044184"/>
-            <a:ext cx="731520" cy="256032"/>
-          </a:xfrm>
-          <a:prstGeom prst="rect">
-            <a:avLst/>
-          </a:prstGeom>
-          <a:noFill/>
-          <a:ln/>
-        </p:spPr>
-        <p:txBody>
-          <a:bodyPr wrap="square" rtlCol="0" anchor="ctr"/>
-          <a:lstStyle/>
-          <a:p>
-            <a:pPr algn="ctr" indent="0" marL="0">
-              <a:buNone/>
-            </a:pPr>
-            <a:r>
-              <a:rPr lang="en-US" sz="1100" dirty="0">
-                <a:solidFill>
-                  <a:srgbClr val="94A3B8"/>
-                </a:solidFill>
-                <a:latin typeface="Calibri" pitchFamily="34" charset="0"/>
-                <a:ea typeface="Calibri" pitchFamily="34" charset="-122"/>
-                <a:cs typeface="Calibri" pitchFamily="34" charset="-120"/>
-              </a:rPr>
-              <a:t>FY15</a:t>
-            </a:r>
-            <a:endParaRPr lang="en-US" sz="1100" dirty="0"/>
-          </a:p>
-        </p:txBody>
-      </p:sp>
-      <p:sp>
-        <p:nvSpPr>
-          <p:cNvPr id="52" name="Text 50"/>
-          <p:cNvSpPr/>
-          <p:nvPr/>
-        </p:nvSpPr>
-        <p:spPr>
-          <a:xfrm>
-            <a:off x="6549390" y="6044184"/>
-            <a:ext cx="731520" cy="256032"/>
-          </a:xfrm>
-          <a:prstGeom prst="rect">
-            <a:avLst/>
-          </a:prstGeom>
-          <a:noFill/>
-          <a:ln/>
-        </p:spPr>
-        <p:txBody>
-          <a:bodyPr wrap="square" rtlCol="0" anchor="ctr"/>
-          <a:lstStyle/>
-          <a:p>
-            <a:pPr algn="ctr" indent="0" marL="0">
-              <a:buNone/>
-            </a:pPr>
-            <a:r>
-              <a:rPr lang="en-US" sz="1100" dirty="0">
-                <a:solidFill>
-                  <a:srgbClr val="94A3B8"/>
-                </a:solidFill>
-                <a:latin typeface="Calibri" pitchFamily="34" charset="0"/>
-                <a:ea typeface="Calibri" pitchFamily="34" charset="-122"/>
-                <a:cs typeface="Calibri" pitchFamily="34" charset="-120"/>
-              </a:rPr>
-              <a:t>FY16</a:t>
-            </a:r>
-            <a:endParaRPr lang="en-US" sz="1100" dirty="0"/>
-          </a:p>
-        </p:txBody>
-      </p:sp>
-      <p:sp>
-        <p:nvSpPr>
-          <p:cNvPr id="53" name="Text 51"/>
-          <p:cNvSpPr/>
-          <p:nvPr/>
-        </p:nvSpPr>
-        <p:spPr>
-          <a:xfrm>
-            <a:off x="8115300" y="6044184"/>
-            <a:ext cx="731520" cy="256032"/>
-          </a:xfrm>
-          <a:prstGeom prst="rect">
-            <a:avLst/>
-          </a:prstGeom>
-          <a:noFill/>
-          <a:ln/>
-        </p:spPr>
-        <p:txBody>
-          <a:bodyPr wrap="square" rtlCol="0" anchor="ctr"/>
-          <a:lstStyle/>
-          <a:p>
-            <a:pPr algn="ctr" indent="0" marL="0">
-              <a:buNone/>
-            </a:pPr>
-            <a:r>
-              <a:rPr lang="en-US" sz="1100" dirty="0">
-                <a:solidFill>
-                  <a:srgbClr val="94A3B8"/>
-                </a:solidFill>
-                <a:latin typeface="Calibri" pitchFamily="34" charset="0"/>
-                <a:ea typeface="Calibri" pitchFamily="34" charset="-122"/>
-                <a:cs typeface="Calibri" pitchFamily="34" charset="-120"/>
-              </a:rPr>
-              <a:t>FY17</a:t>
-            </a:r>
-            <a:endParaRPr lang="en-US" sz="1100" dirty="0"/>
-          </a:p>
-        </p:txBody>
-      </p:sp>
-      <p:sp>
-        <p:nvSpPr>
-          <p:cNvPr id="54" name="Text 52"/>
-          <p:cNvSpPr/>
-          <p:nvPr/>
-        </p:nvSpPr>
-        <p:spPr>
-          <a:xfrm>
-            <a:off x="9681210" y="6044184"/>
-            <a:ext cx="731520" cy="256032"/>
-          </a:xfrm>
-          <a:prstGeom prst="rect">
-            <a:avLst/>
-          </a:prstGeom>
-          <a:noFill/>
-          <a:ln/>
-        </p:spPr>
-        <p:txBody>
-          <a:bodyPr wrap="square" rtlCol="0" anchor="ctr"/>
-          <a:lstStyle/>
-          <a:p>
-            <a:pPr algn="ctr" indent="0" marL="0">
-              <a:buNone/>
-            </a:pPr>
-            <a:r>
-              <a:rPr lang="en-US" sz="1100" dirty="0">
-                <a:solidFill>
-                  <a:srgbClr val="94A3B8"/>
-                </a:solidFill>
-                <a:latin typeface="Calibri" pitchFamily="34" charset="0"/>
-                <a:ea typeface="Calibri" pitchFamily="34" charset="-122"/>
-                <a:cs typeface="Calibri" pitchFamily="34" charset="-120"/>
-              </a:rPr>
-              <a:t>FY18</a:t>
-            </a:r>
-            <a:endParaRPr lang="en-US" sz="1100" dirty="0"/>
-          </a:p>
-        </p:txBody>
-      </p:sp>
-      <p:sp>
-        <p:nvSpPr>
-          <p:cNvPr id="55" name="Text 53"/>
-          <p:cNvSpPr/>
-          <p:nvPr/>
-        </p:nvSpPr>
-        <p:spPr>
-          <a:xfrm>
-            <a:off x="11247120" y="6044184"/>
-            <a:ext cx="731520" cy="256032"/>
-          </a:xfrm>
-          <a:prstGeom prst="rect">
-            <a:avLst/>
-          </a:prstGeom>
-          <a:noFill/>
-          <a:ln/>
-        </p:spPr>
-        <p:txBody>
-          <a:bodyPr wrap="square" rtlCol="0" anchor="ctr"/>
-          <a:lstStyle/>
-          <a:p>
-            <a:pPr algn="ctr" indent="0" marL="0">
-              <a:buNone/>
-            </a:pPr>
-            <a:r>
-              <a:rPr lang="en-US" sz="1100" dirty="0">
-                <a:solidFill>
-                  <a:srgbClr val="94A3B8"/>
-                </a:solidFill>
-                <a:latin typeface="Calibri" pitchFamily="34" charset="0"/>
-                <a:ea typeface="Calibri" pitchFamily="34" charset="-122"/>
-                <a:cs typeface="Calibri" pitchFamily="34" charset="-120"/>
-              </a:rPr>
-              <a:t>FY19</a:t>
-            </a:r>
-            <a:endParaRPr lang="en-US" sz="1100" dirty="0"/>
-          </a:p>
-        </p:txBody>
-      </p:sp>
-      <p:sp>
-        <p:nvSpPr>
-          <p:cNvPr id="56" name="Shape 54"/>
-          <p:cNvSpPr/>
-          <p:nvPr/>
-        </p:nvSpPr>
-        <p:spPr>
-          <a:xfrm>
-            <a:off x="9116568" y="1984248"/>
-            <a:ext cx="2468880" cy="804672"/>
-          </a:xfrm>
-          <a:prstGeom prst="roundRect">
-            <a:avLst>
-              <a:gd name="adj" fmla="val 6818"/>
-            </a:avLst>
-          </a:prstGeom>
-          <a:solidFill>
-            <a:srgbClr val="0A1628"/>
-          </a:solidFill>
-          <a:ln w="12700">
-            <a:solidFill>
-              <a:srgbClr val="1E3350"/>
-            </a:solidFill>
-            <a:prstDash val="solid"/>
-          </a:ln>
-        </p:spPr>
-      </p:sp>
-      <p:sp>
-        <p:nvSpPr>
-          <p:cNvPr id="57" name="Shape 55"/>
-          <p:cNvSpPr/>
-          <p:nvPr/>
-        </p:nvSpPr>
-        <p:spPr>
-          <a:xfrm>
-            <a:off x="9281160" y="2240280"/>
-            <a:ext cx="365760" cy="914"/>
-          </a:xfrm>
-          <a:prstGeom prst="line">
-            <a:avLst/>
-          </a:prstGeom>
-          <a:noFill/>
-          <a:ln w="44450">
-            <a:solidFill>
-              <a:srgbClr val="F59E0B"/>
-            </a:solidFill>
-            <a:prstDash val="solid"/>
-          </a:ln>
-        </p:spPr>
-      </p:sp>
-      <p:sp>
-        <p:nvSpPr>
-          <p:cNvPr id="58" name="Text 56"/>
-          <p:cNvSpPr/>
-          <p:nvPr/>
-        </p:nvSpPr>
-        <p:spPr>
-          <a:xfrm>
-            <a:off x="9738360" y="2112264"/>
-            <a:ext cx="1828800" cy="237744"/>
-          </a:xfrm>
-          <a:prstGeom prst="rect">
-            <a:avLst/>
-          </a:prstGeom>
-          <a:noFill/>
-          <a:ln/>
-        </p:spPr>
-        <p:txBody>
-          <a:bodyPr wrap="square" rtlCol="0" anchor="ctr"/>
-          <a:lstStyle/>
-          <a:p>
-            <a:pPr indent="0" marL="0">
-              <a:buNone/>
-            </a:pPr>
-            <a:r>
-              <a:rPr lang="en-US" sz="1000" dirty="0">
-                <a:solidFill>
-                  <a:srgbClr val="FFFFFF"/>
-                </a:solidFill>
-                <a:latin typeface="Calibri" pitchFamily="34" charset="0"/>
-                <a:ea typeface="Calibri" pitchFamily="34" charset="-122"/>
-                <a:cs typeface="Calibri" pitchFamily="34" charset="-120"/>
-              </a:rPr>
-              <a:t>ForesightAI (comprehensive)</a:t>
-            </a:r>
-            <a:endParaRPr lang="en-US" sz="1000" dirty="0"/>
-          </a:p>
-        </p:txBody>
-      </p:sp>
-      <p:sp>
-        <p:nvSpPr>
-          <p:cNvPr id="59" name="Shape 57"/>
-          <p:cNvSpPr/>
-          <p:nvPr/>
-        </p:nvSpPr>
-        <p:spPr>
-          <a:xfrm>
-            <a:off x="9281160" y="2569464"/>
-            <a:ext cx="365760" cy="914"/>
-          </a:xfrm>
-          <a:prstGeom prst="line">
-            <a:avLst/>
-          </a:prstGeom>
-          <a:noFill/>
-          <a:ln w="31750">
-            <a:solidFill>
-              <a:srgbClr val="5B9BD5"/>
-            </a:solidFill>
-            <a:prstDash val="solid"/>
-          </a:ln>
-        </p:spPr>
-      </p:sp>
-      <p:sp>
-        <p:nvSpPr>
-          <p:cNvPr id="60" name="Text 58"/>
-          <p:cNvSpPr/>
-          <p:nvPr/>
-        </p:nvSpPr>
-        <p:spPr>
-          <a:xfrm>
-            <a:off x="9738360" y="2441448"/>
-            <a:ext cx="1828800" cy="237744"/>
-          </a:xfrm>
-          <a:prstGeom prst="rect">
-            <a:avLst/>
-          </a:prstGeom>
-          <a:noFill/>
-          <a:ln/>
-        </p:spPr>
-        <p:txBody>
-          <a:bodyPr wrap="square" rtlCol="0" anchor="ctr"/>
-          <a:lstStyle/>
-          <a:p>
-            <a:pPr indent="0" marL="0">
-              <a:buNone/>
-            </a:pPr>
-            <a:r>
-              <a:rPr lang="en-US" sz="1000" dirty="0">
-                <a:solidFill>
-                  <a:srgbClr val="94A3B8"/>
-                </a:solidFill>
-                <a:latin typeface="Calibri" pitchFamily="34" charset="0"/>
-                <a:ea typeface="Calibri" pitchFamily="34" charset="-122"/>
-                <a:cs typeface="Calibri" pitchFamily="34" charset="-120"/>
-              </a:rPr>
-              <a:t>Altman (financial only)</a:t>
-            </a:r>
-            <a:endParaRPr lang="en-US" sz="1000" dirty="0"/>
+              <a:t>The amber block is the risk Altman alone misses - only the comprehensive score shows it.</a:t>
+            </a:r>
+            <a:endParaRPr lang="en-US" sz="1050" dirty="0"/>
           </a:p>
         </p:txBody>
       </p:sp>
@@ -6912,7 +6065,9 @@
       </p:sp>
       <p:sp>
         <p:nvSpPr>
-          <p:cNvPr id="24" name="Shape 18"/>
+          <p:cNvPr id="24" name="Shape 18">
+            <a:hlinkClick r:id="rId5" tooltip="Open the live Foresight AI dashboard"/>
+          </p:cNvPr>
           <p:cNvSpPr/>
           <p:nvPr/>
         </p:nvSpPr>
@@ -6934,7 +6089,9 @@
       </p:sp>
       <p:sp>
         <p:nvSpPr>
-          <p:cNvPr id="25" name="Text 19"/>
+          <p:cNvPr id="25" name="Text 19">
+            <a:hlinkClick r:id="rId5" tooltip="Open the live Foresight AI dashboard"/>
+          </p:cNvPr>
           <p:cNvSpPr/>
           <p:nvPr/>
         </p:nvSpPr>
@@ -6957,31 +6114,45 @@
               <a:buNone/>
             </a:pPr>
             <a:r>
-              <a:rPr lang="en-US" sz="1800" b="1" dirty="0">
+              <a:rPr lang="en-US" sz="1700" b="1" u="sng" dirty="0">
                 <a:solidFill>
                   <a:srgbClr val="0A1628"/>
                 </a:solidFill>
                 <a:latin typeface="Calibri" pitchFamily="34" charset="0"/>
                 <a:ea typeface="Calibri" pitchFamily="34" charset="-122"/>
                 <a:cs typeface="Calibri" pitchFamily="34" charset="-120"/>
-              </a:rPr>
-              <a:t>Try it live   </a:t>
+                <a:hlinkClick r:id="rId5" invalidUrl="" action="" tgtFrame="" tooltip="Open the live Foresight AI dashboard" history="1" highlightClick="0" endSnd="0">
+                  <a:extLst>
+                    <a:ext uri="{A12FA001-AC4F-418D-AE19-62706E023703}">
+                      <ahyp:hlinkClr xmlns:ahyp="http://schemas.microsoft.com/office/drawing/2018/hyperlinkcolor" val="tx"/>
+                    </a:ext>
+                  </a:extLst>
+                </a:hlinkClick>
+              </a:rPr>
+              <a:t>Open the live dashboard   </a:t>
             </a:r>
             <a:pPr algn="ctr" indent="0" marL="0">
               <a:buNone/>
             </a:pPr>
             <a:r>
-              <a:rPr lang="en-US" sz="2000" b="1" dirty="0">
+              <a:rPr lang="en-US" sz="1900" b="1" u="sng" dirty="0">
                 <a:solidFill>
                   <a:srgbClr val="0A1628"/>
                 </a:solidFill>
                 <a:latin typeface="Calibri" pitchFamily="34" charset="0"/>
                 <a:ea typeface="Calibri" pitchFamily="34" charset="-122"/>
                 <a:cs typeface="Calibri" pitchFamily="34" charset="-120"/>
+                <a:hlinkClick r:id="rId5" invalidUrl="" action="" tgtFrame="" tooltip="Open the live Foresight AI dashboard" history="1" highlightClick="0" endSnd="0">
+                  <a:extLst>
+                    <a:ext uri="{A12FA001-AC4F-418D-AE19-62706E023703}">
+                      <ahyp:hlinkClr xmlns:ahyp="http://schemas.microsoft.com/office/drawing/2018/hyperlinkcolor" val="tx"/>
+                    </a:ext>
+                  </a:extLst>
+                </a:hlinkClick>
               </a:rPr>
               <a:t>foresightai.streamlit.app</a:t>
             </a:r>
-            <a:endParaRPr lang="en-US" sz="1800" dirty="0"/>
+            <a:endParaRPr lang="en-US" sz="1700" dirty="0"/>
           </a:p>
         </p:txBody>
       </p:sp>
@@ -7024,13 +6195,20 @@
               <a:buNone/>
             </a:pPr>
             <a:r>
-              <a:rPr lang="en-US" sz="1300" b="1" dirty="0">
+              <a:rPr lang="en-US" sz="1300" b="1" u="sng" dirty="0">
                 <a:solidFill>
                   <a:srgbClr val="FFFFFF"/>
                 </a:solidFill>
                 <a:latin typeface="Calibri" pitchFamily="34" charset="0"/>
                 <a:ea typeface="Calibri" pitchFamily="34" charset="-122"/>
                 <a:cs typeface="Calibri" pitchFamily="34" charset="-120"/>
+                <a:hlinkClick r:id="rId6" invalidUrl="" action="" tgtFrame="" tooltip="View the code on GitHub" history="1" highlightClick="0" endSnd="0">
+                  <a:extLst>
+                    <a:ext uri="{A12FA001-AC4F-418D-AE19-62706E023703}">
+                      <ahyp:hlinkClr xmlns:ahyp="http://schemas.microsoft.com/office/drawing/2018/hyperlinkcolor" val="tx"/>
+                    </a:ext>
+                  </a:extLst>
+                </a:hlinkClick>
               </a:rPr>
               <a:t>github.com/hiralsarkar/ForesightAI</a:t>
             </a:r>
@@ -7282,7 +6460,7 @@
         </p:xfrm>
         <a:graphic xmlns:a="http://schemas.openxmlformats.org/drawingml/2006/main">
           <a:graphicData uri="http://schemas.openxmlformats.org/drawingml/2006/chart">
-            <c:chart xmlns:c="http://schemas.openxmlformats.org/drawingml/2006/chart" r:id="rId5"/>
+            <c:chart xmlns:c="http://schemas.openxmlformats.org/drawingml/2006/chart" r:id="rId7"/>
           </a:graphicData>
         </a:graphic>
       </p:graphicFrame>

</xml_diff>

<commit_message>
Track Record polish, engaging README, updated deck
Track Record: drop the stray Altman markers (the base is now a single clean
line), restore the low/medium/high risk zone bands with labels, and brighten
the palette - sky-blue Altman base, vivid orange added-risk band, gold
comprehensive line, teal price.

README rewritten to be lively and in sync with the dashboard and deck.
Deck updated with the latest slide edits.
</commit_message>
<xml_diff>
--- a/deck/ForesightAI.pptx
+++ b/deck/ForesightAI.pptx
@@ -4,6 +4,9 @@
   <p:sldMasterIdLst>
     <p:sldMasterId id="2147483648" r:id="rId1"/>
   </p:sldMasterIdLst>
+  <p:notesMasterIdLst>
+    <p:notesMasterId r:id="rId7"/>
+  </p:notesMasterIdLst>
   <p:sldIdLst>
     <p:sldId id="256" r:id="rId2"/>
     <p:sldId id="257" r:id="rId3"/>
@@ -11,11 +14,8 @@
     <p:sldId id="259" r:id="rId5"/>
     <p:sldId id="260" r:id="rId6"/>
   </p:sldIdLst>
-  <p:notesMasterIdLst>
-    <p:notesMasterId r:id="rId7"/>
-  </p:notesMasterIdLst>
-  <p:sldSz cx="12191695" cy="6858000"/>
-  <p:notesSz cx="6858000" cy="12191695"/>
+  <p:sldSz cx="12192000" cy="6858000"/>
+  <p:notesSz cx="6858000" cy="12192000"/>
   <p:defaultTextStyle>
     <a:lvl1pPr marL="0" algn="l" defTabSz="914400" rtl="0" eaLnBrk="1" latinLnBrk="0" hangingPunct="1">
       <a:defRPr sz="1800" kern="1200">
@@ -108,13 +108,20 @@
       </a:defRPr>
     </a:lvl9pPr>
   </p:defaultTextStyle>
+  <p:extLst>
+    <p:ext uri="{EFAFB233-063F-42B5-8137-9DF3F51BA10A}">
+      <p15:sldGuideLst xmlns:p15="http://schemas.microsoft.com/office/powerpoint/2012/main"/>
+    </p:ext>
+  </p:extLst>
 </p:presentation>
 </file>
 
 <file path=ppt/charts/chart1.xml><?xml version="1.0" encoding="utf-8"?>
-<c:chartSpace xmlns:c="http://schemas.openxmlformats.org/drawingml/2006/chart" xmlns:a="http://schemas.openxmlformats.org/drawingml/2006/main" xmlns:r="http://schemas.openxmlformats.org/officeDocument/2006/relationships">
+<c:chartSpace xmlns:c="http://schemas.openxmlformats.org/drawingml/2006/chart" xmlns:a="http://schemas.openxmlformats.org/drawingml/2006/main" xmlns:r="http://schemas.openxmlformats.org/officeDocument/2006/relationships" xmlns:c16r2="http://schemas.microsoft.com/office/drawing/2015/06/chart">
   <c:date1904 val="0"/>
+  <c:lang val="en-US"/>
   <c:roundedCorners val="1"/>
+  <c:style val="2"/>
   <c:chart>
     <c:autoTitleDeleted val="1"/>
     <c:plotArea>
@@ -164,6 +171,11 @@
               </a:ln>
               <a:effectLst/>
             </c:spPr>
+            <c:extLst>
+              <c:ext xmlns:c16="http://schemas.microsoft.com/office/drawing/2014/chart" uri="{C3380CC4-5D6E-409C-BE32-E72D297353CC}">
+                <c16:uniqueId val="{00000001-D1CE-47F4-A59C-17DCD59A40B0}"/>
+              </c:ext>
+            </c:extLst>
           </c:dPt>
           <c:dPt>
             <c:idx val="1"/>
@@ -181,81 +193,12 @@
               </a:ln>
               <a:effectLst/>
             </c:spPr>
+            <c:extLst>
+              <c:ext xmlns:c16="http://schemas.microsoft.com/office/drawing/2014/chart" uri="{C3380CC4-5D6E-409C-BE32-E72D297353CC}">
+                <c16:uniqueId val="{00000003-D1CE-47F4-A59C-17DCD59A40B0}"/>
+              </c:ext>
+            </c:extLst>
           </c:dPt>
-          <c:dLbls>
-            <c:dLbl>
-              <c:idx val="0"/>
-              <c:numFmt formatCode="General" sourceLinked="0"/>
-              <c:spPr/>
-              <c:txPr>
-                <a:bodyPr/>
-                <a:lstStyle/>
-                <a:p>
-                  <a:pPr>
-                    <a:defRPr sz="1200" b="0" i="0" u="none" strike="noStrike">
-                      <a:solidFill>
-                        <a:srgbClr val="000000"/>
-                      </a:solidFill>
-                      <a:latin typeface="Arial"/>
-                    </a:defRPr>
-                  </a:pPr>
-                </a:p>
-              </c:txPr>
-              <c:showLegendKey val="0"/>
-              <c:showVal val="0"/>
-              <c:showCatName val="0"/>
-              <c:showSerName val="0"/>
-              <c:showPercent val="0"/>
-              <c:showBubbleSize val="0"/>
-            </c:dLbl>
-            <c:dLbl>
-              <c:idx val="1"/>
-              <c:numFmt formatCode="General" sourceLinked="0"/>
-              <c:spPr/>
-              <c:txPr>
-                <a:bodyPr/>
-                <a:lstStyle/>
-                <a:p>
-                  <a:pPr>
-                    <a:defRPr sz="1200" b="0" i="0" u="none" strike="noStrike">
-                      <a:solidFill>
-                        <a:srgbClr val="000000"/>
-                      </a:solidFill>
-                      <a:latin typeface="Arial"/>
-                    </a:defRPr>
-                  </a:pPr>
-                </a:p>
-              </c:txPr>
-              <c:showLegendKey val="0"/>
-              <c:showVal val="0"/>
-              <c:showCatName val="0"/>
-              <c:showSerName val="0"/>
-              <c:showPercent val="0"/>
-              <c:showBubbleSize val="0"/>
-            </c:dLbl>
-            <c:numFmt formatCode="General" sourceLinked="0"/>
-            <c:txPr>
-              <a:bodyPr/>
-              <a:lstStyle/>
-              <a:p>
-                <a:pPr>
-                  <a:defRPr sz="1800" b="0" i="0" u="none" strike="noStrike">
-                    <a:solidFill>
-                      <a:srgbClr val="000000"/>
-                    </a:solidFill>
-                    <a:latin typeface="Arial"/>
-                  </a:defRPr>
-                </a:pPr>
-              </a:p>
-            </c:txPr>
-            <c:showLegendKey val="0"/>
-            <c:showVal val="0"/>
-            <c:showCatName val="1"/>
-            <c:showSerName val="0"/>
-            <c:showPercent val="1"/>
-            <c:showBubbleSize val="0"/>
-            <c:showLeaderLines val="0"/>
-          </c:dLbls>
           <c:cat>
             <c:strRef>
               <c:f>Sheet1!$A$2:$A$3</c:f>
@@ -274,6 +217,7 @@
             <c:numRef>
               <c:f>Sheet1!$B$2:$B$3</c:f>
               <c:numCache>
+                <c:formatCode>General</c:formatCode>
                 <c:ptCount val="2"/>
                 <c:pt idx="0">
                   <c:v>58</c:v>
@@ -284,7 +228,21 @@
               </c:numCache>
             </c:numRef>
           </c:val>
+          <c:extLst>
+            <c:ext xmlns:c16="http://schemas.microsoft.com/office/drawing/2014/chart" uri="{C3380CC4-5D6E-409C-BE32-E72D297353CC}">
+              <c16:uniqueId val="{00000004-D1CE-47F4-A59C-17DCD59A40B0}"/>
+            </c:ext>
+          </c:extLst>
         </c:ser>
+        <c:dLbls>
+          <c:showLegendKey val="0"/>
+          <c:showVal val="0"/>
+          <c:showCatName val="0"/>
+          <c:showSerName val="0"/>
+          <c:showPercent val="0"/>
+          <c:showBubbleSize val="0"/>
+          <c:showLeaderLines val="0"/>
+        </c:dLbls>
         <c:firstSliceAng val="0"/>
         <c:holeSize val="74"/>
       </c:doughnutChart>
@@ -298,6 +256,7 @@
     </c:plotArea>
     <c:plotVisOnly val="1"/>
     <c:dispBlanksAs val="span"/>
+    <c:showDLblsOverMax val="1"/>
   </c:chart>
   <c:spPr>
     <a:noFill/>
@@ -313,9 +272,11 @@
 </file>
 
 <file path=ppt/charts/chart2.xml><?xml version="1.0" encoding="utf-8"?>
-<c:chartSpace xmlns:c="http://schemas.openxmlformats.org/drawingml/2006/chart" xmlns:a="http://schemas.openxmlformats.org/drawingml/2006/main" xmlns:r="http://schemas.openxmlformats.org/officeDocument/2006/relationships">
+<c:chartSpace xmlns:c="http://schemas.openxmlformats.org/drawingml/2006/chart" xmlns:a="http://schemas.openxmlformats.org/drawingml/2006/main" xmlns:r="http://schemas.openxmlformats.org/officeDocument/2006/relationships" xmlns:c16r2="http://schemas.microsoft.com/office/drawing/2015/06/chart">
   <c:date1904 val="0"/>
+  <c:lang val="en-US"/>
   <c:roundedCorners val="1"/>
+  <c:style val="2"/>
   <c:chart>
     <c:autoTitleDeleted val="1"/>
     <c:plotArea>
@@ -345,66 +306,40 @@
             <a:effectLst/>
           </c:spPr>
           <c:invertIfNegative val="0"/>
-          <c:dLbls>
-            <c:numFmt formatCode="#,##0" sourceLinked="0"/>
-            <c:txPr>
-              <a:bodyPr/>
-              <a:lstStyle/>
-              <a:p>
-                <a:pPr>
-                  <a:defRPr b="0" i="0" strike="noStrike" sz="1200" u="none">
-                    <a:solidFill>
-                      <a:srgbClr val="000000"/>
-                    </a:solidFill>
-                    <a:latin typeface="Arial"/>
-                  </a:defRPr>
-                </a:pPr>
-              </a:p>
-            </c:txPr>
-            <c:showLegendKey val="0"/>
-            <c:showVal val="0"/>
-            <c:showCatName val="0"/>
-            <c:showSerName val="0"/>
-            <c:showPercent val="0"/>
-            <c:showBubbleSize val="0"/>
-            <c:showLeaderLines val="0"/>
-          </c:dLbls>
           <c:cat>
-            <c:multiLvlStrRef>
+            <c:strRef>
               <c:f>Sheet1!$A$2:$A$10</c:f>
-              <c:multiLvlStrCache>
+              <c:strCache>
                 <c:ptCount val="9"/>
-                <c:lvl>
-                  <c:pt idx="0">
-                    <c:v>FY15</c:v>
-                  </c:pt>
-                  <c:pt idx="1">
-                    <c:v>FY16</c:v>
-                  </c:pt>
-                  <c:pt idx="2">
-                    <c:v>FY17</c:v>
-                  </c:pt>
-                  <c:pt idx="3">
-                    <c:v>FY18</c:v>
-                  </c:pt>
-                  <c:pt idx="4">
-                    <c:v>FY19</c:v>
-                  </c:pt>
-                  <c:pt idx="5">
-                    <c:v>FY20</c:v>
-                  </c:pt>
-                  <c:pt idx="6">
-                    <c:v>FY21</c:v>
-                  </c:pt>
-                  <c:pt idx="7">
-                    <c:v>FY22</c:v>
-                  </c:pt>
-                  <c:pt idx="8">
-                    <c:v>FY23</c:v>
-                  </c:pt>
-                </c:lvl>
-              </c:multiLvlStrCache>
-            </c:multiLvlStrRef>
+                <c:pt idx="0">
+                  <c:v>FY15</c:v>
+                </c:pt>
+                <c:pt idx="1">
+                  <c:v>FY16</c:v>
+                </c:pt>
+                <c:pt idx="2">
+                  <c:v>FY17</c:v>
+                </c:pt>
+                <c:pt idx="3">
+                  <c:v>FY18</c:v>
+                </c:pt>
+                <c:pt idx="4">
+                  <c:v>FY19</c:v>
+                </c:pt>
+                <c:pt idx="5">
+                  <c:v>FY20</c:v>
+                </c:pt>
+                <c:pt idx="6">
+                  <c:v>FY21</c:v>
+                </c:pt>
+                <c:pt idx="7">
+                  <c:v>FY22</c:v>
+                </c:pt>
+                <c:pt idx="8">
+                  <c:v>FY23</c:v>
+                </c:pt>
+              </c:strCache>
+            </c:strRef>
           </c:cat>
           <c:val>
             <c:numRef>
@@ -442,6 +377,11 @@
               </c:numCache>
             </c:numRef>
           </c:val>
+          <c:extLst>
+            <c:ext xmlns:c16="http://schemas.microsoft.com/office/drawing/2014/chart" uri="{C3380CC4-5D6E-409C-BE32-E72D297353CC}">
+              <c16:uniqueId val="{00000000-6D01-4D2F-96DC-1B2F4918DE4A}"/>
+            </c:ext>
+          </c:extLst>
         </c:ser>
         <c:ser>
           <c:idx val="1"/>
@@ -464,66 +404,40 @@
             <a:effectLst/>
           </c:spPr>
           <c:invertIfNegative val="0"/>
-          <c:dLbls>
-            <c:numFmt formatCode="#,##0" sourceLinked="0"/>
-            <c:txPr>
-              <a:bodyPr/>
-              <a:lstStyle/>
-              <a:p>
-                <a:pPr>
-                  <a:defRPr b="0" i="0" strike="noStrike" sz="1200" u="none">
-                    <a:solidFill>
-                      <a:srgbClr val="000000"/>
-                    </a:solidFill>
-                    <a:latin typeface="Arial"/>
-                  </a:defRPr>
-                </a:pPr>
-              </a:p>
-            </c:txPr>
-            <c:showLegendKey val="0"/>
-            <c:showVal val="0"/>
-            <c:showCatName val="0"/>
-            <c:showSerName val="0"/>
-            <c:showPercent val="0"/>
-            <c:showBubbleSize val="0"/>
-            <c:showLeaderLines val="0"/>
-          </c:dLbls>
           <c:cat>
-            <c:multiLvlStrRef>
+            <c:strRef>
               <c:f>Sheet1!$A$2:$A$10</c:f>
-              <c:multiLvlStrCache>
+              <c:strCache>
                 <c:ptCount val="9"/>
-                <c:lvl>
-                  <c:pt idx="0">
-                    <c:v>FY15</c:v>
-                  </c:pt>
-                  <c:pt idx="1">
-                    <c:v>FY16</c:v>
-                  </c:pt>
-                  <c:pt idx="2">
-                    <c:v>FY17</c:v>
-                  </c:pt>
-                  <c:pt idx="3">
-                    <c:v>FY18</c:v>
-                  </c:pt>
-                  <c:pt idx="4">
-                    <c:v>FY19</c:v>
-                  </c:pt>
-                  <c:pt idx="5">
-                    <c:v>FY20</c:v>
-                  </c:pt>
-                  <c:pt idx="6">
-                    <c:v>FY21</c:v>
-                  </c:pt>
-                  <c:pt idx="7">
-                    <c:v>FY22</c:v>
-                  </c:pt>
-                  <c:pt idx="8">
-                    <c:v>FY23</c:v>
-                  </c:pt>
-                </c:lvl>
-              </c:multiLvlStrCache>
-            </c:multiLvlStrRef>
+                <c:pt idx="0">
+                  <c:v>FY15</c:v>
+                </c:pt>
+                <c:pt idx="1">
+                  <c:v>FY16</c:v>
+                </c:pt>
+                <c:pt idx="2">
+                  <c:v>FY17</c:v>
+                </c:pt>
+                <c:pt idx="3">
+                  <c:v>FY18</c:v>
+                </c:pt>
+                <c:pt idx="4">
+                  <c:v>FY19</c:v>
+                </c:pt>
+                <c:pt idx="5">
+                  <c:v>FY20</c:v>
+                </c:pt>
+                <c:pt idx="6">
+                  <c:v>FY21</c:v>
+                </c:pt>
+                <c:pt idx="7">
+                  <c:v>FY22</c:v>
+                </c:pt>
+                <c:pt idx="8">
+                  <c:v>FY23</c:v>
+                </c:pt>
+              </c:strCache>
+            </c:strRef>
           </c:cat>
           <c:val>
             <c:numRef>
@@ -561,36 +475,24 @@
               </c:numCache>
             </c:numRef>
           </c:val>
+          <c:extLst>
+            <c:ext xmlns:c16="http://schemas.microsoft.com/office/drawing/2014/chart" uri="{C3380CC4-5D6E-409C-BE32-E72D297353CC}">
+              <c16:uniqueId val="{00000001-6D01-4D2F-96DC-1B2F4918DE4A}"/>
+            </c:ext>
+          </c:extLst>
         </c:ser>
         <c:dLbls>
-          <c:numFmt formatCode="#,##0" sourceLinked="0"/>
-          <c:txPr>
-            <a:bodyPr/>
-            <a:lstStyle/>
-            <a:p>
-              <a:pPr>
-                <a:defRPr b="0" i="0" strike="noStrike" sz="1200" u="none">
-                  <a:solidFill>
-                    <a:srgbClr val="000000"/>
-                  </a:solidFill>
-                  <a:latin typeface="Arial"/>
-                </a:defRPr>
-              </a:pPr>
-            </a:p>
-          </c:txPr>
           <c:showLegendKey val="0"/>
           <c:showVal val="0"/>
           <c:showCatName val="0"/>
           <c:showSerName val="0"/>
           <c:showPercent val="0"/>
           <c:showBubbleSize val="0"/>
-          <c:showLeaderLines val="0"/>
         </c:dLbls>
         <c:gapWidth val="45"/>
         <c:overlap val="100"/>
         <c:axId val="2094734554"/>
         <c:axId val="2094734552"/>
-        <c:axId val="2094734556"/>
       </c:barChart>
       <c:catAx>
         <c:axId val="2094734554"/>
@@ -629,6 +531,7 @@
         <c:crosses val="autoZero"/>
         <c:auto val="1"/>
         <c:lblAlgn val="ctr"/>
+        <c:lblOffset val="100"/>
         <c:noMultiLvlLbl val="1"/>
       </c:catAx>
       <c:valAx>
@@ -710,6 +613,7 @@
     </c:legend>
     <c:plotVisOnly val="1"/>
     <c:dispBlanksAs val="span"/>
+    <c:showDLblsOverMax val="1"/>
   </c:chart>
   <c:spPr>
     <a:noFill/>
@@ -725,9 +629,11 @@
 </file>
 
 <file path=ppt/charts/chart3.xml><?xml version="1.0" encoding="utf-8"?>
-<c:chartSpace xmlns:c="http://schemas.openxmlformats.org/drawingml/2006/chart" xmlns:a="http://schemas.openxmlformats.org/drawingml/2006/main" xmlns:r="http://schemas.openxmlformats.org/officeDocument/2006/relationships">
+<c:chartSpace xmlns:c="http://schemas.openxmlformats.org/drawingml/2006/chart" xmlns:a="http://schemas.openxmlformats.org/drawingml/2006/main" xmlns:r="http://schemas.openxmlformats.org/officeDocument/2006/relationships" xmlns:c16r2="http://schemas.microsoft.com/office/drawing/2015/06/chart">
   <c:date1904 val="0"/>
+  <c:lang val="en-US"/>
   <c:roundedCorners val="1"/>
+  <c:style val="2"/>
   <c:chart>
     <c:autoTitleDeleted val="1"/>
     <c:plotArea>
@@ -777,6 +683,11 @@
               </a:ln>
               <a:effectLst/>
             </c:spPr>
+            <c:extLst>
+              <c:ext xmlns:c16="http://schemas.microsoft.com/office/drawing/2014/chart" uri="{C3380CC4-5D6E-409C-BE32-E72D297353CC}">
+                <c16:uniqueId val="{00000001-7329-49C7-9E0C-634D159C3487}"/>
+              </c:ext>
+            </c:extLst>
           </c:dPt>
           <c:dPt>
             <c:idx val="1"/>
@@ -794,81 +705,12 @@
               </a:ln>
               <a:effectLst/>
             </c:spPr>
+            <c:extLst>
+              <c:ext xmlns:c16="http://schemas.microsoft.com/office/drawing/2014/chart" uri="{C3380CC4-5D6E-409C-BE32-E72D297353CC}">
+                <c16:uniqueId val="{00000003-7329-49C7-9E0C-634D159C3487}"/>
+              </c:ext>
+            </c:extLst>
           </c:dPt>
-          <c:dLbls>
-            <c:dLbl>
-              <c:idx val="0"/>
-              <c:numFmt formatCode="General" sourceLinked="0"/>
-              <c:spPr/>
-              <c:txPr>
-                <a:bodyPr/>
-                <a:lstStyle/>
-                <a:p>
-                  <a:pPr>
-                    <a:defRPr sz="1200" b="0" i="0" u="none" strike="noStrike">
-                      <a:solidFill>
-                        <a:srgbClr val="000000"/>
-                      </a:solidFill>
-                      <a:latin typeface="Arial"/>
-                    </a:defRPr>
-                  </a:pPr>
-                </a:p>
-              </c:txPr>
-              <c:showLegendKey val="0"/>
-              <c:showVal val="0"/>
-              <c:showCatName val="0"/>
-              <c:showSerName val="0"/>
-              <c:showPercent val="0"/>
-              <c:showBubbleSize val="0"/>
-            </c:dLbl>
-            <c:dLbl>
-              <c:idx val="1"/>
-              <c:numFmt formatCode="General" sourceLinked="0"/>
-              <c:spPr/>
-              <c:txPr>
-                <a:bodyPr/>
-                <a:lstStyle/>
-                <a:p>
-                  <a:pPr>
-                    <a:defRPr sz="1200" b="0" i="0" u="none" strike="noStrike">
-                      <a:solidFill>
-                        <a:srgbClr val="000000"/>
-                      </a:solidFill>
-                      <a:latin typeface="Arial"/>
-                    </a:defRPr>
-                  </a:pPr>
-                </a:p>
-              </c:txPr>
-              <c:showLegendKey val="0"/>
-              <c:showVal val="0"/>
-              <c:showCatName val="0"/>
-              <c:showSerName val="0"/>
-              <c:showPercent val="0"/>
-              <c:showBubbleSize val="0"/>
-            </c:dLbl>
-            <c:numFmt formatCode="General" sourceLinked="0"/>
-            <c:txPr>
-              <a:bodyPr/>
-              <a:lstStyle/>
-              <a:p>
-                <a:pPr>
-                  <a:defRPr sz="1800" b="0" i="0" u="none" strike="noStrike">
-                    <a:solidFill>
-                      <a:srgbClr val="000000"/>
-                    </a:solidFill>
-                    <a:latin typeface="Arial"/>
-                  </a:defRPr>
-                </a:pPr>
-              </a:p>
-            </c:txPr>
-            <c:showLegendKey val="0"/>
-            <c:showVal val="0"/>
-            <c:showCatName val="1"/>
-            <c:showSerName val="0"/>
-            <c:showPercent val="1"/>
-            <c:showBubbleSize val="0"/>
-            <c:showLeaderLines val="0"/>
-          </c:dLbls>
           <c:cat>
             <c:strRef>
               <c:f>Sheet1!$A$2:$A$3</c:f>
@@ -887,6 +729,7 @@
             <c:numRef>
               <c:f>Sheet1!$B$2:$B$3</c:f>
               <c:numCache>
+                <c:formatCode>General</c:formatCode>
                 <c:ptCount val="2"/>
                 <c:pt idx="0">
                   <c:v>58</c:v>
@@ -897,7 +740,21 @@
               </c:numCache>
             </c:numRef>
           </c:val>
+          <c:extLst>
+            <c:ext xmlns:c16="http://schemas.microsoft.com/office/drawing/2014/chart" uri="{C3380CC4-5D6E-409C-BE32-E72D297353CC}">
+              <c16:uniqueId val="{00000004-7329-49C7-9E0C-634D159C3487}"/>
+            </c:ext>
+          </c:extLst>
         </c:ser>
+        <c:dLbls>
+          <c:showLegendKey val="0"/>
+          <c:showVal val="0"/>
+          <c:showCatName val="0"/>
+          <c:showSerName val="0"/>
+          <c:showPercent val="0"/>
+          <c:showBubbleSize val="0"/>
+          <c:showLeaderLines val="0"/>
+        </c:dLbls>
         <c:firstSliceAng val="0"/>
         <c:holeSize val="74"/>
       </c:doughnutChart>
@@ -911,6 +768,7 @@
     </c:plotArea>
     <c:plotVisOnly val="1"/>
     <c:dispBlanksAs val="span"/>
+    <c:showDLblsOverMax val="1"/>
   </c:chart>
   <c:spPr>
     <a:noFill/>
@@ -947,234 +805,10 @@
           <a:chExt cx="0" cy="0"/>
         </a:xfrm>
       </p:grpSpPr>
-      <p:sp>
-        <p:nvSpPr>
-          <p:cNvPr id="2" name="Header Placeholder 1"/>
-          <p:cNvSpPr>
-            <a:spLocks noGrp="1"/>
-          </p:cNvSpPr>
-          <p:nvPr>
-            <p:ph type="hdr" sz="quarter"/>
-          </p:nvPr>
-        </p:nvSpPr>
-        <p:spPr>
-          <a:xfrm>
-            <a:off x="0" y="0"/>
-            <a:ext cx="2971800" cy="458788"/>
-          </a:xfrm>
-          <a:prstGeom prst="rect">
-            <a:avLst/>
-          </a:prstGeom>
-        </p:spPr>
-        <p:txBody>
-          <a:bodyPr vert="horz" lIns="91440" tIns="45720" rIns="91440" bIns="45720" rtlCol="0"/>
-          <a:lstStyle>
-            <a:lvl1pPr algn="l">
-              <a:defRPr sz="1200"/>
-            </a:lvl1pPr>
-          </a:lstStyle>
-          <a:p>
-            <a:endParaRPr lang="en-US"/>
-          </a:p>
-        </p:txBody>
-      </p:sp>
-      <p:sp>
-        <p:nvSpPr>
-          <p:cNvPr id="3" name="Date Placeholder 2"/>
-          <p:cNvSpPr>
-            <a:spLocks noGrp="1"/>
-          </p:cNvSpPr>
-          <p:nvPr>
-            <p:ph type="dt" idx="1"/>
-          </p:nvPr>
-        </p:nvSpPr>
-        <p:spPr>
-          <a:xfrm>
-            <a:off x="3884613" y="0"/>
-            <a:ext cx="2971800" cy="458788"/>
-          </a:xfrm>
-          <a:prstGeom prst="rect">
-            <a:avLst/>
-          </a:prstGeom>
-        </p:spPr>
-        <p:txBody>
-          <a:bodyPr vert="horz" lIns="91440" tIns="45720" rIns="91440" bIns="45720" rtlCol="0"/>
-          <a:lstStyle>
-            <a:lvl1pPr algn="r">
-              <a:defRPr sz="1200"/>
-            </a:lvl1pPr>
-          </a:lstStyle>
-          <a:p>
-            <a:fld id="{5282F153-3F37-0F45-9E97-73ACFA13230C}" type="datetimeFigureOut">
-              <a:rPr lang="en-US"/>
-              <a:t>7/23/19</a:t>
-            </a:fld>
-            <a:endParaRPr lang="en-US"/>
-          </a:p>
-        </p:txBody>
-      </p:sp>
-      <p:sp>
-        <p:nvSpPr>
-          <p:cNvPr id="4" name="Slide Image Placeholder 3"/>
-          <p:cNvSpPr>
-            <a:spLocks noGrp="1" noRot="1" noChangeAspect="1"/>
-          </p:cNvSpPr>
-          <p:nvPr>
-            <p:ph type="sldImg" idx="2"/>
-          </p:nvPr>
-        </p:nvSpPr>
-        <p:spPr>
-          <a:xfrm>
-            <a:off x="685800" y="1143000"/>
-            <a:ext cx="5486400" cy="3086100"/>
-          </a:xfrm>
-          <a:prstGeom prst="rect">
-            <a:avLst/>
-          </a:prstGeom>
-          <a:noFill/>
-          <a:ln w="12700">
-            <a:solidFill>
-              <a:prstClr val="black"/>
-            </a:solidFill>
-          </a:ln>
-        </p:spPr>
-        <p:txBody>
-          <a:bodyPr vert="horz" lIns="91440" tIns="45720" rIns="91440" bIns="45720" rtlCol="0" anchor="ctr"/>
-          <a:lstStyle/>
-          <a:p>
-            <a:endParaRPr lang="en-US"/>
-          </a:p>
-        </p:txBody>
-      </p:sp>
-      <p:sp>
-        <p:nvSpPr>
-          <p:cNvPr id="5" name="Notes Placeholder 4"/>
-          <p:cNvSpPr>
-            <a:spLocks noGrp="1"/>
-          </p:cNvSpPr>
-          <p:nvPr>
-            <p:ph type="body" sz="quarter" idx="3"/>
-          </p:nvPr>
-        </p:nvSpPr>
-        <p:spPr>
-          <a:xfrm>
-            <a:off x="685800" y="4400550"/>
-            <a:ext cx="5486400" cy="3600450"/>
-          </a:xfrm>
-          <a:prstGeom prst="rect">
-            <a:avLst/>
-          </a:prstGeom>
-        </p:spPr>
-        <p:txBody>
-          <a:bodyPr vert="horz" lIns="91440" tIns="45720" rIns="91440" bIns="45720" rtlCol="0"/>
-          <a:lstStyle/>
-          <a:p>
-            <a:pPr lvl="0"/>
-            <a:r>
-              <a:rPr lang="en-US"/>
-              <a:t>Click to edit Master text styles</a:t>
-            </a:r>
-          </a:p>
-          <a:p>
-            <a:pPr lvl="1"/>
-            <a:r>
-              <a:rPr lang="en-US"/>
-              <a:t>Second level</a:t>
-            </a:r>
-          </a:p>
-          <a:p>
-            <a:pPr lvl="2"/>
-            <a:r>
-              <a:rPr lang="en-US"/>
-              <a:t>Third level</a:t>
-            </a:r>
-          </a:p>
-          <a:p>
-            <a:pPr lvl="3"/>
-            <a:r>
-              <a:rPr lang="en-US"/>
-              <a:t>Fourth level</a:t>
-            </a:r>
-          </a:p>
-          <a:p>
-            <a:pPr lvl="4"/>
-            <a:r>
-              <a:rPr lang="en-US"/>
-              <a:t>Fifth level</a:t>
-            </a:r>
-          </a:p>
-        </p:txBody>
-      </p:sp>
-      <p:sp>
-        <p:nvSpPr>
-          <p:cNvPr id="6" name="Footer Placeholder 5"/>
-          <p:cNvSpPr>
-            <a:spLocks noGrp="1"/>
-          </p:cNvSpPr>
-          <p:nvPr>
-            <p:ph type="ftr" sz="quarter" idx="4"/>
-          </p:nvPr>
-        </p:nvSpPr>
-        <p:spPr>
-          <a:xfrm>
-            <a:off x="0" y="8685213"/>
-            <a:ext cx="2971800" cy="458787"/>
-          </a:xfrm>
-          <a:prstGeom prst="rect">
-            <a:avLst/>
-          </a:prstGeom>
-        </p:spPr>
-        <p:txBody>
-          <a:bodyPr vert="horz" lIns="91440" tIns="45720" rIns="91440" bIns="45720" rtlCol="0" anchor="b"/>
-          <a:lstStyle>
-            <a:lvl1pPr algn="l">
-              <a:defRPr sz="1200"/>
-            </a:lvl1pPr>
-          </a:lstStyle>
-          <a:p>
-            <a:endParaRPr lang="en-US"/>
-          </a:p>
-        </p:txBody>
-      </p:sp>
-      <p:sp>
-        <p:nvSpPr>
-          <p:cNvPr id="7" name="Slide Number Placeholder 6"/>
-          <p:cNvSpPr>
-            <a:spLocks noGrp="1"/>
-          </p:cNvSpPr>
-          <p:nvPr>
-            <p:ph type="sldNum" sz="quarter" idx="5"/>
-          </p:nvPr>
-        </p:nvSpPr>
-        <p:spPr>
-          <a:xfrm>
-            <a:off x="3884613" y="8685213"/>
-            <a:ext cx="2971800" cy="458787"/>
-          </a:xfrm>
-          <a:prstGeom prst="rect">
-            <a:avLst/>
-          </a:prstGeom>
-        </p:spPr>
-        <p:txBody>
-          <a:bodyPr vert="horz" lIns="91440" tIns="45720" rIns="91440" bIns="45720" rtlCol="0" anchor="b"/>
-          <a:lstStyle>
-            <a:lvl1pPr algn="r">
-              <a:defRPr sz="1200"/>
-            </a:lvl1pPr>
-          </a:lstStyle>
-          <a:p>
-            <a:fld id="{CE5E9CC1-C706-0F49-92D6-E571CC5EEA8F}" type="slidenum">
-              <a:rPr lang="en-US"/>
-              <a:t>‹#›</a:t>
-            </a:fld>
-            <a:endParaRPr lang="en-US"/>
-          </a:p>
-        </p:txBody>
-      </p:sp>
     </p:spTree>
     <p:extLst>
       <p:ext uri="{BB962C8B-B14F-4D97-AF65-F5344CB8AC3E}">
-        <p14:creationId xmlns:p14="http://schemas.microsoft.com/office/powerpoint/2010/main" val="1024086991"/>
+        <p14:creationId xmlns:p14="http://schemas.microsoft.com/office/powerpoint/2010/main" val="1283528057"/>
       </p:ext>
     </p:extLst>
   </p:cSld>
@@ -1318,10 +952,6 @@
           <a:bodyPr/>
           <a:lstStyle/>
           <a:p>
-            <a:r>
-              <a:rPr lang="en-US" dirty="0"/>
-              <a:t/>
-            </a:r>
             <a:endParaRPr lang="en-US" dirty="0"/>
           </a:p>
         </p:txBody>
@@ -1406,10 +1036,6 @@
           <a:bodyPr/>
           <a:lstStyle/>
           <a:p>
-            <a:r>
-              <a:rPr lang="en-US" dirty="0"/>
-              <a:t/>
-            </a:r>
             <a:endParaRPr lang="en-US" dirty="0"/>
           </a:p>
         </p:txBody>
@@ -1494,10 +1120,6 @@
           <a:bodyPr/>
           <a:lstStyle/>
           <a:p>
-            <a:r>
-              <a:rPr lang="en-US" dirty="0"/>
-              <a:t/>
-            </a:r>
             <a:endParaRPr lang="en-US" dirty="0"/>
           </a:p>
         </p:txBody>
@@ -1582,10 +1204,6 @@
           <a:bodyPr/>
           <a:lstStyle/>
           <a:p>
-            <a:r>
-              <a:rPr lang="en-US" dirty="0"/>
-              <a:t/>
-            </a:r>
             <a:endParaRPr lang="en-US" dirty="0"/>
           </a:p>
         </p:txBody>
@@ -1670,10 +1288,6 @@
           <a:bodyPr/>
           <a:lstStyle/>
           <a:p>
-            <a:r>
-              <a:rPr lang="en-US" dirty="0"/>
-              <a:t/>
-            </a:r>
             <a:endParaRPr lang="en-US" dirty="0"/>
           </a:p>
         </p:txBody>
@@ -1747,6 +1361,11 @@
 <file path=ppt/slideMasters/slideMaster1.xml><?xml version="1.0" encoding="utf-8"?>
 <p:sldMaster xmlns:a="http://schemas.openxmlformats.org/drawingml/2006/main" xmlns:r="http://schemas.openxmlformats.org/officeDocument/2006/relationships" xmlns:p="http://schemas.openxmlformats.org/presentationml/2006/main">
   <p:cSld>
+    <p:bg>
+      <p:bgRef idx="1001">
+        <a:schemeClr val="bg1"/>
+      </p:bgRef>
+    </p:bg>
     <p:spTree>
       <p:nvGrpSpPr>
         <p:cNvPr id="1" name=""/>
@@ -2029,6 +1648,7 @@
         <a:solidFill>
           <a:srgbClr val="0A1628"/>
         </a:solidFill>
+        <a:effectLst/>
       </p:bgPr>
     </p:bg>
     <p:spTree>
@@ -2066,11 +1686,11 @@
           <a:bodyPr wrap="square" rtlCol="0" anchor="ctr"/>
           <a:lstStyle/>
           <a:p>
-            <a:pPr indent="0" marL="0">
+            <a:pPr marL="0" indent="0">
               <a:buNone/>
             </a:pPr>
             <a:r>
-              <a:rPr lang="en-US" sz="1300" b="1" spc="400" kern="0" dirty="0">
+              <a:rPr lang="en-US" sz="1300" b="1" kern="0" spc="400" dirty="0">
                 <a:solidFill>
                   <a:srgbClr val="F59E0B"/>
                 </a:solidFill>
@@ -2078,7 +1698,7 @@
                 <a:ea typeface="Calibri" pitchFamily="34" charset="-122"/>
                 <a:cs typeface="Calibri" pitchFamily="34" charset="-120"/>
               </a:rPr>
-              <a:t>LIVE CORPORATE RISK ENGINE</a:t>
+              <a:t>LIVE CORPORATE RISK INTELLIGENCE SYSTEM</a:t>
             </a:r>
             <a:endParaRPr lang="en-US" sz="1300" dirty="0"/>
           </a:p>
@@ -2105,7 +1725,7 @@
           <a:bodyPr wrap="square" rtlCol="0" anchor="ctr"/>
           <a:lstStyle/>
           <a:p>
-            <a:pPr indent="0" marL="0">
+            <a:pPr marL="0" indent="0">
               <a:buNone/>
             </a:pPr>
             <a:r>
@@ -2119,9 +1739,6 @@
               </a:rPr>
               <a:t>Foresight </a:t>
             </a:r>
-            <a:pPr indent="0" marL="0">
-              <a:buNone/>
-            </a:pPr>
             <a:r>
               <a:rPr lang="en-US" sz="6600" b="1" dirty="0">
                 <a:solidFill>
@@ -2145,8 +1762,8 @@
         </p:nvSpPr>
         <p:spPr>
           <a:xfrm>
-            <a:off x="822960" y="2788920"/>
-            <a:ext cx="7223760" cy="1097280"/>
+            <a:off x="822960" y="2788919"/>
+            <a:ext cx="7863840" cy="1198039"/>
           </a:xfrm>
           <a:prstGeom prst="rect">
             <a:avLst/>
@@ -2158,12 +1775,22 @@
           <a:bodyPr wrap="square" rtlCol="0" anchor="ctr"/>
           <a:lstStyle/>
           <a:p>
-            <a:pPr indent="0" marL="0">
+            <a:pPr>
               <a:lnSpc>
                 <a:spcPct val="112000"/>
               </a:lnSpc>
-              <a:buNone/>
-            </a:pPr>
+            </a:pPr>
+            <a:r>
+              <a:rPr lang="en-US" dirty="0">
+                <a:solidFill>
+                  <a:srgbClr val="94A3B8"/>
+                </a:solidFill>
+                <a:latin typeface="Calibri" pitchFamily="34" charset="0"/>
+                <a:ea typeface="Calibri" pitchFamily="34" charset="-122"/>
+                <a:cs typeface="Calibri" pitchFamily="34" charset="-120"/>
+              </a:rPr>
+              <a:t>O</a:t>
+            </a:r>
             <a:r>
               <a:rPr lang="en-US" sz="1800" dirty="0">
                 <a:solidFill>
@@ -2173,63 +1800,82 @@
                 <a:ea typeface="Calibri" pitchFamily="34" charset="-122"/>
                 <a:cs typeface="Calibri" pitchFamily="34" charset="-120"/>
               </a:rPr>
-              <a:t>Point it at any listed Indian company. Get one explainable 0-100 score</a:t>
+              <a:t>ne explainable 0-100 score</a:t>
+            </a:r>
+            <a:r>
+              <a:rPr lang="en-US" dirty="0"/>
+              <a:t> </a:t>
+            </a:r>
+            <a:r>
+              <a:rPr lang="en-US" sz="1800" dirty="0">
+                <a:solidFill>
+                  <a:srgbClr val="94A3B8"/>
+                </a:solidFill>
+                <a:latin typeface="Calibri" pitchFamily="34" charset="0"/>
+                <a:ea typeface="Calibri" pitchFamily="34" charset="-122"/>
+                <a:cs typeface="Calibri" pitchFamily="34" charset="-120"/>
+              </a:rPr>
+              <a:t>that fuses the </a:t>
+            </a:r>
+            <a:r>
+              <a:rPr lang="en-US" sz="1800" b="1" dirty="0">
+                <a:solidFill>
+                  <a:srgbClr val="94A3B8"/>
+                </a:solidFill>
+                <a:latin typeface="Calibri" pitchFamily="34" charset="0"/>
+                <a:ea typeface="Calibri" pitchFamily="34" charset="-122"/>
+                <a:cs typeface="Calibri" pitchFamily="34" charset="-120"/>
+              </a:rPr>
+              <a:t>Altman Z-Score </a:t>
+            </a:r>
+            <a:r>
+              <a:rPr lang="en-US" sz="1800" dirty="0">
+                <a:solidFill>
+                  <a:srgbClr val="94A3B8"/>
+                </a:solidFill>
+                <a:latin typeface="Calibri" pitchFamily="34" charset="0"/>
+                <a:ea typeface="Calibri" pitchFamily="34" charset="-122"/>
+                <a:cs typeface="Calibri" pitchFamily="34" charset="-120"/>
+              </a:rPr>
+              <a:t>(Company Financial Analysis) with the </a:t>
+            </a:r>
+            <a:r>
+              <a:rPr lang="en-US" sz="1800" b="1" dirty="0">
+                <a:solidFill>
+                  <a:srgbClr val="94A3B8"/>
+                </a:solidFill>
+                <a:latin typeface="Calibri" pitchFamily="34" charset="0"/>
+                <a:ea typeface="Calibri" pitchFamily="34" charset="-122"/>
+                <a:cs typeface="Calibri" pitchFamily="34" charset="-120"/>
+              </a:rPr>
+              <a:t>Market signals </a:t>
+            </a:r>
+            <a:r>
+              <a:rPr lang="en-US" dirty="0">
+                <a:solidFill>
+                  <a:srgbClr val="94A3B8"/>
+                </a:solidFill>
+                <a:latin typeface="Calibri" pitchFamily="34" charset="0"/>
+                <a:ea typeface="Calibri" pitchFamily="34" charset="-122"/>
+                <a:cs typeface="Calibri" pitchFamily="34" charset="-120"/>
+              </a:rPr>
+              <a:t>(credit ratings, leadership, news, hiring and employee sentiment) Live, giving you a Comprehensive Understanding in one go.</a:t>
             </a:r>
             <a:endParaRPr lang="en-US" sz="1800" dirty="0"/>
           </a:p>
-          <a:p>
-            <a:pPr indent="0" marL="0">
-              <a:lnSpc>
-                <a:spcPct val="112000"/>
-              </a:lnSpc>
-              <a:buNone/>
-            </a:pPr>
-            <a:r>
-              <a:rPr lang="en-US" sz="1800" dirty="0">
-                <a:solidFill>
-                  <a:srgbClr val="94A3B8"/>
-                </a:solidFill>
-                <a:latin typeface="Calibri" pitchFamily="34" charset="0"/>
-                <a:ea typeface="Calibri" pitchFamily="34" charset="-122"/>
-                <a:cs typeface="Calibri" pitchFamily="34" charset="-120"/>
-              </a:rPr>
-              <a:t>that fuses the Altman Z-Score with the market signals others read separately:</a:t>
-            </a:r>
-            <a:endParaRPr lang="en-US" sz="1800" dirty="0"/>
-          </a:p>
-          <a:p>
-            <a:pPr indent="0" marL="0">
-              <a:lnSpc>
-                <a:spcPct val="112000"/>
-              </a:lnSpc>
-              <a:buNone/>
-            </a:pPr>
-            <a:r>
-              <a:rPr lang="en-US" sz="1800" dirty="0">
-                <a:solidFill>
-                  <a:srgbClr val="94A3B8"/>
-                </a:solidFill>
-                <a:latin typeface="Calibri" pitchFamily="34" charset="0"/>
-                <a:ea typeface="Calibri" pitchFamily="34" charset="-122"/>
-                <a:cs typeface="Calibri" pitchFamily="34" charset="-120"/>
-              </a:rPr>
-              <a:t>credit ratings, leadership, news, hiring and employee sentiment.</a:t>
-            </a:r>
-            <a:endParaRPr lang="en-US" sz="1800" dirty="0"/>
-          </a:p>
         </p:txBody>
       </p:sp>
       <p:sp>
         <p:nvSpPr>
           <p:cNvPr id="5" name="Shape 3">
-            <a:hlinkClick r:id="rId1" tooltip="Open the live Foresight AI dashboard"/>
+            <a:hlinkClick r:id="rId3" tooltip="Open the live Foresight AI dashboard"/>
           </p:cNvPr>
           <p:cNvSpPr/>
           <p:nvPr/>
         </p:nvSpPr>
         <p:spPr>
           <a:xfrm>
-            <a:off x="822960" y="3977640"/>
+            <a:off x="822960" y="4132913"/>
             <a:ext cx="4160520" cy="566928"/>
           </a:xfrm>
           <a:prstGeom prst="roundRect">
@@ -2251,14 +1897,14 @@
       <p:sp>
         <p:nvSpPr>
           <p:cNvPr id="6" name="Text 4">
-            <a:hlinkClick r:id="rId1" tooltip="Open the live Foresight AI dashboard"/>
+            <a:hlinkClick r:id="rId3" tooltip="Open the live Foresight AI dashboard"/>
           </p:cNvPr>
           <p:cNvSpPr/>
           <p:nvPr/>
         </p:nvSpPr>
         <p:spPr>
           <a:xfrm>
-            <a:off x="822960" y="3977640"/>
+            <a:off x="822960" y="4141537"/>
             <a:ext cx="4160520" cy="566928"/>
           </a:xfrm>
           <a:prstGeom prst="rect">
@@ -2271,7 +1917,7 @@
           <a:bodyPr wrap="square" rtlCol="0" anchor="ctr"/>
           <a:lstStyle/>
           <a:p>
-            <a:pPr algn="ctr" indent="0" marL="0">
+            <a:pPr marL="0" indent="0" algn="ctr">
               <a:buNone/>
             </a:pPr>
             <a:r>
@@ -2282,7 +1928,7 @@
                 <a:latin typeface="Calibri" pitchFamily="34" charset="0"/>
                 <a:ea typeface="Calibri" pitchFamily="34" charset="-122"/>
                 <a:cs typeface="Calibri" pitchFamily="34" charset="-120"/>
-                <a:hlinkClick r:id="rId1" invalidUrl="" action="" tgtFrame="" tooltip="Open the live Foresight AI dashboard" history="1" highlightClick="0" endSnd="0">
+                <a:hlinkClick r:id="rId3" tooltip="Open the live Foresight AI dashboard">
                   <a:extLst>
                     <a:ext uri="{A12FA001-AC4F-418D-AE19-62706E023703}">
                       <ahyp:hlinkClr xmlns:ahyp="http://schemas.microsoft.com/office/drawing/2018/hyperlinkcolor" val="tx"/>
@@ -2292,9 +1938,6 @@
               </a:rPr>
               <a:t>Live demo   </a:t>
             </a:r>
-            <a:pPr algn="ctr" indent="0" marL="0">
-              <a:buNone/>
-            </a:pPr>
             <a:r>
               <a:rPr lang="en-US" sz="1500" b="1" u="sng" dirty="0">
                 <a:solidFill>
@@ -2303,7 +1946,7 @@
                 <a:latin typeface="Calibri" pitchFamily="34" charset="0"/>
                 <a:ea typeface="Calibri" pitchFamily="34" charset="-122"/>
                 <a:cs typeface="Calibri" pitchFamily="34" charset="-120"/>
-                <a:hlinkClick r:id="rId1" invalidUrl="" action="" tgtFrame="" tooltip="Open the live Foresight AI dashboard" history="1" highlightClick="0" endSnd="0">
+                <a:hlinkClick r:id="rId3" tooltip="Open the live Foresight AI dashboard">
                   <a:extLst>
                     <a:ext uri="{A12FA001-AC4F-418D-AE19-62706E023703}">
                       <ahyp:hlinkClr xmlns:ahyp="http://schemas.microsoft.com/office/drawing/2018/hyperlinkcolor" val="tx"/>
@@ -2338,7 +1981,7 @@
           <a:bodyPr wrap="square" rtlCol="0" anchor="ctr"/>
           <a:lstStyle/>
           <a:p>
-            <a:pPr indent="0" marL="0">
+            <a:pPr marL="0" indent="0">
               <a:buNone/>
             </a:pPr>
             <a:r>
@@ -2383,7 +2026,7 @@
       </p:sp>
       <p:graphicFrame>
         <p:nvGraphicFramePr>
-          <p:cNvPr id="9" name="Chart 0" descr=""/>
+          <p:cNvPr id="9" name="Chart 0"/>
           <p:cNvGraphicFramePr/>
           <p:nvPr/>
         </p:nvGraphicFramePr>
@@ -2391,9 +2034,9 @@
           <a:off x="9006840" y="1828800"/>
           <a:ext cx="2651760" cy="2651760"/>
         </p:xfrm>
-        <a:graphic xmlns:a="http://schemas.openxmlformats.org/drawingml/2006/main">
+        <a:graphic>
           <a:graphicData uri="http://schemas.openxmlformats.org/drawingml/2006/chart">
-            <c:chart xmlns:c="http://schemas.openxmlformats.org/drawingml/2006/chart" r:id="rId2"/>
+            <c:chart xmlns:c="http://schemas.openxmlformats.org/drawingml/2006/chart" xmlns:r="http://schemas.openxmlformats.org/officeDocument/2006/relationships" r:id="rId4"/>
           </a:graphicData>
         </a:graphic>
       </p:graphicFrame>
@@ -2418,7 +2061,7 @@
           <a:bodyPr wrap="square" rtlCol="0" anchor="ctr"/>
           <a:lstStyle/>
           <a:p>
-            <a:pPr algn="ctr" indent="0" marL="0">
+            <a:pPr marL="0" indent="0" algn="ctr">
               <a:buNone/>
             </a:pPr>
             <a:r>
@@ -2457,11 +2100,11 @@
           <a:bodyPr wrap="square" rtlCol="0" anchor="ctr"/>
           <a:lstStyle/>
           <a:p>
-            <a:pPr algn="ctr" indent="0" marL="0">
+            <a:pPr marL="0" indent="0" algn="ctr">
               <a:buNone/>
             </a:pPr>
             <a:r>
-              <a:rPr lang="en-US" sz="1200" spc="200" kern="0" dirty="0">
+              <a:rPr lang="en-US" sz="1200" kern="0" spc="200" dirty="0">
                 <a:solidFill>
                   <a:srgbClr val="94A3B8"/>
                 </a:solidFill>
@@ -2483,7 +2126,7 @@
         </p:nvSpPr>
         <p:spPr>
           <a:xfrm>
-            <a:off x="9006840" y="1810512"/>
+            <a:off x="9006840" y="1620734"/>
             <a:ext cx="2651760" cy="274320"/>
           </a:xfrm>
           <a:prstGeom prst="rect">
@@ -2496,11 +2139,11 @@
           <a:bodyPr wrap="square" rtlCol="0" anchor="ctr"/>
           <a:lstStyle/>
           <a:p>
-            <a:pPr algn="ctr" indent="0" marL="0">
+            <a:pPr marL="0" indent="0" algn="ctr">
               <a:buNone/>
             </a:pPr>
             <a:r>
-              <a:rPr lang="en-US" sz="1200" b="1" spc="300" kern="0" dirty="0">
+              <a:rPr lang="en-US" sz="1200" b="1" kern="0" spc="300" dirty="0">
                 <a:solidFill>
                   <a:srgbClr val="F59E0B"/>
                 </a:solidFill>
@@ -2535,7 +2178,7 @@
           <a:bodyPr wrap="square" rtlCol="0" anchor="ctr"/>
           <a:lstStyle/>
           <a:p>
-            <a:pPr algn="ctr" indent="0" marL="0">
+            <a:pPr marL="0" indent="0" algn="ctr">
               <a:buNone/>
             </a:pPr>
             <a:r>
@@ -2569,6 +2212,7 @@
         <a:solidFill>
           <a:srgbClr val="0A1628"/>
         </a:solidFill>
+        <a:effectLst/>
       </p:bgPr>
     </p:bg>
     <p:spTree>
@@ -2606,7 +2250,7 @@
           <a:bodyPr wrap="square" rtlCol="0" anchor="ctr"/>
           <a:lstStyle/>
           <a:p>
-            <a:pPr indent="0" marL="0">
+            <a:pPr marL="0" indent="0">
               <a:buNone/>
             </a:pPr>
             <a:r>
@@ -2620,9 +2264,6 @@
               </a:rPr>
               <a:t>The warning signs are </a:t>
             </a:r>
-            <a:pPr indent="0" marL="0">
-              <a:buNone/>
-            </a:pPr>
             <a:r>
               <a:rPr lang="en-US" sz="3300" b="1" dirty="0">
                 <a:solidFill>
@@ -2634,9 +2275,6 @@
               </a:rPr>
               <a:t>public</a:t>
             </a:r>
-            <a:pPr indent="0" marL="0">
-              <a:buNone/>
-            </a:pPr>
             <a:r>
               <a:rPr lang="en-US" sz="3300" b="1" dirty="0">
                 <a:solidFill>
@@ -2673,7 +2311,7 @@
           <a:bodyPr wrap="square" rtlCol="0" anchor="ctr"/>
           <a:lstStyle/>
           <a:p>
-            <a:pPr indent="0" marL="0">
+            <a:pPr marL="0" indent="0">
               <a:buNone/>
             </a:pPr>
             <a:r>
@@ -2740,14 +2378,14 @@
       </p:sp>
       <p:pic>
         <p:nvPicPr>
-          <p:cNvPr id="6" name="Image 0" descr="preencoded.png">    </p:cNvPr>
+          <p:cNvPr id="6" name="Image 0" descr="preencoded.png"/>
           <p:cNvPicPr>
             <a:picLocks noChangeAspect="1"/>
           </p:cNvPicPr>
           <p:nvPr/>
         </p:nvPicPr>
         <p:blipFill>
-          <a:blip r:embed="rId1"/>
+          <a:blip r:embed="rId3"/>
           <a:stretch>
             <a:fillRect/>
           </a:stretch>
@@ -2783,7 +2421,7 @@
           <a:bodyPr wrap="square" rtlCol="0" anchor="ctr"/>
           <a:lstStyle/>
           <a:p>
-            <a:pPr indent="0" marL="0">
+            <a:pPr marL="0" indent="0">
               <a:buNone/>
             </a:pPr>
             <a:r>
@@ -2822,7 +2460,7 @@
           <a:bodyPr wrap="square" rtlCol="0" anchor="ctr"/>
           <a:lstStyle/>
           <a:p>
-            <a:pPr indent="0" marL="0">
+            <a:pPr marL="0" indent="0">
               <a:lnSpc>
                 <a:spcPct val="105000"/>
               </a:lnSpc>
@@ -2892,14 +2530,14 @@
       </p:sp>
       <p:pic>
         <p:nvPicPr>
-          <p:cNvPr id="11" name="Image 1" descr="preencoded.png">    </p:cNvPr>
+          <p:cNvPr id="11" name="Image 1" descr="preencoded.png"/>
           <p:cNvPicPr>
             <a:picLocks noChangeAspect="1"/>
           </p:cNvPicPr>
           <p:nvPr/>
         </p:nvPicPr>
         <p:blipFill>
-          <a:blip r:embed="rId2"/>
+          <a:blip r:embed="rId4"/>
           <a:stretch>
             <a:fillRect/>
           </a:stretch>
@@ -2935,7 +2573,7 @@
           <a:bodyPr wrap="square" rtlCol="0" anchor="ctr"/>
           <a:lstStyle/>
           <a:p>
-            <a:pPr indent="0" marL="0">
+            <a:pPr marL="0" indent="0">
               <a:buNone/>
             </a:pPr>
             <a:r>
@@ -2974,7 +2612,7 @@
           <a:bodyPr wrap="square" rtlCol="0" anchor="ctr"/>
           <a:lstStyle/>
           <a:p>
-            <a:pPr indent="0" marL="0">
+            <a:pPr marL="0" indent="0">
               <a:lnSpc>
                 <a:spcPct val="105000"/>
               </a:lnSpc>
@@ -3044,14 +2682,14 @@
       </p:sp>
       <p:pic>
         <p:nvPicPr>
-          <p:cNvPr id="16" name="Image 2" descr="preencoded.png">    </p:cNvPr>
+          <p:cNvPr id="16" name="Image 2" descr="preencoded.png"/>
           <p:cNvPicPr>
             <a:picLocks noChangeAspect="1"/>
           </p:cNvPicPr>
           <p:nvPr/>
         </p:nvPicPr>
         <p:blipFill>
-          <a:blip r:embed="rId3"/>
+          <a:blip r:embed="rId5"/>
           <a:stretch>
             <a:fillRect/>
           </a:stretch>
@@ -3087,7 +2725,7 @@
           <a:bodyPr wrap="square" rtlCol="0" anchor="ctr"/>
           <a:lstStyle/>
           <a:p>
-            <a:pPr indent="0" marL="0">
+            <a:pPr marL="0" indent="0">
               <a:buNone/>
             </a:pPr>
             <a:r>
@@ -3126,7 +2764,7 @@
           <a:bodyPr wrap="square" rtlCol="0" anchor="ctr"/>
           <a:lstStyle/>
           <a:p>
-            <a:pPr indent="0" marL="0">
+            <a:pPr marL="0" indent="0">
               <a:lnSpc>
                 <a:spcPct val="105000"/>
               </a:lnSpc>
@@ -3195,11 +2833,11 @@
           <a:bodyPr wrap="square" rtlCol="0" anchor="ctr"/>
           <a:lstStyle/>
           <a:p>
-            <a:pPr indent="0" marL="0">
+            <a:pPr marL="0" indent="0">
               <a:buNone/>
             </a:pPr>
             <a:r>
-              <a:rPr lang="en-US" sz="1150" b="1" spc="300" kern="0" dirty="0">
+              <a:rPr lang="en-US" sz="1150" b="1" kern="0" spc="300" dirty="0">
                 <a:solidFill>
                   <a:srgbClr val="F59E0B"/>
                 </a:solidFill>
@@ -3234,7 +2872,7 @@
           <a:bodyPr wrap="square" rtlCol="0" anchor="ctr"/>
           <a:lstStyle/>
           <a:p>
-            <a:pPr indent="0" marL="0">
+            <a:pPr marL="0" indent="0">
               <a:buNone/>
             </a:pPr>
             <a:r>
@@ -3260,7 +2898,7 @@
         </p:nvSpPr>
         <p:spPr>
           <a:xfrm>
-            <a:off x="7360920" y="3035808"/>
+            <a:off x="7999268" y="3156572"/>
             <a:ext cx="1280160" cy="1005840"/>
           </a:xfrm>
           <a:prstGeom prst="rect">
@@ -3273,7 +2911,7 @@
           <a:bodyPr wrap="square" rtlCol="0" anchor="ctr"/>
           <a:lstStyle/>
           <a:p>
-            <a:pPr algn="l" indent="0" marL="0">
+            <a:pPr marL="0" indent="0" algn="l">
               <a:buNone/>
             </a:pPr>
             <a:r>
@@ -3312,7 +2950,7 @@
           <a:bodyPr wrap="square" rtlCol="0" anchor="ctr"/>
           <a:lstStyle/>
           <a:p>
-            <a:pPr indent="0" marL="0">
+            <a:pPr marL="0" indent="0">
               <a:lnSpc>
                 <a:spcPct val="102000"/>
               </a:lnSpc>
@@ -3329,16 +2967,30 @@
               </a:rPr>
               <a:t>signals</a:t>
             </a:r>
-            <a:pPr indent="0" marL="0">
+            <a:endParaRPr lang="en-US" sz="2000" dirty="0"/>
+          </a:p>
+          <a:p>
+            <a:pPr marL="0" indent="0">
               <a:lnSpc>
                 <a:spcPct val="102000"/>
               </a:lnSpc>
               <a:buNone/>
             </a:pPr>
+            <a:r>
+              <a:rPr lang="en-US" sz="1400" dirty="0">
+                <a:solidFill>
+                  <a:srgbClr val="94A3B8"/>
+                </a:solidFill>
+                <a:latin typeface="Calibri" pitchFamily="34" charset="0"/>
+                <a:ea typeface="Calibri" pitchFamily="34" charset="-122"/>
+                <a:cs typeface="Calibri" pitchFamily="34" charset="-120"/>
+              </a:rPr>
+              <a:t>fused into one</a:t>
+            </a:r>
             <a:endParaRPr lang="en-US" sz="2000" dirty="0"/>
           </a:p>
           <a:p>
-            <a:pPr indent="0" marL="0">
+            <a:pPr marL="0" indent="0">
               <a:lnSpc>
                 <a:spcPct val="102000"/>
               </a:lnSpc>
@@ -3353,30 +3005,10 @@
                 <a:ea typeface="Calibri" pitchFamily="34" charset="-122"/>
                 <a:cs typeface="Calibri" pitchFamily="34" charset="-120"/>
               </a:rPr>
-              <a:t>fused into one</a:t>
+              <a:t>0-100 score</a:t>
             </a:r>
             <a:endParaRPr lang="en-US" sz="2000" dirty="0"/>
           </a:p>
-          <a:p>
-            <a:pPr indent="0" marL="0">
-              <a:lnSpc>
-                <a:spcPct val="102000"/>
-              </a:lnSpc>
-              <a:buNone/>
-            </a:pPr>
-            <a:r>
-              <a:rPr lang="en-US" sz="1400" dirty="0">
-                <a:solidFill>
-                  <a:srgbClr val="94A3B8"/>
-                </a:solidFill>
-                <a:latin typeface="Calibri" pitchFamily="34" charset="0"/>
-                <a:ea typeface="Calibri" pitchFamily="34" charset="-122"/>
-                <a:cs typeface="Calibri" pitchFamily="34" charset="-120"/>
-              </a:rPr>
-              <a:t>0-100 read</a:t>
-            </a:r>
-            <a:endParaRPr lang="en-US" sz="2000" dirty="0"/>
-          </a:p>
         </p:txBody>
       </p:sp>
       <p:sp>
@@ -3387,7 +3019,7 @@
         </p:nvSpPr>
         <p:spPr>
           <a:xfrm>
-            <a:off x="7406640" y="4526280"/>
+            <a:off x="7406640" y="4431391"/>
             <a:ext cx="3703320" cy="640080"/>
           </a:xfrm>
           <a:prstGeom prst="rect">
@@ -3400,7 +3032,7 @@
           <a:bodyPr wrap="square" rtlCol="0" anchor="ctr"/>
           <a:lstStyle/>
           <a:p>
-            <a:pPr indent="0" marL="0">
+            <a:pPr marL="0" indent="0" algn="ctr">
               <a:lnSpc>
                 <a:spcPct val="110000"/>
               </a:lnSpc>
@@ -3415,7 +3047,28 @@
                 <a:ea typeface="Calibri" pitchFamily="34" charset="-122"/>
                 <a:cs typeface="Calibri" pitchFamily="34" charset="-120"/>
               </a:rPr>
-              <a:t>Financials  .  credit ratings  .  leadership  .  news  .  hiring  .  employee sentiment</a:t>
+              <a:t>Financials  .  Credit ratings  .  Leadership  .  </a:t>
+            </a:r>
+            <a:br>
+              <a:rPr lang="en-US" sz="1250" dirty="0">
+                <a:solidFill>
+                  <a:srgbClr val="FFFFFF"/>
+                </a:solidFill>
+                <a:latin typeface="Calibri" pitchFamily="34" charset="0"/>
+                <a:ea typeface="Calibri" pitchFamily="34" charset="-122"/>
+                <a:cs typeface="Calibri" pitchFamily="34" charset="-120"/>
+              </a:rPr>
+            </a:br>
+            <a:r>
+              <a:rPr lang="en-US" sz="1250" dirty="0">
+                <a:solidFill>
+                  <a:srgbClr val="FFFFFF"/>
+                </a:solidFill>
+                <a:latin typeface="Calibri" pitchFamily="34" charset="0"/>
+                <a:ea typeface="Calibri" pitchFamily="34" charset="-122"/>
+                <a:cs typeface="Calibri" pitchFamily="34" charset="-120"/>
+              </a:rPr>
+              <a:t>News  .  Hiring  .  Employee sentiment</a:t>
             </a:r>
             <a:endParaRPr lang="en-US" sz="1250" dirty="0"/>
           </a:p>
@@ -3429,7 +3082,7 @@
         </p:nvSpPr>
         <p:spPr>
           <a:xfrm>
-            <a:off x="7406640" y="5440680"/>
+            <a:off x="7406640" y="5345794"/>
             <a:ext cx="3703320" cy="365760"/>
           </a:xfrm>
           <a:prstGeom prst="rect">
@@ -3442,7 +3095,7 @@
           <a:bodyPr wrap="square" rtlCol="0" anchor="ctr"/>
           <a:lstStyle/>
           <a:p>
-            <a:pPr indent="0" marL="0">
+            <a:pPr marL="0" indent="0">
               <a:buNone/>
             </a:pPr>
             <a:r>
@@ -3476,6 +3129,7 @@
         <a:solidFill>
           <a:srgbClr val="0A1628"/>
         </a:solidFill>
+        <a:effectLst/>
       </p:bgPr>
     </p:bg>
     <p:spTree>
@@ -3513,7 +3167,7 @@
           <a:bodyPr wrap="square" rtlCol="0" anchor="ctr"/>
           <a:lstStyle/>
           <a:p>
-            <a:pPr indent="0" marL="0">
+            <a:pPr marL="0" indent="0">
               <a:buNone/>
             </a:pPr>
             <a:r>
@@ -3527,9 +3181,6 @@
               </a:rPr>
               <a:t>One live pipeline, </a:t>
             </a:r>
-            <a:pPr indent="0" marL="0">
-              <a:buNone/>
-            </a:pPr>
             <a:r>
               <a:rPr lang="en-US" sz="3300" b="1" dirty="0">
                 <a:solidFill>
@@ -3566,7 +3217,7 @@
           <a:bodyPr wrap="square" rtlCol="0" anchor="ctr"/>
           <a:lstStyle/>
           <a:p>
-            <a:pPr indent="0" marL="0">
+            <a:pPr marL="0" indent="0">
               <a:buNone/>
             </a:pPr>
             <a:r>
@@ -3633,14 +3284,14 @@
       </p:sp>
       <p:pic>
         <p:nvPicPr>
-          <p:cNvPr id="6" name="Image 0" descr="preencoded.png">    </p:cNvPr>
+          <p:cNvPr id="6" name="Image 0" descr="preencoded.png"/>
           <p:cNvPicPr>
             <a:picLocks noChangeAspect="1"/>
           </p:cNvPicPr>
           <p:nvPr/>
         </p:nvPicPr>
         <p:blipFill>
-          <a:blip r:embed="rId1"/>
+          <a:blip r:embed="rId3"/>
           <a:stretch>
             <a:fillRect/>
           </a:stretch>
@@ -3676,7 +3327,7 @@
           <a:bodyPr wrap="square" rtlCol="0" anchor="ctr"/>
           <a:lstStyle/>
           <a:p>
-            <a:pPr indent="0" marL="0">
+            <a:pPr marL="0" indent="0">
               <a:buNone/>
             </a:pPr>
             <a:r>
@@ -3715,7 +3366,7 @@
           <a:bodyPr wrap="square" rtlCol="0" anchor="ctr"/>
           <a:lstStyle/>
           <a:p>
-            <a:pPr algn="ctr" indent="0" marL="0">
+            <a:pPr marL="0" indent="0" algn="ctr">
               <a:buNone/>
             </a:pPr>
             <a:r>
@@ -3754,7 +3405,7 @@
           <a:bodyPr wrap="square" rtlCol="0" anchor="ctr"/>
           <a:lstStyle/>
           <a:p>
-            <a:pPr algn="ctr" indent="0" marL="0">
+            <a:pPr marL="0" indent="0" algn="ctr">
               <a:lnSpc>
                 <a:spcPct val="103000"/>
               </a:lnSpc>
@@ -3777,14 +3428,14 @@
       </p:sp>
       <p:pic>
         <p:nvPicPr>
-          <p:cNvPr id="10" name="Image 1" descr="preencoded.png">    </p:cNvPr>
+          <p:cNvPr id="10" name="Image 1" descr="preencoded.png"/>
           <p:cNvPicPr>
             <a:picLocks noChangeAspect="1"/>
           </p:cNvPicPr>
           <p:nvPr/>
         </p:nvPicPr>
         <p:blipFill>
-          <a:blip r:embed="rId2"/>
+          <a:blip r:embed="rId4"/>
           <a:stretch>
             <a:fillRect/>
           </a:stretch>
@@ -3848,14 +3499,14 @@
       </p:sp>
       <p:pic>
         <p:nvPicPr>
-          <p:cNvPr id="13" name="Image 2" descr="preencoded.png">    </p:cNvPr>
+          <p:cNvPr id="13" name="Image 2" descr="preencoded.png"/>
           <p:cNvPicPr>
             <a:picLocks noChangeAspect="1"/>
           </p:cNvPicPr>
           <p:nvPr/>
         </p:nvPicPr>
         <p:blipFill>
-          <a:blip r:embed="rId3"/>
+          <a:blip r:embed="rId5"/>
           <a:stretch>
             <a:fillRect/>
           </a:stretch>
@@ -3891,7 +3542,7 @@
           <a:bodyPr wrap="square" rtlCol="0" anchor="ctr"/>
           <a:lstStyle/>
           <a:p>
-            <a:pPr indent="0" marL="0">
+            <a:pPr marL="0" indent="0">
               <a:buNone/>
             </a:pPr>
             <a:r>
@@ -3930,7 +3581,7 @@
           <a:bodyPr wrap="square" rtlCol="0" anchor="ctr"/>
           <a:lstStyle/>
           <a:p>
-            <a:pPr algn="ctr" indent="0" marL="0">
+            <a:pPr marL="0" indent="0" algn="ctr">
               <a:buNone/>
             </a:pPr>
             <a:r>
@@ -3969,7 +3620,7 @@
           <a:bodyPr wrap="square" rtlCol="0" anchor="ctr"/>
           <a:lstStyle/>
           <a:p>
-            <a:pPr algn="ctr" indent="0" marL="0">
+            <a:pPr marL="0" indent="0" algn="ctr">
               <a:lnSpc>
                 <a:spcPct val="103000"/>
               </a:lnSpc>
@@ -3992,7 +3643,7 @@
       </p:sp>
       <p:pic>
         <p:nvPicPr>
-          <p:cNvPr id="17" name="Image 3" descr="preencoded.png">    </p:cNvPr>
+          <p:cNvPr id="17" name="Image 3" descr="preencoded.png"/>
           <p:cNvPicPr>
             <a:picLocks noChangeAspect="1"/>
           </p:cNvPicPr>
@@ -4063,14 +3714,14 @@
       </p:sp>
       <p:pic>
         <p:nvPicPr>
-          <p:cNvPr id="20" name="Image 4" descr="preencoded.png">    </p:cNvPr>
+          <p:cNvPr id="20" name="Image 4" descr="preencoded.png"/>
           <p:cNvPicPr>
             <a:picLocks noChangeAspect="1"/>
           </p:cNvPicPr>
           <p:nvPr/>
         </p:nvPicPr>
         <p:blipFill>
-          <a:blip r:embed="rId5"/>
+          <a:blip r:embed="rId6"/>
           <a:stretch>
             <a:fillRect/>
           </a:stretch>
@@ -4106,7 +3757,7 @@
           <a:bodyPr wrap="square" rtlCol="0" anchor="ctr"/>
           <a:lstStyle/>
           <a:p>
-            <a:pPr indent="0" marL="0">
+            <a:pPr marL="0" indent="0">
               <a:buNone/>
             </a:pPr>
             <a:r>
@@ -4145,7 +3796,7 @@
           <a:bodyPr wrap="square" rtlCol="0" anchor="ctr"/>
           <a:lstStyle/>
           <a:p>
-            <a:pPr algn="ctr" indent="0" marL="0">
+            <a:pPr marL="0" indent="0" algn="ctr">
               <a:buNone/>
             </a:pPr>
             <a:r>
@@ -4184,7 +3835,7 @@
           <a:bodyPr wrap="square" rtlCol="0" anchor="ctr"/>
           <a:lstStyle/>
           <a:p>
-            <a:pPr algn="ctr" indent="0" marL="0">
+            <a:pPr marL="0" indent="0" algn="ctr">
               <a:lnSpc>
                 <a:spcPct val="103000"/>
               </a:lnSpc>
@@ -4207,14 +3858,14 @@
       </p:sp>
       <p:pic>
         <p:nvPicPr>
-          <p:cNvPr id="24" name="Image 5" descr="preencoded.png">    </p:cNvPr>
+          <p:cNvPr id="24" name="Image 5" descr="preencoded.png"/>
           <p:cNvPicPr>
             <a:picLocks noChangeAspect="1"/>
           </p:cNvPicPr>
           <p:nvPr/>
         </p:nvPicPr>
         <p:blipFill>
-          <a:blip r:embed="rId6"/>
+          <a:blip r:embed="rId4"/>
           <a:stretch>
             <a:fillRect/>
           </a:stretch>
@@ -4278,7 +3929,7 @@
       </p:sp>
       <p:pic>
         <p:nvPicPr>
-          <p:cNvPr id="27" name="Image 6" descr="preencoded.png">    </p:cNvPr>
+          <p:cNvPr id="27" name="Image 6" descr="preencoded.png"/>
           <p:cNvPicPr>
             <a:picLocks noChangeAspect="1"/>
           </p:cNvPicPr>
@@ -4321,7 +3972,7 @@
           <a:bodyPr wrap="square" rtlCol="0" anchor="ctr"/>
           <a:lstStyle/>
           <a:p>
-            <a:pPr indent="0" marL="0">
+            <a:pPr marL="0" indent="0">
               <a:buNone/>
             </a:pPr>
             <a:r>
@@ -4360,7 +4011,7 @@
           <a:bodyPr wrap="square" rtlCol="0" anchor="ctr"/>
           <a:lstStyle/>
           <a:p>
-            <a:pPr algn="ctr" indent="0" marL="0">
+            <a:pPr marL="0" indent="0" algn="ctr">
               <a:buNone/>
             </a:pPr>
             <a:r>
@@ -4399,7 +4050,7 @@
           <a:bodyPr wrap="square" rtlCol="0" anchor="ctr"/>
           <a:lstStyle/>
           <a:p>
-            <a:pPr algn="ctr" indent="0" marL="0">
+            <a:pPr marL="0" indent="0" algn="ctr">
               <a:lnSpc>
                 <a:spcPct val="103000"/>
               </a:lnSpc>
@@ -4455,7 +4106,7 @@
         </p:nvSpPr>
         <p:spPr>
           <a:xfrm>
-            <a:off x="868680" y="4910328"/>
+            <a:off x="868680" y="4841319"/>
             <a:ext cx="3657600" cy="274320"/>
           </a:xfrm>
           <a:prstGeom prst="rect">
@@ -4468,11 +4119,11 @@
           <a:bodyPr wrap="square" rtlCol="0" anchor="ctr"/>
           <a:lstStyle/>
           <a:p>
-            <a:pPr indent="0" marL="0">
+            <a:pPr marL="0" indent="0">
               <a:buNone/>
             </a:pPr>
             <a:r>
-              <a:rPr lang="en-US" sz="1100" b="1" spc="300" kern="0" dirty="0">
+              <a:rPr lang="en-US" sz="1100" b="1" kern="0" spc="300" dirty="0">
                 <a:solidFill>
                   <a:srgbClr val="F59E0B"/>
                 </a:solidFill>
@@ -4508,7 +4159,7 @@
       </p:sp>
       <p:pic>
         <p:nvPicPr>
-          <p:cNvPr id="34" name="Image 7" descr="preencoded.png">    </p:cNvPr>
+          <p:cNvPr id="34" name="Image 7" descr="preencoded.png"/>
           <p:cNvPicPr>
             <a:picLocks noChangeAspect="1"/>
           </p:cNvPicPr>
@@ -4538,7 +4189,7 @@
         </p:nvSpPr>
         <p:spPr>
           <a:xfrm>
-            <a:off x="1554480" y="5257800"/>
+            <a:off x="1554480" y="5188790"/>
             <a:ext cx="4572000" cy="777240"/>
           </a:xfrm>
           <a:prstGeom prst="rect">
@@ -4551,7 +4202,7 @@
           <a:bodyPr wrap="square" rtlCol="0" anchor="t"/>
           <a:lstStyle/>
           <a:p>
-            <a:pPr indent="0" marL="0">
+            <a:pPr marL="0" indent="0">
               <a:lnSpc>
                 <a:spcPct val="102000"/>
               </a:lnSpc>
@@ -4568,12 +4219,6 @@
               </a:rPr>
               <a:t>Financial leg</a:t>
             </a:r>
-            <a:pPr indent="0" marL="0">
-              <a:lnSpc>
-                <a:spcPct val="102000"/>
-              </a:lnSpc>
-              <a:buNone/>
-            </a:pPr>
             <a:r>
               <a:rPr lang="en-US" sz="1250" dirty="0">
                 <a:solidFill>
@@ -4634,7 +4279,7 @@
       </p:sp>
       <p:pic>
         <p:nvPicPr>
-          <p:cNvPr id="38" name="Image 8" descr="preencoded.png">    </p:cNvPr>
+          <p:cNvPr id="38" name="Image 8" descr="preencoded.png"/>
           <p:cNvPicPr>
             <a:picLocks noChangeAspect="1"/>
           </p:cNvPicPr>
@@ -4664,7 +4309,7 @@
         </p:nvSpPr>
         <p:spPr>
           <a:xfrm>
-            <a:off x="7406640" y="5239512"/>
+            <a:off x="7406640" y="5118743"/>
             <a:ext cx="4160520" cy="868680"/>
           </a:xfrm>
           <a:prstGeom prst="rect">
@@ -4677,7 +4322,7 @@
           <a:bodyPr wrap="square" rtlCol="0" anchor="t"/>
           <a:lstStyle/>
           <a:p>
-            <a:pPr indent="0" marL="0">
+            <a:pPr marL="0" indent="0">
               <a:lnSpc>
                 <a:spcPct val="100000"/>
               </a:lnSpc>
@@ -4694,12 +4339,6 @@
               </a:rPr>
               <a:t>Market leg</a:t>
             </a:r>
-            <a:pPr indent="0" marL="0">
-              <a:lnSpc>
-                <a:spcPct val="100000"/>
-              </a:lnSpc>
-              <a:buNone/>
-            </a:pPr>
             <a:r>
               <a:rPr lang="en-US" sz="1200" dirty="0">
                 <a:solidFill>
@@ -4731,6 +4370,7 @@
         <a:solidFill>
           <a:srgbClr val="0A1628"/>
         </a:solidFill>
+        <a:effectLst/>
       </p:bgPr>
     </p:bg>
     <p:spTree>
@@ -4768,7 +4408,7 @@
           <a:bodyPr wrap="square" rtlCol="0" anchor="ctr"/>
           <a:lstStyle/>
           <a:p>
-            <a:pPr indent="0" marL="0">
+            <a:pPr marL="0" indent="0">
               <a:buNone/>
             </a:pPr>
             <a:r>
@@ -4782,9 +4422,6 @@
               </a:rPr>
               <a:t>One </a:t>
             </a:r>
-            <a:pPr indent="0" marL="0">
-              <a:buNone/>
-            </a:pPr>
             <a:r>
               <a:rPr lang="en-US" sz="3300" b="1" dirty="0">
                 <a:solidFill>
@@ -4796,9 +4433,6 @@
               </a:rPr>
               <a:t>comprehensive</a:t>
             </a:r>
-            <a:pPr indent="0" marL="0">
-              <a:buNone/>
-            </a:pPr>
             <a:r>
               <a:rPr lang="en-US" sz="3300" b="1" dirty="0">
                 <a:solidFill>
@@ -4835,7 +4469,7 @@
           <a:bodyPr wrap="square" rtlCol="0" anchor="ctr"/>
           <a:lstStyle/>
           <a:p>
-            <a:pPr indent="0" marL="0">
+            <a:pPr marL="0" indent="0">
               <a:buNone/>
             </a:pPr>
             <a:r>
@@ -4874,7 +4508,7 @@
           <a:bodyPr wrap="square" rtlCol="0" anchor="ctr"/>
           <a:lstStyle/>
           <a:p>
-            <a:pPr indent="0" marL="0">
+            <a:pPr marL="0" indent="0">
               <a:buNone/>
             </a:pPr>
             <a:r>
@@ -4913,7 +4547,7 @@
           <a:bodyPr wrap="square" rtlCol="0" anchor="ctr"/>
           <a:lstStyle/>
           <a:p>
-            <a:pPr indent="0" marL="0">
+            <a:pPr marL="0" indent="0">
               <a:lnSpc>
                 <a:spcPct val="110000"/>
               </a:lnSpc>
@@ -4955,7 +4589,7 @@
           <a:bodyPr wrap="square" rtlCol="0" anchor="ctr"/>
           <a:lstStyle/>
           <a:p>
-            <a:pPr indent="0" marL="0">
+            <a:pPr marL="0" indent="0">
               <a:lnSpc>
                 <a:spcPct val="108000"/>
               </a:lnSpc>
@@ -4985,7 +4619,7 @@
         <p:spPr>
           <a:xfrm>
             <a:off x="777240" y="4553712"/>
-            <a:ext cx="3977640" cy="1554480"/>
+            <a:ext cx="3776472" cy="1976484"/>
           </a:xfrm>
           <a:prstGeom prst="roundRect">
             <a:avLst>
@@ -5011,8 +4645,8 @@
         </p:nvSpPr>
         <p:spPr>
           <a:xfrm>
-            <a:off x="987552" y="4663440"/>
-            <a:ext cx="3566160" cy="256032"/>
+            <a:off x="1004812" y="4672066"/>
+            <a:ext cx="2782192" cy="256032"/>
           </a:xfrm>
           <a:prstGeom prst="rect">
             <a:avLst/>
@@ -5024,11 +4658,11 @@
           <a:bodyPr wrap="square" rtlCol="0" anchor="ctr"/>
           <a:lstStyle/>
           <a:p>
-            <a:pPr indent="0" marL="0">
+            <a:pPr marL="0" indent="0">
               <a:buNone/>
             </a:pPr>
             <a:r>
-              <a:rPr lang="en-US" sz="1050" b="1" spc="200" kern="0" dirty="0">
+              <a:rPr lang="en-US" sz="1400" b="1" kern="0" spc="200" dirty="0">
                 <a:solidFill>
                   <a:srgbClr val="F59E0B"/>
                 </a:solidFill>
@@ -5038,7 +4672,7 @@
               </a:rPr>
               <a:t>FIVE CASES, FIVE SECTORS</a:t>
             </a:r>
-            <a:endParaRPr lang="en-US" sz="1050" dirty="0"/>
+            <a:endParaRPr lang="en-US" sz="1400" dirty="0"/>
           </a:p>
         </p:txBody>
       </p:sp>
@@ -5050,8 +4684,8 @@
         </p:nvSpPr>
         <p:spPr>
           <a:xfrm>
-            <a:off x="987552" y="4919472"/>
-            <a:ext cx="3566160" cy="1133856"/>
+            <a:off x="1013429" y="5040240"/>
+            <a:ext cx="3368789" cy="1231164"/>
           </a:xfrm>
           <a:prstGeom prst="rect">
             <a:avLst/>
@@ -5063,14 +4697,14 @@
           <a:bodyPr wrap="square" rtlCol="0" anchor="t"/>
           <a:lstStyle/>
           <a:p>
-            <a:pPr indent="0" marL="0">
+            <a:pPr marL="0" indent="0">
               <a:lnSpc>
                 <a:spcPct val="103000"/>
               </a:lnSpc>
               <a:buNone/>
             </a:pPr>
             <a:r>
-              <a:rPr lang="en-US" sz="1050" b="1" dirty="0">
+              <a:rPr lang="en-US" sz="1400" b="1" dirty="0">
                 <a:solidFill>
                   <a:srgbClr val="FFFFFF"/>
                 </a:solidFill>
@@ -5080,14 +4714,8 @@
               </a:rPr>
               <a:t>Unitech </a:t>
             </a:r>
-            <a:pPr indent="0" marL="0">
-              <a:lnSpc>
-                <a:spcPct val="103000"/>
-              </a:lnSpc>
-              <a:buNone/>
-            </a:pPr>
-            <a:r>
-              <a:rPr lang="en-US" sz="1050" dirty="0">
+            <a:r>
+              <a:rPr lang="en-US" sz="1400" dirty="0">
                 <a:solidFill>
                   <a:srgbClr val="94A3B8"/>
                 </a:solidFill>
@@ -5097,14 +4725,18 @@
               </a:rPr>
               <a:t>(real estate), </a:t>
             </a:r>
-            <a:pPr indent="0" marL="0">
-              <a:lnSpc>
-                <a:spcPct val="103000"/>
-              </a:lnSpc>
-              <a:buNone/>
-            </a:pPr>
-            <a:r>
-              <a:rPr lang="en-US" sz="1050" b="1" dirty="0">
+            <a:br>
+              <a:rPr lang="en-US" sz="1400" dirty="0">
+                <a:solidFill>
+                  <a:srgbClr val="94A3B8"/>
+                </a:solidFill>
+                <a:latin typeface="Calibri" pitchFamily="34" charset="0"/>
+                <a:ea typeface="Calibri" pitchFamily="34" charset="-122"/>
+                <a:cs typeface="Calibri" pitchFamily="34" charset="-120"/>
+              </a:rPr>
+            </a:br>
+            <a:r>
+              <a:rPr lang="en-US" sz="1400" b="1" dirty="0">
                 <a:solidFill>
                   <a:srgbClr val="FFFFFF"/>
                 </a:solidFill>
@@ -5114,14 +4746,8 @@
               </a:rPr>
               <a:t>Future Retail </a:t>
             </a:r>
-            <a:pPr indent="0" marL="0">
-              <a:lnSpc>
-                <a:spcPct val="103000"/>
-              </a:lnSpc>
-              <a:buNone/>
-            </a:pPr>
-            <a:r>
-              <a:rPr lang="en-US" sz="1050" dirty="0">
+            <a:r>
+              <a:rPr lang="en-US" sz="1400" dirty="0">
                 <a:solidFill>
                   <a:srgbClr val="94A3B8"/>
                 </a:solidFill>
@@ -5131,14 +4757,18 @@
               </a:rPr>
               <a:t>(retail), </a:t>
             </a:r>
-            <a:pPr indent="0" marL="0">
-              <a:lnSpc>
-                <a:spcPct val="103000"/>
-              </a:lnSpc>
-              <a:buNone/>
-            </a:pPr>
-            <a:r>
-              <a:rPr lang="en-US" sz="1050" b="1" dirty="0">
+            <a:br>
+              <a:rPr lang="en-US" sz="1400" dirty="0">
+                <a:solidFill>
+                  <a:srgbClr val="94A3B8"/>
+                </a:solidFill>
+                <a:latin typeface="Calibri" pitchFamily="34" charset="0"/>
+                <a:ea typeface="Calibri" pitchFamily="34" charset="-122"/>
+                <a:cs typeface="Calibri" pitchFamily="34" charset="-120"/>
+              </a:rPr>
+            </a:br>
+            <a:r>
+              <a:rPr lang="en-US" sz="1400" b="1" dirty="0">
                 <a:solidFill>
                   <a:srgbClr val="FFFFFF"/>
                 </a:solidFill>
@@ -5148,14 +4778,8 @@
               </a:rPr>
               <a:t>Reliance Communications </a:t>
             </a:r>
-            <a:pPr indent="0" marL="0">
-              <a:lnSpc>
-                <a:spcPct val="103000"/>
-              </a:lnSpc>
-              <a:buNone/>
-            </a:pPr>
-            <a:r>
-              <a:rPr lang="en-US" sz="1050" dirty="0">
+            <a:r>
+              <a:rPr lang="en-US" sz="1400" dirty="0">
                 <a:solidFill>
                   <a:srgbClr val="94A3B8"/>
                 </a:solidFill>
@@ -5165,14 +4789,18 @@
               </a:rPr>
               <a:t>(telecom), </a:t>
             </a:r>
-            <a:pPr indent="0" marL="0">
-              <a:lnSpc>
-                <a:spcPct val="103000"/>
-              </a:lnSpc>
-              <a:buNone/>
-            </a:pPr>
-            <a:r>
-              <a:rPr lang="en-US" sz="1050" b="1" dirty="0">
+            <a:br>
+              <a:rPr lang="en-US" sz="1400" dirty="0">
+                <a:solidFill>
+                  <a:srgbClr val="94A3B8"/>
+                </a:solidFill>
+                <a:latin typeface="Calibri" pitchFamily="34" charset="0"/>
+                <a:ea typeface="Calibri" pitchFamily="34" charset="-122"/>
+                <a:cs typeface="Calibri" pitchFamily="34" charset="-120"/>
+              </a:rPr>
+            </a:br>
+            <a:r>
+              <a:rPr lang="en-US" sz="1400" b="1" dirty="0">
                 <a:solidFill>
                   <a:srgbClr val="FFFFFF"/>
                 </a:solidFill>
@@ -5182,14 +4810,8 @@
               </a:rPr>
               <a:t>Jaiprakash Associates </a:t>
             </a:r>
-            <a:pPr indent="0" marL="0">
-              <a:lnSpc>
-                <a:spcPct val="103000"/>
-              </a:lnSpc>
-              <a:buNone/>
-            </a:pPr>
-            <a:r>
-              <a:rPr lang="en-US" sz="1050" dirty="0">
+            <a:r>
+              <a:rPr lang="en-US" sz="1400" dirty="0">
                 <a:solidFill>
                   <a:srgbClr val="94A3B8"/>
                 </a:solidFill>
@@ -5199,14 +4821,18 @@
               </a:rPr>
               <a:t>(infrastructure), </a:t>
             </a:r>
-            <a:pPr indent="0" marL="0">
-              <a:lnSpc>
-                <a:spcPct val="103000"/>
-              </a:lnSpc>
-              <a:buNone/>
-            </a:pPr>
-            <a:r>
-              <a:rPr lang="en-US" sz="1050" b="1" dirty="0">
+            <a:br>
+              <a:rPr lang="en-US" sz="1400" dirty="0">
+                <a:solidFill>
+                  <a:srgbClr val="94A3B8"/>
+                </a:solidFill>
+                <a:latin typeface="Calibri" pitchFamily="34" charset="0"/>
+                <a:ea typeface="Calibri" pitchFamily="34" charset="-122"/>
+                <a:cs typeface="Calibri" pitchFamily="34" charset="-120"/>
+              </a:rPr>
+            </a:br>
+            <a:r>
+              <a:rPr lang="en-US" sz="1400" b="1" dirty="0">
                 <a:solidFill>
                   <a:srgbClr val="FFFFFF"/>
                 </a:solidFill>
@@ -5216,14 +4842,8 @@
               </a:rPr>
               <a:t>Suzlon </a:t>
             </a:r>
-            <a:pPr indent="0" marL="0">
-              <a:lnSpc>
-                <a:spcPct val="103000"/>
-              </a:lnSpc>
-              <a:buNone/>
-            </a:pPr>
-            <a:r>
-              <a:rPr lang="en-US" sz="1050" dirty="0">
+            <a:r>
+              <a:rPr lang="en-US" sz="1400" dirty="0">
                 <a:solidFill>
                   <a:srgbClr val="94A3B8"/>
                 </a:solidFill>
@@ -5231,9 +4851,30 @@
                 <a:ea typeface="Calibri" pitchFamily="34" charset="-122"/>
                 <a:cs typeface="Calibri" pitchFamily="34" charset="-120"/>
               </a:rPr>
-              <a:t>(renewables - a recovery). Real financials, real events.</a:t>
-            </a:r>
-            <a:endParaRPr lang="en-US" sz="1050" dirty="0"/>
+              <a:t>(renewables - a recovery). </a:t>
+            </a:r>
+            <a:br>
+              <a:rPr lang="en-US" sz="1400" dirty="0">
+                <a:solidFill>
+                  <a:srgbClr val="94A3B8"/>
+                </a:solidFill>
+                <a:latin typeface="Calibri" pitchFamily="34" charset="0"/>
+                <a:ea typeface="Calibri" pitchFamily="34" charset="-122"/>
+                <a:cs typeface="Calibri" pitchFamily="34" charset="-120"/>
+              </a:rPr>
+            </a:br>
+            <a:r>
+              <a:rPr lang="en-US" sz="1400" dirty="0">
+                <a:solidFill>
+                  <a:srgbClr val="94A3B8"/>
+                </a:solidFill>
+                <a:latin typeface="Calibri" pitchFamily="34" charset="0"/>
+                <a:ea typeface="Calibri" pitchFamily="34" charset="-122"/>
+                <a:cs typeface="Calibri" pitchFamily="34" charset="-120"/>
+              </a:rPr>
+              <a:t>Real financials, real events.</a:t>
+            </a:r>
+            <a:endParaRPr lang="en-US" sz="1400" dirty="0"/>
           </a:p>
         </p:txBody>
       </p:sp>
@@ -5258,7 +4899,7 @@
           <a:bodyPr wrap="square" rtlCol="0" anchor="ctr"/>
           <a:lstStyle/>
           <a:p>
-            <a:pPr indent="0" marL="0">
+            <a:pPr marL="0" indent="0">
               <a:buNone/>
             </a:pPr>
             <a:r>
@@ -5278,7 +4919,7 @@
       </p:sp>
       <p:graphicFrame>
         <p:nvGraphicFramePr>
-          <p:cNvPr id="11" name="Chart 0" descr=""/>
+          <p:cNvPr id="11" name="Chart 0"/>
           <p:cNvGraphicFramePr/>
           <p:nvPr/>
         </p:nvGraphicFramePr>
@@ -5286,9 +4927,9 @@
           <a:off x="5349240" y="2194560"/>
           <a:ext cx="6263640" cy="3611880"/>
         </p:xfrm>
-        <a:graphic xmlns:a="http://schemas.openxmlformats.org/drawingml/2006/main">
+        <a:graphic>
           <a:graphicData uri="http://schemas.openxmlformats.org/drawingml/2006/chart">
-            <c:chart xmlns:c="http://schemas.openxmlformats.org/drawingml/2006/chart" r:id="rId1"/>
+            <c:chart xmlns:c="http://schemas.openxmlformats.org/drawingml/2006/chart" xmlns:r="http://schemas.openxmlformats.org/officeDocument/2006/relationships" r:id="rId3"/>
           </a:graphicData>
         </a:graphic>
       </p:graphicFrame>
@@ -5313,7 +4954,7 @@
           <a:bodyPr wrap="square" rtlCol="0" anchor="ctr"/>
           <a:lstStyle/>
           <a:p>
-            <a:pPr indent="0" marL="0">
+            <a:pPr marL="0" indent="0">
               <a:buNone/>
             </a:pPr>
             <a:r>
@@ -5347,6 +4988,7 @@
         <a:solidFill>
           <a:srgbClr val="0A1628"/>
         </a:solidFill>
+        <a:effectLst/>
       </p:bgPr>
     </p:bg>
     <p:spTree>
@@ -5384,7 +5026,7 @@
           <a:bodyPr wrap="square" rtlCol="0" anchor="ctr"/>
           <a:lstStyle/>
           <a:p>
-            <a:pPr indent="0" marL="0">
+            <a:pPr marL="0" indent="0">
               <a:buNone/>
             </a:pPr>
             <a:r>
@@ -5398,9 +5040,6 @@
               </a:rPr>
               <a:t>A live risk analyst for </a:t>
             </a:r>
-            <a:pPr indent="0" marL="0">
-              <a:buNone/>
-            </a:pPr>
             <a:r>
               <a:rPr lang="en-US" sz="3300" b="1" dirty="0">
                 <a:solidFill>
@@ -5437,7 +5076,7 @@
           <a:bodyPr wrap="square" rtlCol="0" anchor="ctr"/>
           <a:lstStyle/>
           <a:p>
-            <a:pPr indent="0" marL="0">
+            <a:pPr marL="0" indent="0">
               <a:buNone/>
             </a:pPr>
             <a:r>
@@ -5504,14 +5143,14 @@
       </p:sp>
       <p:pic>
         <p:nvPicPr>
-          <p:cNvPr id="6" name="Image 0" descr="preencoded.png">    </p:cNvPr>
+          <p:cNvPr id="6" name="Image 0" descr="preencoded.png"/>
           <p:cNvPicPr>
             <a:picLocks noChangeAspect="1"/>
           </p:cNvPicPr>
           <p:nvPr/>
         </p:nvPicPr>
         <p:blipFill>
-          <a:blip r:embed="rId1"/>
+          <a:blip r:embed="rId3"/>
           <a:stretch>
             <a:fillRect/>
           </a:stretch>
@@ -5547,7 +5186,7 @@
           <a:bodyPr wrap="square" rtlCol="0" anchor="ctr"/>
           <a:lstStyle/>
           <a:p>
-            <a:pPr indent="0" marL="0">
+            <a:pPr marL="0" indent="0">
               <a:buNone/>
             </a:pPr>
             <a:r>
@@ -5586,7 +5225,7 @@
           <a:bodyPr wrap="square" rtlCol="0" anchor="ctr"/>
           <a:lstStyle/>
           <a:p>
-            <a:pPr indent="0" marL="0">
+            <a:pPr marL="0" indent="0">
               <a:lnSpc>
                 <a:spcPct val="106000"/>
               </a:lnSpc>
@@ -5656,14 +5295,14 @@
       </p:sp>
       <p:pic>
         <p:nvPicPr>
-          <p:cNvPr id="11" name="Image 1" descr="preencoded.png">    </p:cNvPr>
+          <p:cNvPr id="11" name="Image 1" descr="preencoded.png"/>
           <p:cNvPicPr>
             <a:picLocks noChangeAspect="1"/>
           </p:cNvPicPr>
           <p:nvPr/>
         </p:nvPicPr>
         <p:blipFill>
-          <a:blip r:embed="rId2"/>
+          <a:blip r:embed="rId4"/>
           <a:stretch>
             <a:fillRect/>
           </a:stretch>
@@ -5699,7 +5338,7 @@
           <a:bodyPr wrap="square" rtlCol="0" anchor="ctr"/>
           <a:lstStyle/>
           <a:p>
-            <a:pPr indent="0" marL="0">
+            <a:pPr marL="0" indent="0">
               <a:buNone/>
             </a:pPr>
             <a:r>
@@ -5726,7 +5365,7 @@
         <p:spPr>
           <a:xfrm>
             <a:off x="3758184" y="3429000"/>
-            <a:ext cx="2139696" cy="822960"/>
+            <a:ext cx="2219922" cy="822960"/>
           </a:xfrm>
           <a:prstGeom prst="rect">
             <a:avLst/>
@@ -5738,7 +5377,7 @@
           <a:bodyPr wrap="square" rtlCol="0" anchor="ctr"/>
           <a:lstStyle/>
           <a:p>
-            <a:pPr indent="0" marL="0">
+            <a:pPr marL="0" indent="0">
               <a:lnSpc>
                 <a:spcPct val="106000"/>
               </a:lnSpc>
@@ -5753,7 +5392,7 @@
                 <a:ea typeface="Calibri" pitchFamily="34" charset="-122"/>
                 <a:cs typeface="Calibri" pitchFamily="34" charset="-120"/>
               </a:rPr>
-              <a:t>Any listed company, on demand. No manual pull, no waiting on filings.</a:t>
+              <a:t>Any listed company, on demand. No manual searching for every information.</a:t>
             </a:r>
             <a:endParaRPr lang="en-US" sz="1250" dirty="0"/>
           </a:p>
@@ -5808,14 +5447,14 @@
       </p:sp>
       <p:pic>
         <p:nvPicPr>
-          <p:cNvPr id="16" name="Image 2" descr="preencoded.png">    </p:cNvPr>
+          <p:cNvPr id="16" name="Image 2" descr="preencoded.png"/>
           <p:cNvPicPr>
             <a:picLocks noChangeAspect="1"/>
           </p:cNvPicPr>
           <p:nvPr/>
         </p:nvPicPr>
         <p:blipFill>
-          <a:blip r:embed="rId3"/>
+          <a:blip r:embed="rId5"/>
           <a:stretch>
             <a:fillRect/>
           </a:stretch>
@@ -5851,7 +5490,7 @@
           <a:bodyPr wrap="square" rtlCol="0" anchor="ctr"/>
           <a:lstStyle/>
           <a:p>
-            <a:pPr indent="0" marL="0">
+            <a:pPr marL="0" indent="0">
               <a:buNone/>
             </a:pPr>
             <a:r>
@@ -5890,7 +5529,7 @@
           <a:bodyPr wrap="square" rtlCol="0" anchor="ctr"/>
           <a:lstStyle/>
           <a:p>
-            <a:pPr indent="0" marL="0">
+            <a:pPr marL="0" indent="0">
               <a:lnSpc>
                 <a:spcPct val="106000"/>
               </a:lnSpc>
@@ -5960,14 +5599,14 @@
       </p:sp>
       <p:pic>
         <p:nvPicPr>
-          <p:cNvPr id="21" name="Image 3" descr="preencoded.png">    </p:cNvPr>
+          <p:cNvPr id="21" name="Image 3" descr="preencoded.png"/>
           <p:cNvPicPr>
             <a:picLocks noChangeAspect="1"/>
           </p:cNvPicPr>
           <p:nvPr/>
         </p:nvPicPr>
         <p:blipFill>
-          <a:blip r:embed="rId4"/>
+          <a:blip r:embed="rId6"/>
           <a:stretch>
             <a:fillRect/>
           </a:stretch>
@@ -6003,7 +5642,7 @@
           <a:bodyPr wrap="square" rtlCol="0" anchor="ctr"/>
           <a:lstStyle/>
           <a:p>
-            <a:pPr indent="0" marL="0">
+            <a:pPr marL="0" indent="0">
               <a:buNone/>
             </a:pPr>
             <a:r>
@@ -6042,7 +5681,7 @@
           <a:bodyPr wrap="square" rtlCol="0" anchor="ctr"/>
           <a:lstStyle/>
           <a:p>
-            <a:pPr indent="0" marL="0">
+            <a:pPr marL="0" indent="0">
               <a:lnSpc>
                 <a:spcPct val="106000"/>
               </a:lnSpc>
@@ -6066,7 +5705,7 @@
       <p:sp>
         <p:nvSpPr>
           <p:cNvPr id="24" name="Shape 18">
-            <a:hlinkClick r:id="rId5" tooltip="Open the live Foresight AI dashboard"/>
+            <a:hlinkClick r:id="rId7" tooltip="Open the live Foresight AI dashboard"/>
           </p:cNvPr>
           <p:cNvSpPr/>
           <p:nvPr/>
@@ -6090,7 +5729,7 @@
       <p:sp>
         <p:nvSpPr>
           <p:cNvPr id="25" name="Text 19">
-            <a:hlinkClick r:id="rId5" tooltip="Open the live Foresight AI dashboard"/>
+            <a:hlinkClick r:id="rId7" tooltip="Open the live Foresight AI dashboard"/>
           </p:cNvPr>
           <p:cNvSpPr/>
           <p:nvPr/>
@@ -6110,7 +5749,7 @@
           <a:bodyPr wrap="square" rtlCol="0" anchor="ctr"/>
           <a:lstStyle/>
           <a:p>
-            <a:pPr algn="ctr" indent="0" marL="0">
+            <a:pPr marL="0" indent="0" algn="ctr">
               <a:buNone/>
             </a:pPr>
             <a:r>
@@ -6121,7 +5760,7 @@
                 <a:latin typeface="Calibri" pitchFamily="34" charset="0"/>
                 <a:ea typeface="Calibri" pitchFamily="34" charset="-122"/>
                 <a:cs typeface="Calibri" pitchFamily="34" charset="-120"/>
-                <a:hlinkClick r:id="rId5" invalidUrl="" action="" tgtFrame="" tooltip="Open the live Foresight AI dashboard" history="1" highlightClick="0" endSnd="0">
+                <a:hlinkClick r:id="rId7" tooltip="Open the live Foresight AI dashboard">
                   <a:extLst>
                     <a:ext uri="{A12FA001-AC4F-418D-AE19-62706E023703}">
                       <ahyp:hlinkClr xmlns:ahyp="http://schemas.microsoft.com/office/drawing/2018/hyperlinkcolor" val="tx"/>
@@ -6129,11 +5768,8 @@
                   </a:extLst>
                 </a:hlinkClick>
               </a:rPr>
-              <a:t>Open the live dashboard   </a:t>
-            </a:r>
-            <a:pPr algn="ctr" indent="0" marL="0">
-              <a:buNone/>
-            </a:pPr>
+              <a:t>Open the live dashboard: </a:t>
+            </a:r>
             <a:r>
               <a:rPr lang="en-US" sz="1900" b="1" u="sng" dirty="0">
                 <a:solidFill>
@@ -6142,7 +5778,7 @@
                 <a:latin typeface="Calibri" pitchFamily="34" charset="0"/>
                 <a:ea typeface="Calibri" pitchFamily="34" charset="-122"/>
                 <a:cs typeface="Calibri" pitchFamily="34" charset="-120"/>
-                <a:hlinkClick r:id="rId5" invalidUrl="" action="" tgtFrame="" tooltip="Open the live Foresight AI dashboard" history="1" highlightClick="0" endSnd="0">
+                <a:hlinkClick r:id="rId7" tooltip="Open the live Foresight AI dashboard">
                   <a:extLst>
                     <a:ext uri="{A12FA001-AC4F-418D-AE19-62706E023703}">
                       <ahyp:hlinkClr xmlns:ahyp="http://schemas.microsoft.com/office/drawing/2018/hyperlinkcolor" val="tx"/>
@@ -6164,7 +5800,7 @@
         </p:nvSpPr>
         <p:spPr>
           <a:xfrm>
-            <a:off x="822960" y="6053328"/>
+            <a:off x="2505104" y="6217226"/>
             <a:ext cx="7315200" cy="320040"/>
           </a:xfrm>
           <a:prstGeom prst="rect">
@@ -6177,7 +5813,7 @@
           <a:bodyPr wrap="square" rtlCol="0" anchor="ctr"/>
           <a:lstStyle/>
           <a:p>
-            <a:pPr indent="0" marL="0">
+            <a:pPr marL="0" indent="0" algn="ctr">
               <a:buNone/>
             </a:pPr>
             <a:r>
@@ -6191,9 +5827,6 @@
               </a:rPr>
               <a:t>Source &amp; notebooks:  </a:t>
             </a:r>
-            <a:pPr indent="0" marL="0">
-              <a:buNone/>
-            </a:pPr>
             <a:r>
               <a:rPr lang="en-US" sz="1300" b="1" u="sng" dirty="0">
                 <a:solidFill>
@@ -6202,7 +5835,7 @@
                 <a:latin typeface="Calibri" pitchFamily="34" charset="0"/>
                 <a:ea typeface="Calibri" pitchFamily="34" charset="-122"/>
                 <a:cs typeface="Calibri" pitchFamily="34" charset="-120"/>
-                <a:hlinkClick r:id="rId6" invalidUrl="" action="" tgtFrame="" tooltip="View the code on GitHub" history="1" highlightClick="0" endSnd="0">
+                <a:hlinkClick r:id="rId8" tooltip="View the code on GitHub">
                   <a:extLst>
                     <a:ext uri="{A12FA001-AC4F-418D-AE19-62706E023703}">
                       <ahyp:hlinkClr xmlns:ahyp="http://schemas.microsoft.com/office/drawing/2018/hyperlinkcolor" val="tx"/>
@@ -6264,11 +5897,11 @@
           <a:bodyPr wrap="square" rtlCol="0" anchor="ctr"/>
           <a:lstStyle/>
           <a:p>
-            <a:pPr indent="0" marL="0">
+            <a:pPr marL="0" indent="0">
               <a:buNone/>
             </a:pPr>
             <a:r>
-              <a:rPr lang="en-US" sz="1050" b="1" spc="200" kern="0" dirty="0">
+              <a:rPr lang="en-US" sz="1050" b="1" kern="0" spc="200" dirty="0">
                 <a:solidFill>
                   <a:srgbClr val="F59E0B"/>
                 </a:solidFill>
@@ -6303,7 +5936,7 @@
           <a:bodyPr wrap="square" rtlCol="0" anchor="ctr"/>
           <a:lstStyle/>
           <a:p>
-            <a:pPr indent="0" marL="0">
+            <a:pPr marL="0" indent="0">
               <a:buNone/>
             </a:pPr>
             <a:r>
@@ -6386,7 +6019,7 @@
           <a:bodyPr wrap="square" rtlCol="0" anchor="ctr"/>
           <a:lstStyle/>
           <a:p>
-            <a:pPr indent="0" marL="0">
+            <a:pPr marL="0" indent="0">
               <a:buNone/>
             </a:pPr>
             <a:r>
@@ -6450,7 +6083,7 @@
       </p:sp>
       <p:graphicFrame>
         <p:nvGraphicFramePr>
-          <p:cNvPr id="35" name="Chart 0" descr=""/>
+          <p:cNvPr id="35" name="Chart 0"/>
           <p:cNvGraphicFramePr/>
           <p:nvPr/>
         </p:nvGraphicFramePr>
@@ -6458,9 +6091,9 @@
           <a:off x="10561320" y="5120640"/>
           <a:ext cx="731520" cy="731520"/>
         </p:xfrm>
-        <a:graphic xmlns:a="http://schemas.openxmlformats.org/drawingml/2006/main">
+        <a:graphic>
           <a:graphicData uri="http://schemas.openxmlformats.org/drawingml/2006/chart">
-            <c:chart xmlns:c="http://schemas.openxmlformats.org/drawingml/2006/chart" r:id="rId7"/>
+            <c:chart xmlns:c="http://schemas.openxmlformats.org/drawingml/2006/chart" xmlns:r="http://schemas.openxmlformats.org/officeDocument/2006/relationships" r:id="rId9"/>
           </a:graphicData>
         </a:graphic>
       </p:graphicFrame>
@@ -6485,7 +6118,7 @@
           <a:bodyPr wrap="square" rtlCol="0" anchor="ctr"/>
           <a:lstStyle/>
           <a:p>
-            <a:pPr algn="ctr" indent="0" marL="0">
+            <a:pPr marL="0" indent="0" algn="ctr">
               <a:buNone/>
             </a:pPr>
             <a:r>
@@ -6804,4 +6437,319 @@
     </a:ext>
   </a:extLst>
 </a:theme>
+</file>
+
+<file path=ppt/theme/theme2.xml><?xml version="1.0" encoding="utf-8"?>
+<a:theme xmlns:a="http://schemas.openxmlformats.org/drawingml/2006/main" name="Office Theme">
+  <a:themeElements>
+    <a:clrScheme name="Office">
+      <a:dk1>
+        <a:sysClr val="windowText" lastClr="000000"/>
+      </a:dk1>
+      <a:lt1>
+        <a:sysClr val="window" lastClr="FFFFFF"/>
+      </a:lt1>
+      <a:dk2>
+        <a:srgbClr val="0E2841"/>
+      </a:dk2>
+      <a:lt2>
+        <a:srgbClr val="E8E8E8"/>
+      </a:lt2>
+      <a:accent1>
+        <a:srgbClr val="156082"/>
+      </a:accent1>
+      <a:accent2>
+        <a:srgbClr val="E97132"/>
+      </a:accent2>
+      <a:accent3>
+        <a:srgbClr val="196B24"/>
+      </a:accent3>
+      <a:accent4>
+        <a:srgbClr val="0F9ED5"/>
+      </a:accent4>
+      <a:accent5>
+        <a:srgbClr val="A02B93"/>
+      </a:accent5>
+      <a:accent6>
+        <a:srgbClr val="4EA72E"/>
+      </a:accent6>
+      <a:hlink>
+        <a:srgbClr val="467886"/>
+      </a:hlink>
+      <a:folHlink>
+        <a:srgbClr val="96607D"/>
+      </a:folHlink>
+    </a:clrScheme>
+    <a:fontScheme name="Office">
+      <a:majorFont>
+        <a:latin typeface="Aptos Display" panose="02110004020202020204"/>
+        <a:ea typeface=""/>
+        <a:cs typeface=""/>
+        <a:font script="Jpan" typeface="游ゴシック Light"/>
+        <a:font script="Hang" typeface="맑은 고딕"/>
+        <a:font script="Hans" typeface="等线 Light"/>
+        <a:font script="Hant" typeface="新細明體"/>
+        <a:font script="Arab" typeface="Times New Roman"/>
+        <a:font script="Hebr" typeface="Times New Roman"/>
+        <a:font script="Thai" typeface="Angsana New"/>
+        <a:font script="Ethi" typeface="Nyala"/>
+        <a:font script="Beng" typeface="Vrinda"/>
+        <a:font script="Gujr" typeface="Shruti"/>
+        <a:font script="Khmr" typeface="MoolBoran"/>
+        <a:font script="Knda" typeface="Tunga"/>
+        <a:font script="Guru" typeface="Raavi"/>
+        <a:font script="Cans" typeface="Euphemia"/>
+        <a:font script="Cher" typeface="Plantagenet Cherokee"/>
+        <a:font script="Yiii" typeface="Microsoft Yi Baiti"/>
+        <a:font script="Tibt" typeface="Microsoft Himalaya"/>
+        <a:font script="Thaa" typeface="MV Boli"/>
+        <a:font script="Deva" typeface="Mangal"/>
+        <a:font script="Telu" typeface="Gautami"/>
+        <a:font script="Taml" typeface="Latha"/>
+        <a:font script="Syrc" typeface="Estrangelo Edessa"/>
+        <a:font script="Orya" typeface="Kalinga"/>
+        <a:font script="Mlym" typeface="Kartika"/>
+        <a:font script="Laoo" typeface="DokChampa"/>
+        <a:font script="Sinh" typeface="Iskoola Pota"/>
+        <a:font script="Mong" typeface="Mongolian Baiti"/>
+        <a:font script="Viet" typeface="Times New Roman"/>
+        <a:font script="Uigh" typeface="Microsoft Uighur"/>
+        <a:font script="Geor" typeface="Sylfaen"/>
+        <a:font script="Armn" typeface="Arial"/>
+        <a:font script="Bugi" typeface="Leelawadee UI"/>
+        <a:font script="Bopo" typeface="Microsoft JhengHei"/>
+        <a:font script="Java" typeface="Javanese Text"/>
+        <a:font script="Lisu" typeface="Segoe UI"/>
+        <a:font script="Mymr" typeface="Myanmar Text"/>
+        <a:font script="Nkoo" typeface="Ebrima"/>
+        <a:font script="Olck" typeface="Nirmala UI"/>
+        <a:font script="Osma" typeface="Ebrima"/>
+        <a:font script="Phag" typeface="Phagspa"/>
+        <a:font script="Syrn" typeface="Estrangelo Edessa"/>
+        <a:font script="Syrj" typeface="Estrangelo Edessa"/>
+        <a:font script="Syre" typeface="Estrangelo Edessa"/>
+        <a:font script="Sora" typeface="Nirmala UI"/>
+        <a:font script="Tale" typeface="Microsoft Tai Le"/>
+        <a:font script="Talu" typeface="Microsoft New Tai Lue"/>
+        <a:font script="Tfng" typeface="Ebrima"/>
+      </a:majorFont>
+      <a:minorFont>
+        <a:latin typeface="Aptos" panose="02110004020202020204"/>
+        <a:ea typeface=""/>
+        <a:cs typeface=""/>
+        <a:font script="Jpan" typeface="游ゴシック"/>
+        <a:font script="Hang" typeface="맑은 고딕"/>
+        <a:font script="Hans" typeface="等线"/>
+        <a:font script="Hant" typeface="新細明體"/>
+        <a:font script="Arab" typeface="Arial"/>
+        <a:font script="Hebr" typeface="Arial"/>
+        <a:font script="Thai" typeface="Cordia New"/>
+        <a:font script="Ethi" typeface="Nyala"/>
+        <a:font script="Beng" typeface="Vrinda"/>
+        <a:font script="Gujr" typeface="Shruti"/>
+        <a:font script="Khmr" typeface="DaunPenh"/>
+        <a:font script="Knda" typeface="Tunga"/>
+        <a:font script="Guru" typeface="Raavi"/>
+        <a:font script="Cans" typeface="Euphemia"/>
+        <a:font script="Cher" typeface="Plantagenet Cherokee"/>
+        <a:font script="Yiii" typeface="Microsoft Yi Baiti"/>
+        <a:font script="Tibt" typeface="Microsoft Himalaya"/>
+        <a:font script="Thaa" typeface="MV Boli"/>
+        <a:font script="Deva" typeface="Mangal"/>
+        <a:font script="Telu" typeface="Gautami"/>
+        <a:font script="Taml" typeface="Latha"/>
+        <a:font script="Syrc" typeface="Estrangelo Edessa"/>
+        <a:font script="Orya" typeface="Kalinga"/>
+        <a:font script="Mlym" typeface="Kartika"/>
+        <a:font script="Laoo" typeface="DokChampa"/>
+        <a:font script="Sinh" typeface="Iskoola Pota"/>
+        <a:font script="Mong" typeface="Mongolian Baiti"/>
+        <a:font script="Viet" typeface="Arial"/>
+        <a:font script="Uigh" typeface="Microsoft Uighur"/>
+        <a:font script="Geor" typeface="Sylfaen"/>
+        <a:font script="Armn" typeface="Arial"/>
+        <a:font script="Bugi" typeface="Leelawadee UI"/>
+        <a:font script="Bopo" typeface="Microsoft JhengHei"/>
+        <a:font script="Java" typeface="Javanese Text"/>
+        <a:font script="Lisu" typeface="Segoe UI"/>
+        <a:font script="Mymr" typeface="Myanmar Text"/>
+        <a:font script="Nkoo" typeface="Ebrima"/>
+        <a:font script="Olck" typeface="Nirmala UI"/>
+        <a:font script="Osma" typeface="Ebrima"/>
+        <a:font script="Phag" typeface="Phagspa"/>
+        <a:font script="Syrn" typeface="Estrangelo Edessa"/>
+        <a:font script="Syrj" typeface="Estrangelo Edessa"/>
+        <a:font script="Syre" typeface="Estrangelo Edessa"/>
+        <a:font script="Sora" typeface="Nirmala UI"/>
+        <a:font script="Tale" typeface="Microsoft Tai Le"/>
+        <a:font script="Talu" typeface="Microsoft New Tai Lue"/>
+        <a:font script="Tfng" typeface="Ebrima"/>
+      </a:minorFont>
+    </a:fontScheme>
+    <a:fmtScheme name="Office">
+      <a:fillStyleLst>
+        <a:solidFill>
+          <a:schemeClr val="phClr"/>
+        </a:solidFill>
+        <a:gradFill rotWithShape="1">
+          <a:gsLst>
+            <a:gs pos="0">
+              <a:schemeClr val="phClr">
+                <a:lumMod val="110000"/>
+                <a:satMod val="105000"/>
+                <a:tint val="67000"/>
+              </a:schemeClr>
+            </a:gs>
+            <a:gs pos="50000">
+              <a:schemeClr val="phClr">
+                <a:lumMod val="105000"/>
+                <a:satMod val="103000"/>
+                <a:tint val="73000"/>
+              </a:schemeClr>
+            </a:gs>
+            <a:gs pos="100000">
+              <a:schemeClr val="phClr">
+                <a:lumMod val="105000"/>
+                <a:satMod val="109000"/>
+                <a:tint val="81000"/>
+              </a:schemeClr>
+            </a:gs>
+          </a:gsLst>
+          <a:lin ang="5400000" scaled="0"/>
+        </a:gradFill>
+        <a:gradFill rotWithShape="1">
+          <a:gsLst>
+            <a:gs pos="0">
+              <a:schemeClr val="phClr">
+                <a:satMod val="103000"/>
+                <a:lumMod val="102000"/>
+                <a:tint val="94000"/>
+              </a:schemeClr>
+            </a:gs>
+            <a:gs pos="50000">
+              <a:schemeClr val="phClr">
+                <a:satMod val="110000"/>
+                <a:lumMod val="100000"/>
+                <a:shade val="100000"/>
+              </a:schemeClr>
+            </a:gs>
+            <a:gs pos="100000">
+              <a:schemeClr val="phClr">
+                <a:lumMod val="99000"/>
+                <a:satMod val="120000"/>
+                <a:shade val="78000"/>
+              </a:schemeClr>
+            </a:gs>
+          </a:gsLst>
+          <a:lin ang="5400000" scaled="0"/>
+        </a:gradFill>
+      </a:fillStyleLst>
+      <a:lnStyleLst>
+        <a:ln w="12700" cap="flat" cmpd="sng" algn="ctr">
+          <a:solidFill>
+            <a:schemeClr val="phClr"/>
+          </a:solidFill>
+          <a:prstDash val="solid"/>
+          <a:miter lim="800000"/>
+        </a:ln>
+        <a:ln w="19050" cap="flat" cmpd="sng" algn="ctr">
+          <a:solidFill>
+            <a:schemeClr val="phClr"/>
+          </a:solidFill>
+          <a:prstDash val="solid"/>
+          <a:miter lim="800000"/>
+        </a:ln>
+        <a:ln w="25400" cap="flat" cmpd="sng" algn="ctr">
+          <a:solidFill>
+            <a:schemeClr val="phClr"/>
+          </a:solidFill>
+          <a:prstDash val="solid"/>
+          <a:miter lim="800000"/>
+        </a:ln>
+      </a:lnStyleLst>
+      <a:effectStyleLst>
+        <a:effectStyle>
+          <a:effectLst/>
+        </a:effectStyle>
+        <a:effectStyle>
+          <a:effectLst/>
+        </a:effectStyle>
+        <a:effectStyle>
+          <a:effectLst>
+            <a:outerShdw blurRad="57150" dist="19050" dir="5400000" algn="ctr" rotWithShape="0">
+              <a:srgbClr val="000000">
+                <a:alpha val="63000"/>
+              </a:srgbClr>
+            </a:outerShdw>
+          </a:effectLst>
+        </a:effectStyle>
+      </a:effectStyleLst>
+      <a:bgFillStyleLst>
+        <a:solidFill>
+          <a:schemeClr val="phClr"/>
+        </a:solidFill>
+        <a:solidFill>
+          <a:schemeClr val="phClr">
+            <a:tint val="95000"/>
+            <a:satMod val="170000"/>
+          </a:schemeClr>
+        </a:solidFill>
+        <a:gradFill rotWithShape="1">
+          <a:gsLst>
+            <a:gs pos="0">
+              <a:schemeClr val="phClr">
+                <a:tint val="93000"/>
+                <a:satMod val="150000"/>
+                <a:shade val="98000"/>
+                <a:lumMod val="102000"/>
+              </a:schemeClr>
+            </a:gs>
+            <a:gs pos="50000">
+              <a:schemeClr val="phClr">
+                <a:tint val="98000"/>
+                <a:satMod val="130000"/>
+                <a:shade val="90000"/>
+                <a:lumMod val="103000"/>
+              </a:schemeClr>
+            </a:gs>
+            <a:gs pos="100000">
+              <a:schemeClr val="phClr">
+                <a:shade val="63000"/>
+                <a:satMod val="120000"/>
+              </a:schemeClr>
+            </a:gs>
+          </a:gsLst>
+          <a:lin ang="5400000" scaled="0"/>
+        </a:gradFill>
+      </a:bgFillStyleLst>
+    </a:fmtScheme>
+  </a:themeElements>
+  <a:objectDefaults>
+    <a:lnDef>
+      <a:spPr/>
+      <a:bodyPr/>
+      <a:lstStyle/>
+      <a:style>
+        <a:lnRef idx="2">
+          <a:schemeClr val="accent1"/>
+        </a:lnRef>
+        <a:fillRef idx="0">
+          <a:schemeClr val="accent1"/>
+        </a:fillRef>
+        <a:effectRef idx="1">
+          <a:schemeClr val="accent1"/>
+        </a:effectRef>
+        <a:fontRef idx="minor">
+          <a:schemeClr val="tx1"/>
+        </a:fontRef>
+      </a:style>
+    </a:lnDef>
+  </a:objectDefaults>
+  <a:extraClrSchemeLst/>
+  <a:extLst>
+    <a:ext uri="{05A4C25C-085E-4340-85A3-A5531E510DB2}">
+      <thm15:themeFamily xmlns:thm15="http://schemas.microsoft.com/office/thememl/2012/main" name="Office Theme" id="{2E142A2C-CD16-42D6-873A-C26D2A0506FA}" vid="{1BDDFF52-6CD6-40A5-AB3C-68EB2F1E4D0A}"/>
+    </a:ext>
+  </a:extLst>
+</a:theme>
 </file>
</xml_diff>

<commit_message>
Lead with measured findings; honest provenance; 6-slide deck
- Add notebooks/04_findings.ipynb: reproducible discrimination, lead-time,
  hard-event-floor and weight-robustness results
- Rewrite REPORT Key Findings around the measured numbers
- Auditor exit now floors the leadership reading (hard-event floor binds)
- Reword NCLT-labelled -> insolvency-labelled; fix the UCI download note
- Add requirements-notebooks.txt; add a quantified Key Findings deck slide
</commit_message>
<xml_diff>
--- a/deck/ForesightAI.pptx
+++ b/deck/ForesightAI.pptx
@@ -4,18 +4,19 @@
   <p:sldMasterIdLst>
     <p:sldMasterId id="2147483648" r:id="rId1"/>
   </p:sldMasterIdLst>
-  <p:notesMasterIdLst>
-    <p:notesMasterId r:id="rId7"/>
-  </p:notesMasterIdLst>
   <p:sldIdLst>
     <p:sldId id="256" r:id="rId2"/>
     <p:sldId id="257" r:id="rId3"/>
     <p:sldId id="258" r:id="rId4"/>
     <p:sldId id="259" r:id="rId5"/>
     <p:sldId id="260" r:id="rId6"/>
+    <p:sldId id="261" r:id="rId7"/>
   </p:sldIdLst>
-  <p:sldSz cx="12192000" cy="6858000"/>
-  <p:notesSz cx="6858000" cy="12192000"/>
+  <p:notesMasterIdLst>
+    <p:notesMasterId r:id="rId8"/>
+  </p:notesMasterIdLst>
+  <p:sldSz cx="12191695" cy="6858000"/>
+  <p:notesSz cx="6858000" cy="12191695"/>
   <p:defaultTextStyle>
     <a:lvl1pPr marL="0" algn="l" defTabSz="914400" rtl="0" eaLnBrk="1" latinLnBrk="0" hangingPunct="1">
       <a:defRPr sz="1800" kern="1200">
@@ -108,20 +109,13 @@
       </a:defRPr>
     </a:lvl9pPr>
   </p:defaultTextStyle>
-  <p:extLst>
-    <p:ext uri="{EFAFB233-063F-42B5-8137-9DF3F51BA10A}">
-      <p15:sldGuideLst xmlns:p15="http://schemas.microsoft.com/office/powerpoint/2012/main"/>
-    </p:ext>
-  </p:extLst>
 </p:presentation>
 </file>
 
 <file path=ppt/charts/chart1.xml><?xml version="1.0" encoding="utf-8"?>
-<c:chartSpace xmlns:c="http://schemas.openxmlformats.org/drawingml/2006/chart" xmlns:a="http://schemas.openxmlformats.org/drawingml/2006/main" xmlns:r="http://schemas.openxmlformats.org/officeDocument/2006/relationships" xmlns:c16r2="http://schemas.microsoft.com/office/drawing/2015/06/chart">
+<c:chartSpace xmlns:c="http://schemas.openxmlformats.org/drawingml/2006/chart" xmlns:a="http://schemas.openxmlformats.org/drawingml/2006/main" xmlns:r="http://schemas.openxmlformats.org/officeDocument/2006/relationships">
   <c:date1904 val="0"/>
-  <c:lang val="en-US"/>
   <c:roundedCorners val="1"/>
-  <c:style val="2"/>
   <c:chart>
     <c:autoTitleDeleted val="1"/>
     <c:plotArea>
@@ -171,11 +165,6 @@
               </a:ln>
               <a:effectLst/>
             </c:spPr>
-            <c:extLst>
-              <c:ext xmlns:c16="http://schemas.microsoft.com/office/drawing/2014/chart" uri="{C3380CC4-5D6E-409C-BE32-E72D297353CC}">
-                <c16:uniqueId val="{00000001-D1CE-47F4-A59C-17DCD59A40B0}"/>
-              </c:ext>
-            </c:extLst>
           </c:dPt>
           <c:dPt>
             <c:idx val="1"/>
@@ -193,12 +182,81 @@
               </a:ln>
               <a:effectLst/>
             </c:spPr>
-            <c:extLst>
-              <c:ext xmlns:c16="http://schemas.microsoft.com/office/drawing/2014/chart" uri="{C3380CC4-5D6E-409C-BE32-E72D297353CC}">
-                <c16:uniqueId val="{00000003-D1CE-47F4-A59C-17DCD59A40B0}"/>
-              </c:ext>
-            </c:extLst>
           </c:dPt>
+          <c:dLbls>
+            <c:dLbl>
+              <c:idx val="0"/>
+              <c:numFmt formatCode="General" sourceLinked="0"/>
+              <c:spPr/>
+              <c:txPr>
+                <a:bodyPr/>
+                <a:lstStyle/>
+                <a:p>
+                  <a:pPr>
+                    <a:defRPr sz="1200" b="0" i="0" u="none" strike="noStrike">
+                      <a:solidFill>
+                        <a:srgbClr val="000000"/>
+                      </a:solidFill>
+                      <a:latin typeface="Arial"/>
+                    </a:defRPr>
+                  </a:pPr>
+                </a:p>
+              </c:txPr>
+              <c:showLegendKey val="0"/>
+              <c:showVal val="0"/>
+              <c:showCatName val="0"/>
+              <c:showSerName val="0"/>
+              <c:showPercent val="0"/>
+              <c:showBubbleSize val="0"/>
+            </c:dLbl>
+            <c:dLbl>
+              <c:idx val="1"/>
+              <c:numFmt formatCode="General" sourceLinked="0"/>
+              <c:spPr/>
+              <c:txPr>
+                <a:bodyPr/>
+                <a:lstStyle/>
+                <a:p>
+                  <a:pPr>
+                    <a:defRPr sz="1200" b="0" i="0" u="none" strike="noStrike">
+                      <a:solidFill>
+                        <a:srgbClr val="000000"/>
+                      </a:solidFill>
+                      <a:latin typeface="Arial"/>
+                    </a:defRPr>
+                  </a:pPr>
+                </a:p>
+              </c:txPr>
+              <c:showLegendKey val="0"/>
+              <c:showVal val="0"/>
+              <c:showCatName val="0"/>
+              <c:showSerName val="0"/>
+              <c:showPercent val="0"/>
+              <c:showBubbleSize val="0"/>
+            </c:dLbl>
+            <c:numFmt formatCode="General" sourceLinked="0"/>
+            <c:txPr>
+              <a:bodyPr/>
+              <a:lstStyle/>
+              <a:p>
+                <a:pPr>
+                  <a:defRPr sz="1800" b="0" i="0" u="none" strike="noStrike">
+                    <a:solidFill>
+                      <a:srgbClr val="000000"/>
+                    </a:solidFill>
+                    <a:latin typeface="Arial"/>
+                  </a:defRPr>
+                </a:pPr>
+              </a:p>
+            </c:txPr>
+            <c:showLegendKey val="0"/>
+            <c:showVal val="0"/>
+            <c:showCatName val="1"/>
+            <c:showSerName val="0"/>
+            <c:showPercent val="1"/>
+            <c:showBubbleSize val="0"/>
+            <c:showLeaderLines val="0"/>
+          </c:dLbls>
           <c:cat>
             <c:strRef>
               <c:f>Sheet1!$A$2:$A$3</c:f>
@@ -217,7 +275,6 @@
             <c:numRef>
               <c:f>Sheet1!$B$2:$B$3</c:f>
               <c:numCache>
-                <c:formatCode>General</c:formatCode>
                 <c:ptCount val="2"/>
                 <c:pt idx="0">
                   <c:v>58</c:v>
@@ -228,21 +285,7 @@
               </c:numCache>
             </c:numRef>
           </c:val>
-          <c:extLst>
-            <c:ext xmlns:c16="http://schemas.microsoft.com/office/drawing/2014/chart" uri="{C3380CC4-5D6E-409C-BE32-E72D297353CC}">
-              <c16:uniqueId val="{00000004-D1CE-47F4-A59C-17DCD59A40B0}"/>
-            </c:ext>
-          </c:extLst>
         </c:ser>
-        <c:dLbls>
-          <c:showLegendKey val="0"/>
-          <c:showVal val="0"/>
-          <c:showCatName val="0"/>
-          <c:showSerName val="0"/>
-          <c:showPercent val="0"/>
-          <c:showBubbleSize val="0"/>
-          <c:showLeaderLines val="0"/>
-        </c:dLbls>
         <c:firstSliceAng val="0"/>
         <c:holeSize val="74"/>
       </c:doughnutChart>
@@ -256,7 +299,6 @@
     </c:plotArea>
     <c:plotVisOnly val="1"/>
     <c:dispBlanksAs val="span"/>
-    <c:showDLblsOverMax val="1"/>
   </c:chart>
   <c:spPr>
     <a:noFill/>
@@ -272,11 +314,9 @@
 </file>
 
 <file path=ppt/charts/chart2.xml><?xml version="1.0" encoding="utf-8"?>
-<c:chartSpace xmlns:c="http://schemas.openxmlformats.org/drawingml/2006/chart" xmlns:a="http://schemas.openxmlformats.org/drawingml/2006/main" xmlns:r="http://schemas.openxmlformats.org/officeDocument/2006/relationships" xmlns:c16r2="http://schemas.microsoft.com/office/drawing/2015/06/chart">
+<c:chartSpace xmlns:c="http://schemas.openxmlformats.org/drawingml/2006/chart" xmlns:a="http://schemas.openxmlformats.org/drawingml/2006/main" xmlns:r="http://schemas.openxmlformats.org/officeDocument/2006/relationships">
   <c:date1904 val="0"/>
-  <c:lang val="en-US"/>
   <c:roundedCorners val="1"/>
-  <c:style val="2"/>
   <c:chart>
     <c:autoTitleDeleted val="1"/>
     <c:plotArea>
@@ -306,40 +346,66 @@
             <a:effectLst/>
           </c:spPr>
           <c:invertIfNegative val="0"/>
+          <c:dLbls>
+            <c:numFmt formatCode="#,##0" sourceLinked="0"/>
+            <c:txPr>
+              <a:bodyPr/>
+              <a:lstStyle/>
+              <a:p>
+                <a:pPr>
+                  <a:defRPr b="0" i="0" strike="noStrike" sz="1200" u="none">
+                    <a:solidFill>
+                      <a:srgbClr val="000000"/>
+                    </a:solidFill>
+                    <a:latin typeface="Arial"/>
+                  </a:defRPr>
+                </a:pPr>
+              </a:p>
+            </c:txPr>
+            <c:showLegendKey val="0"/>
+            <c:showVal val="0"/>
+            <c:showCatName val="0"/>
+            <c:showSerName val="0"/>
+            <c:showPercent val="0"/>
+            <c:showBubbleSize val="0"/>
+            <c:showLeaderLines val="0"/>
+          </c:dLbls>
           <c:cat>
-            <c:strRef>
+            <c:multiLvlStrRef>
               <c:f>Sheet1!$A$2:$A$10</c:f>
-              <c:strCache>
+              <c:multiLvlStrCache>
                 <c:ptCount val="9"/>
-                <c:pt idx="0">
-                  <c:v>FY15</c:v>
-                </c:pt>
-                <c:pt idx="1">
-                  <c:v>FY16</c:v>
-                </c:pt>
-                <c:pt idx="2">
-                  <c:v>FY17</c:v>
-                </c:pt>
-                <c:pt idx="3">
-                  <c:v>FY18</c:v>
-                </c:pt>
-                <c:pt idx="4">
-                  <c:v>FY19</c:v>
-                </c:pt>
-                <c:pt idx="5">
-                  <c:v>FY20</c:v>
-                </c:pt>
-                <c:pt idx="6">
-                  <c:v>FY21</c:v>
-                </c:pt>
-                <c:pt idx="7">
-                  <c:v>FY22</c:v>
-                </c:pt>
-                <c:pt idx="8">
-                  <c:v>FY23</c:v>
-                </c:pt>
-              </c:strCache>
-            </c:strRef>
+                <c:lvl>
+                  <c:pt idx="0">
+                    <c:v>FY15</c:v>
+                  </c:pt>
+                  <c:pt idx="1">
+                    <c:v>FY16</c:v>
+                  </c:pt>
+                  <c:pt idx="2">
+                    <c:v>FY17</c:v>
+                  </c:pt>
+                  <c:pt idx="3">
+                    <c:v>FY18</c:v>
+                  </c:pt>
+                  <c:pt idx="4">
+                    <c:v>FY19</c:v>
+                  </c:pt>
+                  <c:pt idx="5">
+                    <c:v>FY20</c:v>
+                  </c:pt>
+                  <c:pt idx="6">
+                    <c:v>FY21</c:v>
+                  </c:pt>
+                  <c:pt idx="7">
+                    <c:v>FY22</c:v>
+                  </c:pt>
+                  <c:pt idx="8">
+                    <c:v>FY23</c:v>
+                  </c:pt>
+                </c:lvl>
+              </c:multiLvlStrCache>
+            </c:multiLvlStrRef>
           </c:cat>
           <c:val>
             <c:numRef>
@@ -377,11 +443,6 @@
               </c:numCache>
             </c:numRef>
           </c:val>
-          <c:extLst>
-            <c:ext xmlns:c16="http://schemas.microsoft.com/office/drawing/2014/chart" uri="{C3380CC4-5D6E-409C-BE32-E72D297353CC}">
-              <c16:uniqueId val="{00000000-6D01-4D2F-96DC-1B2F4918DE4A}"/>
-            </c:ext>
-          </c:extLst>
         </c:ser>
         <c:ser>
           <c:idx val="1"/>
@@ -404,40 +465,66 @@
             <a:effectLst/>
           </c:spPr>
           <c:invertIfNegative val="0"/>
+          <c:dLbls>
+            <c:numFmt formatCode="#,##0" sourceLinked="0"/>
+            <c:txPr>
+              <a:bodyPr/>
+              <a:lstStyle/>
+              <a:p>
+                <a:pPr>
+                  <a:defRPr b="0" i="0" strike="noStrike" sz="1200" u="none">
+                    <a:solidFill>
+                      <a:srgbClr val="000000"/>
+                    </a:solidFill>
+                    <a:latin typeface="Arial"/>
+                  </a:defRPr>
+                </a:pPr>
+              </a:p>
+            </c:txPr>
+            <c:showLegendKey val="0"/>
+            <c:showVal val="0"/>
+            <c:showCatName val="0"/>
+            <c:showSerName val="0"/>
+            <c:showPercent val="0"/>
+            <c:showBubbleSize val="0"/>
+            <c:showLeaderLines val="0"/>
+          </c:dLbls>
           <c:cat>
-            <c:strRef>
+            <c:multiLvlStrRef>
               <c:f>Sheet1!$A$2:$A$10</c:f>
-              <c:strCache>
+              <c:multiLvlStrCache>
                 <c:ptCount val="9"/>
-                <c:pt idx="0">
-                  <c:v>FY15</c:v>
-                </c:pt>
-                <c:pt idx="1">
-                  <c:v>FY16</c:v>
-                </c:pt>
-                <c:pt idx="2">
-                  <c:v>FY17</c:v>
-                </c:pt>
-                <c:pt idx="3">
-                  <c:v>FY18</c:v>
-                </c:pt>
-                <c:pt idx="4">
-                  <c:v>FY19</c:v>
-                </c:pt>
-                <c:pt idx="5">
-                  <c:v>FY20</c:v>
-                </c:pt>
-                <c:pt idx="6">
-                  <c:v>FY21</c:v>
-                </c:pt>
-                <c:pt idx="7">
-                  <c:v>FY22</c:v>
-                </c:pt>
-                <c:pt idx="8">
-                  <c:v>FY23</c:v>
-                </c:pt>
-              </c:strCache>
-            </c:strRef>
+                <c:lvl>
+                  <c:pt idx="0">
+                    <c:v>FY15</c:v>
+                  </c:pt>
+                  <c:pt idx="1">
+                    <c:v>FY16</c:v>
+                  </c:pt>
+                  <c:pt idx="2">
+                    <c:v>FY17</c:v>
+                  </c:pt>
+                  <c:pt idx="3">
+                    <c:v>FY18</c:v>
+                  </c:pt>
+                  <c:pt idx="4">
+                    <c:v>FY19</c:v>
+                  </c:pt>
+                  <c:pt idx="5">
+                    <c:v>FY20</c:v>
+                  </c:pt>
+                  <c:pt idx="6">
+                    <c:v>FY21</c:v>
+                  </c:pt>
+                  <c:pt idx="7">
+                    <c:v>FY22</c:v>
+                  </c:pt>
+                  <c:pt idx="8">
+                    <c:v>FY23</c:v>
+                  </c:pt>
+                </c:lvl>
+              </c:multiLvlStrCache>
+            </c:multiLvlStrRef>
           </c:cat>
           <c:val>
             <c:numRef>
@@ -475,24 +562,36 @@
               </c:numCache>
             </c:numRef>
           </c:val>
-          <c:extLst>
-            <c:ext xmlns:c16="http://schemas.microsoft.com/office/drawing/2014/chart" uri="{C3380CC4-5D6E-409C-BE32-E72D297353CC}">
-              <c16:uniqueId val="{00000001-6D01-4D2F-96DC-1B2F4918DE4A}"/>
-            </c:ext>
-          </c:extLst>
         </c:ser>
         <c:dLbls>
+          <c:numFmt formatCode="#,##0" sourceLinked="0"/>
+          <c:txPr>
+            <a:bodyPr/>
+            <a:lstStyle/>
+            <a:p>
+              <a:pPr>
+                <a:defRPr b="0" i="0" strike="noStrike" sz="1200" u="none">
+                  <a:solidFill>
+                    <a:srgbClr val="000000"/>
+                  </a:solidFill>
+                  <a:latin typeface="Arial"/>
+                </a:defRPr>
+              </a:pPr>
+            </a:p>
+          </c:txPr>
           <c:showLegendKey val="0"/>
           <c:showVal val="0"/>
           <c:showCatName val="0"/>
           <c:showSerName val="0"/>
           <c:showPercent val="0"/>
           <c:showBubbleSize val="0"/>
+          <c:showLeaderLines val="0"/>
         </c:dLbls>
         <c:gapWidth val="45"/>
         <c:overlap val="100"/>
         <c:axId val="2094734554"/>
         <c:axId val="2094734552"/>
+        <c:axId val="2094734556"/>
       </c:barChart>
       <c:catAx>
         <c:axId val="2094734554"/>
@@ -531,7 +630,6 @@
         <c:crosses val="autoZero"/>
         <c:auto val="1"/>
         <c:lblAlgn val="ctr"/>
-        <c:lblOffset val="100"/>
         <c:noMultiLvlLbl val="1"/>
       </c:catAx>
       <c:valAx>
@@ -613,7 +711,6 @@
     </c:legend>
     <c:plotVisOnly val="1"/>
     <c:dispBlanksAs val="span"/>
-    <c:showDLblsOverMax val="1"/>
   </c:chart>
   <c:spPr>
     <a:noFill/>
@@ -629,11 +726,9 @@
 </file>
 
 <file path=ppt/charts/chart3.xml><?xml version="1.0" encoding="utf-8"?>
-<c:chartSpace xmlns:c="http://schemas.openxmlformats.org/drawingml/2006/chart" xmlns:a="http://schemas.openxmlformats.org/drawingml/2006/main" xmlns:r="http://schemas.openxmlformats.org/officeDocument/2006/relationships" xmlns:c16r2="http://schemas.microsoft.com/office/drawing/2015/06/chart">
+<c:chartSpace xmlns:c="http://schemas.openxmlformats.org/drawingml/2006/chart" xmlns:a="http://schemas.openxmlformats.org/drawingml/2006/main" xmlns:r="http://schemas.openxmlformats.org/officeDocument/2006/relationships">
   <c:date1904 val="0"/>
-  <c:lang val="en-US"/>
   <c:roundedCorners val="1"/>
-  <c:style val="2"/>
   <c:chart>
     <c:autoTitleDeleted val="1"/>
     <c:plotArea>
@@ -683,11 +778,6 @@
               </a:ln>
               <a:effectLst/>
             </c:spPr>
-            <c:extLst>
-              <c:ext xmlns:c16="http://schemas.microsoft.com/office/drawing/2014/chart" uri="{C3380CC4-5D6E-409C-BE32-E72D297353CC}">
-                <c16:uniqueId val="{00000001-7329-49C7-9E0C-634D159C3487}"/>
-              </c:ext>
-            </c:extLst>
           </c:dPt>
           <c:dPt>
             <c:idx val="1"/>
@@ -705,12 +795,81 @@
               </a:ln>
               <a:effectLst/>
             </c:spPr>
-            <c:extLst>
-              <c:ext xmlns:c16="http://schemas.microsoft.com/office/drawing/2014/chart" uri="{C3380CC4-5D6E-409C-BE32-E72D297353CC}">
-                <c16:uniqueId val="{00000003-7329-49C7-9E0C-634D159C3487}"/>
-              </c:ext>
-            </c:extLst>
           </c:dPt>
+          <c:dLbls>
+            <c:dLbl>
+              <c:idx val="0"/>
+              <c:numFmt formatCode="General" sourceLinked="0"/>
+              <c:spPr/>
+              <c:txPr>
+                <a:bodyPr/>
+                <a:lstStyle/>
+                <a:p>
+                  <a:pPr>
+                    <a:defRPr sz="1200" b="0" i="0" u="none" strike="noStrike">
+                      <a:solidFill>
+                        <a:srgbClr val="000000"/>
+                      </a:solidFill>
+                      <a:latin typeface="Arial"/>
+                    </a:defRPr>
+                  </a:pPr>
+                </a:p>
+              </c:txPr>
+              <c:showLegendKey val="0"/>
+              <c:showVal val="0"/>
+              <c:showCatName val="0"/>
+              <c:showSerName val="0"/>
+              <c:showPercent val="0"/>
+              <c:showBubbleSize val="0"/>
+            </c:dLbl>
+            <c:dLbl>
+              <c:idx val="1"/>
+              <c:numFmt formatCode="General" sourceLinked="0"/>
+              <c:spPr/>
+              <c:txPr>
+                <a:bodyPr/>
+                <a:lstStyle/>
+                <a:p>
+                  <a:pPr>
+                    <a:defRPr sz="1200" b="0" i="0" u="none" strike="noStrike">
+                      <a:solidFill>
+                        <a:srgbClr val="000000"/>
+                      </a:solidFill>
+                      <a:latin typeface="Arial"/>
+                    </a:defRPr>
+                  </a:pPr>
+                </a:p>
+              </c:txPr>
+              <c:showLegendKey val="0"/>
+              <c:showVal val="0"/>
+              <c:showCatName val="0"/>
+              <c:showSerName val="0"/>
+              <c:showPercent val="0"/>
+              <c:showBubbleSize val="0"/>
+            </c:dLbl>
+            <c:numFmt formatCode="General" sourceLinked="0"/>
+            <c:txPr>
+              <a:bodyPr/>
+              <a:lstStyle/>
+              <a:p>
+                <a:pPr>
+                  <a:defRPr sz="1800" b="0" i="0" u="none" strike="noStrike">
+                    <a:solidFill>
+                      <a:srgbClr val="000000"/>
+                    </a:solidFill>
+                    <a:latin typeface="Arial"/>
+                  </a:defRPr>
+                </a:pPr>
+              </a:p>
+            </c:txPr>
+            <c:showLegendKey val="0"/>
+            <c:showVal val="0"/>
+            <c:showCatName val="1"/>
+            <c:showSerName val="0"/>
+            <c:showPercent val="1"/>
+            <c:showBubbleSize val="0"/>
+            <c:showLeaderLines val="0"/>
+          </c:dLbls>
           <c:cat>
             <c:strRef>
               <c:f>Sheet1!$A$2:$A$3</c:f>
@@ -729,7 +888,6 @@
             <c:numRef>
               <c:f>Sheet1!$B$2:$B$3</c:f>
               <c:numCache>
-                <c:formatCode>General</c:formatCode>
                 <c:ptCount val="2"/>
                 <c:pt idx="0">
                   <c:v>58</c:v>
@@ -740,21 +898,7 @@
               </c:numCache>
             </c:numRef>
           </c:val>
-          <c:extLst>
-            <c:ext xmlns:c16="http://schemas.microsoft.com/office/drawing/2014/chart" uri="{C3380CC4-5D6E-409C-BE32-E72D297353CC}">
-              <c16:uniqueId val="{00000004-7329-49C7-9E0C-634D159C3487}"/>
-            </c:ext>
-          </c:extLst>
         </c:ser>
-        <c:dLbls>
-          <c:showLegendKey val="0"/>
-          <c:showVal val="0"/>
-          <c:showCatName val="0"/>
-          <c:showSerName val="0"/>
-          <c:showPercent val="0"/>
-          <c:showBubbleSize val="0"/>
-          <c:showLeaderLines val="0"/>
-        </c:dLbls>
         <c:firstSliceAng val="0"/>
         <c:holeSize val="74"/>
       </c:doughnutChart>
@@ -768,7 +912,6 @@
     </c:plotArea>
     <c:plotVisOnly val="1"/>
     <c:dispBlanksAs val="span"/>
-    <c:showDLblsOverMax val="1"/>
   </c:chart>
   <c:spPr>
     <a:noFill/>
@@ -805,10 +948,234 @@
           <a:chExt cx="0" cy="0"/>
         </a:xfrm>
       </p:grpSpPr>
+      <p:sp>
+        <p:nvSpPr>
+          <p:cNvPr id="2" name="Header Placeholder 1"/>
+          <p:cNvSpPr>
+            <a:spLocks noGrp="1"/>
+          </p:cNvSpPr>
+          <p:nvPr>
+            <p:ph type="hdr" sz="quarter"/>
+          </p:nvPr>
+        </p:nvSpPr>
+        <p:spPr>
+          <a:xfrm>
+            <a:off x="0" y="0"/>
+            <a:ext cx="2971800" cy="458788"/>
+          </a:xfrm>
+          <a:prstGeom prst="rect">
+            <a:avLst/>
+          </a:prstGeom>
+        </p:spPr>
+        <p:txBody>
+          <a:bodyPr vert="horz" lIns="91440" tIns="45720" rIns="91440" bIns="45720" rtlCol="0"/>
+          <a:lstStyle>
+            <a:lvl1pPr algn="l">
+              <a:defRPr sz="1200"/>
+            </a:lvl1pPr>
+          </a:lstStyle>
+          <a:p>
+            <a:endParaRPr lang="en-US"/>
+          </a:p>
+        </p:txBody>
+      </p:sp>
+      <p:sp>
+        <p:nvSpPr>
+          <p:cNvPr id="3" name="Date Placeholder 2"/>
+          <p:cNvSpPr>
+            <a:spLocks noGrp="1"/>
+          </p:cNvSpPr>
+          <p:nvPr>
+            <p:ph type="dt" idx="1"/>
+          </p:nvPr>
+        </p:nvSpPr>
+        <p:spPr>
+          <a:xfrm>
+            <a:off x="3884613" y="0"/>
+            <a:ext cx="2971800" cy="458788"/>
+          </a:xfrm>
+          <a:prstGeom prst="rect">
+            <a:avLst/>
+          </a:prstGeom>
+        </p:spPr>
+        <p:txBody>
+          <a:bodyPr vert="horz" lIns="91440" tIns="45720" rIns="91440" bIns="45720" rtlCol="0"/>
+          <a:lstStyle>
+            <a:lvl1pPr algn="r">
+              <a:defRPr sz="1200"/>
+            </a:lvl1pPr>
+          </a:lstStyle>
+          <a:p>
+            <a:fld id="{5282F153-3F37-0F45-9E97-73ACFA13230C}" type="datetimeFigureOut">
+              <a:rPr lang="en-US"/>
+              <a:t>7/23/19</a:t>
+            </a:fld>
+            <a:endParaRPr lang="en-US"/>
+          </a:p>
+        </p:txBody>
+      </p:sp>
+      <p:sp>
+        <p:nvSpPr>
+          <p:cNvPr id="4" name="Slide Image Placeholder 3"/>
+          <p:cNvSpPr>
+            <a:spLocks noGrp="1" noRot="1" noChangeAspect="1"/>
+          </p:cNvSpPr>
+          <p:nvPr>
+            <p:ph type="sldImg" idx="2"/>
+          </p:nvPr>
+        </p:nvSpPr>
+        <p:spPr>
+          <a:xfrm>
+            <a:off x="685800" y="1143000"/>
+            <a:ext cx="5486400" cy="3086100"/>
+          </a:xfrm>
+          <a:prstGeom prst="rect">
+            <a:avLst/>
+          </a:prstGeom>
+          <a:noFill/>
+          <a:ln w="12700">
+            <a:solidFill>
+              <a:prstClr val="black"/>
+            </a:solidFill>
+          </a:ln>
+        </p:spPr>
+        <p:txBody>
+          <a:bodyPr vert="horz" lIns="91440" tIns="45720" rIns="91440" bIns="45720" rtlCol="0" anchor="ctr"/>
+          <a:lstStyle/>
+          <a:p>
+            <a:endParaRPr lang="en-US"/>
+          </a:p>
+        </p:txBody>
+      </p:sp>
+      <p:sp>
+        <p:nvSpPr>
+          <p:cNvPr id="5" name="Notes Placeholder 4"/>
+          <p:cNvSpPr>
+            <a:spLocks noGrp="1"/>
+          </p:cNvSpPr>
+          <p:nvPr>
+            <p:ph type="body" sz="quarter" idx="3"/>
+          </p:nvPr>
+        </p:nvSpPr>
+        <p:spPr>
+          <a:xfrm>
+            <a:off x="685800" y="4400550"/>
+            <a:ext cx="5486400" cy="3600450"/>
+          </a:xfrm>
+          <a:prstGeom prst="rect">
+            <a:avLst/>
+          </a:prstGeom>
+        </p:spPr>
+        <p:txBody>
+          <a:bodyPr vert="horz" lIns="91440" tIns="45720" rIns="91440" bIns="45720" rtlCol="0"/>
+          <a:lstStyle/>
+          <a:p>
+            <a:pPr lvl="0"/>
+            <a:r>
+              <a:rPr lang="en-US"/>
+              <a:t>Click to edit Master text styles</a:t>
+            </a:r>
+          </a:p>
+          <a:p>
+            <a:pPr lvl="1"/>
+            <a:r>
+              <a:rPr lang="en-US"/>
+              <a:t>Second level</a:t>
+            </a:r>
+          </a:p>
+          <a:p>
+            <a:pPr lvl="2"/>
+            <a:r>
+              <a:rPr lang="en-US"/>
+              <a:t>Third level</a:t>
+            </a:r>
+          </a:p>
+          <a:p>
+            <a:pPr lvl="3"/>
+            <a:r>
+              <a:rPr lang="en-US"/>
+              <a:t>Fourth level</a:t>
+            </a:r>
+          </a:p>
+          <a:p>
+            <a:pPr lvl="4"/>
+            <a:r>
+              <a:rPr lang="en-US"/>
+              <a:t>Fifth level</a:t>
+            </a:r>
+          </a:p>
+        </p:txBody>
+      </p:sp>
+      <p:sp>
+        <p:nvSpPr>
+          <p:cNvPr id="6" name="Footer Placeholder 5"/>
+          <p:cNvSpPr>
+            <a:spLocks noGrp="1"/>
+          </p:cNvSpPr>
+          <p:nvPr>
+            <p:ph type="ftr" sz="quarter" idx="4"/>
+          </p:nvPr>
+        </p:nvSpPr>
+        <p:spPr>
+          <a:xfrm>
+            <a:off x="0" y="8685213"/>
+            <a:ext cx="2971800" cy="458787"/>
+          </a:xfrm>
+          <a:prstGeom prst="rect">
+            <a:avLst/>
+          </a:prstGeom>
+        </p:spPr>
+        <p:txBody>
+          <a:bodyPr vert="horz" lIns="91440" tIns="45720" rIns="91440" bIns="45720" rtlCol="0" anchor="b"/>
+          <a:lstStyle>
+            <a:lvl1pPr algn="l">
+              <a:defRPr sz="1200"/>
+            </a:lvl1pPr>
+          </a:lstStyle>
+          <a:p>
+            <a:endParaRPr lang="en-US"/>
+          </a:p>
+        </p:txBody>
+      </p:sp>
+      <p:sp>
+        <p:nvSpPr>
+          <p:cNvPr id="7" name="Slide Number Placeholder 6"/>
+          <p:cNvSpPr>
+            <a:spLocks noGrp="1"/>
+          </p:cNvSpPr>
+          <p:nvPr>
+            <p:ph type="sldNum" sz="quarter" idx="5"/>
+          </p:nvPr>
+        </p:nvSpPr>
+        <p:spPr>
+          <a:xfrm>
+            <a:off x="3884613" y="8685213"/>
+            <a:ext cx="2971800" cy="458787"/>
+          </a:xfrm>
+          <a:prstGeom prst="rect">
+            <a:avLst/>
+          </a:prstGeom>
+        </p:spPr>
+        <p:txBody>
+          <a:bodyPr vert="horz" lIns="91440" tIns="45720" rIns="91440" bIns="45720" rtlCol="0" anchor="b"/>
+          <a:lstStyle>
+            <a:lvl1pPr algn="r">
+              <a:defRPr sz="1200"/>
+            </a:lvl1pPr>
+          </a:lstStyle>
+          <a:p>
+            <a:fld id="{CE5E9CC1-C706-0F49-92D6-E571CC5EEA8F}" type="slidenum">
+              <a:rPr lang="en-US"/>
+              <a:t>‹#›</a:t>
+            </a:fld>
+            <a:endParaRPr lang="en-US"/>
+          </a:p>
+        </p:txBody>
+      </p:sp>
     </p:spTree>
     <p:extLst>
       <p:ext uri="{BB962C8B-B14F-4D97-AF65-F5344CB8AC3E}">
-        <p14:creationId xmlns:p14="http://schemas.microsoft.com/office/powerpoint/2010/main" val="1283528057"/>
+        <p14:creationId xmlns:p14="http://schemas.microsoft.com/office/powerpoint/2010/main" val="1024086991"/>
       </p:ext>
     </p:extLst>
   </p:cSld>
@@ -952,6 +1319,10 @@
           <a:bodyPr/>
           <a:lstStyle/>
           <a:p>
+            <a:r>
+              <a:rPr lang="en-US" dirty="0"/>
+              <a:t/>
+            </a:r>
             <a:endParaRPr lang="en-US" dirty="0"/>
           </a:p>
         </p:txBody>
@@ -1036,6 +1407,10 @@
           <a:bodyPr/>
           <a:lstStyle/>
           <a:p>
+            <a:r>
+              <a:rPr lang="en-US" dirty="0"/>
+              <a:t/>
+            </a:r>
             <a:endParaRPr lang="en-US" dirty="0"/>
           </a:p>
         </p:txBody>
@@ -1120,6 +1495,10 @@
           <a:bodyPr/>
           <a:lstStyle/>
           <a:p>
+            <a:r>
+              <a:rPr lang="en-US" dirty="0"/>
+              <a:t/>
+            </a:r>
             <a:endParaRPr lang="en-US" dirty="0"/>
           </a:p>
         </p:txBody>
@@ -1204,6 +1583,10 @@
           <a:bodyPr/>
           <a:lstStyle/>
           <a:p>
+            <a:r>
+              <a:rPr lang="en-US" dirty="0"/>
+              <a:t/>
+            </a:r>
             <a:endParaRPr lang="en-US" dirty="0"/>
           </a:p>
         </p:txBody>
@@ -1288,6 +1671,10 @@
           <a:bodyPr/>
           <a:lstStyle/>
           <a:p>
+            <a:r>
+              <a:rPr lang="en-US" dirty="0"/>
+              <a:t/>
+            </a:r>
             <a:endParaRPr lang="en-US" dirty="0"/>
           </a:p>
         </p:txBody>
@@ -1310,6 +1697,94 @@
             <a:fld id="{F7021451-1387-4CA6-816F-3879F97B5CBC}" type="slidenum">
               <a:rPr lang="en-US"/>
               <a:t>5</a:t>
+            </a:fld>
+            <a:endParaRPr lang="en-US"/>
+          </a:p>
+        </p:txBody>
+      </p:sp>
+    </p:spTree>
+    <p:extLst>
+      <p:ext uri="{BB962C8B-B14F-4D97-AF65-F5344CB8AC3E}">
+        <p14:creationId xmlns:p14="http://schemas.microsoft.com/office/powerpoint/2010/main" val="1024086991"/>
+      </p:ext>
+    </p:extLst>
+  </p:cSld>
+  <p:clrMapOvr>
+    <a:masterClrMapping/>
+  </p:clrMapOvr>
+</p:notes>
+</file>
+
+<file path=ppt/notesSlides/notesSlide6.xml><?xml version="1.0" encoding="utf-8"?>
+<p:notes xmlns:a="http://schemas.openxmlformats.org/drawingml/2006/main" xmlns:r="http://schemas.openxmlformats.org/officeDocument/2006/relationships" xmlns:p="http://schemas.openxmlformats.org/presentationml/2006/main">
+  <p:cSld>
+    <p:spTree>
+      <p:nvGrpSpPr>
+        <p:cNvPr id="1" name=""/>
+        <p:cNvGrpSpPr/>
+        <p:nvPr/>
+      </p:nvGrpSpPr>
+      <p:grpSpPr>
+        <a:xfrm>
+          <a:off x="0" y="0"/>
+          <a:ext cx="0" cy="0"/>
+          <a:chOff x="0" y="0"/>
+          <a:chExt cx="0" cy="0"/>
+        </a:xfrm>
+      </p:grpSpPr>
+      <p:sp>
+        <p:nvSpPr>
+          <p:cNvPr id="2" name="Slide Image Placeholder 1"/>
+          <p:cNvSpPr>
+            <a:spLocks noGrp="1" noRot="1" noChangeAspect="1"/>
+          </p:cNvSpPr>
+          <p:nvPr>
+            <p:ph type="sldImg"/>
+          </p:nvPr>
+        </p:nvSpPr>
+        <p:spPr/>
+      </p:sp>
+      <p:sp>
+        <p:nvSpPr>
+          <p:cNvPr id="3" name="Notes Placeholder 2"/>
+          <p:cNvSpPr>
+            <a:spLocks noGrp="1"/>
+          </p:cNvSpPr>
+          <p:nvPr>
+            <p:ph type="body" idx="1"/>
+          </p:nvPr>
+        </p:nvSpPr>
+        <p:spPr/>
+        <p:txBody>
+          <a:bodyPr/>
+          <a:lstStyle/>
+          <a:p>
+            <a:r>
+              <a:rPr lang="en-US" dirty="0"/>
+              <a:t/>
+            </a:r>
+            <a:endParaRPr lang="en-US" dirty="0"/>
+          </a:p>
+        </p:txBody>
+      </p:sp>
+      <p:sp>
+        <p:nvSpPr>
+          <p:cNvPr id="4" name="Slide Number Placeholder 3"/>
+          <p:cNvSpPr>
+            <a:spLocks noGrp="1"/>
+          </p:cNvSpPr>
+          <p:nvPr>
+            <p:ph type="sldNum" sz="quarter" idx="10"/>
+          </p:nvPr>
+        </p:nvSpPr>
+        <p:spPr/>
+        <p:txBody>
+          <a:bodyPr/>
+          <a:lstStyle/>
+          <a:p>
+            <a:fld id="{F7021451-1387-4CA6-816F-3879F97B5CBC}" type="slidenum">
+              <a:rPr lang="en-US"/>
+              <a:t>6</a:t>
             </a:fld>
             <a:endParaRPr lang="en-US"/>
           </a:p>
@@ -1361,11 +1836,6 @@
 <file path=ppt/slideMasters/slideMaster1.xml><?xml version="1.0" encoding="utf-8"?>
 <p:sldMaster xmlns:a="http://schemas.openxmlformats.org/drawingml/2006/main" xmlns:r="http://schemas.openxmlformats.org/officeDocument/2006/relationships" xmlns:p="http://schemas.openxmlformats.org/presentationml/2006/main">
   <p:cSld>
-    <p:bg>
-      <p:bgRef idx="1001">
-        <a:schemeClr val="bg1"/>
-      </p:bgRef>
-    </p:bg>
     <p:spTree>
       <p:nvGrpSpPr>
         <p:cNvPr id="1" name=""/>
@@ -1648,7 +2118,6 @@
         <a:solidFill>
           <a:srgbClr val="0A1628"/>
         </a:solidFill>
-        <a:effectLst/>
       </p:bgPr>
     </p:bg>
     <p:spTree>
@@ -1686,11 +2155,11 @@
           <a:bodyPr wrap="square" rtlCol="0" anchor="ctr"/>
           <a:lstStyle/>
           <a:p>
-            <a:pPr marL="0" indent="0">
-              <a:buNone/>
-            </a:pPr>
-            <a:r>
-              <a:rPr lang="en-US" sz="1300" b="1" kern="0" spc="400" dirty="0">
+            <a:pPr indent="0" marL="0">
+              <a:buNone/>
+            </a:pPr>
+            <a:r>
+              <a:rPr lang="en-US" sz="1300" b="1" spc="400" kern="0" dirty="0">
                 <a:solidFill>
                   <a:srgbClr val="F59E0B"/>
                 </a:solidFill>
@@ -1698,7 +2167,7 @@
                 <a:ea typeface="Calibri" pitchFamily="34" charset="-122"/>
                 <a:cs typeface="Calibri" pitchFamily="34" charset="-120"/>
               </a:rPr>
-              <a:t>LIVE CORPORATE RISK INTELLIGENCE SYSTEM</a:t>
+              <a:t>LIVE CORPORATE RISK ENGINE</a:t>
             </a:r>
             <a:endParaRPr lang="en-US" sz="1300" dirty="0"/>
           </a:p>
@@ -1725,7 +2194,7 @@
           <a:bodyPr wrap="square" rtlCol="0" anchor="ctr"/>
           <a:lstStyle/>
           <a:p>
-            <a:pPr marL="0" indent="0">
+            <a:pPr indent="0" marL="0">
               <a:buNone/>
             </a:pPr>
             <a:r>
@@ -1739,6 +2208,9 @@
               </a:rPr>
               <a:t>Foresight </a:t>
             </a:r>
+            <a:pPr indent="0" marL="0">
+              <a:buNone/>
+            </a:pPr>
             <a:r>
               <a:rPr lang="en-US" sz="6600" b="1" dirty="0">
                 <a:solidFill>
@@ -1762,8 +2234,8 @@
         </p:nvSpPr>
         <p:spPr>
           <a:xfrm>
-            <a:off x="822960" y="2788919"/>
-            <a:ext cx="7863840" cy="1198039"/>
+            <a:off x="822960" y="2788920"/>
+            <a:ext cx="7223760" cy="1097280"/>
           </a:xfrm>
           <a:prstGeom prst="rect">
             <a:avLst/>
@@ -1775,13 +2247,14 @@
           <a:bodyPr wrap="square" rtlCol="0" anchor="ctr"/>
           <a:lstStyle/>
           <a:p>
-            <a:pPr>
+            <a:pPr indent="0" marL="0">
               <a:lnSpc>
                 <a:spcPct val="112000"/>
               </a:lnSpc>
-            </a:pPr>
-            <a:r>
-              <a:rPr lang="en-US" dirty="0">
+              <a:buNone/>
+            </a:pPr>
+            <a:r>
+              <a:rPr lang="en-US" sz="1800" dirty="0">
                 <a:solidFill>
                   <a:srgbClr val="94A3B8"/>
                 </a:solidFill>
@@ -1789,8 +2262,17 @@
                 <a:ea typeface="Calibri" pitchFamily="34" charset="-122"/>
                 <a:cs typeface="Calibri" pitchFamily="34" charset="-120"/>
               </a:rPr>
-              <a:t>O</a:t>
-            </a:r>
+              <a:t>Point it at any listed Indian company. Get one explainable 0-100 score</a:t>
+            </a:r>
+            <a:endParaRPr lang="en-US" sz="1800" dirty="0"/>
+          </a:p>
+          <a:p>
+            <a:pPr indent="0" marL="0">
+              <a:lnSpc>
+                <a:spcPct val="112000"/>
+              </a:lnSpc>
+              <a:buNone/>
+            </a:pPr>
             <a:r>
               <a:rPr lang="en-US" sz="1800" dirty="0">
                 <a:solidFill>
@@ -1800,12 +2282,17 @@
                 <a:ea typeface="Calibri" pitchFamily="34" charset="-122"/>
                 <a:cs typeface="Calibri" pitchFamily="34" charset="-120"/>
               </a:rPr>
-              <a:t>ne explainable 0-100 score</a:t>
-            </a:r>
-            <a:r>
-              <a:rPr lang="en-US" dirty="0"/>
-              <a:t> </a:t>
-            </a:r>
+              <a:t>that fuses the Altman Z-Score with the market signals others read separately:</a:t>
+            </a:r>
+            <a:endParaRPr lang="en-US" sz="1800" dirty="0"/>
+          </a:p>
+          <a:p>
+            <a:pPr indent="0" marL="0">
+              <a:lnSpc>
+                <a:spcPct val="112000"/>
+              </a:lnSpc>
+              <a:buNone/>
+            </a:pPr>
             <a:r>
               <a:rPr lang="en-US" sz="1800" dirty="0">
                 <a:solidFill>
@@ -1815,51 +2302,7 @@
                 <a:ea typeface="Calibri" pitchFamily="34" charset="-122"/>
                 <a:cs typeface="Calibri" pitchFamily="34" charset="-120"/>
               </a:rPr>
-              <a:t>that fuses the </a:t>
-            </a:r>
-            <a:r>
-              <a:rPr lang="en-US" sz="1800" b="1" dirty="0">
-                <a:solidFill>
-                  <a:srgbClr val="94A3B8"/>
-                </a:solidFill>
-                <a:latin typeface="Calibri" pitchFamily="34" charset="0"/>
-                <a:ea typeface="Calibri" pitchFamily="34" charset="-122"/>
-                <a:cs typeface="Calibri" pitchFamily="34" charset="-120"/>
-              </a:rPr>
-              <a:t>Altman Z-Score </a:t>
-            </a:r>
-            <a:r>
-              <a:rPr lang="en-US" sz="1800" dirty="0">
-                <a:solidFill>
-                  <a:srgbClr val="94A3B8"/>
-                </a:solidFill>
-                <a:latin typeface="Calibri" pitchFamily="34" charset="0"/>
-                <a:ea typeface="Calibri" pitchFamily="34" charset="-122"/>
-                <a:cs typeface="Calibri" pitchFamily="34" charset="-120"/>
-              </a:rPr>
-              <a:t>(Company Financial Analysis) with the </a:t>
-            </a:r>
-            <a:r>
-              <a:rPr lang="en-US" sz="1800" b="1" dirty="0">
-                <a:solidFill>
-                  <a:srgbClr val="94A3B8"/>
-                </a:solidFill>
-                <a:latin typeface="Calibri" pitchFamily="34" charset="0"/>
-                <a:ea typeface="Calibri" pitchFamily="34" charset="-122"/>
-                <a:cs typeface="Calibri" pitchFamily="34" charset="-120"/>
-              </a:rPr>
-              <a:t>Market signals </a:t>
-            </a:r>
-            <a:r>
-              <a:rPr lang="en-US" dirty="0">
-                <a:solidFill>
-                  <a:srgbClr val="94A3B8"/>
-                </a:solidFill>
-                <a:latin typeface="Calibri" pitchFamily="34" charset="0"/>
-                <a:ea typeface="Calibri" pitchFamily="34" charset="-122"/>
-                <a:cs typeface="Calibri" pitchFamily="34" charset="-120"/>
-              </a:rPr>
-              <a:t>(credit ratings, leadership, news, hiring and employee sentiment) Live, giving you a Comprehensive Understanding in one go.</a:t>
+              <a:t>credit ratings, leadership, news, hiring and employee sentiment.</a:t>
             </a:r>
             <a:endParaRPr lang="en-US" sz="1800" dirty="0"/>
           </a:p>
@@ -1868,14 +2311,14 @@
       <p:sp>
         <p:nvSpPr>
           <p:cNvPr id="5" name="Shape 3">
-            <a:hlinkClick r:id="rId3" tooltip="Open the live Foresight AI dashboard"/>
+            <a:hlinkClick r:id="rId1" tooltip="Open the live Foresight AI dashboard"/>
           </p:cNvPr>
           <p:cNvSpPr/>
           <p:nvPr/>
         </p:nvSpPr>
         <p:spPr>
           <a:xfrm>
-            <a:off x="822960" y="4132913"/>
+            <a:off x="822960" y="3977640"/>
             <a:ext cx="4160520" cy="566928"/>
           </a:xfrm>
           <a:prstGeom prst="roundRect">
@@ -1897,14 +2340,14 @@
       <p:sp>
         <p:nvSpPr>
           <p:cNvPr id="6" name="Text 4">
-            <a:hlinkClick r:id="rId3" tooltip="Open the live Foresight AI dashboard"/>
+            <a:hlinkClick r:id="rId1" tooltip="Open the live Foresight AI dashboard"/>
           </p:cNvPr>
           <p:cNvSpPr/>
           <p:nvPr/>
         </p:nvSpPr>
         <p:spPr>
           <a:xfrm>
-            <a:off x="822960" y="4141537"/>
+            <a:off x="822960" y="3977640"/>
             <a:ext cx="4160520" cy="566928"/>
           </a:xfrm>
           <a:prstGeom prst="rect">
@@ -1917,7 +2360,7 @@
           <a:bodyPr wrap="square" rtlCol="0" anchor="ctr"/>
           <a:lstStyle/>
           <a:p>
-            <a:pPr marL="0" indent="0" algn="ctr">
+            <a:pPr algn="ctr" indent="0" marL="0">
               <a:buNone/>
             </a:pPr>
             <a:r>
@@ -1928,7 +2371,7 @@
                 <a:latin typeface="Calibri" pitchFamily="34" charset="0"/>
                 <a:ea typeface="Calibri" pitchFamily="34" charset="-122"/>
                 <a:cs typeface="Calibri" pitchFamily="34" charset="-120"/>
-                <a:hlinkClick r:id="rId3" tooltip="Open the live Foresight AI dashboard">
+                <a:hlinkClick r:id="rId1" invalidUrl="" action="" tgtFrame="" tooltip="Open the live Foresight AI dashboard" history="1" highlightClick="0" endSnd="0">
                   <a:extLst>
                     <a:ext uri="{A12FA001-AC4F-418D-AE19-62706E023703}">
                       <ahyp:hlinkClr xmlns:ahyp="http://schemas.microsoft.com/office/drawing/2018/hyperlinkcolor" val="tx"/>
@@ -1938,6 +2381,9 @@
               </a:rPr>
               <a:t>Live demo   </a:t>
             </a:r>
+            <a:pPr algn="ctr" indent="0" marL="0">
+              <a:buNone/>
+            </a:pPr>
             <a:r>
               <a:rPr lang="en-US" sz="1500" b="1" u="sng" dirty="0">
                 <a:solidFill>
@@ -1946,7 +2392,7 @@
                 <a:latin typeface="Calibri" pitchFamily="34" charset="0"/>
                 <a:ea typeface="Calibri" pitchFamily="34" charset="-122"/>
                 <a:cs typeface="Calibri" pitchFamily="34" charset="-120"/>
-                <a:hlinkClick r:id="rId3" tooltip="Open the live Foresight AI dashboard">
+                <a:hlinkClick r:id="rId1" invalidUrl="" action="" tgtFrame="" tooltip="Open the live Foresight AI dashboard" history="1" highlightClick="0" endSnd="0">
                   <a:extLst>
                     <a:ext uri="{A12FA001-AC4F-418D-AE19-62706E023703}">
                       <ahyp:hlinkClr xmlns:ahyp="http://schemas.microsoft.com/office/drawing/2018/hyperlinkcolor" val="tx"/>
@@ -1981,7 +2427,7 @@
           <a:bodyPr wrap="square" rtlCol="0" anchor="ctr"/>
           <a:lstStyle/>
           <a:p>
-            <a:pPr marL="0" indent="0">
+            <a:pPr indent="0" marL="0">
               <a:buNone/>
             </a:pPr>
             <a:r>
@@ -2026,7 +2472,7 @@
       </p:sp>
       <p:graphicFrame>
         <p:nvGraphicFramePr>
-          <p:cNvPr id="9" name="Chart 0"/>
+          <p:cNvPr id="9" name="Chart 0" descr=""/>
           <p:cNvGraphicFramePr/>
           <p:nvPr/>
         </p:nvGraphicFramePr>
@@ -2034,9 +2480,9 @@
           <a:off x="9006840" y="1828800"/>
           <a:ext cx="2651760" cy="2651760"/>
         </p:xfrm>
-        <a:graphic>
+        <a:graphic xmlns:a="http://schemas.openxmlformats.org/drawingml/2006/main">
           <a:graphicData uri="http://schemas.openxmlformats.org/drawingml/2006/chart">
-            <c:chart xmlns:c="http://schemas.openxmlformats.org/drawingml/2006/chart" xmlns:r="http://schemas.openxmlformats.org/officeDocument/2006/relationships" r:id="rId4"/>
+            <c:chart xmlns:c="http://schemas.openxmlformats.org/drawingml/2006/chart" r:id="rId2"/>
           </a:graphicData>
         </a:graphic>
       </p:graphicFrame>
@@ -2061,7 +2507,7 @@
           <a:bodyPr wrap="square" rtlCol="0" anchor="ctr"/>
           <a:lstStyle/>
           <a:p>
-            <a:pPr marL="0" indent="0" algn="ctr">
+            <a:pPr algn="ctr" indent="0" marL="0">
               <a:buNone/>
             </a:pPr>
             <a:r>
@@ -2100,11 +2546,11 @@
           <a:bodyPr wrap="square" rtlCol="0" anchor="ctr"/>
           <a:lstStyle/>
           <a:p>
-            <a:pPr marL="0" indent="0" algn="ctr">
-              <a:buNone/>
-            </a:pPr>
-            <a:r>
-              <a:rPr lang="en-US" sz="1200" kern="0" spc="200" dirty="0">
+            <a:pPr algn="ctr" indent="0" marL="0">
+              <a:buNone/>
+            </a:pPr>
+            <a:r>
+              <a:rPr lang="en-US" sz="1200" spc="200" kern="0" dirty="0">
                 <a:solidFill>
                   <a:srgbClr val="94A3B8"/>
                 </a:solidFill>
@@ -2126,7 +2572,7 @@
         </p:nvSpPr>
         <p:spPr>
           <a:xfrm>
-            <a:off x="9006840" y="1620734"/>
+            <a:off x="9006840" y="1810512"/>
             <a:ext cx="2651760" cy="274320"/>
           </a:xfrm>
           <a:prstGeom prst="rect">
@@ -2139,11 +2585,11 @@
           <a:bodyPr wrap="square" rtlCol="0" anchor="ctr"/>
           <a:lstStyle/>
           <a:p>
-            <a:pPr marL="0" indent="0" algn="ctr">
-              <a:buNone/>
-            </a:pPr>
-            <a:r>
-              <a:rPr lang="en-US" sz="1200" b="1" kern="0" spc="300" dirty="0">
+            <a:pPr algn="ctr" indent="0" marL="0">
+              <a:buNone/>
+            </a:pPr>
+            <a:r>
+              <a:rPr lang="en-US" sz="1200" b="1" spc="300" kern="0" dirty="0">
                 <a:solidFill>
                   <a:srgbClr val="F59E0B"/>
                 </a:solidFill>
@@ -2178,7 +2624,7 @@
           <a:bodyPr wrap="square" rtlCol="0" anchor="ctr"/>
           <a:lstStyle/>
           <a:p>
-            <a:pPr marL="0" indent="0" algn="ctr">
+            <a:pPr algn="ctr" indent="0" marL="0">
               <a:buNone/>
             </a:pPr>
             <a:r>
@@ -2212,7 +2658,6 @@
         <a:solidFill>
           <a:srgbClr val="0A1628"/>
         </a:solidFill>
-        <a:effectLst/>
       </p:bgPr>
     </p:bg>
     <p:spTree>
@@ -2250,7 +2695,7 @@
           <a:bodyPr wrap="square" rtlCol="0" anchor="ctr"/>
           <a:lstStyle/>
           <a:p>
-            <a:pPr marL="0" indent="0">
+            <a:pPr indent="0" marL="0">
               <a:buNone/>
             </a:pPr>
             <a:r>
@@ -2264,6 +2709,9 @@
               </a:rPr>
               <a:t>The warning signs are </a:t>
             </a:r>
+            <a:pPr indent="0" marL="0">
+              <a:buNone/>
+            </a:pPr>
             <a:r>
               <a:rPr lang="en-US" sz="3300" b="1" dirty="0">
                 <a:solidFill>
@@ -2275,6 +2723,9 @@
               </a:rPr>
               <a:t>public</a:t>
             </a:r>
+            <a:pPr indent="0" marL="0">
+              <a:buNone/>
+            </a:pPr>
             <a:r>
               <a:rPr lang="en-US" sz="3300" b="1" dirty="0">
                 <a:solidFill>
@@ -2311,7 +2762,7 @@
           <a:bodyPr wrap="square" rtlCol="0" anchor="ctr"/>
           <a:lstStyle/>
           <a:p>
-            <a:pPr marL="0" indent="0">
+            <a:pPr indent="0" marL="0">
               <a:buNone/>
             </a:pPr>
             <a:r>
@@ -2378,14 +2829,14 @@
       </p:sp>
       <p:pic>
         <p:nvPicPr>
-          <p:cNvPr id="6" name="Image 0" descr="preencoded.png"/>
+          <p:cNvPr id="6" name="Image 0" descr="preencoded.png">    </p:cNvPr>
           <p:cNvPicPr>
             <a:picLocks noChangeAspect="1"/>
           </p:cNvPicPr>
           <p:nvPr/>
         </p:nvPicPr>
         <p:blipFill>
-          <a:blip r:embed="rId3"/>
+          <a:blip r:embed="rId1"/>
           <a:stretch>
             <a:fillRect/>
           </a:stretch>
@@ -2421,7 +2872,7 @@
           <a:bodyPr wrap="square" rtlCol="0" anchor="ctr"/>
           <a:lstStyle/>
           <a:p>
-            <a:pPr marL="0" indent="0">
+            <a:pPr indent="0" marL="0">
               <a:buNone/>
             </a:pPr>
             <a:r>
@@ -2460,7 +2911,7 @@
           <a:bodyPr wrap="square" rtlCol="0" anchor="ctr"/>
           <a:lstStyle/>
           <a:p>
-            <a:pPr marL="0" indent="0">
+            <a:pPr indent="0" marL="0">
               <a:lnSpc>
                 <a:spcPct val="105000"/>
               </a:lnSpc>
@@ -2530,14 +2981,14 @@
       </p:sp>
       <p:pic>
         <p:nvPicPr>
-          <p:cNvPr id="11" name="Image 1" descr="preencoded.png"/>
+          <p:cNvPr id="11" name="Image 1" descr="preencoded.png">    </p:cNvPr>
           <p:cNvPicPr>
             <a:picLocks noChangeAspect="1"/>
           </p:cNvPicPr>
           <p:nvPr/>
         </p:nvPicPr>
         <p:blipFill>
-          <a:blip r:embed="rId4"/>
+          <a:blip r:embed="rId2"/>
           <a:stretch>
             <a:fillRect/>
           </a:stretch>
@@ -2573,7 +3024,7 @@
           <a:bodyPr wrap="square" rtlCol="0" anchor="ctr"/>
           <a:lstStyle/>
           <a:p>
-            <a:pPr marL="0" indent="0">
+            <a:pPr indent="0" marL="0">
               <a:buNone/>
             </a:pPr>
             <a:r>
@@ -2612,7 +3063,7 @@
           <a:bodyPr wrap="square" rtlCol="0" anchor="ctr"/>
           <a:lstStyle/>
           <a:p>
-            <a:pPr marL="0" indent="0">
+            <a:pPr indent="0" marL="0">
               <a:lnSpc>
                 <a:spcPct val="105000"/>
               </a:lnSpc>
@@ -2682,14 +3133,14 @@
       </p:sp>
       <p:pic>
         <p:nvPicPr>
-          <p:cNvPr id="16" name="Image 2" descr="preencoded.png"/>
+          <p:cNvPr id="16" name="Image 2" descr="preencoded.png">    </p:cNvPr>
           <p:cNvPicPr>
             <a:picLocks noChangeAspect="1"/>
           </p:cNvPicPr>
           <p:nvPr/>
         </p:nvPicPr>
         <p:blipFill>
-          <a:blip r:embed="rId5"/>
+          <a:blip r:embed="rId3"/>
           <a:stretch>
             <a:fillRect/>
           </a:stretch>
@@ -2725,7 +3176,7 @@
           <a:bodyPr wrap="square" rtlCol="0" anchor="ctr"/>
           <a:lstStyle/>
           <a:p>
-            <a:pPr marL="0" indent="0">
+            <a:pPr indent="0" marL="0">
               <a:buNone/>
             </a:pPr>
             <a:r>
@@ -2764,7 +3215,7 @@
           <a:bodyPr wrap="square" rtlCol="0" anchor="ctr"/>
           <a:lstStyle/>
           <a:p>
-            <a:pPr marL="0" indent="0">
+            <a:pPr indent="0" marL="0">
               <a:lnSpc>
                 <a:spcPct val="105000"/>
               </a:lnSpc>
@@ -2833,11 +3284,11 @@
           <a:bodyPr wrap="square" rtlCol="0" anchor="ctr"/>
           <a:lstStyle/>
           <a:p>
-            <a:pPr marL="0" indent="0">
-              <a:buNone/>
-            </a:pPr>
-            <a:r>
-              <a:rPr lang="en-US" sz="1150" b="1" kern="0" spc="300" dirty="0">
+            <a:pPr indent="0" marL="0">
+              <a:buNone/>
+            </a:pPr>
+            <a:r>
+              <a:rPr lang="en-US" sz="1150" b="1" spc="300" kern="0" dirty="0">
                 <a:solidFill>
                   <a:srgbClr val="F59E0B"/>
                 </a:solidFill>
@@ -2872,7 +3323,7 @@
           <a:bodyPr wrap="square" rtlCol="0" anchor="ctr"/>
           <a:lstStyle/>
           <a:p>
-            <a:pPr marL="0" indent="0">
+            <a:pPr indent="0" marL="0">
               <a:buNone/>
             </a:pPr>
             <a:r>
@@ -2898,7 +3349,7 @@
         </p:nvSpPr>
         <p:spPr>
           <a:xfrm>
-            <a:off x="7999268" y="3156572"/>
+            <a:off x="7360920" y="3035808"/>
             <a:ext cx="1280160" cy="1005840"/>
           </a:xfrm>
           <a:prstGeom prst="rect">
@@ -2911,7 +3362,7 @@
           <a:bodyPr wrap="square" rtlCol="0" anchor="ctr"/>
           <a:lstStyle/>
           <a:p>
-            <a:pPr marL="0" indent="0" algn="l">
+            <a:pPr algn="l" indent="0" marL="0">
               <a:buNone/>
             </a:pPr>
             <a:r>
@@ -2950,7 +3401,7 @@
           <a:bodyPr wrap="square" rtlCol="0" anchor="ctr"/>
           <a:lstStyle/>
           <a:p>
-            <a:pPr marL="0" indent="0">
+            <a:pPr indent="0" marL="0">
               <a:lnSpc>
                 <a:spcPct val="102000"/>
               </a:lnSpc>
@@ -2967,30 +3418,16 @@
               </a:rPr>
               <a:t>signals</a:t>
             </a:r>
-            <a:endParaRPr lang="en-US" sz="2000" dirty="0"/>
-          </a:p>
-          <a:p>
-            <a:pPr marL="0" indent="0">
+            <a:pPr indent="0" marL="0">
               <a:lnSpc>
                 <a:spcPct val="102000"/>
               </a:lnSpc>
               <a:buNone/>
             </a:pPr>
-            <a:r>
-              <a:rPr lang="en-US" sz="1400" dirty="0">
-                <a:solidFill>
-                  <a:srgbClr val="94A3B8"/>
-                </a:solidFill>
-                <a:latin typeface="Calibri" pitchFamily="34" charset="0"/>
-                <a:ea typeface="Calibri" pitchFamily="34" charset="-122"/>
-                <a:cs typeface="Calibri" pitchFamily="34" charset="-120"/>
-              </a:rPr>
-              <a:t>fused into one</a:t>
-            </a:r>
             <a:endParaRPr lang="en-US" sz="2000" dirty="0"/>
           </a:p>
           <a:p>
-            <a:pPr marL="0" indent="0">
+            <a:pPr indent="0" marL="0">
               <a:lnSpc>
                 <a:spcPct val="102000"/>
               </a:lnSpc>
@@ -3005,10 +3442,30 @@
                 <a:ea typeface="Calibri" pitchFamily="34" charset="-122"/>
                 <a:cs typeface="Calibri" pitchFamily="34" charset="-120"/>
               </a:rPr>
-              <a:t>0-100 score</a:t>
+              <a:t>fused into one</a:t>
             </a:r>
             <a:endParaRPr lang="en-US" sz="2000" dirty="0"/>
           </a:p>
+          <a:p>
+            <a:pPr indent="0" marL="0">
+              <a:lnSpc>
+                <a:spcPct val="102000"/>
+              </a:lnSpc>
+              <a:buNone/>
+            </a:pPr>
+            <a:r>
+              <a:rPr lang="en-US" sz="1400" dirty="0">
+                <a:solidFill>
+                  <a:srgbClr val="94A3B8"/>
+                </a:solidFill>
+                <a:latin typeface="Calibri" pitchFamily="34" charset="0"/>
+                <a:ea typeface="Calibri" pitchFamily="34" charset="-122"/>
+                <a:cs typeface="Calibri" pitchFamily="34" charset="-120"/>
+              </a:rPr>
+              <a:t>0-100 read</a:t>
+            </a:r>
+            <a:endParaRPr lang="en-US" sz="2000" dirty="0"/>
+          </a:p>
         </p:txBody>
       </p:sp>
       <p:sp>
@@ -3019,7 +3476,7 @@
         </p:nvSpPr>
         <p:spPr>
           <a:xfrm>
-            <a:off x="7406640" y="4431391"/>
+            <a:off x="7406640" y="4526280"/>
             <a:ext cx="3703320" cy="640080"/>
           </a:xfrm>
           <a:prstGeom prst="rect">
@@ -3032,7 +3489,7 @@
           <a:bodyPr wrap="square" rtlCol="0" anchor="ctr"/>
           <a:lstStyle/>
           <a:p>
-            <a:pPr marL="0" indent="0" algn="ctr">
+            <a:pPr indent="0" marL="0">
               <a:lnSpc>
                 <a:spcPct val="110000"/>
               </a:lnSpc>
@@ -3047,28 +3504,7 @@
                 <a:ea typeface="Calibri" pitchFamily="34" charset="-122"/>
                 <a:cs typeface="Calibri" pitchFamily="34" charset="-120"/>
               </a:rPr>
-              <a:t>Financials  .  Credit ratings  .  Leadership  .  </a:t>
-            </a:r>
-            <a:br>
-              <a:rPr lang="en-US" sz="1250" dirty="0">
-                <a:solidFill>
-                  <a:srgbClr val="FFFFFF"/>
-                </a:solidFill>
-                <a:latin typeface="Calibri" pitchFamily="34" charset="0"/>
-                <a:ea typeface="Calibri" pitchFamily="34" charset="-122"/>
-                <a:cs typeface="Calibri" pitchFamily="34" charset="-120"/>
-              </a:rPr>
-            </a:br>
-            <a:r>
-              <a:rPr lang="en-US" sz="1250" dirty="0">
-                <a:solidFill>
-                  <a:srgbClr val="FFFFFF"/>
-                </a:solidFill>
-                <a:latin typeface="Calibri" pitchFamily="34" charset="0"/>
-                <a:ea typeface="Calibri" pitchFamily="34" charset="-122"/>
-                <a:cs typeface="Calibri" pitchFamily="34" charset="-120"/>
-              </a:rPr>
-              <a:t>News  .  Hiring  .  Employee sentiment</a:t>
+              <a:t>Financials  .  credit ratings  .  leadership  .  news  .  hiring  .  employee sentiment</a:t>
             </a:r>
             <a:endParaRPr lang="en-US" sz="1250" dirty="0"/>
           </a:p>
@@ -3082,7 +3518,7 @@
         </p:nvSpPr>
         <p:spPr>
           <a:xfrm>
-            <a:off x="7406640" y="5345794"/>
+            <a:off x="7406640" y="5440680"/>
             <a:ext cx="3703320" cy="365760"/>
           </a:xfrm>
           <a:prstGeom prst="rect">
@@ -3095,7 +3531,7 @@
           <a:bodyPr wrap="square" rtlCol="0" anchor="ctr"/>
           <a:lstStyle/>
           <a:p>
-            <a:pPr marL="0" indent="0">
+            <a:pPr indent="0" marL="0">
               <a:buNone/>
             </a:pPr>
             <a:r>
@@ -3129,7 +3565,6 @@
         <a:solidFill>
           <a:srgbClr val="0A1628"/>
         </a:solidFill>
-        <a:effectLst/>
       </p:bgPr>
     </p:bg>
     <p:spTree>
@@ -3167,7 +3602,7 @@
           <a:bodyPr wrap="square" rtlCol="0" anchor="ctr"/>
           <a:lstStyle/>
           <a:p>
-            <a:pPr marL="0" indent="0">
+            <a:pPr indent="0" marL="0">
               <a:buNone/>
             </a:pPr>
             <a:r>
@@ -3181,6 +3616,9 @@
               </a:rPr>
               <a:t>One live pipeline, </a:t>
             </a:r>
+            <a:pPr indent="0" marL="0">
+              <a:buNone/>
+            </a:pPr>
             <a:r>
               <a:rPr lang="en-US" sz="3300" b="1" dirty="0">
                 <a:solidFill>
@@ -3217,7 +3655,7 @@
           <a:bodyPr wrap="square" rtlCol="0" anchor="ctr"/>
           <a:lstStyle/>
           <a:p>
-            <a:pPr marL="0" indent="0">
+            <a:pPr indent="0" marL="0">
               <a:buNone/>
             </a:pPr>
             <a:r>
@@ -3284,14 +3722,14 @@
       </p:sp>
       <p:pic>
         <p:nvPicPr>
-          <p:cNvPr id="6" name="Image 0" descr="preencoded.png"/>
+          <p:cNvPr id="6" name="Image 0" descr="preencoded.png">    </p:cNvPr>
           <p:cNvPicPr>
             <a:picLocks noChangeAspect="1"/>
           </p:cNvPicPr>
           <p:nvPr/>
         </p:nvPicPr>
         <p:blipFill>
-          <a:blip r:embed="rId3"/>
+          <a:blip r:embed="rId1"/>
           <a:stretch>
             <a:fillRect/>
           </a:stretch>
@@ -3327,7 +3765,7 @@
           <a:bodyPr wrap="square" rtlCol="0" anchor="ctr"/>
           <a:lstStyle/>
           <a:p>
-            <a:pPr marL="0" indent="0">
+            <a:pPr indent="0" marL="0">
               <a:buNone/>
             </a:pPr>
             <a:r>
@@ -3366,7 +3804,7 @@
           <a:bodyPr wrap="square" rtlCol="0" anchor="ctr"/>
           <a:lstStyle/>
           <a:p>
-            <a:pPr marL="0" indent="0" algn="ctr">
+            <a:pPr algn="ctr" indent="0" marL="0">
               <a:buNone/>
             </a:pPr>
             <a:r>
@@ -3405,7 +3843,7 @@
           <a:bodyPr wrap="square" rtlCol="0" anchor="ctr"/>
           <a:lstStyle/>
           <a:p>
-            <a:pPr marL="0" indent="0" algn="ctr">
+            <a:pPr algn="ctr" indent="0" marL="0">
               <a:lnSpc>
                 <a:spcPct val="103000"/>
               </a:lnSpc>
@@ -3428,14 +3866,14 @@
       </p:sp>
       <p:pic>
         <p:nvPicPr>
-          <p:cNvPr id="10" name="Image 1" descr="preencoded.png"/>
+          <p:cNvPr id="10" name="Image 1" descr="preencoded.png">    </p:cNvPr>
           <p:cNvPicPr>
             <a:picLocks noChangeAspect="1"/>
           </p:cNvPicPr>
           <p:nvPr/>
         </p:nvPicPr>
         <p:blipFill>
-          <a:blip r:embed="rId4"/>
+          <a:blip r:embed="rId2"/>
           <a:stretch>
             <a:fillRect/>
           </a:stretch>
@@ -3499,14 +3937,14 @@
       </p:sp>
       <p:pic>
         <p:nvPicPr>
-          <p:cNvPr id="13" name="Image 2" descr="preencoded.png"/>
+          <p:cNvPr id="13" name="Image 2" descr="preencoded.png">    </p:cNvPr>
           <p:cNvPicPr>
             <a:picLocks noChangeAspect="1"/>
           </p:cNvPicPr>
           <p:nvPr/>
         </p:nvPicPr>
         <p:blipFill>
-          <a:blip r:embed="rId5"/>
+          <a:blip r:embed="rId3"/>
           <a:stretch>
             <a:fillRect/>
           </a:stretch>
@@ -3542,7 +3980,7 @@
           <a:bodyPr wrap="square" rtlCol="0" anchor="ctr"/>
           <a:lstStyle/>
           <a:p>
-            <a:pPr marL="0" indent="0">
+            <a:pPr indent="0" marL="0">
               <a:buNone/>
             </a:pPr>
             <a:r>
@@ -3581,7 +4019,7 @@
           <a:bodyPr wrap="square" rtlCol="0" anchor="ctr"/>
           <a:lstStyle/>
           <a:p>
-            <a:pPr marL="0" indent="0" algn="ctr">
+            <a:pPr algn="ctr" indent="0" marL="0">
               <a:buNone/>
             </a:pPr>
             <a:r>
@@ -3620,7 +4058,7 @@
           <a:bodyPr wrap="square" rtlCol="0" anchor="ctr"/>
           <a:lstStyle/>
           <a:p>
-            <a:pPr marL="0" indent="0" algn="ctr">
+            <a:pPr algn="ctr" indent="0" marL="0">
               <a:lnSpc>
                 <a:spcPct val="103000"/>
               </a:lnSpc>
@@ -3643,7 +4081,7 @@
       </p:sp>
       <p:pic>
         <p:nvPicPr>
-          <p:cNvPr id="17" name="Image 3" descr="preencoded.png"/>
+          <p:cNvPr id="17" name="Image 3" descr="preencoded.png">    </p:cNvPr>
           <p:cNvPicPr>
             <a:picLocks noChangeAspect="1"/>
           </p:cNvPicPr>
@@ -3714,14 +4152,14 @@
       </p:sp>
       <p:pic>
         <p:nvPicPr>
-          <p:cNvPr id="20" name="Image 4" descr="preencoded.png"/>
+          <p:cNvPr id="20" name="Image 4" descr="preencoded.png">    </p:cNvPr>
           <p:cNvPicPr>
             <a:picLocks noChangeAspect="1"/>
           </p:cNvPicPr>
           <p:nvPr/>
         </p:nvPicPr>
         <p:blipFill>
-          <a:blip r:embed="rId6"/>
+          <a:blip r:embed="rId5"/>
           <a:stretch>
             <a:fillRect/>
           </a:stretch>
@@ -3757,7 +4195,7 @@
           <a:bodyPr wrap="square" rtlCol="0" anchor="ctr"/>
           <a:lstStyle/>
           <a:p>
-            <a:pPr marL="0" indent="0">
+            <a:pPr indent="0" marL="0">
               <a:buNone/>
             </a:pPr>
             <a:r>
@@ -3796,7 +4234,7 @@
           <a:bodyPr wrap="square" rtlCol="0" anchor="ctr"/>
           <a:lstStyle/>
           <a:p>
-            <a:pPr marL="0" indent="0" algn="ctr">
+            <a:pPr algn="ctr" indent="0" marL="0">
               <a:buNone/>
             </a:pPr>
             <a:r>
@@ -3835,7 +4273,7 @@
           <a:bodyPr wrap="square" rtlCol="0" anchor="ctr"/>
           <a:lstStyle/>
           <a:p>
-            <a:pPr marL="0" indent="0" algn="ctr">
+            <a:pPr algn="ctr" indent="0" marL="0">
               <a:lnSpc>
                 <a:spcPct val="103000"/>
               </a:lnSpc>
@@ -3858,14 +4296,14 @@
       </p:sp>
       <p:pic>
         <p:nvPicPr>
-          <p:cNvPr id="24" name="Image 5" descr="preencoded.png"/>
+          <p:cNvPr id="24" name="Image 5" descr="preencoded.png">    </p:cNvPr>
           <p:cNvPicPr>
             <a:picLocks noChangeAspect="1"/>
           </p:cNvPicPr>
           <p:nvPr/>
         </p:nvPicPr>
         <p:blipFill>
-          <a:blip r:embed="rId4"/>
+          <a:blip r:embed="rId6"/>
           <a:stretch>
             <a:fillRect/>
           </a:stretch>
@@ -3929,7 +4367,7 @@
       </p:sp>
       <p:pic>
         <p:nvPicPr>
-          <p:cNvPr id="27" name="Image 6" descr="preencoded.png"/>
+          <p:cNvPr id="27" name="Image 6" descr="preencoded.png">    </p:cNvPr>
           <p:cNvPicPr>
             <a:picLocks noChangeAspect="1"/>
           </p:cNvPicPr>
@@ -3972,7 +4410,7 @@
           <a:bodyPr wrap="square" rtlCol="0" anchor="ctr"/>
           <a:lstStyle/>
           <a:p>
-            <a:pPr marL="0" indent="0">
+            <a:pPr indent="0" marL="0">
               <a:buNone/>
             </a:pPr>
             <a:r>
@@ -4011,7 +4449,7 @@
           <a:bodyPr wrap="square" rtlCol="0" anchor="ctr"/>
           <a:lstStyle/>
           <a:p>
-            <a:pPr marL="0" indent="0" algn="ctr">
+            <a:pPr algn="ctr" indent="0" marL="0">
               <a:buNone/>
             </a:pPr>
             <a:r>
@@ -4050,7 +4488,7 @@
           <a:bodyPr wrap="square" rtlCol="0" anchor="ctr"/>
           <a:lstStyle/>
           <a:p>
-            <a:pPr marL="0" indent="0" algn="ctr">
+            <a:pPr algn="ctr" indent="0" marL="0">
               <a:lnSpc>
                 <a:spcPct val="103000"/>
               </a:lnSpc>
@@ -4106,7 +4544,7 @@
         </p:nvSpPr>
         <p:spPr>
           <a:xfrm>
-            <a:off x="868680" y="4841319"/>
+            <a:off x="868680" y="4910328"/>
             <a:ext cx="3657600" cy="274320"/>
           </a:xfrm>
           <a:prstGeom prst="rect">
@@ -4119,11 +4557,11 @@
           <a:bodyPr wrap="square" rtlCol="0" anchor="ctr"/>
           <a:lstStyle/>
           <a:p>
-            <a:pPr marL="0" indent="0">
-              <a:buNone/>
-            </a:pPr>
-            <a:r>
-              <a:rPr lang="en-US" sz="1100" b="1" kern="0" spc="300" dirty="0">
+            <a:pPr indent="0" marL="0">
+              <a:buNone/>
+            </a:pPr>
+            <a:r>
+              <a:rPr lang="en-US" sz="1100" b="1" spc="300" kern="0" dirty="0">
                 <a:solidFill>
                   <a:srgbClr val="F59E0B"/>
                 </a:solidFill>
@@ -4159,7 +4597,7 @@
       </p:sp>
       <p:pic>
         <p:nvPicPr>
-          <p:cNvPr id="34" name="Image 7" descr="preencoded.png"/>
+          <p:cNvPr id="34" name="Image 7" descr="preencoded.png">    </p:cNvPr>
           <p:cNvPicPr>
             <a:picLocks noChangeAspect="1"/>
           </p:cNvPicPr>
@@ -4189,7 +4627,7 @@
         </p:nvSpPr>
         <p:spPr>
           <a:xfrm>
-            <a:off x="1554480" y="5188790"/>
+            <a:off x="1554480" y="5257800"/>
             <a:ext cx="4572000" cy="777240"/>
           </a:xfrm>
           <a:prstGeom prst="rect">
@@ -4202,7 +4640,7 @@
           <a:bodyPr wrap="square" rtlCol="0" anchor="t"/>
           <a:lstStyle/>
           <a:p>
-            <a:pPr marL="0" indent="0">
+            <a:pPr indent="0" marL="0">
               <a:lnSpc>
                 <a:spcPct val="102000"/>
               </a:lnSpc>
@@ -4219,6 +4657,12 @@
               </a:rPr>
               <a:t>Financial leg</a:t>
             </a:r>
+            <a:pPr indent="0" marL="0">
+              <a:lnSpc>
+                <a:spcPct val="102000"/>
+              </a:lnSpc>
+              <a:buNone/>
+            </a:pPr>
             <a:r>
               <a:rPr lang="en-US" sz="1250" dirty="0">
                 <a:solidFill>
@@ -4279,7 +4723,7 @@
       </p:sp>
       <p:pic>
         <p:nvPicPr>
-          <p:cNvPr id="38" name="Image 8" descr="preencoded.png"/>
+          <p:cNvPr id="38" name="Image 8" descr="preencoded.png">    </p:cNvPr>
           <p:cNvPicPr>
             <a:picLocks noChangeAspect="1"/>
           </p:cNvPicPr>
@@ -4309,7 +4753,7 @@
         </p:nvSpPr>
         <p:spPr>
           <a:xfrm>
-            <a:off x="7406640" y="5118743"/>
+            <a:off x="7406640" y="5239512"/>
             <a:ext cx="4160520" cy="868680"/>
           </a:xfrm>
           <a:prstGeom prst="rect">
@@ -4322,7 +4766,7 @@
           <a:bodyPr wrap="square" rtlCol="0" anchor="t"/>
           <a:lstStyle/>
           <a:p>
-            <a:pPr marL="0" indent="0">
+            <a:pPr indent="0" marL="0">
               <a:lnSpc>
                 <a:spcPct val="100000"/>
               </a:lnSpc>
@@ -4339,6 +4783,12 @@
               </a:rPr>
               <a:t>Market leg</a:t>
             </a:r>
+            <a:pPr indent="0" marL="0">
+              <a:lnSpc>
+                <a:spcPct val="100000"/>
+              </a:lnSpc>
+              <a:buNone/>
+            </a:pPr>
             <a:r>
               <a:rPr lang="en-US" sz="1200" dirty="0">
                 <a:solidFill>
@@ -4370,7 +4820,6 @@
         <a:solidFill>
           <a:srgbClr val="0A1628"/>
         </a:solidFill>
-        <a:effectLst/>
       </p:bgPr>
     </p:bg>
     <p:spTree>
@@ -4408,7 +4857,7 @@
           <a:bodyPr wrap="square" rtlCol="0" anchor="ctr"/>
           <a:lstStyle/>
           <a:p>
-            <a:pPr marL="0" indent="0">
+            <a:pPr indent="0" marL="0">
               <a:buNone/>
             </a:pPr>
             <a:r>
@@ -4422,6 +4871,9 @@
               </a:rPr>
               <a:t>One </a:t>
             </a:r>
+            <a:pPr indent="0" marL="0">
+              <a:buNone/>
+            </a:pPr>
             <a:r>
               <a:rPr lang="en-US" sz="3300" b="1" dirty="0">
                 <a:solidFill>
@@ -4433,6 +4885,9 @@
               </a:rPr>
               <a:t>comprehensive</a:t>
             </a:r>
+            <a:pPr indent="0" marL="0">
+              <a:buNone/>
+            </a:pPr>
             <a:r>
               <a:rPr lang="en-US" sz="3300" b="1" dirty="0">
                 <a:solidFill>
@@ -4469,7 +4924,7 @@
           <a:bodyPr wrap="square" rtlCol="0" anchor="ctr"/>
           <a:lstStyle/>
           <a:p>
-            <a:pPr marL="0" indent="0">
+            <a:pPr indent="0" marL="0">
               <a:buNone/>
             </a:pPr>
             <a:r>
@@ -4508,7 +4963,7 @@
           <a:bodyPr wrap="square" rtlCol="0" anchor="ctr"/>
           <a:lstStyle/>
           <a:p>
-            <a:pPr marL="0" indent="0">
+            <a:pPr indent="0" marL="0">
               <a:buNone/>
             </a:pPr>
             <a:r>
@@ -4547,7 +5002,7 @@
           <a:bodyPr wrap="square" rtlCol="0" anchor="ctr"/>
           <a:lstStyle/>
           <a:p>
-            <a:pPr marL="0" indent="0">
+            <a:pPr indent="0" marL="0">
               <a:lnSpc>
                 <a:spcPct val="110000"/>
               </a:lnSpc>
@@ -4589,7 +5044,7 @@
           <a:bodyPr wrap="square" rtlCol="0" anchor="ctr"/>
           <a:lstStyle/>
           <a:p>
-            <a:pPr marL="0" indent="0">
+            <a:pPr indent="0" marL="0">
               <a:lnSpc>
                 <a:spcPct val="108000"/>
               </a:lnSpc>
@@ -4619,7 +5074,7 @@
         <p:spPr>
           <a:xfrm>
             <a:off x="777240" y="4553712"/>
-            <a:ext cx="3776472" cy="1976484"/>
+            <a:ext cx="3977640" cy="1554480"/>
           </a:xfrm>
           <a:prstGeom prst="roundRect">
             <a:avLst>
@@ -4645,8 +5100,8 @@
         </p:nvSpPr>
         <p:spPr>
           <a:xfrm>
-            <a:off x="1004812" y="4672066"/>
-            <a:ext cx="2782192" cy="256032"/>
+            <a:off x="987552" y="4663440"/>
+            <a:ext cx="3566160" cy="256032"/>
           </a:xfrm>
           <a:prstGeom prst="rect">
             <a:avLst/>
@@ -4658,11 +5113,11 @@
           <a:bodyPr wrap="square" rtlCol="0" anchor="ctr"/>
           <a:lstStyle/>
           <a:p>
-            <a:pPr marL="0" indent="0">
-              <a:buNone/>
-            </a:pPr>
-            <a:r>
-              <a:rPr lang="en-US" sz="1400" b="1" kern="0" spc="200" dirty="0">
+            <a:pPr indent="0" marL="0">
+              <a:buNone/>
+            </a:pPr>
+            <a:r>
+              <a:rPr lang="en-US" sz="1050" b="1" spc="200" kern="0" dirty="0">
                 <a:solidFill>
                   <a:srgbClr val="F59E0B"/>
                 </a:solidFill>
@@ -4672,7 +5127,7 @@
               </a:rPr>
               <a:t>FIVE CASES, FIVE SECTORS</a:t>
             </a:r>
-            <a:endParaRPr lang="en-US" sz="1400" dirty="0"/>
+            <a:endParaRPr lang="en-US" sz="1050" dirty="0"/>
           </a:p>
         </p:txBody>
       </p:sp>
@@ -4684,8 +5139,8 @@
         </p:nvSpPr>
         <p:spPr>
           <a:xfrm>
-            <a:off x="1013429" y="5040240"/>
-            <a:ext cx="3368789" cy="1231164"/>
+            <a:off x="987552" y="4919472"/>
+            <a:ext cx="3566160" cy="1133856"/>
           </a:xfrm>
           <a:prstGeom prst="rect">
             <a:avLst/>
@@ -4697,14 +5152,14 @@
           <a:bodyPr wrap="square" rtlCol="0" anchor="t"/>
           <a:lstStyle/>
           <a:p>
-            <a:pPr marL="0" indent="0">
+            <a:pPr indent="0" marL="0">
               <a:lnSpc>
                 <a:spcPct val="103000"/>
               </a:lnSpc>
               <a:buNone/>
             </a:pPr>
             <a:r>
-              <a:rPr lang="en-US" sz="1400" b="1" dirty="0">
+              <a:rPr lang="en-US" sz="1050" b="1" dirty="0">
                 <a:solidFill>
                   <a:srgbClr val="FFFFFF"/>
                 </a:solidFill>
@@ -4714,8 +5169,14 @@
               </a:rPr>
               <a:t>Unitech </a:t>
             </a:r>
-            <a:r>
-              <a:rPr lang="en-US" sz="1400" dirty="0">
+            <a:pPr indent="0" marL="0">
+              <a:lnSpc>
+                <a:spcPct val="103000"/>
+              </a:lnSpc>
+              <a:buNone/>
+            </a:pPr>
+            <a:r>
+              <a:rPr lang="en-US" sz="1050" dirty="0">
                 <a:solidFill>
                   <a:srgbClr val="94A3B8"/>
                 </a:solidFill>
@@ -4725,8 +5186,31 @@
               </a:rPr>
               <a:t>(real estate), </a:t>
             </a:r>
-            <a:br>
-              <a:rPr lang="en-US" sz="1400" dirty="0">
+            <a:pPr indent="0" marL="0">
+              <a:lnSpc>
+                <a:spcPct val="103000"/>
+              </a:lnSpc>
+              <a:buNone/>
+            </a:pPr>
+            <a:r>
+              <a:rPr lang="en-US" sz="1050" b="1" dirty="0">
+                <a:solidFill>
+                  <a:srgbClr val="FFFFFF"/>
+                </a:solidFill>
+                <a:latin typeface="Calibri" pitchFamily="34" charset="0"/>
+                <a:ea typeface="Calibri" pitchFamily="34" charset="-122"/>
+                <a:cs typeface="Calibri" pitchFamily="34" charset="-120"/>
+              </a:rPr>
+              <a:t>Future Retail </a:t>
+            </a:r>
+            <a:pPr indent="0" marL="0">
+              <a:lnSpc>
+                <a:spcPct val="103000"/>
+              </a:lnSpc>
+              <a:buNone/>
+            </a:pPr>
+            <a:r>
+              <a:rPr lang="en-US" sz="1050" dirty="0">
                 <a:solidFill>
                   <a:srgbClr val="94A3B8"/>
                 </a:solidFill>
@@ -4734,9 +5218,16 @@
                 <a:ea typeface="Calibri" pitchFamily="34" charset="-122"/>
                 <a:cs typeface="Calibri" pitchFamily="34" charset="-120"/>
               </a:rPr>
-            </a:br>
-            <a:r>
-              <a:rPr lang="en-US" sz="1400" b="1" dirty="0">
+              <a:t>(retail), </a:t>
+            </a:r>
+            <a:pPr indent="0" marL="0">
+              <a:lnSpc>
+                <a:spcPct val="103000"/>
+              </a:lnSpc>
+              <a:buNone/>
+            </a:pPr>
+            <a:r>
+              <a:rPr lang="en-US" sz="1050" b="1" dirty="0">
                 <a:solidFill>
                   <a:srgbClr val="FFFFFF"/>
                 </a:solidFill>
@@ -4744,10 +5235,16 @@
                 <a:ea typeface="Calibri" pitchFamily="34" charset="-122"/>
                 <a:cs typeface="Calibri" pitchFamily="34" charset="-120"/>
               </a:rPr>
-              <a:t>Future Retail </a:t>
-            </a:r>
-            <a:r>
-              <a:rPr lang="en-US" sz="1400" dirty="0">
+              <a:t>Reliance Communications </a:t>
+            </a:r>
+            <a:pPr indent="0" marL="0">
+              <a:lnSpc>
+                <a:spcPct val="103000"/>
+              </a:lnSpc>
+              <a:buNone/>
+            </a:pPr>
+            <a:r>
+              <a:rPr lang="en-US" sz="1050" dirty="0">
                 <a:solidFill>
                   <a:srgbClr val="94A3B8"/>
                 </a:solidFill>
@@ -4755,10 +5252,33 @@
                 <a:ea typeface="Calibri" pitchFamily="34" charset="-122"/>
                 <a:cs typeface="Calibri" pitchFamily="34" charset="-120"/>
               </a:rPr>
-              <a:t>(retail), </a:t>
-            </a:r>
-            <a:br>
-              <a:rPr lang="en-US" sz="1400" dirty="0">
+              <a:t>(telecom), </a:t>
+            </a:r>
+            <a:pPr indent="0" marL="0">
+              <a:lnSpc>
+                <a:spcPct val="103000"/>
+              </a:lnSpc>
+              <a:buNone/>
+            </a:pPr>
+            <a:r>
+              <a:rPr lang="en-US" sz="1050" b="1" dirty="0">
+                <a:solidFill>
+                  <a:srgbClr val="FFFFFF"/>
+                </a:solidFill>
+                <a:latin typeface="Calibri" pitchFamily="34" charset="0"/>
+                <a:ea typeface="Calibri" pitchFamily="34" charset="-122"/>
+                <a:cs typeface="Calibri" pitchFamily="34" charset="-120"/>
+              </a:rPr>
+              <a:t>Jaiprakash Associates </a:t>
+            </a:r>
+            <a:pPr indent="0" marL="0">
+              <a:lnSpc>
+                <a:spcPct val="103000"/>
+              </a:lnSpc>
+              <a:buNone/>
+            </a:pPr>
+            <a:r>
+              <a:rPr lang="en-US" sz="1050" dirty="0">
                 <a:solidFill>
                   <a:srgbClr val="94A3B8"/>
                 </a:solidFill>
@@ -4766,9 +5286,16 @@
                 <a:ea typeface="Calibri" pitchFamily="34" charset="-122"/>
                 <a:cs typeface="Calibri" pitchFamily="34" charset="-120"/>
               </a:rPr>
-            </a:br>
-            <a:r>
-              <a:rPr lang="en-US" sz="1400" b="1" dirty="0">
+              <a:t>(infrastructure), </a:t>
+            </a:r>
+            <a:pPr indent="0" marL="0">
+              <a:lnSpc>
+                <a:spcPct val="103000"/>
+              </a:lnSpc>
+              <a:buNone/>
+            </a:pPr>
+            <a:r>
+              <a:rPr lang="en-US" sz="1050" b="1" dirty="0">
                 <a:solidFill>
                   <a:srgbClr val="FFFFFF"/>
                 </a:solidFill>
@@ -4776,10 +5303,16 @@
                 <a:ea typeface="Calibri" pitchFamily="34" charset="-122"/>
                 <a:cs typeface="Calibri" pitchFamily="34" charset="-120"/>
               </a:rPr>
-              <a:t>Reliance Communications </a:t>
-            </a:r>
-            <a:r>
-              <a:rPr lang="en-US" sz="1400" dirty="0">
+              <a:t>Suzlon </a:t>
+            </a:r>
+            <a:pPr indent="0" marL="0">
+              <a:lnSpc>
+                <a:spcPct val="103000"/>
+              </a:lnSpc>
+              <a:buNone/>
+            </a:pPr>
+            <a:r>
+              <a:rPr lang="en-US" sz="1050" dirty="0">
                 <a:solidFill>
                   <a:srgbClr val="94A3B8"/>
                 </a:solidFill>
@@ -4787,94 +5320,9 @@
                 <a:ea typeface="Calibri" pitchFamily="34" charset="-122"/>
                 <a:cs typeface="Calibri" pitchFamily="34" charset="-120"/>
               </a:rPr>
-              <a:t>(telecom), </a:t>
-            </a:r>
-            <a:br>
-              <a:rPr lang="en-US" sz="1400" dirty="0">
-                <a:solidFill>
-                  <a:srgbClr val="94A3B8"/>
-                </a:solidFill>
-                <a:latin typeface="Calibri" pitchFamily="34" charset="0"/>
-                <a:ea typeface="Calibri" pitchFamily="34" charset="-122"/>
-                <a:cs typeface="Calibri" pitchFamily="34" charset="-120"/>
-              </a:rPr>
-            </a:br>
-            <a:r>
-              <a:rPr lang="en-US" sz="1400" b="1" dirty="0">
-                <a:solidFill>
-                  <a:srgbClr val="FFFFFF"/>
-                </a:solidFill>
-                <a:latin typeface="Calibri" pitchFamily="34" charset="0"/>
-                <a:ea typeface="Calibri" pitchFamily="34" charset="-122"/>
-                <a:cs typeface="Calibri" pitchFamily="34" charset="-120"/>
-              </a:rPr>
-              <a:t>Jaiprakash Associates </a:t>
-            </a:r>
-            <a:r>
-              <a:rPr lang="en-US" sz="1400" dirty="0">
-                <a:solidFill>
-                  <a:srgbClr val="94A3B8"/>
-                </a:solidFill>
-                <a:latin typeface="Calibri" pitchFamily="34" charset="0"/>
-                <a:ea typeface="Calibri" pitchFamily="34" charset="-122"/>
-                <a:cs typeface="Calibri" pitchFamily="34" charset="-120"/>
-              </a:rPr>
-              <a:t>(infrastructure), </a:t>
-            </a:r>
-            <a:br>
-              <a:rPr lang="en-US" sz="1400" dirty="0">
-                <a:solidFill>
-                  <a:srgbClr val="94A3B8"/>
-                </a:solidFill>
-                <a:latin typeface="Calibri" pitchFamily="34" charset="0"/>
-                <a:ea typeface="Calibri" pitchFamily="34" charset="-122"/>
-                <a:cs typeface="Calibri" pitchFamily="34" charset="-120"/>
-              </a:rPr>
-            </a:br>
-            <a:r>
-              <a:rPr lang="en-US" sz="1400" b="1" dirty="0">
-                <a:solidFill>
-                  <a:srgbClr val="FFFFFF"/>
-                </a:solidFill>
-                <a:latin typeface="Calibri" pitchFamily="34" charset="0"/>
-                <a:ea typeface="Calibri" pitchFamily="34" charset="-122"/>
-                <a:cs typeface="Calibri" pitchFamily="34" charset="-120"/>
-              </a:rPr>
-              <a:t>Suzlon </a:t>
-            </a:r>
-            <a:r>
-              <a:rPr lang="en-US" sz="1400" dirty="0">
-                <a:solidFill>
-                  <a:srgbClr val="94A3B8"/>
-                </a:solidFill>
-                <a:latin typeface="Calibri" pitchFamily="34" charset="0"/>
-                <a:ea typeface="Calibri" pitchFamily="34" charset="-122"/>
-                <a:cs typeface="Calibri" pitchFamily="34" charset="-120"/>
-              </a:rPr>
-              <a:t>(renewables - a recovery). </a:t>
-            </a:r>
-            <a:br>
-              <a:rPr lang="en-US" sz="1400" dirty="0">
-                <a:solidFill>
-                  <a:srgbClr val="94A3B8"/>
-                </a:solidFill>
-                <a:latin typeface="Calibri" pitchFamily="34" charset="0"/>
-                <a:ea typeface="Calibri" pitchFamily="34" charset="-122"/>
-                <a:cs typeface="Calibri" pitchFamily="34" charset="-120"/>
-              </a:rPr>
-            </a:br>
-            <a:r>
-              <a:rPr lang="en-US" sz="1400" dirty="0">
-                <a:solidFill>
-                  <a:srgbClr val="94A3B8"/>
-                </a:solidFill>
-                <a:latin typeface="Calibri" pitchFamily="34" charset="0"/>
-                <a:ea typeface="Calibri" pitchFamily="34" charset="-122"/>
-                <a:cs typeface="Calibri" pitchFamily="34" charset="-120"/>
-              </a:rPr>
-              <a:t>Real financials, real events.</a:t>
-            </a:r>
-            <a:endParaRPr lang="en-US" sz="1400" dirty="0"/>
+              <a:t>(renewables - a recovery). Real financials, real events.</a:t>
+            </a:r>
+            <a:endParaRPr lang="en-US" sz="1050" dirty="0"/>
           </a:p>
         </p:txBody>
       </p:sp>
@@ -4899,7 +5347,7 @@
           <a:bodyPr wrap="square" rtlCol="0" anchor="ctr"/>
           <a:lstStyle/>
           <a:p>
-            <a:pPr marL="0" indent="0">
+            <a:pPr indent="0" marL="0">
               <a:buNone/>
             </a:pPr>
             <a:r>
@@ -4919,7 +5367,7 @@
       </p:sp>
       <p:graphicFrame>
         <p:nvGraphicFramePr>
-          <p:cNvPr id="11" name="Chart 0"/>
+          <p:cNvPr id="11" name="Chart 0" descr=""/>
           <p:cNvGraphicFramePr/>
           <p:nvPr/>
         </p:nvGraphicFramePr>
@@ -4927,9 +5375,9 @@
           <a:off x="5349240" y="2194560"/>
           <a:ext cx="6263640" cy="3611880"/>
         </p:xfrm>
-        <a:graphic>
+        <a:graphic xmlns:a="http://schemas.openxmlformats.org/drawingml/2006/main">
           <a:graphicData uri="http://schemas.openxmlformats.org/drawingml/2006/chart">
-            <c:chart xmlns:c="http://schemas.openxmlformats.org/drawingml/2006/chart" xmlns:r="http://schemas.openxmlformats.org/officeDocument/2006/relationships" r:id="rId3"/>
+            <c:chart xmlns:c="http://schemas.openxmlformats.org/drawingml/2006/chart" r:id="rId1"/>
           </a:graphicData>
         </a:graphic>
       </p:graphicFrame>
@@ -4954,7 +5402,7 @@
           <a:bodyPr wrap="square" rtlCol="0" anchor="ctr"/>
           <a:lstStyle/>
           <a:p>
-            <a:pPr marL="0" indent="0">
+            <a:pPr indent="0" marL="0">
               <a:buNone/>
             </a:pPr>
             <a:r>
@@ -4988,7 +5436,6 @@
         <a:solidFill>
           <a:srgbClr val="0A1628"/>
         </a:solidFill>
-        <a:effectLst/>
       </p:bgPr>
     </p:bg>
     <p:spTree>
@@ -5013,8 +5460,8 @@
         </p:nvSpPr>
         <p:spPr>
           <a:xfrm>
-            <a:off x="777240" y="548640"/>
-            <a:ext cx="10698480" cy="685800"/>
+            <a:off x="777240" y="502920"/>
+            <a:ext cx="10698480" cy="640080"/>
           </a:xfrm>
           <a:prstGeom prst="rect">
             <a:avLst/>
@@ -5026,7 +5473,7 @@
           <a:bodyPr wrap="square" rtlCol="0" anchor="ctr"/>
           <a:lstStyle/>
           <a:p>
-            <a:pPr marL="0" indent="0">
+            <a:pPr indent="0" marL="0">
               <a:buNone/>
             </a:pPr>
             <a:r>
@@ -5038,8 +5485,11 @@
                 <a:ea typeface="Calibri" pitchFamily="34" charset="-122"/>
                 <a:cs typeface="Calibri" pitchFamily="34" charset="-120"/>
               </a:rPr>
-              <a:t>A live risk analyst for </a:t>
-            </a:r>
+              <a:t>What the numbers </a:t>
+            </a:r>
+            <a:pPr indent="0" marL="0">
+              <a:buNone/>
+            </a:pPr>
             <a:r>
               <a:rPr lang="en-US" sz="3300" b="1" dirty="0">
                 <a:solidFill>
@@ -5049,7 +5499,7 @@
                 <a:ea typeface="Calibri" pitchFamily="34" charset="-122"/>
                 <a:cs typeface="Calibri" pitchFamily="34" charset="-120"/>
               </a:rPr>
-              <a:t>every name in your book</a:t>
+              <a:t>actually say</a:t>
             </a:r>
             <a:endParaRPr lang="en-US" sz="3300" dirty="0"/>
           </a:p>
@@ -5063,8 +5513,8 @@
         </p:nvSpPr>
         <p:spPr>
           <a:xfrm>
-            <a:off x="795528" y="1316736"/>
-            <a:ext cx="10515600" cy="365760"/>
+            <a:off x="795528" y="1225296"/>
+            <a:ext cx="10607040" cy="365760"/>
           </a:xfrm>
           <a:prstGeom prst="rect">
             <a:avLst/>
@@ -5076,7 +5526,7 @@
           <a:bodyPr wrap="square" rtlCol="0" anchor="ctr"/>
           <a:lstStyle/>
           <a:p>
-            <a:pPr marL="0" indent="0">
+            <a:pPr indent="0" marL="0">
               <a:buNone/>
             </a:pPr>
             <a:r>
@@ -5088,7 +5538,7 @@
                 <a:ea typeface="Calibri" pitchFamily="34" charset="-122"/>
                 <a:cs typeface="Calibri" pitchFamily="34" charset="-120"/>
               </a:rPr>
-              <a:t>Faster credit reviews   .   earlier watch-list triage   .   one defensible number, on demand.</a:t>
+              <a:t>Four findings, each reproducible from the notebooks - a measurement, not a story.</a:t>
             </a:r>
             <a:endParaRPr lang="en-US" sz="1550" dirty="0"/>
           </a:p>
@@ -5102,12 +5552,203 @@
         </p:nvSpPr>
         <p:spPr>
           <a:xfrm>
-            <a:off x="777240" y="2057400"/>
-            <a:ext cx="2542032" cy="2331720"/>
+            <a:off x="777240" y="1874520"/>
+            <a:ext cx="5349240" cy="1874520"/>
           </a:xfrm>
           <a:prstGeom prst="roundRect">
             <a:avLst>
-              <a:gd name="adj" fmla="val 3529"/>
+              <a:gd name="adj" fmla="val 4390"/>
+            </a:avLst>
+          </a:prstGeom>
+          <a:solidFill>
+            <a:srgbClr val="152740"/>
+          </a:solidFill>
+          <a:ln w="12700">
+            <a:solidFill>
+              <a:srgbClr val="1E3350"/>
+            </a:solidFill>
+            <a:prstDash val="solid"/>
+          </a:ln>
+        </p:spPr>
+      </p:sp>
+      <p:sp>
+        <p:nvSpPr>
+          <p:cNvPr id="5" name="Shape 3"/>
+          <p:cNvSpPr/>
+          <p:nvPr/>
+        </p:nvSpPr>
+        <p:spPr>
+          <a:xfrm>
+            <a:off x="1033272" y="2130552"/>
+            <a:ext cx="566928" cy="566928"/>
+          </a:xfrm>
+          <a:prstGeom prst="ellipse">
+            <a:avLst/>
+          </a:prstGeom>
+          <a:solidFill>
+            <a:srgbClr val="F59E0B"/>
+          </a:solidFill>
+          <a:ln/>
+        </p:spPr>
+      </p:sp>
+      <p:pic>
+        <p:nvPicPr>
+          <p:cNvPr id="6" name="Image 0" descr="preencoded.png">    </p:cNvPr>
+          <p:cNvPicPr>
+            <a:picLocks noChangeAspect="1"/>
+          </p:cNvPicPr>
+          <p:nvPr/>
+        </p:nvPicPr>
+        <p:blipFill>
+          <a:blip r:embed="rId1"/>
+          <a:stretch>
+            <a:fillRect/>
+          </a:stretch>
+        </p:blipFill>
+        <p:spPr>
+          <a:xfrm>
+            <a:off x="1169335" y="2266615"/>
+            <a:ext cx="294803" cy="294803"/>
+          </a:xfrm>
+          <a:prstGeom prst="rect">
+            <a:avLst/>
+          </a:prstGeom>
+        </p:spPr>
+      </p:pic>
+      <p:sp>
+        <p:nvSpPr>
+          <p:cNvPr id="7" name="Text 4"/>
+          <p:cNvSpPr/>
+          <p:nvPr/>
+        </p:nvSpPr>
+        <p:spPr>
+          <a:xfrm>
+            <a:off x="1737360" y="2039112"/>
+            <a:ext cx="4206240" cy="566928"/>
+          </a:xfrm>
+          <a:prstGeom prst="rect">
+            <a:avLst/>
+          </a:prstGeom>
+          <a:noFill/>
+          <a:ln/>
+        </p:spPr>
+        <p:txBody>
+          <a:bodyPr wrap="square" rtlCol="0" anchor="ctr"/>
+          <a:lstStyle/>
+          <a:p>
+            <a:pPr indent="0" marL="0">
+              <a:buNone/>
+            </a:pPr>
+            <a:r>
+              <a:rPr lang="en-US" sz="3000" b="1" dirty="0">
+                <a:solidFill>
+                  <a:srgbClr val="F59E0B"/>
+                </a:solidFill>
+                <a:latin typeface="Calibri" pitchFamily="34" charset="0"/>
+                <a:ea typeface="Calibri" pitchFamily="34" charset="-122"/>
+                <a:cs typeface="Calibri" pitchFamily="34" charset="-120"/>
+              </a:rPr>
+              <a:t>8 / 9</a:t>
+            </a:r>
+            <a:endParaRPr lang="en-US" sz="3000" dirty="0"/>
+          </a:p>
+        </p:txBody>
+      </p:sp>
+      <p:sp>
+        <p:nvSpPr>
+          <p:cNvPr id="8" name="Text 5"/>
+          <p:cNvSpPr/>
+          <p:nvPr/>
+        </p:nvSpPr>
+        <p:spPr>
+          <a:xfrm>
+            <a:off x="1051560" y="2697480"/>
+            <a:ext cx="4800600" cy="274320"/>
+          </a:xfrm>
+          <a:prstGeom prst="rect">
+            <a:avLst/>
+          </a:prstGeom>
+          <a:noFill/>
+          <a:ln/>
+        </p:spPr>
+        <p:txBody>
+          <a:bodyPr wrap="square" rtlCol="0" anchor="ctr"/>
+          <a:lstStyle/>
+          <a:p>
+            <a:pPr indent="0" marL="0">
+              <a:buNone/>
+            </a:pPr>
+            <a:r>
+              <a:rPr lang="en-US" sz="1300" b="1" dirty="0">
+                <a:solidFill>
+                  <a:srgbClr val="FFFFFF"/>
+                </a:solidFill>
+                <a:latin typeface="Calibri" pitchFamily="34" charset="0"/>
+                <a:ea typeface="Calibri" pitchFamily="34" charset="-122"/>
+                <a:cs typeface="Calibri" pitchFamily="34" charset="-120"/>
+              </a:rPr>
+              <a:t>caught at zero false alarms</a:t>
+            </a:r>
+            <a:endParaRPr lang="en-US" sz="1300" dirty="0"/>
+          </a:p>
+        </p:txBody>
+      </p:sp>
+      <p:sp>
+        <p:nvSpPr>
+          <p:cNvPr id="9" name="Text 6"/>
+          <p:cNvSpPr/>
+          <p:nvPr/>
+        </p:nvSpPr>
+        <p:spPr>
+          <a:xfrm>
+            <a:off x="1051560" y="2971800"/>
+            <a:ext cx="4800600" cy="713232"/>
+          </a:xfrm>
+          <a:prstGeom prst="rect">
+            <a:avLst/>
+          </a:prstGeom>
+          <a:noFill/>
+          <a:ln/>
+        </p:spPr>
+        <p:txBody>
+          <a:bodyPr wrap="square" rtlCol="0" anchor="ctr"/>
+          <a:lstStyle/>
+          <a:p>
+            <a:pPr indent="0" marL="0">
+              <a:lnSpc>
+                <a:spcPct val="105000"/>
+              </a:lnSpc>
+              <a:buNone/>
+            </a:pPr>
+            <a:r>
+              <a:rPr lang="en-US" sz="1150" dirty="0">
+                <a:solidFill>
+                  <a:srgbClr val="94A3B8"/>
+                </a:solidFill>
+                <a:latin typeface="Calibri" pitchFamily="34" charset="0"/>
+                <a:ea typeface="Calibri" pitchFamily="34" charset="-122"/>
+                <a:cs typeface="Calibri" pitchFamily="34" charset="-120"/>
+              </a:rPr>
+              <a:t>Across 12 healthy blue-chips and 9 firms that failed, a threshold that flags NO healthy name still catches 8 of the 9 failures. Median distress probability 0.83 vs 0.13 (leave-one-out ROC-AUC 0.97).</a:t>
+            </a:r>
+            <a:endParaRPr lang="en-US" sz="1150" dirty="0"/>
+          </a:p>
+        </p:txBody>
+      </p:sp>
+      <p:sp>
+        <p:nvSpPr>
+          <p:cNvPr id="10" name="Shape 7"/>
+          <p:cNvSpPr/>
+          <p:nvPr/>
+        </p:nvSpPr>
+        <p:spPr>
+          <a:xfrm>
+            <a:off x="6812280" y="1874520"/>
+            <a:ext cx="5349240" cy="1874520"/>
+          </a:xfrm>
+          <a:prstGeom prst="roundRect">
+            <a:avLst>
+              <a:gd name="adj" fmla="val 4390"/>
             </a:avLst>
           </a:prstGeom>
           <a:solidFill>
@@ -5123,14 +5764,14 @@
       </p:sp>
       <p:sp>
         <p:nvSpPr>
-          <p:cNvPr id="5" name="Shape 3"/>
-          <p:cNvSpPr/>
-          <p:nvPr/>
-        </p:nvSpPr>
-        <p:spPr>
-          <a:xfrm>
-            <a:off x="1033272" y="2331720"/>
-            <a:ext cx="640080" cy="640080"/>
+          <p:cNvPr id="11" name="Shape 8"/>
+          <p:cNvSpPr/>
+          <p:nvPr/>
+        </p:nvSpPr>
+        <p:spPr>
+          <a:xfrm>
+            <a:off x="7068312" y="2130552"/>
+            <a:ext cx="566928" cy="566928"/>
           </a:xfrm>
           <a:prstGeom prst="ellipse">
             <a:avLst/>
@@ -5143,22 +5784,22 @@
       </p:sp>
       <p:pic>
         <p:nvPicPr>
-          <p:cNvPr id="6" name="Image 0" descr="preencoded.png"/>
+          <p:cNvPr id="12" name="Image 1" descr="preencoded.png">    </p:cNvPr>
           <p:cNvPicPr>
             <a:picLocks noChangeAspect="1"/>
           </p:cNvPicPr>
           <p:nvPr/>
         </p:nvPicPr>
         <p:blipFill>
-          <a:blip r:embed="rId3"/>
+          <a:blip r:embed="rId2"/>
           <a:stretch>
             <a:fillRect/>
           </a:stretch>
         </p:blipFill>
         <p:spPr>
           <a:xfrm>
-            <a:off x="1186891" y="2485339"/>
-            <a:ext cx="332842" cy="332842"/>
+            <a:off x="7204375" y="2266615"/>
+            <a:ext cx="294803" cy="294803"/>
           </a:xfrm>
           <a:prstGeom prst="rect">
             <a:avLst/>
@@ -5167,14 +5808,14 @@
       </p:pic>
       <p:sp>
         <p:nvSpPr>
-          <p:cNvPr id="7" name="Text 4"/>
-          <p:cNvSpPr/>
-          <p:nvPr/>
-        </p:nvSpPr>
-        <p:spPr>
-          <a:xfrm>
-            <a:off x="996696" y="3081528"/>
-            <a:ext cx="2139696" cy="365760"/>
+          <p:cNvPr id="13" name="Text 9"/>
+          <p:cNvSpPr/>
+          <p:nvPr/>
+        </p:nvSpPr>
+        <p:spPr>
+          <a:xfrm>
+            <a:off x="7772400" y="2039112"/>
+            <a:ext cx="4206240" cy="566928"/>
           </a:xfrm>
           <a:prstGeom prst="rect">
             <a:avLst/>
@@ -5186,11 +5827,50 @@
           <a:bodyPr wrap="square" rtlCol="0" anchor="ctr"/>
           <a:lstStyle/>
           <a:p>
-            <a:pPr marL="0" indent="0">
-              <a:buNone/>
-            </a:pPr>
-            <a:r>
-              <a:rPr lang="en-US" sz="1550" b="1" dirty="0">
+            <a:pPr indent="0" marL="0">
+              <a:buNone/>
+            </a:pPr>
+            <a:r>
+              <a:rPr lang="en-US" sz="3000" b="1" dirty="0">
+                <a:solidFill>
+                  <a:srgbClr val="F59E0B"/>
+                </a:solidFill>
+                <a:latin typeface="Calibri" pitchFamily="34" charset="0"/>
+                <a:ea typeface="Calibri" pitchFamily="34" charset="-122"/>
+                <a:cs typeface="Calibri" pitchFamily="34" charset="-120"/>
+              </a:rPr>
+              <a:t>27 months</a:t>
+            </a:r>
+            <a:endParaRPr lang="en-US" sz="3000" dirty="0"/>
+          </a:p>
+        </p:txBody>
+      </p:sp>
+      <p:sp>
+        <p:nvSpPr>
+          <p:cNvPr id="14" name="Text 10"/>
+          <p:cNvSpPr/>
+          <p:nvPr/>
+        </p:nvSpPr>
+        <p:spPr>
+          <a:xfrm>
+            <a:off x="7086600" y="2697480"/>
+            <a:ext cx="4800600" cy="274320"/>
+          </a:xfrm>
+          <a:prstGeom prst="rect">
+            <a:avLst/>
+          </a:prstGeom>
+          <a:noFill/>
+          <a:ln/>
+        </p:spPr>
+        <p:txBody>
+          <a:bodyPr wrap="square" rtlCol="0" anchor="ctr"/>
+          <a:lstStyle/>
+          <a:p>
+            <a:pPr indent="0" marL="0">
+              <a:buNone/>
+            </a:pPr>
+            <a:r>
+              <a:rPr lang="en-US" sz="1300" b="1" dirty="0">
                 <a:solidFill>
                   <a:srgbClr val="FFFFFF"/>
                 </a:solidFill>
@@ -5198,22 +5878,22 @@
                 <a:ea typeface="Calibri" pitchFamily="34" charset="-122"/>
                 <a:cs typeface="Calibri" pitchFamily="34" charset="-120"/>
               </a:rPr>
-              <a:t>Comprehensive</a:t>
-            </a:r>
-            <a:endParaRPr lang="en-US" sz="1550" dirty="0"/>
-          </a:p>
-        </p:txBody>
-      </p:sp>
-      <p:sp>
-        <p:nvSpPr>
-          <p:cNvPr id="8" name="Text 5"/>
-          <p:cNvSpPr/>
-          <p:nvPr/>
-        </p:nvSpPr>
-        <p:spPr>
-          <a:xfrm>
-            <a:off x="996696" y="3429000"/>
-            <a:ext cx="2139696" cy="822960"/>
+              <a:t>median early warning</a:t>
+            </a:r>
+            <a:endParaRPr lang="en-US" sz="1300" dirty="0"/>
+          </a:p>
+        </p:txBody>
+      </p:sp>
+      <p:sp>
+        <p:nvSpPr>
+          <p:cNvPr id="15" name="Text 11"/>
+          <p:cNvSpPr/>
+          <p:nvPr/>
+        </p:nvSpPr>
+        <p:spPr>
+          <a:xfrm>
+            <a:off x="7086600" y="2971800"/>
+            <a:ext cx="4800600" cy="713232"/>
           </a:xfrm>
           <a:prstGeom prst="rect">
             <a:avLst/>
@@ -5225,14 +5905,14 @@
           <a:bodyPr wrap="square" rtlCol="0" anchor="ctr"/>
           <a:lstStyle/>
           <a:p>
-            <a:pPr marL="0" indent="0">
+            <a:pPr indent="0" marL="0">
               <a:lnSpc>
-                <a:spcPct val="106000"/>
+                <a:spcPct val="105000"/>
               </a:lnSpc>
               <a:buNone/>
             </a:pPr>
             <a:r>
-              <a:rPr lang="en-US" sz="1250" dirty="0">
+              <a:rPr lang="en-US" sz="1150" dirty="0">
                 <a:solidFill>
                   <a:srgbClr val="94A3B8"/>
                 </a:solidFill>
@@ -5240,26 +5920,26 @@
                 <a:ea typeface="Calibri" pitchFamily="34" charset="-122"/>
                 <a:cs typeface="Calibri" pitchFamily="34" charset="-120"/>
               </a:rPr>
-              <a:t>Six inputs - financials, ratings, leadership, news, hiring, sentiment - in one score.</a:t>
-            </a:r>
-            <a:endParaRPr lang="en-US" sz="1250" dirty="0"/>
-          </a:p>
-        </p:txBody>
-      </p:sp>
-      <p:sp>
-        <p:nvSpPr>
-          <p:cNvPr id="9" name="Shape 6"/>
-          <p:cNvSpPr/>
-          <p:nvPr/>
-        </p:nvSpPr>
-        <p:spPr>
-          <a:xfrm>
-            <a:off x="3538728" y="2057400"/>
-            <a:ext cx="2542032" cy="2331720"/>
+              <a:t>The comprehensive score crosses into high risk a median 27 months before insolvency - 6 months earlier than Altman. Unitech: 26 months, where Altman never warned in time.</a:t>
+            </a:r>
+            <a:endParaRPr lang="en-US" sz="1150" dirty="0"/>
+          </a:p>
+        </p:txBody>
+      </p:sp>
+      <p:sp>
+        <p:nvSpPr>
+          <p:cNvPr id="16" name="Shape 12"/>
+          <p:cNvSpPr/>
+          <p:nvPr/>
+        </p:nvSpPr>
+        <p:spPr>
+          <a:xfrm>
+            <a:off x="777240" y="3959352"/>
+            <a:ext cx="5349240" cy="1874520"/>
           </a:xfrm>
           <a:prstGeom prst="roundRect">
             <a:avLst>
-              <a:gd name="adj" fmla="val 3529"/>
+              <a:gd name="adj" fmla="val 4390"/>
             </a:avLst>
           </a:prstGeom>
           <a:solidFill>
@@ -5275,14 +5955,14 @@
       </p:sp>
       <p:sp>
         <p:nvSpPr>
-          <p:cNvPr id="10" name="Shape 7"/>
-          <p:cNvSpPr/>
-          <p:nvPr/>
-        </p:nvSpPr>
-        <p:spPr>
-          <a:xfrm>
-            <a:off x="3794760" y="2331720"/>
-            <a:ext cx="640080" cy="640080"/>
+          <p:cNvPr id="17" name="Shape 13"/>
+          <p:cNvSpPr/>
+          <p:nvPr/>
+        </p:nvSpPr>
+        <p:spPr>
+          <a:xfrm>
+            <a:off x="1033272" y="4215384"/>
+            <a:ext cx="566928" cy="566928"/>
           </a:xfrm>
           <a:prstGeom prst="ellipse">
             <a:avLst/>
@@ -5295,22 +5975,22 @@
       </p:sp>
       <p:pic>
         <p:nvPicPr>
-          <p:cNvPr id="11" name="Image 1" descr="preencoded.png"/>
+          <p:cNvPr id="18" name="Image 2" descr="preencoded.png">    </p:cNvPr>
           <p:cNvPicPr>
             <a:picLocks noChangeAspect="1"/>
           </p:cNvPicPr>
           <p:nvPr/>
         </p:nvPicPr>
         <p:blipFill>
-          <a:blip r:embed="rId4"/>
+          <a:blip r:embed="rId3"/>
           <a:stretch>
             <a:fillRect/>
           </a:stretch>
         </p:blipFill>
         <p:spPr>
           <a:xfrm>
-            <a:off x="3948379" y="2485339"/>
-            <a:ext cx="332842" cy="332842"/>
+            <a:off x="1169335" y="4351447"/>
+            <a:ext cx="294803" cy="294803"/>
           </a:xfrm>
           <a:prstGeom prst="rect">
             <a:avLst/>
@@ -5319,14 +5999,14 @@
       </p:pic>
       <p:sp>
         <p:nvSpPr>
-          <p:cNvPr id="12" name="Text 8"/>
-          <p:cNvSpPr/>
-          <p:nvPr/>
-        </p:nvSpPr>
-        <p:spPr>
-          <a:xfrm>
-            <a:off x="3758184" y="3081528"/>
-            <a:ext cx="2139696" cy="365760"/>
+          <p:cNvPr id="19" name="Text 14"/>
+          <p:cNvSpPr/>
+          <p:nvPr/>
+        </p:nvSpPr>
+        <p:spPr>
+          <a:xfrm>
+            <a:off x="1737360" y="4123944"/>
+            <a:ext cx="4206240" cy="566928"/>
           </a:xfrm>
           <a:prstGeom prst="rect">
             <a:avLst/>
@@ -5338,11 +6018,50 @@
           <a:bodyPr wrap="square" rtlCol="0" anchor="ctr"/>
           <a:lstStyle/>
           <a:p>
-            <a:pPr marL="0" indent="0">
-              <a:buNone/>
-            </a:pPr>
-            <a:r>
-              <a:rPr lang="en-US" sz="1550" b="1" dirty="0">
+            <a:pPr indent="0" marL="0">
+              <a:buNone/>
+            </a:pPr>
+            <a:r>
+              <a:rPr lang="en-US" sz="3000" b="1" dirty="0">
+                <a:solidFill>
+                  <a:srgbClr val="F59E0B"/>
+                </a:solidFill>
+                <a:latin typeface="Calibri" pitchFamily="34" charset="0"/>
+                <a:ea typeface="Calibri" pitchFamily="34" charset="-122"/>
+                <a:cs typeface="Calibri" pitchFamily="34" charset="-120"/>
+              </a:rPr>
+              <a:t>76 -&gt; 78</a:t>
+            </a:r>
+            <a:endParaRPr lang="en-US" sz="3000" dirty="0"/>
+          </a:p>
+        </p:txBody>
+      </p:sp>
+      <p:sp>
+        <p:nvSpPr>
+          <p:cNvPr id="20" name="Text 15"/>
+          <p:cNvSpPr/>
+          <p:nvPr/>
+        </p:nvSpPr>
+        <p:spPr>
+          <a:xfrm>
+            <a:off x="1051560" y="4782312"/>
+            <a:ext cx="4800600" cy="274320"/>
+          </a:xfrm>
+          <a:prstGeom prst="rect">
+            <a:avLst/>
+          </a:prstGeom>
+          <a:noFill/>
+          <a:ln/>
+        </p:spPr>
+        <p:txBody>
+          <a:bodyPr wrap="square" rtlCol="0" anchor="ctr"/>
+          <a:lstStyle/>
+          <a:p>
+            <a:pPr indent="0" marL="0">
+              <a:buNone/>
+            </a:pPr>
+            <a:r>
+              <a:rPr lang="en-US" sz="1300" b="1" dirty="0">
                 <a:solidFill>
                   <a:srgbClr val="FFFFFF"/>
                 </a:solidFill>
@@ -5350,22 +6069,22 @@
                 <a:ea typeface="Calibri" pitchFamily="34" charset="-122"/>
                 <a:cs typeface="Calibri" pitchFamily="34" charset="-120"/>
               </a:rPr>
-              <a:t>Live &amp; automated</a:t>
-            </a:r>
-            <a:endParaRPr lang="en-US" sz="1550" dirty="0"/>
-          </a:p>
-        </p:txBody>
-      </p:sp>
-      <p:sp>
-        <p:nvSpPr>
-          <p:cNvPr id="13" name="Text 9"/>
-          <p:cNvSpPr/>
-          <p:nvPr/>
-        </p:nvSpPr>
-        <p:spPr>
-          <a:xfrm>
-            <a:off x="3758184" y="3429000"/>
-            <a:ext cx="2219922" cy="822960"/>
+              <a:t>the hard-event floor binds</a:t>
+            </a:r>
+            <a:endParaRPr lang="en-US" sz="1300" dirty="0"/>
+          </a:p>
+        </p:txBody>
+      </p:sp>
+      <p:sp>
+        <p:nvSpPr>
+          <p:cNvPr id="21" name="Text 16"/>
+          <p:cNvSpPr/>
+          <p:nvPr/>
+        </p:nvSpPr>
+        <p:spPr>
+          <a:xfrm>
+            <a:off x="1051560" y="5056632"/>
+            <a:ext cx="4800600" cy="713232"/>
           </a:xfrm>
           <a:prstGeom prst="rect">
             <a:avLst/>
@@ -5377,14 +6096,14 @@
           <a:bodyPr wrap="square" rtlCol="0" anchor="ctr"/>
           <a:lstStyle/>
           <a:p>
-            <a:pPr marL="0" indent="0">
+            <a:pPr indent="0" marL="0">
               <a:lnSpc>
-                <a:spcPct val="106000"/>
+                <a:spcPct val="105000"/>
               </a:lnSpc>
               <a:buNone/>
             </a:pPr>
             <a:r>
-              <a:rPr lang="en-US" sz="1250" dirty="0">
+              <a:rPr lang="en-US" sz="1150" dirty="0">
                 <a:solidFill>
                   <a:srgbClr val="94A3B8"/>
                 </a:solidFill>
@@ -5392,26 +6111,26 @@
                 <a:ea typeface="Calibri" pitchFamily="34" charset="-122"/>
                 <a:cs typeface="Calibri" pitchFamily="34" charset="-120"/>
               </a:rPr>
-              <a:t>Any listed company, on demand. No manual searching for every information.</a:t>
-            </a:r>
-            <a:endParaRPr lang="en-US" sz="1250" dirty="0"/>
-          </a:p>
-        </p:txBody>
-      </p:sp>
-      <p:sp>
-        <p:nvSpPr>
-          <p:cNvPr id="14" name="Shape 10"/>
-          <p:cNvSpPr/>
-          <p:nvPr/>
-        </p:nvSpPr>
-        <p:spPr>
-          <a:xfrm>
-            <a:off x="6300216" y="2057400"/>
-            <a:ext cx="2542032" cy="2331720"/>
+              <a:t>SpiceJet's verified auditor exit floors the signal pulse - a fact that softer, tone-based signals cannot average away. It stays inert on the healthy names.</a:t>
+            </a:r>
+            <a:endParaRPr lang="en-US" sz="1150" dirty="0"/>
+          </a:p>
+        </p:txBody>
+      </p:sp>
+      <p:sp>
+        <p:nvSpPr>
+          <p:cNvPr id="22" name="Shape 17"/>
+          <p:cNvSpPr/>
+          <p:nvPr/>
+        </p:nvSpPr>
+        <p:spPr>
+          <a:xfrm>
+            <a:off x="6812280" y="3959352"/>
+            <a:ext cx="5349240" cy="1874520"/>
           </a:xfrm>
           <a:prstGeom prst="roundRect">
             <a:avLst>
-              <a:gd name="adj" fmla="val 3529"/>
+              <a:gd name="adj" fmla="val 4390"/>
             </a:avLst>
           </a:prstGeom>
           <a:solidFill>
@@ -5427,14 +6146,14 @@
       </p:sp>
       <p:sp>
         <p:nvSpPr>
-          <p:cNvPr id="15" name="Shape 11"/>
-          <p:cNvSpPr/>
-          <p:nvPr/>
-        </p:nvSpPr>
-        <p:spPr>
-          <a:xfrm>
-            <a:off x="6556248" y="2331720"/>
-            <a:ext cx="640080" cy="640080"/>
+          <p:cNvPr id="23" name="Shape 18"/>
+          <p:cNvSpPr/>
+          <p:nvPr/>
+        </p:nvSpPr>
+        <p:spPr>
+          <a:xfrm>
+            <a:off x="7068312" y="4215384"/>
+            <a:ext cx="566928" cy="566928"/>
           </a:xfrm>
           <a:prstGeom prst="ellipse">
             <a:avLst/>
@@ -5447,22 +6166,22 @@
       </p:sp>
       <p:pic>
         <p:nvPicPr>
-          <p:cNvPr id="16" name="Image 2" descr="preencoded.png"/>
+          <p:cNvPr id="24" name="Image 3" descr="preencoded.png">    </p:cNvPr>
           <p:cNvPicPr>
             <a:picLocks noChangeAspect="1"/>
           </p:cNvPicPr>
           <p:nvPr/>
         </p:nvPicPr>
         <p:blipFill>
-          <a:blip r:embed="rId5"/>
+          <a:blip r:embed="rId4"/>
           <a:stretch>
             <a:fillRect/>
           </a:stretch>
         </p:blipFill>
         <p:spPr>
           <a:xfrm>
-            <a:off x="6709867" y="2485339"/>
-            <a:ext cx="332842" cy="332842"/>
+            <a:off x="7204375" y="4351447"/>
+            <a:ext cx="294803" cy="294803"/>
           </a:xfrm>
           <a:prstGeom prst="rect">
             <a:avLst/>
@@ -5471,14 +6190,14 @@
       </p:pic>
       <p:sp>
         <p:nvSpPr>
-          <p:cNvPr id="17" name="Text 12"/>
-          <p:cNvSpPr/>
-          <p:nvPr/>
-        </p:nvSpPr>
-        <p:spPr>
-          <a:xfrm>
-            <a:off x="6519672" y="3081528"/>
-            <a:ext cx="2139696" cy="365760"/>
+          <p:cNvPr id="25" name="Text 19"/>
+          <p:cNvSpPr/>
+          <p:nvPr/>
+        </p:nvSpPr>
+        <p:spPr>
+          <a:xfrm>
+            <a:off x="7772400" y="4123944"/>
+            <a:ext cx="4206240" cy="566928"/>
           </a:xfrm>
           <a:prstGeom prst="rect">
             <a:avLst/>
@@ -5490,11 +6209,50 @@
           <a:bodyPr wrap="square" rtlCol="0" anchor="ctr"/>
           <a:lstStyle/>
           <a:p>
-            <a:pPr marL="0" indent="0">
-              <a:buNone/>
-            </a:pPr>
-            <a:r>
-              <a:rPr lang="en-US" sz="1550" b="1" dirty="0">
+            <a:pPr indent="0" marL="0">
+              <a:buNone/>
+            </a:pPr>
+            <a:r>
+              <a:rPr lang="en-US" sz="1900" b="1" dirty="0">
+                <a:solidFill>
+                  <a:srgbClr val="F59E0B"/>
+                </a:solidFill>
+                <a:latin typeface="Calibri" pitchFamily="34" charset="0"/>
+                <a:ea typeface="Calibri" pitchFamily="34" charset="-122"/>
+                <a:cs typeface="Calibri" pitchFamily="34" charset="-120"/>
+              </a:rPr>
+              <a:t>50/50 = 60/40 = 70/30</a:t>
+            </a:r>
+            <a:endParaRPr lang="en-US" sz="1900" dirty="0"/>
+          </a:p>
+        </p:txBody>
+      </p:sp>
+      <p:sp>
+        <p:nvSpPr>
+          <p:cNvPr id="26" name="Text 20"/>
+          <p:cNvSpPr/>
+          <p:nvPr/>
+        </p:nvSpPr>
+        <p:spPr>
+          <a:xfrm>
+            <a:off x="7086600" y="4782312"/>
+            <a:ext cx="4800600" cy="274320"/>
+          </a:xfrm>
+          <a:prstGeom prst="rect">
+            <a:avLst/>
+          </a:prstGeom>
+          <a:noFill/>
+          <a:ln/>
+        </p:spPr>
+        <p:txBody>
+          <a:bodyPr wrap="square" rtlCol="0" anchor="ctr"/>
+          <a:lstStyle/>
+          <a:p>
+            <a:pPr indent="0" marL="0">
+              <a:buNone/>
+            </a:pPr>
+            <a:r>
+              <a:rPr lang="en-US" sz="1300" b="1" dirty="0">
                 <a:solidFill>
                   <a:srgbClr val="FFFFFF"/>
                 </a:solidFill>
@@ -5502,7 +6260,226 @@
                 <a:ea typeface="Calibri" pitchFamily="34" charset="-122"/>
                 <a:cs typeface="Calibri" pitchFamily="34" charset="-120"/>
               </a:rPr>
-              <a:t>Explainable</a:t>
+              <a:t>robust to its weights</a:t>
+            </a:r>
+            <a:endParaRPr lang="en-US" sz="1300" dirty="0"/>
+          </a:p>
+        </p:txBody>
+      </p:sp>
+      <p:sp>
+        <p:nvSpPr>
+          <p:cNvPr id="27" name="Text 21"/>
+          <p:cNvSpPr/>
+          <p:nvPr/>
+        </p:nvSpPr>
+        <p:spPr>
+          <a:xfrm>
+            <a:off x="7086600" y="5056632"/>
+            <a:ext cx="4800600" cy="713232"/>
+          </a:xfrm>
+          <a:prstGeom prst="rect">
+            <a:avLst/>
+          </a:prstGeom>
+          <a:noFill/>
+          <a:ln/>
+        </p:spPr>
+        <p:txBody>
+          <a:bodyPr wrap="square" rtlCol="0" anchor="ctr"/>
+          <a:lstStyle/>
+          <a:p>
+            <a:pPr indent="0" marL="0">
+              <a:lnSpc>
+                <a:spcPct val="105000"/>
+              </a:lnSpc>
+              <a:buNone/>
+            </a:pPr>
+            <a:r>
+              <a:rPr lang="en-US" sz="1150" dirty="0">
+                <a:solidFill>
+                  <a:srgbClr val="94A3B8"/>
+                </a:solidFill>
+                <a:latin typeface="Calibri" pitchFamily="34" charset="0"/>
+                <a:ea typeface="Calibri" pitchFamily="34" charset="-122"/>
+                <a:cs typeface="Calibri" pitchFamily="34" charset="-120"/>
+              </a:rPr>
+              <a:t>The worst-to-best risk ranking of the six tracked names is identical across all three blends - the signals drive the read, not the exact weighting.</a:t>
+            </a:r>
+            <a:endParaRPr lang="en-US" sz="1150" dirty="0"/>
+          </a:p>
+        </p:txBody>
+      </p:sp>
+      <p:sp>
+        <p:nvSpPr>
+          <p:cNvPr id="28" name="Text 22"/>
+          <p:cNvSpPr/>
+          <p:nvPr/>
+        </p:nvSpPr>
+        <p:spPr>
+          <a:xfrm>
+            <a:off x="795528" y="6080760"/>
+            <a:ext cx="10607040" cy="320040"/>
+          </a:xfrm>
+          <a:prstGeom prst="rect">
+            <a:avLst/>
+          </a:prstGeom>
+          <a:noFill/>
+          <a:ln/>
+        </p:spPr>
+        <p:txBody>
+          <a:bodyPr wrap="square" rtlCol="0" anchor="ctr"/>
+          <a:lstStyle/>
+          <a:p>
+            <a:pPr indent="0" marL="0">
+              <a:buNone/>
+            </a:pPr>
+            <a:r>
+              <a:rPr lang="en-US" sz="1200" b="1" dirty="0">
+                <a:solidFill>
+                  <a:srgbClr val="F59E0B"/>
+                </a:solidFill>
+                <a:latin typeface="Calibri" pitchFamily="34" charset="0"/>
+                <a:ea typeface="Calibri" pitchFamily="34" charset="-122"/>
+                <a:cs typeface="Calibri" pitchFamily="34" charset="-120"/>
+              </a:rPr>
+              <a:t>Reproducible:  </a:t>
+            </a:r>
+            <a:pPr indent="0" marL="0">
+              <a:buNone/>
+            </a:pPr>
+            <a:r>
+              <a:rPr lang="en-US" sz="1200" dirty="0">
+                <a:solidFill>
+                  <a:srgbClr val="94A3B8"/>
+                </a:solidFill>
+                <a:latin typeface="Calibri" pitchFamily="34" charset="0"/>
+                <a:ea typeface="Calibri" pitchFamily="34" charset="-122"/>
+                <a:cs typeface="Calibri" pitchFamily="34" charset="-120"/>
+              </a:rPr>
+              <a:t>notebooks/04_findings.ipynb  -  runs on the base requirements, no heavy ML deps.</a:t>
+            </a:r>
+            <a:endParaRPr lang="en-US" sz="1200" dirty="0"/>
+          </a:p>
+        </p:txBody>
+      </p:sp>
+    </p:spTree>
+  </p:cSld>
+  <p:clrMapOvr>
+    <a:masterClrMapping/>
+  </p:clrMapOvr>
+</p:sld>
+</file>
+
+<file path=ppt/slides/slide6.xml><?xml version="1.0" encoding="utf-8"?>
+<p:sld xmlns:a="http://schemas.openxmlformats.org/drawingml/2006/main" xmlns:r="http://schemas.openxmlformats.org/officeDocument/2006/relationships" xmlns:p="http://schemas.openxmlformats.org/presentationml/2006/main">
+  <p:cSld name="Slide 6">
+    <p:bg>
+      <p:bgPr>
+        <a:solidFill>
+          <a:srgbClr val="0A1628"/>
+        </a:solidFill>
+      </p:bgPr>
+    </p:bg>
+    <p:spTree>
+      <p:nvGrpSpPr>
+        <p:cNvPr id="1" name=""/>
+        <p:cNvGrpSpPr/>
+        <p:nvPr/>
+      </p:nvGrpSpPr>
+      <p:grpSpPr>
+        <a:xfrm>
+          <a:off x="0" y="0"/>
+          <a:ext cx="0" cy="0"/>
+          <a:chOff x="0" y="0"/>
+          <a:chExt cx="0" cy="0"/>
+        </a:xfrm>
+      </p:grpSpPr>
+      <p:sp>
+        <p:nvSpPr>
+          <p:cNvPr id="2" name="Text 0"/>
+          <p:cNvSpPr/>
+          <p:nvPr/>
+        </p:nvSpPr>
+        <p:spPr>
+          <a:xfrm>
+            <a:off x="777240" y="548640"/>
+            <a:ext cx="10698480" cy="685800"/>
+          </a:xfrm>
+          <a:prstGeom prst="rect">
+            <a:avLst/>
+          </a:prstGeom>
+          <a:noFill/>
+          <a:ln/>
+        </p:spPr>
+        <p:txBody>
+          <a:bodyPr wrap="square" rtlCol="0" anchor="ctr"/>
+          <a:lstStyle/>
+          <a:p>
+            <a:pPr indent="0" marL="0">
+              <a:buNone/>
+            </a:pPr>
+            <a:r>
+              <a:rPr lang="en-US" sz="3300" b="1" dirty="0">
+                <a:solidFill>
+                  <a:srgbClr val="FFFFFF"/>
+                </a:solidFill>
+                <a:latin typeface="Calibri" pitchFamily="34" charset="0"/>
+                <a:ea typeface="Calibri" pitchFamily="34" charset="-122"/>
+                <a:cs typeface="Calibri" pitchFamily="34" charset="-120"/>
+              </a:rPr>
+              <a:t>A live risk analyst for </a:t>
+            </a:r>
+            <a:pPr indent="0" marL="0">
+              <a:buNone/>
+            </a:pPr>
+            <a:r>
+              <a:rPr lang="en-US" sz="3300" b="1" dirty="0">
+                <a:solidFill>
+                  <a:srgbClr val="F59E0B"/>
+                </a:solidFill>
+                <a:latin typeface="Calibri" pitchFamily="34" charset="0"/>
+                <a:ea typeface="Calibri" pitchFamily="34" charset="-122"/>
+                <a:cs typeface="Calibri" pitchFamily="34" charset="-120"/>
+              </a:rPr>
+              <a:t>every name in your book</a:t>
+            </a:r>
+            <a:endParaRPr lang="en-US" sz="3300" dirty="0"/>
+          </a:p>
+        </p:txBody>
+      </p:sp>
+      <p:sp>
+        <p:nvSpPr>
+          <p:cNvPr id="3" name="Text 1"/>
+          <p:cNvSpPr/>
+          <p:nvPr/>
+        </p:nvSpPr>
+        <p:spPr>
+          <a:xfrm>
+            <a:off x="795528" y="1316736"/>
+            <a:ext cx="10515600" cy="365760"/>
+          </a:xfrm>
+          <a:prstGeom prst="rect">
+            <a:avLst/>
+          </a:prstGeom>
+          <a:noFill/>
+          <a:ln/>
+        </p:spPr>
+        <p:txBody>
+          <a:bodyPr wrap="square" rtlCol="0" anchor="ctr"/>
+          <a:lstStyle/>
+          <a:p>
+            <a:pPr indent="0" marL="0">
+              <a:buNone/>
+            </a:pPr>
+            <a:r>
+              <a:rPr lang="en-US" sz="1550" dirty="0">
+                <a:solidFill>
+                  <a:srgbClr val="94A3B8"/>
+                </a:solidFill>
+                <a:latin typeface="Calibri" pitchFamily="34" charset="0"/>
+                <a:ea typeface="Calibri" pitchFamily="34" charset="-122"/>
+                <a:cs typeface="Calibri" pitchFamily="34" charset="-120"/>
+              </a:rPr>
+              <a:t>Faster credit reviews   .   earlier watch-list triage   .   one defensible number, on demand.</a:t>
             </a:r>
             <a:endParaRPr lang="en-US" sz="1550" dirty="0"/>
           </a:p>
@@ -5510,55 +6487,13 @@
       </p:sp>
       <p:sp>
         <p:nvSpPr>
-          <p:cNvPr id="18" name="Text 13"/>
-          <p:cNvSpPr/>
-          <p:nvPr/>
-        </p:nvSpPr>
-        <p:spPr>
-          <a:xfrm>
-            <a:off x="6519672" y="3429000"/>
-            <a:ext cx="2139696" cy="822960"/>
-          </a:xfrm>
-          <a:prstGeom prst="rect">
-            <a:avLst/>
-          </a:prstGeom>
-          <a:noFill/>
-          <a:ln/>
-        </p:spPr>
-        <p:txBody>
-          <a:bodyPr wrap="square" rtlCol="0" anchor="ctr"/>
-          <a:lstStyle/>
-          <a:p>
-            <a:pPr marL="0" indent="0">
-              <a:lnSpc>
-                <a:spcPct val="106000"/>
-              </a:lnSpc>
-              <a:buNone/>
-            </a:pPr>
-            <a:r>
-              <a:rPr lang="en-US" sz="1250" dirty="0">
-                <a:solidFill>
-                  <a:srgbClr val="94A3B8"/>
-                </a:solidFill>
-                <a:latin typeface="Calibri" pitchFamily="34" charset="0"/>
-                <a:ea typeface="Calibri" pitchFamily="34" charset="-122"/>
-                <a:cs typeface="Calibri" pitchFamily="34" charset="-120"/>
-              </a:rPr>
-              <a:t>Every point traces to a real ratio, rating or headline.</a:t>
-            </a:r>
-            <a:endParaRPr lang="en-US" sz="1250" dirty="0"/>
-          </a:p>
-        </p:txBody>
-      </p:sp>
-      <p:sp>
-        <p:nvSpPr>
-          <p:cNvPr id="19" name="Shape 14"/>
-          <p:cNvSpPr/>
-          <p:nvPr/>
-        </p:nvSpPr>
-        <p:spPr>
-          <a:xfrm>
-            <a:off x="9061704" y="2057400"/>
+          <p:cNvPr id="4" name="Shape 2"/>
+          <p:cNvSpPr/>
+          <p:nvPr/>
+        </p:nvSpPr>
+        <p:spPr>
+          <a:xfrm>
+            <a:off x="777240" y="2057400"/>
             <a:ext cx="2542032" cy="2331720"/>
           </a:xfrm>
           <a:prstGeom prst="roundRect">
@@ -5579,13 +6514,13 @@
       </p:sp>
       <p:sp>
         <p:nvSpPr>
-          <p:cNvPr id="20" name="Shape 15"/>
-          <p:cNvSpPr/>
-          <p:nvPr/>
-        </p:nvSpPr>
-        <p:spPr>
-          <a:xfrm>
-            <a:off x="9317736" y="2331720"/>
+          <p:cNvPr id="5" name="Shape 3"/>
+          <p:cNvSpPr/>
+          <p:nvPr/>
+        </p:nvSpPr>
+        <p:spPr>
+          <a:xfrm>
+            <a:off x="1033272" y="2331720"/>
             <a:ext cx="640080" cy="640080"/>
           </a:xfrm>
           <a:prstGeom prst="ellipse">
@@ -5599,21 +6534,21 @@
       </p:sp>
       <p:pic>
         <p:nvPicPr>
-          <p:cNvPr id="21" name="Image 3" descr="preencoded.png"/>
+          <p:cNvPr id="6" name="Image 0" descr="preencoded.png">    </p:cNvPr>
           <p:cNvPicPr>
             <a:picLocks noChangeAspect="1"/>
           </p:cNvPicPr>
           <p:nvPr/>
         </p:nvPicPr>
         <p:blipFill>
-          <a:blip r:embed="rId6"/>
+          <a:blip r:embed="rId1"/>
           <a:stretch>
             <a:fillRect/>
           </a:stretch>
         </p:blipFill>
         <p:spPr>
           <a:xfrm>
-            <a:off x="9471355" y="2485339"/>
+            <a:off x="1186891" y="2485339"/>
             <a:ext cx="332842" cy="332842"/>
           </a:xfrm>
           <a:prstGeom prst="rect">
@@ -5623,13 +6558,13 @@
       </p:pic>
       <p:sp>
         <p:nvSpPr>
-          <p:cNvPr id="22" name="Text 16"/>
-          <p:cNvSpPr/>
-          <p:nvPr/>
-        </p:nvSpPr>
-        <p:spPr>
-          <a:xfrm>
-            <a:off x="9281160" y="3081528"/>
+          <p:cNvPr id="7" name="Text 4"/>
+          <p:cNvSpPr/>
+          <p:nvPr/>
+        </p:nvSpPr>
+        <p:spPr>
+          <a:xfrm>
+            <a:off x="996696" y="3081528"/>
             <a:ext cx="2139696" cy="365760"/>
           </a:xfrm>
           <a:prstGeom prst="rect">
@@ -5642,7 +6577,7 @@
           <a:bodyPr wrap="square" rtlCol="0" anchor="ctr"/>
           <a:lstStyle/>
           <a:p>
-            <a:pPr marL="0" indent="0">
+            <a:pPr indent="0" marL="0">
               <a:buNone/>
             </a:pPr>
             <a:r>
@@ -5654,7 +6589,7 @@
                 <a:ea typeface="Calibri" pitchFamily="34" charset="-122"/>
                 <a:cs typeface="Calibri" pitchFamily="34" charset="-120"/>
               </a:rPr>
-              <a:t>Proven on real cases</a:t>
+              <a:t>Comprehensive</a:t>
             </a:r>
             <a:endParaRPr lang="en-US" sz="1550" dirty="0"/>
           </a:p>
@@ -5662,13 +6597,13 @@
       </p:sp>
       <p:sp>
         <p:nvSpPr>
-          <p:cNvPr id="23" name="Text 17"/>
-          <p:cNvSpPr/>
-          <p:nvPr/>
-        </p:nvSpPr>
-        <p:spPr>
-          <a:xfrm>
-            <a:off x="9281160" y="3429000"/>
+          <p:cNvPr id="8" name="Text 5"/>
+          <p:cNvSpPr/>
+          <p:nvPr/>
+        </p:nvSpPr>
+        <p:spPr>
+          <a:xfrm>
+            <a:off x="996696" y="3429000"/>
             <a:ext cx="2139696" cy="822960"/>
           </a:xfrm>
           <a:prstGeom prst="rect">
@@ -5681,7 +6616,7 @@
           <a:bodyPr wrap="square" rtlCol="0" anchor="ctr"/>
           <a:lstStyle/>
           <a:p>
-            <a:pPr marL="0" indent="0">
+            <a:pPr indent="0" marL="0">
               <a:lnSpc>
                 <a:spcPct val="106000"/>
               </a:lnSpc>
@@ -5696,6 +6631,462 @@
                 <a:ea typeface="Calibri" pitchFamily="34" charset="-122"/>
                 <a:cs typeface="Calibri" pitchFamily="34" charset="-120"/>
               </a:rPr>
+              <a:t>Six inputs - financials, ratings, leadership, news, hiring, sentiment - in one score.</a:t>
+            </a:r>
+            <a:endParaRPr lang="en-US" sz="1250" dirty="0"/>
+          </a:p>
+        </p:txBody>
+      </p:sp>
+      <p:sp>
+        <p:nvSpPr>
+          <p:cNvPr id="9" name="Shape 6"/>
+          <p:cNvSpPr/>
+          <p:nvPr/>
+        </p:nvSpPr>
+        <p:spPr>
+          <a:xfrm>
+            <a:off x="3538728" y="2057400"/>
+            <a:ext cx="2542032" cy="2331720"/>
+          </a:xfrm>
+          <a:prstGeom prst="roundRect">
+            <a:avLst>
+              <a:gd name="adj" fmla="val 3529"/>
+            </a:avLst>
+          </a:prstGeom>
+          <a:solidFill>
+            <a:srgbClr val="0F1E33"/>
+          </a:solidFill>
+          <a:ln w="12700">
+            <a:solidFill>
+              <a:srgbClr val="1E3350"/>
+            </a:solidFill>
+            <a:prstDash val="solid"/>
+          </a:ln>
+        </p:spPr>
+      </p:sp>
+      <p:sp>
+        <p:nvSpPr>
+          <p:cNvPr id="10" name="Shape 7"/>
+          <p:cNvSpPr/>
+          <p:nvPr/>
+        </p:nvSpPr>
+        <p:spPr>
+          <a:xfrm>
+            <a:off x="3794760" y="2331720"/>
+            <a:ext cx="640080" cy="640080"/>
+          </a:xfrm>
+          <a:prstGeom prst="ellipse">
+            <a:avLst/>
+          </a:prstGeom>
+          <a:solidFill>
+            <a:srgbClr val="F59E0B"/>
+          </a:solidFill>
+          <a:ln/>
+        </p:spPr>
+      </p:sp>
+      <p:pic>
+        <p:nvPicPr>
+          <p:cNvPr id="11" name="Image 1" descr="preencoded.png">    </p:cNvPr>
+          <p:cNvPicPr>
+            <a:picLocks noChangeAspect="1"/>
+          </p:cNvPicPr>
+          <p:nvPr/>
+        </p:nvPicPr>
+        <p:blipFill>
+          <a:blip r:embed="rId2"/>
+          <a:stretch>
+            <a:fillRect/>
+          </a:stretch>
+        </p:blipFill>
+        <p:spPr>
+          <a:xfrm>
+            <a:off x="3948379" y="2485339"/>
+            <a:ext cx="332842" cy="332842"/>
+          </a:xfrm>
+          <a:prstGeom prst="rect">
+            <a:avLst/>
+          </a:prstGeom>
+        </p:spPr>
+      </p:pic>
+      <p:sp>
+        <p:nvSpPr>
+          <p:cNvPr id="12" name="Text 8"/>
+          <p:cNvSpPr/>
+          <p:nvPr/>
+        </p:nvSpPr>
+        <p:spPr>
+          <a:xfrm>
+            <a:off x="3758184" y="3081528"/>
+            <a:ext cx="2139696" cy="365760"/>
+          </a:xfrm>
+          <a:prstGeom prst="rect">
+            <a:avLst/>
+          </a:prstGeom>
+          <a:noFill/>
+          <a:ln/>
+        </p:spPr>
+        <p:txBody>
+          <a:bodyPr wrap="square" rtlCol="0" anchor="ctr"/>
+          <a:lstStyle/>
+          <a:p>
+            <a:pPr indent="0" marL="0">
+              <a:buNone/>
+            </a:pPr>
+            <a:r>
+              <a:rPr lang="en-US" sz="1550" b="1" dirty="0">
+                <a:solidFill>
+                  <a:srgbClr val="FFFFFF"/>
+                </a:solidFill>
+                <a:latin typeface="Calibri" pitchFamily="34" charset="0"/>
+                <a:ea typeface="Calibri" pitchFamily="34" charset="-122"/>
+                <a:cs typeface="Calibri" pitchFamily="34" charset="-120"/>
+              </a:rPr>
+              <a:t>Live &amp; automated</a:t>
+            </a:r>
+            <a:endParaRPr lang="en-US" sz="1550" dirty="0"/>
+          </a:p>
+        </p:txBody>
+      </p:sp>
+      <p:sp>
+        <p:nvSpPr>
+          <p:cNvPr id="13" name="Text 9"/>
+          <p:cNvSpPr/>
+          <p:nvPr/>
+        </p:nvSpPr>
+        <p:spPr>
+          <a:xfrm>
+            <a:off x="3758184" y="3429000"/>
+            <a:ext cx="2139696" cy="822960"/>
+          </a:xfrm>
+          <a:prstGeom prst="rect">
+            <a:avLst/>
+          </a:prstGeom>
+          <a:noFill/>
+          <a:ln/>
+        </p:spPr>
+        <p:txBody>
+          <a:bodyPr wrap="square" rtlCol="0" anchor="ctr"/>
+          <a:lstStyle/>
+          <a:p>
+            <a:pPr indent="0" marL="0">
+              <a:lnSpc>
+                <a:spcPct val="106000"/>
+              </a:lnSpc>
+              <a:buNone/>
+            </a:pPr>
+            <a:r>
+              <a:rPr lang="en-US" sz="1250" dirty="0">
+                <a:solidFill>
+                  <a:srgbClr val="94A3B8"/>
+                </a:solidFill>
+                <a:latin typeface="Calibri" pitchFamily="34" charset="0"/>
+                <a:ea typeface="Calibri" pitchFamily="34" charset="-122"/>
+                <a:cs typeface="Calibri" pitchFamily="34" charset="-120"/>
+              </a:rPr>
+              <a:t>Any listed company, on demand. No manual pull, no waiting on filings.</a:t>
+            </a:r>
+            <a:endParaRPr lang="en-US" sz="1250" dirty="0"/>
+          </a:p>
+        </p:txBody>
+      </p:sp>
+      <p:sp>
+        <p:nvSpPr>
+          <p:cNvPr id="14" name="Shape 10"/>
+          <p:cNvSpPr/>
+          <p:nvPr/>
+        </p:nvSpPr>
+        <p:spPr>
+          <a:xfrm>
+            <a:off x="6300216" y="2057400"/>
+            <a:ext cx="2542032" cy="2331720"/>
+          </a:xfrm>
+          <a:prstGeom prst="roundRect">
+            <a:avLst>
+              <a:gd name="adj" fmla="val 3529"/>
+            </a:avLst>
+          </a:prstGeom>
+          <a:solidFill>
+            <a:srgbClr val="0F1E33"/>
+          </a:solidFill>
+          <a:ln w="12700">
+            <a:solidFill>
+              <a:srgbClr val="1E3350"/>
+            </a:solidFill>
+            <a:prstDash val="solid"/>
+          </a:ln>
+        </p:spPr>
+      </p:sp>
+      <p:sp>
+        <p:nvSpPr>
+          <p:cNvPr id="15" name="Shape 11"/>
+          <p:cNvSpPr/>
+          <p:nvPr/>
+        </p:nvSpPr>
+        <p:spPr>
+          <a:xfrm>
+            <a:off x="6556248" y="2331720"/>
+            <a:ext cx="640080" cy="640080"/>
+          </a:xfrm>
+          <a:prstGeom prst="ellipse">
+            <a:avLst/>
+          </a:prstGeom>
+          <a:solidFill>
+            <a:srgbClr val="F59E0B"/>
+          </a:solidFill>
+          <a:ln/>
+        </p:spPr>
+      </p:sp>
+      <p:pic>
+        <p:nvPicPr>
+          <p:cNvPr id="16" name="Image 2" descr="preencoded.png">    </p:cNvPr>
+          <p:cNvPicPr>
+            <a:picLocks noChangeAspect="1"/>
+          </p:cNvPicPr>
+          <p:nvPr/>
+        </p:nvPicPr>
+        <p:blipFill>
+          <a:blip r:embed="rId3"/>
+          <a:stretch>
+            <a:fillRect/>
+          </a:stretch>
+        </p:blipFill>
+        <p:spPr>
+          <a:xfrm>
+            <a:off x="6709867" y="2485339"/>
+            <a:ext cx="332842" cy="332842"/>
+          </a:xfrm>
+          <a:prstGeom prst="rect">
+            <a:avLst/>
+          </a:prstGeom>
+        </p:spPr>
+      </p:pic>
+      <p:sp>
+        <p:nvSpPr>
+          <p:cNvPr id="17" name="Text 12"/>
+          <p:cNvSpPr/>
+          <p:nvPr/>
+        </p:nvSpPr>
+        <p:spPr>
+          <a:xfrm>
+            <a:off x="6519672" y="3081528"/>
+            <a:ext cx="2139696" cy="365760"/>
+          </a:xfrm>
+          <a:prstGeom prst="rect">
+            <a:avLst/>
+          </a:prstGeom>
+          <a:noFill/>
+          <a:ln/>
+        </p:spPr>
+        <p:txBody>
+          <a:bodyPr wrap="square" rtlCol="0" anchor="ctr"/>
+          <a:lstStyle/>
+          <a:p>
+            <a:pPr indent="0" marL="0">
+              <a:buNone/>
+            </a:pPr>
+            <a:r>
+              <a:rPr lang="en-US" sz="1550" b="1" dirty="0">
+                <a:solidFill>
+                  <a:srgbClr val="FFFFFF"/>
+                </a:solidFill>
+                <a:latin typeface="Calibri" pitchFamily="34" charset="0"/>
+                <a:ea typeface="Calibri" pitchFamily="34" charset="-122"/>
+                <a:cs typeface="Calibri" pitchFamily="34" charset="-120"/>
+              </a:rPr>
+              <a:t>Explainable</a:t>
+            </a:r>
+            <a:endParaRPr lang="en-US" sz="1550" dirty="0"/>
+          </a:p>
+        </p:txBody>
+      </p:sp>
+      <p:sp>
+        <p:nvSpPr>
+          <p:cNvPr id="18" name="Text 13"/>
+          <p:cNvSpPr/>
+          <p:nvPr/>
+        </p:nvSpPr>
+        <p:spPr>
+          <a:xfrm>
+            <a:off x="6519672" y="3429000"/>
+            <a:ext cx="2139696" cy="822960"/>
+          </a:xfrm>
+          <a:prstGeom prst="rect">
+            <a:avLst/>
+          </a:prstGeom>
+          <a:noFill/>
+          <a:ln/>
+        </p:spPr>
+        <p:txBody>
+          <a:bodyPr wrap="square" rtlCol="0" anchor="ctr"/>
+          <a:lstStyle/>
+          <a:p>
+            <a:pPr indent="0" marL="0">
+              <a:lnSpc>
+                <a:spcPct val="106000"/>
+              </a:lnSpc>
+              <a:buNone/>
+            </a:pPr>
+            <a:r>
+              <a:rPr lang="en-US" sz="1250" dirty="0">
+                <a:solidFill>
+                  <a:srgbClr val="94A3B8"/>
+                </a:solidFill>
+                <a:latin typeface="Calibri" pitchFamily="34" charset="0"/>
+                <a:ea typeface="Calibri" pitchFamily="34" charset="-122"/>
+                <a:cs typeface="Calibri" pitchFamily="34" charset="-120"/>
+              </a:rPr>
+              <a:t>Every point traces to a real ratio, rating or headline.</a:t>
+            </a:r>
+            <a:endParaRPr lang="en-US" sz="1250" dirty="0"/>
+          </a:p>
+        </p:txBody>
+      </p:sp>
+      <p:sp>
+        <p:nvSpPr>
+          <p:cNvPr id="19" name="Shape 14"/>
+          <p:cNvSpPr/>
+          <p:nvPr/>
+        </p:nvSpPr>
+        <p:spPr>
+          <a:xfrm>
+            <a:off x="9061704" y="2057400"/>
+            <a:ext cx="2542032" cy="2331720"/>
+          </a:xfrm>
+          <a:prstGeom prst="roundRect">
+            <a:avLst>
+              <a:gd name="adj" fmla="val 3529"/>
+            </a:avLst>
+          </a:prstGeom>
+          <a:solidFill>
+            <a:srgbClr val="0F1E33"/>
+          </a:solidFill>
+          <a:ln w="12700">
+            <a:solidFill>
+              <a:srgbClr val="1E3350"/>
+            </a:solidFill>
+            <a:prstDash val="solid"/>
+          </a:ln>
+        </p:spPr>
+      </p:sp>
+      <p:sp>
+        <p:nvSpPr>
+          <p:cNvPr id="20" name="Shape 15"/>
+          <p:cNvSpPr/>
+          <p:nvPr/>
+        </p:nvSpPr>
+        <p:spPr>
+          <a:xfrm>
+            <a:off x="9317736" y="2331720"/>
+            <a:ext cx="640080" cy="640080"/>
+          </a:xfrm>
+          <a:prstGeom prst="ellipse">
+            <a:avLst/>
+          </a:prstGeom>
+          <a:solidFill>
+            <a:srgbClr val="F59E0B"/>
+          </a:solidFill>
+          <a:ln/>
+        </p:spPr>
+      </p:sp>
+      <p:pic>
+        <p:nvPicPr>
+          <p:cNvPr id="21" name="Image 3" descr="preencoded.png">    </p:cNvPr>
+          <p:cNvPicPr>
+            <a:picLocks noChangeAspect="1"/>
+          </p:cNvPicPr>
+          <p:nvPr/>
+        </p:nvPicPr>
+        <p:blipFill>
+          <a:blip r:embed="rId4"/>
+          <a:stretch>
+            <a:fillRect/>
+          </a:stretch>
+        </p:blipFill>
+        <p:spPr>
+          <a:xfrm>
+            <a:off x="9471355" y="2485339"/>
+            <a:ext cx="332842" cy="332842"/>
+          </a:xfrm>
+          <a:prstGeom prst="rect">
+            <a:avLst/>
+          </a:prstGeom>
+        </p:spPr>
+      </p:pic>
+      <p:sp>
+        <p:nvSpPr>
+          <p:cNvPr id="22" name="Text 16"/>
+          <p:cNvSpPr/>
+          <p:nvPr/>
+        </p:nvSpPr>
+        <p:spPr>
+          <a:xfrm>
+            <a:off x="9281160" y="3081528"/>
+            <a:ext cx="2139696" cy="365760"/>
+          </a:xfrm>
+          <a:prstGeom prst="rect">
+            <a:avLst/>
+          </a:prstGeom>
+          <a:noFill/>
+          <a:ln/>
+        </p:spPr>
+        <p:txBody>
+          <a:bodyPr wrap="square" rtlCol="0" anchor="ctr"/>
+          <a:lstStyle/>
+          <a:p>
+            <a:pPr indent="0" marL="0">
+              <a:buNone/>
+            </a:pPr>
+            <a:r>
+              <a:rPr lang="en-US" sz="1550" b="1" dirty="0">
+                <a:solidFill>
+                  <a:srgbClr val="FFFFFF"/>
+                </a:solidFill>
+                <a:latin typeface="Calibri" pitchFamily="34" charset="0"/>
+                <a:ea typeface="Calibri" pitchFamily="34" charset="-122"/>
+                <a:cs typeface="Calibri" pitchFamily="34" charset="-120"/>
+              </a:rPr>
+              <a:t>Proven on real cases</a:t>
+            </a:r>
+            <a:endParaRPr lang="en-US" sz="1550" dirty="0"/>
+          </a:p>
+        </p:txBody>
+      </p:sp>
+      <p:sp>
+        <p:nvSpPr>
+          <p:cNvPr id="23" name="Text 17"/>
+          <p:cNvSpPr/>
+          <p:nvPr/>
+        </p:nvSpPr>
+        <p:spPr>
+          <a:xfrm>
+            <a:off x="9281160" y="3429000"/>
+            <a:ext cx="2139696" cy="822960"/>
+          </a:xfrm>
+          <a:prstGeom prst="rect">
+            <a:avLst/>
+          </a:prstGeom>
+          <a:noFill/>
+          <a:ln/>
+        </p:spPr>
+        <p:txBody>
+          <a:bodyPr wrap="square" rtlCol="0" anchor="ctr"/>
+          <a:lstStyle/>
+          <a:p>
+            <a:pPr indent="0" marL="0">
+              <a:lnSpc>
+                <a:spcPct val="106000"/>
+              </a:lnSpc>
+              <a:buNone/>
+            </a:pPr>
+            <a:r>
+              <a:rPr lang="en-US" sz="1250" dirty="0">
+                <a:solidFill>
+                  <a:srgbClr val="94A3B8"/>
+                </a:solidFill>
+                <a:latin typeface="Calibri" pitchFamily="34" charset="0"/>
+                <a:ea typeface="Calibri" pitchFamily="34" charset="-122"/>
+                <a:cs typeface="Calibri" pitchFamily="34" charset="-120"/>
+              </a:rPr>
               <a:t>Replayed across five real collapses, in five sectors.</a:t>
             </a:r>
             <a:endParaRPr lang="en-US" sz="1250" dirty="0"/>
@@ -5705,7 +7096,7 @@
       <p:sp>
         <p:nvSpPr>
           <p:cNvPr id="24" name="Shape 18">
-            <a:hlinkClick r:id="rId7" tooltip="Open the live Foresight AI dashboard"/>
+            <a:hlinkClick r:id="rId5" tooltip="Open the live Foresight AI dashboard"/>
           </p:cNvPr>
           <p:cNvSpPr/>
           <p:nvPr/>
@@ -5729,7 +7120,7 @@
       <p:sp>
         <p:nvSpPr>
           <p:cNvPr id="25" name="Text 19">
-            <a:hlinkClick r:id="rId7" tooltip="Open the live Foresight AI dashboard"/>
+            <a:hlinkClick r:id="rId5" tooltip="Open the live Foresight AI dashboard"/>
           </p:cNvPr>
           <p:cNvSpPr/>
           <p:nvPr/>
@@ -5749,7 +7140,7 @@
           <a:bodyPr wrap="square" rtlCol="0" anchor="ctr"/>
           <a:lstStyle/>
           <a:p>
-            <a:pPr marL="0" indent="0" algn="ctr">
+            <a:pPr algn="ctr" indent="0" marL="0">
               <a:buNone/>
             </a:pPr>
             <a:r>
@@ -5760,7 +7151,7 @@
                 <a:latin typeface="Calibri" pitchFamily="34" charset="0"/>
                 <a:ea typeface="Calibri" pitchFamily="34" charset="-122"/>
                 <a:cs typeface="Calibri" pitchFamily="34" charset="-120"/>
-                <a:hlinkClick r:id="rId7" tooltip="Open the live Foresight AI dashboard">
+                <a:hlinkClick r:id="rId5" invalidUrl="" action="" tgtFrame="" tooltip="Open the live Foresight AI dashboard" history="1" highlightClick="0" endSnd="0">
                   <a:extLst>
                     <a:ext uri="{A12FA001-AC4F-418D-AE19-62706E023703}">
                       <ahyp:hlinkClr xmlns:ahyp="http://schemas.microsoft.com/office/drawing/2018/hyperlinkcolor" val="tx"/>
@@ -5768,8 +7159,11 @@
                   </a:extLst>
                 </a:hlinkClick>
               </a:rPr>
-              <a:t>Open the live dashboard: </a:t>
-            </a:r>
+              <a:t>Open the live dashboard   </a:t>
+            </a:r>
+            <a:pPr algn="ctr" indent="0" marL="0">
+              <a:buNone/>
+            </a:pPr>
             <a:r>
               <a:rPr lang="en-US" sz="1900" b="1" u="sng" dirty="0">
                 <a:solidFill>
@@ -5778,7 +7172,7 @@
                 <a:latin typeface="Calibri" pitchFamily="34" charset="0"/>
                 <a:ea typeface="Calibri" pitchFamily="34" charset="-122"/>
                 <a:cs typeface="Calibri" pitchFamily="34" charset="-120"/>
-                <a:hlinkClick r:id="rId7" tooltip="Open the live Foresight AI dashboard">
+                <a:hlinkClick r:id="rId5" invalidUrl="" action="" tgtFrame="" tooltip="Open the live Foresight AI dashboard" history="1" highlightClick="0" endSnd="0">
                   <a:extLst>
                     <a:ext uri="{A12FA001-AC4F-418D-AE19-62706E023703}">
                       <ahyp:hlinkClr xmlns:ahyp="http://schemas.microsoft.com/office/drawing/2018/hyperlinkcolor" val="tx"/>
@@ -5800,7 +7194,7 @@
         </p:nvSpPr>
         <p:spPr>
           <a:xfrm>
-            <a:off x="2505104" y="6217226"/>
+            <a:off x="822960" y="6053328"/>
             <a:ext cx="7315200" cy="320040"/>
           </a:xfrm>
           <a:prstGeom prst="rect">
@@ -5813,7 +7207,7 @@
           <a:bodyPr wrap="square" rtlCol="0" anchor="ctr"/>
           <a:lstStyle/>
           <a:p>
-            <a:pPr marL="0" indent="0" algn="ctr">
+            <a:pPr indent="0" marL="0">
               <a:buNone/>
             </a:pPr>
             <a:r>
@@ -5827,6 +7221,9 @@
               </a:rPr>
               <a:t>Source &amp; notebooks:  </a:t>
             </a:r>
+            <a:pPr indent="0" marL="0">
+              <a:buNone/>
+            </a:pPr>
             <a:r>
               <a:rPr lang="en-US" sz="1300" b="1" u="sng" dirty="0">
                 <a:solidFill>
@@ -5835,7 +7232,7 @@
                 <a:latin typeface="Calibri" pitchFamily="34" charset="0"/>
                 <a:ea typeface="Calibri" pitchFamily="34" charset="-122"/>
                 <a:cs typeface="Calibri" pitchFamily="34" charset="-120"/>
-                <a:hlinkClick r:id="rId8" tooltip="View the code on GitHub">
+                <a:hlinkClick r:id="rId6" invalidUrl="" action="" tgtFrame="" tooltip="View the code on GitHub" history="1" highlightClick="0" endSnd="0">
                   <a:extLst>
                     <a:ext uri="{A12FA001-AC4F-418D-AE19-62706E023703}">
                       <ahyp:hlinkClr xmlns:ahyp="http://schemas.microsoft.com/office/drawing/2018/hyperlinkcolor" val="tx"/>
@@ -5897,11 +7294,11 @@
           <a:bodyPr wrap="square" rtlCol="0" anchor="ctr"/>
           <a:lstStyle/>
           <a:p>
-            <a:pPr marL="0" indent="0">
-              <a:buNone/>
-            </a:pPr>
-            <a:r>
-              <a:rPr lang="en-US" sz="1050" b="1" kern="0" spc="200" dirty="0">
+            <a:pPr indent="0" marL="0">
+              <a:buNone/>
+            </a:pPr>
+            <a:r>
+              <a:rPr lang="en-US" sz="1050" b="1" spc="200" kern="0" dirty="0">
                 <a:solidFill>
                   <a:srgbClr val="F59E0B"/>
                 </a:solidFill>
@@ -5936,7 +7333,7 @@
           <a:bodyPr wrap="square" rtlCol="0" anchor="ctr"/>
           <a:lstStyle/>
           <a:p>
-            <a:pPr marL="0" indent="0">
+            <a:pPr indent="0" marL="0">
               <a:buNone/>
             </a:pPr>
             <a:r>
@@ -6019,7 +7416,7 @@
           <a:bodyPr wrap="square" rtlCol="0" anchor="ctr"/>
           <a:lstStyle/>
           <a:p>
-            <a:pPr marL="0" indent="0">
+            <a:pPr indent="0" marL="0">
               <a:buNone/>
             </a:pPr>
             <a:r>
@@ -6083,7 +7480,7 @@
       </p:sp>
       <p:graphicFrame>
         <p:nvGraphicFramePr>
-          <p:cNvPr id="35" name="Chart 0"/>
+          <p:cNvPr id="35" name="Chart 0" descr=""/>
           <p:cNvGraphicFramePr/>
           <p:nvPr/>
         </p:nvGraphicFramePr>
@@ -6091,9 +7488,9 @@
           <a:off x="10561320" y="5120640"/>
           <a:ext cx="731520" cy="731520"/>
         </p:xfrm>
-        <a:graphic>
+        <a:graphic xmlns:a="http://schemas.openxmlformats.org/drawingml/2006/main">
           <a:graphicData uri="http://schemas.openxmlformats.org/drawingml/2006/chart">
-            <c:chart xmlns:c="http://schemas.openxmlformats.org/drawingml/2006/chart" xmlns:r="http://schemas.openxmlformats.org/officeDocument/2006/relationships" r:id="rId9"/>
+            <c:chart xmlns:c="http://schemas.openxmlformats.org/drawingml/2006/chart" r:id="rId7"/>
           </a:graphicData>
         </a:graphic>
       </p:graphicFrame>
@@ -6118,7 +7515,7 @@
           <a:bodyPr wrap="square" rtlCol="0" anchor="ctr"/>
           <a:lstStyle/>
           <a:p>
-            <a:pPr marL="0" indent="0" algn="ctr">
+            <a:pPr algn="ctr" indent="0" marL="0">
               <a:buNone/>
             </a:pPr>
             <a:r>
@@ -6437,319 +7834,4 @@
     </a:ext>
   </a:extLst>
 </a:theme>
-</file>
-
-<file path=ppt/theme/theme2.xml><?xml version="1.0" encoding="utf-8"?>
-<a:theme xmlns:a="http://schemas.openxmlformats.org/drawingml/2006/main" name="Office Theme">
-  <a:themeElements>
-    <a:clrScheme name="Office">
-      <a:dk1>
-        <a:sysClr val="windowText" lastClr="000000"/>
-      </a:dk1>
-      <a:lt1>
-        <a:sysClr val="window" lastClr="FFFFFF"/>
-      </a:lt1>
-      <a:dk2>
-        <a:srgbClr val="0E2841"/>
-      </a:dk2>
-      <a:lt2>
-        <a:srgbClr val="E8E8E8"/>
-      </a:lt2>
-      <a:accent1>
-        <a:srgbClr val="156082"/>
-      </a:accent1>
-      <a:accent2>
-        <a:srgbClr val="E97132"/>
-      </a:accent2>
-      <a:accent3>
-        <a:srgbClr val="196B24"/>
-      </a:accent3>
-      <a:accent4>
-        <a:srgbClr val="0F9ED5"/>
-      </a:accent4>
-      <a:accent5>
-        <a:srgbClr val="A02B93"/>
-      </a:accent5>
-      <a:accent6>
-        <a:srgbClr val="4EA72E"/>
-      </a:accent6>
-      <a:hlink>
-        <a:srgbClr val="467886"/>
-      </a:hlink>
-      <a:folHlink>
-        <a:srgbClr val="96607D"/>
-      </a:folHlink>
-    </a:clrScheme>
-    <a:fontScheme name="Office">
-      <a:majorFont>
-        <a:latin typeface="Aptos Display" panose="02110004020202020204"/>
-        <a:ea typeface=""/>
-        <a:cs typeface=""/>
-        <a:font script="Jpan" typeface="游ゴシック Light"/>
-        <a:font script="Hang" typeface="맑은 고딕"/>
-        <a:font script="Hans" typeface="等线 Light"/>
-        <a:font script="Hant" typeface="新細明體"/>
-        <a:font script="Arab" typeface="Times New Roman"/>
-        <a:font script="Hebr" typeface="Times New Roman"/>
-        <a:font script="Thai" typeface="Angsana New"/>
-        <a:font script="Ethi" typeface="Nyala"/>
-        <a:font script="Beng" typeface="Vrinda"/>
-        <a:font script="Gujr" typeface="Shruti"/>
-        <a:font script="Khmr" typeface="MoolBoran"/>
-        <a:font script="Knda" typeface="Tunga"/>
-        <a:font script="Guru" typeface="Raavi"/>
-        <a:font script="Cans" typeface="Euphemia"/>
-        <a:font script="Cher" typeface="Plantagenet Cherokee"/>
-        <a:font script="Yiii" typeface="Microsoft Yi Baiti"/>
-        <a:font script="Tibt" typeface="Microsoft Himalaya"/>
-        <a:font script="Thaa" typeface="MV Boli"/>
-        <a:font script="Deva" typeface="Mangal"/>
-        <a:font script="Telu" typeface="Gautami"/>
-        <a:font script="Taml" typeface="Latha"/>
-        <a:font script="Syrc" typeface="Estrangelo Edessa"/>
-        <a:font script="Orya" typeface="Kalinga"/>
-        <a:font script="Mlym" typeface="Kartika"/>
-        <a:font script="Laoo" typeface="DokChampa"/>
-        <a:font script="Sinh" typeface="Iskoola Pota"/>
-        <a:font script="Mong" typeface="Mongolian Baiti"/>
-        <a:font script="Viet" typeface="Times New Roman"/>
-        <a:font script="Uigh" typeface="Microsoft Uighur"/>
-        <a:font script="Geor" typeface="Sylfaen"/>
-        <a:font script="Armn" typeface="Arial"/>
-        <a:font script="Bugi" typeface="Leelawadee UI"/>
-        <a:font script="Bopo" typeface="Microsoft JhengHei"/>
-        <a:font script="Java" typeface="Javanese Text"/>
-        <a:font script="Lisu" typeface="Segoe UI"/>
-        <a:font script="Mymr" typeface="Myanmar Text"/>
-        <a:font script="Nkoo" typeface="Ebrima"/>
-        <a:font script="Olck" typeface="Nirmala UI"/>
-        <a:font script="Osma" typeface="Ebrima"/>
-        <a:font script="Phag" typeface="Phagspa"/>
-        <a:font script="Syrn" typeface="Estrangelo Edessa"/>
-        <a:font script="Syrj" typeface="Estrangelo Edessa"/>
-        <a:font script="Syre" typeface="Estrangelo Edessa"/>
-        <a:font script="Sora" typeface="Nirmala UI"/>
-        <a:font script="Tale" typeface="Microsoft Tai Le"/>
-        <a:font script="Talu" typeface="Microsoft New Tai Lue"/>
-        <a:font script="Tfng" typeface="Ebrima"/>
-      </a:majorFont>
-      <a:minorFont>
-        <a:latin typeface="Aptos" panose="02110004020202020204"/>
-        <a:ea typeface=""/>
-        <a:cs typeface=""/>
-        <a:font script="Jpan" typeface="游ゴシック"/>
-        <a:font script="Hang" typeface="맑은 고딕"/>
-        <a:font script="Hans" typeface="等线"/>
-        <a:font script="Hant" typeface="新細明體"/>
-        <a:font script="Arab" typeface="Arial"/>
-        <a:font script="Hebr" typeface="Arial"/>
-        <a:font script="Thai" typeface="Cordia New"/>
-        <a:font script="Ethi" typeface="Nyala"/>
-        <a:font script="Beng" typeface="Vrinda"/>
-        <a:font script="Gujr" typeface="Shruti"/>
-        <a:font script="Khmr" typeface="DaunPenh"/>
-        <a:font script="Knda" typeface="Tunga"/>
-        <a:font script="Guru" typeface="Raavi"/>
-        <a:font script="Cans" typeface="Euphemia"/>
-        <a:font script="Cher" typeface="Plantagenet Cherokee"/>
-        <a:font script="Yiii" typeface="Microsoft Yi Baiti"/>
-        <a:font script="Tibt" typeface="Microsoft Himalaya"/>
-        <a:font script="Thaa" typeface="MV Boli"/>
-        <a:font script="Deva" typeface="Mangal"/>
-        <a:font script="Telu" typeface="Gautami"/>
-        <a:font script="Taml" typeface="Latha"/>
-        <a:font script="Syrc" typeface="Estrangelo Edessa"/>
-        <a:font script="Orya" typeface="Kalinga"/>
-        <a:font script="Mlym" typeface="Kartika"/>
-        <a:font script="Laoo" typeface="DokChampa"/>
-        <a:font script="Sinh" typeface="Iskoola Pota"/>
-        <a:font script="Mong" typeface="Mongolian Baiti"/>
-        <a:font script="Viet" typeface="Arial"/>
-        <a:font script="Uigh" typeface="Microsoft Uighur"/>
-        <a:font script="Geor" typeface="Sylfaen"/>
-        <a:font script="Armn" typeface="Arial"/>
-        <a:font script="Bugi" typeface="Leelawadee UI"/>
-        <a:font script="Bopo" typeface="Microsoft JhengHei"/>
-        <a:font script="Java" typeface="Javanese Text"/>
-        <a:font script="Lisu" typeface="Segoe UI"/>
-        <a:font script="Mymr" typeface="Myanmar Text"/>
-        <a:font script="Nkoo" typeface="Ebrima"/>
-        <a:font script="Olck" typeface="Nirmala UI"/>
-        <a:font script="Osma" typeface="Ebrima"/>
-        <a:font script="Phag" typeface="Phagspa"/>
-        <a:font script="Syrn" typeface="Estrangelo Edessa"/>
-        <a:font script="Syrj" typeface="Estrangelo Edessa"/>
-        <a:font script="Syre" typeface="Estrangelo Edessa"/>
-        <a:font script="Sora" typeface="Nirmala UI"/>
-        <a:font script="Tale" typeface="Microsoft Tai Le"/>
-        <a:font script="Talu" typeface="Microsoft New Tai Lue"/>
-        <a:font script="Tfng" typeface="Ebrima"/>
-      </a:minorFont>
-    </a:fontScheme>
-    <a:fmtScheme name="Office">
-      <a:fillStyleLst>
-        <a:solidFill>
-          <a:schemeClr val="phClr"/>
-        </a:solidFill>
-        <a:gradFill rotWithShape="1">
-          <a:gsLst>
-            <a:gs pos="0">
-              <a:schemeClr val="phClr">
-                <a:lumMod val="110000"/>
-                <a:satMod val="105000"/>
-                <a:tint val="67000"/>
-              </a:schemeClr>
-            </a:gs>
-            <a:gs pos="50000">
-              <a:schemeClr val="phClr">
-                <a:lumMod val="105000"/>
-                <a:satMod val="103000"/>
-                <a:tint val="73000"/>
-              </a:schemeClr>
-            </a:gs>
-            <a:gs pos="100000">
-              <a:schemeClr val="phClr">
-                <a:lumMod val="105000"/>
-                <a:satMod val="109000"/>
-                <a:tint val="81000"/>
-              </a:schemeClr>
-            </a:gs>
-          </a:gsLst>
-          <a:lin ang="5400000" scaled="0"/>
-        </a:gradFill>
-        <a:gradFill rotWithShape="1">
-          <a:gsLst>
-            <a:gs pos="0">
-              <a:schemeClr val="phClr">
-                <a:satMod val="103000"/>
-                <a:lumMod val="102000"/>
-                <a:tint val="94000"/>
-              </a:schemeClr>
-            </a:gs>
-            <a:gs pos="50000">
-              <a:schemeClr val="phClr">
-                <a:satMod val="110000"/>
-                <a:lumMod val="100000"/>
-                <a:shade val="100000"/>
-              </a:schemeClr>
-            </a:gs>
-            <a:gs pos="100000">
-              <a:schemeClr val="phClr">
-                <a:lumMod val="99000"/>
-                <a:satMod val="120000"/>
-                <a:shade val="78000"/>
-              </a:schemeClr>
-            </a:gs>
-          </a:gsLst>
-          <a:lin ang="5400000" scaled="0"/>
-        </a:gradFill>
-      </a:fillStyleLst>
-      <a:lnStyleLst>
-        <a:ln w="12700" cap="flat" cmpd="sng" algn="ctr">
-          <a:solidFill>
-            <a:schemeClr val="phClr"/>
-          </a:solidFill>
-          <a:prstDash val="solid"/>
-          <a:miter lim="800000"/>
-        </a:ln>
-        <a:ln w="19050" cap="flat" cmpd="sng" algn="ctr">
-          <a:solidFill>
-            <a:schemeClr val="phClr"/>
-          </a:solidFill>
-          <a:prstDash val="solid"/>
-          <a:miter lim="800000"/>
-        </a:ln>
-        <a:ln w="25400" cap="flat" cmpd="sng" algn="ctr">
-          <a:solidFill>
-            <a:schemeClr val="phClr"/>
-          </a:solidFill>
-          <a:prstDash val="solid"/>
-          <a:miter lim="800000"/>
-        </a:ln>
-      </a:lnStyleLst>
-      <a:effectStyleLst>
-        <a:effectStyle>
-          <a:effectLst/>
-        </a:effectStyle>
-        <a:effectStyle>
-          <a:effectLst/>
-        </a:effectStyle>
-        <a:effectStyle>
-          <a:effectLst>
-            <a:outerShdw blurRad="57150" dist="19050" dir="5400000" algn="ctr" rotWithShape="0">
-              <a:srgbClr val="000000">
-                <a:alpha val="63000"/>
-              </a:srgbClr>
-            </a:outerShdw>
-          </a:effectLst>
-        </a:effectStyle>
-      </a:effectStyleLst>
-      <a:bgFillStyleLst>
-        <a:solidFill>
-          <a:schemeClr val="phClr"/>
-        </a:solidFill>
-        <a:solidFill>
-          <a:schemeClr val="phClr">
-            <a:tint val="95000"/>
-            <a:satMod val="170000"/>
-          </a:schemeClr>
-        </a:solidFill>
-        <a:gradFill rotWithShape="1">
-          <a:gsLst>
-            <a:gs pos="0">
-              <a:schemeClr val="phClr">
-                <a:tint val="93000"/>
-                <a:satMod val="150000"/>
-                <a:shade val="98000"/>
-                <a:lumMod val="102000"/>
-              </a:schemeClr>
-            </a:gs>
-            <a:gs pos="50000">
-              <a:schemeClr val="phClr">
-                <a:tint val="98000"/>
-                <a:satMod val="130000"/>
-                <a:shade val="90000"/>
-                <a:lumMod val="103000"/>
-              </a:schemeClr>
-            </a:gs>
-            <a:gs pos="100000">
-              <a:schemeClr val="phClr">
-                <a:shade val="63000"/>
-                <a:satMod val="120000"/>
-              </a:schemeClr>
-            </a:gs>
-          </a:gsLst>
-          <a:lin ang="5400000" scaled="0"/>
-        </a:gradFill>
-      </a:bgFillStyleLst>
-    </a:fmtScheme>
-  </a:themeElements>
-  <a:objectDefaults>
-    <a:lnDef>
-      <a:spPr/>
-      <a:bodyPr/>
-      <a:lstStyle/>
-      <a:style>
-        <a:lnRef idx="2">
-          <a:schemeClr val="accent1"/>
-        </a:lnRef>
-        <a:fillRef idx="0">
-          <a:schemeClr val="accent1"/>
-        </a:fillRef>
-        <a:effectRef idx="1">
-          <a:schemeClr val="accent1"/>
-        </a:effectRef>
-        <a:fontRef idx="minor">
-          <a:schemeClr val="tx1"/>
-        </a:fontRef>
-      </a:style>
-    </a:lnDef>
-  </a:objectDefaults>
-  <a:extraClrSchemeLst/>
-  <a:extLst>
-    <a:ext uri="{05A4C25C-085E-4340-85A3-A5531E510DB2}">
-      <thm15:themeFamily xmlns:thm15="http://schemas.microsoft.com/office/thememl/2012/main" name="Office Theme" id="{2E142A2C-CD16-42D6-873A-C26D2A0506FA}" vid="{1BDDFF52-6CD6-40A5-AB3C-68EB2F1E4D0A}"/>
-    </a:ext>
-  </a:extLst>
-</a:theme>
 </file>
</xml_diff>